<commit_message>
Verify portable R reproduction and finalize handoff materials
</commit_message>
<xml_diff>
--- a/Submission_Pack/COMP2501_presentation.pptx
+++ b/Submission_Pack/COMP2501_presentation.pptx
@@ -2,24 +2,24 @@
 <file path=ppt/presentation.xml><?xml version="1.0" encoding="utf-8"?>
 <p:presentation xmlns:p="http://schemas.openxmlformats.org/presentationml/2006/main">
   <p:sldMasterIdLst>
-    <p:sldMasterId xmlns:r="http://schemas.openxmlformats.org/officeDocument/2006/relationships" id="2147483648" r:id="R2441884ebc2f449a"/>
+    <p:sldMasterId xmlns:r="http://schemas.openxmlformats.org/officeDocument/2006/relationships" id="2147483648" r:id="R5c04dc6d38774e7d"/>
   </p:sldMasterIdLst>
   <p:notesMasterIdLst>
-    <p:notesMasterId xmlns:r="http://schemas.openxmlformats.org/officeDocument/2006/relationships" r:id="R0a5e57a51b11471b"/>
+    <p:notesMasterId xmlns:r="http://schemas.openxmlformats.org/officeDocument/2006/relationships" r:id="R1f59e7378de84f4a"/>
   </p:notesMasterIdLst>
   <p:sldIdLst>
-    <p:sldId xmlns:r="http://schemas.openxmlformats.org/officeDocument/2006/relationships" id="256" r:id="R5811d115ced74e62"/>
-    <p:sldId xmlns:r="http://schemas.openxmlformats.org/officeDocument/2006/relationships" id="257" r:id="R76ed0e615e174419"/>
-    <p:sldId xmlns:r="http://schemas.openxmlformats.org/officeDocument/2006/relationships" id="258" r:id="R2b1830e266944e21"/>
-    <p:sldId xmlns:r="http://schemas.openxmlformats.org/officeDocument/2006/relationships" id="259" r:id="Rd266fa9cd47e4a3f"/>
-    <p:sldId xmlns:r="http://schemas.openxmlformats.org/officeDocument/2006/relationships" id="260" r:id="R4795d19ad1924653"/>
-    <p:sldId xmlns:r="http://schemas.openxmlformats.org/officeDocument/2006/relationships" id="261" r:id="Ra4141191c5b84e6a"/>
-    <p:sldId xmlns:r="http://schemas.openxmlformats.org/officeDocument/2006/relationships" id="262" r:id="Rfbeaa4e985e8454c"/>
-    <p:sldId xmlns:r="http://schemas.openxmlformats.org/officeDocument/2006/relationships" id="263" r:id="Rec1411b7f82d4224"/>
-    <p:sldId xmlns:r="http://schemas.openxmlformats.org/officeDocument/2006/relationships" id="264" r:id="R2110947d13ab40e1"/>
-    <p:sldId xmlns:r="http://schemas.openxmlformats.org/officeDocument/2006/relationships" id="265" r:id="R35e10a94b20f4bd1"/>
-    <p:sldId xmlns:r="http://schemas.openxmlformats.org/officeDocument/2006/relationships" id="266" r:id="Red642cbe52384bea"/>
-    <p:sldId xmlns:r="http://schemas.openxmlformats.org/officeDocument/2006/relationships" id="267" r:id="Rb76bc6dfca1842c1"/>
+    <p:sldId xmlns:r="http://schemas.openxmlformats.org/officeDocument/2006/relationships" id="256" r:id="Rb68cadcb769e415d"/>
+    <p:sldId xmlns:r="http://schemas.openxmlformats.org/officeDocument/2006/relationships" id="257" r:id="R096c9602e1a64d06"/>
+    <p:sldId xmlns:r="http://schemas.openxmlformats.org/officeDocument/2006/relationships" id="258" r:id="Recea99c7a38a4890"/>
+    <p:sldId xmlns:r="http://schemas.openxmlformats.org/officeDocument/2006/relationships" id="259" r:id="Rf19d0b76fd474167"/>
+    <p:sldId xmlns:r="http://schemas.openxmlformats.org/officeDocument/2006/relationships" id="260" r:id="Ra03d3eaa6195465d"/>
+    <p:sldId xmlns:r="http://schemas.openxmlformats.org/officeDocument/2006/relationships" id="261" r:id="R3767471ff44a43d8"/>
+    <p:sldId xmlns:r="http://schemas.openxmlformats.org/officeDocument/2006/relationships" id="262" r:id="R7fd9f347a5a747a1"/>
+    <p:sldId xmlns:r="http://schemas.openxmlformats.org/officeDocument/2006/relationships" id="263" r:id="R45e77c8f51724d44"/>
+    <p:sldId xmlns:r="http://schemas.openxmlformats.org/officeDocument/2006/relationships" id="264" r:id="Rbcd86a1648304d70"/>
+    <p:sldId xmlns:r="http://schemas.openxmlformats.org/officeDocument/2006/relationships" id="265" r:id="Rd42af67eb2e34a14"/>
+    <p:sldId xmlns:r="http://schemas.openxmlformats.org/officeDocument/2006/relationships" id="266" r:id="Rc1a38be15f8a4667"/>
+    <p:sldId xmlns:r="http://schemas.openxmlformats.org/officeDocument/2006/relationships" id="267" r:id="R7bdd4cae5cb84856"/>
   </p:sldIdLst>
   <p:sldSz cx="12192000" cy="6858000"/>
   <p:notesSz cx="6858000" cy="9144000"/>
@@ -1386,7 +1386,7 @@
   </p:cSld>
   <p:clrMap bg1="lt1" tx1="dk1" bg2="lt2" tx2="dk2" accent1="accent1" accent2="accent2" accent3="accent3" accent4="accent4" accent5="accent5" accent6="accent6" hlink="hlink" folHlink="folHlink"/>
   <p:sldLayoutIdLst>
-    <p:sldLayoutId xmlns:r="http://schemas.openxmlformats.org/officeDocument/2006/relationships" id="2147483649" r:id="Rcd9ae759a24d4b29"/>
+    <p:sldLayoutId xmlns:r="http://schemas.openxmlformats.org/officeDocument/2006/relationships" id="2147483649" r:id="R759eccb53e55440e"/>
   </p:sldLayoutIdLst>
   <p:txStyles>
     <p:titleStyle>
@@ -2744,7 +2744,7 @@
           <p:cNvPr id="6" name="">
             <a:extLst xmlns:a="http://schemas.openxmlformats.org/drawingml/2006/main">
               <a:ext uri="{FF2B5EF4-FFF2-40B4-BE49-F238E27FC236}">
-                <a16:creationId xmlns:a16="http://schemas.microsoft.com/office/drawing/2014/main" id="{B416336B-C197-476D-9DEA-990F3E4869B8}"/>
+                <a16:creationId xmlns:a16="http://schemas.microsoft.com/office/drawing/2014/main" id="{28841B81-E6E3-423C-B473-D9EF28F27641}"/>
               </a:ext>
             </a:extLst>
           </p:cNvPr>
@@ -2824,7 +2824,7 @@
           <p:cNvPr id="2" name="">
             <a:extLst xmlns:a="http://schemas.openxmlformats.org/drawingml/2006/main">
               <a:ext uri="{FF2B5EF4-FFF2-40B4-BE49-F238E27FC236}">
-                <a16:creationId xmlns:a16="http://schemas.microsoft.com/office/drawing/2014/main" id="{1AF998FE-5346-4EF5-ACC8-911030E768CD}"/>
+                <a16:creationId xmlns:a16="http://schemas.microsoft.com/office/drawing/2014/main" id="{9D0D6176-9662-4112-9769-E31C50EA0092}"/>
               </a:ext>
             </a:extLst>
           </p:cNvPr>
@@ -2881,7 +2881,7 @@
           <p:cNvPr id="3" name="">
             <a:extLst xmlns:a="http://schemas.openxmlformats.org/drawingml/2006/main">
               <a:ext uri="{FF2B5EF4-FFF2-40B4-BE49-F238E27FC236}">
-                <a16:creationId xmlns:a16="http://schemas.microsoft.com/office/drawing/2014/main" id="{66E98BF5-D4A5-44B8-AC76-B563E39A0B3A}"/>
+                <a16:creationId xmlns:a16="http://schemas.microsoft.com/office/drawing/2014/main" id="{30831140-E2C6-411B-B69C-BE90660A9B35}"/>
               </a:ext>
             </a:extLst>
           </p:cNvPr>
@@ -2938,7 +2938,7 @@
           <p:cNvPr id="4" name="">
             <a:extLst xmlns:a="http://schemas.openxmlformats.org/drawingml/2006/main">
               <a:ext uri="{FF2B5EF4-FFF2-40B4-BE49-F238E27FC236}">
-                <a16:creationId xmlns:a16="http://schemas.microsoft.com/office/drawing/2014/main" id="{63149B21-9298-4AA0-BC5C-B91ADA45E0FE}"/>
+                <a16:creationId xmlns:a16="http://schemas.microsoft.com/office/drawing/2014/main" id="{EDA61DCC-5BD3-4069-B77F-BDCCE6C27626}"/>
               </a:ext>
             </a:extLst>
           </p:cNvPr>
@@ -2995,7 +2995,7 @@
           <p:cNvPr id="5" name="">
             <a:extLst xmlns:a="http://schemas.openxmlformats.org/drawingml/2006/main">
               <a:ext uri="{FF2B5EF4-FFF2-40B4-BE49-F238E27FC236}">
-                <a16:creationId xmlns:a16="http://schemas.microsoft.com/office/drawing/2014/main" id="{CA210F89-DB0C-4721-8EB7-E539F264DB76}"/>
+                <a16:creationId xmlns:a16="http://schemas.microsoft.com/office/drawing/2014/main" id="{56EF1077-1567-4194-98A0-323FA033B624}"/>
               </a:ext>
             </a:extLst>
           </p:cNvPr>
@@ -3050,7 +3050,7 @@
     </p:spTree>
     <p:extLst>
       <p:ext uri="{BB962C8B-B14F-4D97-AF65-F5344CB8AC3E}">
-        <p14:creationId xmlns:p14="http://schemas.microsoft.com/office/powerpoint/2010/main" val="2110086903"/>
+        <p14:creationId xmlns:p14="http://schemas.microsoft.com/office/powerpoint/2010/main" val="1692311819"/>
       </p:ext>
     </p:extLst>
   </p:cSld>
@@ -3081,7 +3081,7 @@
           <p:cNvPr id="7" name="">
             <a:extLst xmlns:a="http://schemas.openxmlformats.org/drawingml/2006/main">
               <a:ext uri="{FF2B5EF4-FFF2-40B4-BE49-F238E27FC236}">
-                <a16:creationId xmlns:a16="http://schemas.microsoft.com/office/drawing/2014/main" id="{3378A6C5-1D43-4876-A673-F1A6EFE8BEC2}"/>
+                <a16:creationId xmlns:a16="http://schemas.microsoft.com/office/drawing/2014/main" id="{81EEF9B2-4AEE-47FC-82B9-383D58772356}"/>
               </a:ext>
             </a:extLst>
           </p:cNvPr>
@@ -3138,7 +3138,7 @@
           <p:cNvPr id="2" name="">
             <a:extLst xmlns:a="http://schemas.openxmlformats.org/drawingml/2006/main">
               <a:ext uri="{FF2B5EF4-FFF2-40B4-BE49-F238E27FC236}">
-                <a16:creationId xmlns:a16="http://schemas.microsoft.com/office/drawing/2014/main" id="{E88F9F49-01EF-4E68-95AB-AD3EBC76EECE}"/>
+                <a16:creationId xmlns:a16="http://schemas.microsoft.com/office/drawing/2014/main" id="{E5EFC930-BA83-4FFF-9F21-757F8F242A7A}"/>
               </a:ext>
             </a:extLst>
           </p:cNvPr>
@@ -3195,7 +3195,7 @@
           <p:cNvPr id="3" name="">
             <a:extLst xmlns:a="http://schemas.openxmlformats.org/drawingml/2006/main">
               <a:ext uri="{FF2B5EF4-FFF2-40B4-BE49-F238E27FC236}">
-                <a16:creationId xmlns:a16="http://schemas.microsoft.com/office/drawing/2014/main" id="{69992A1A-BBF8-4284-A842-639E2CAF8E60}"/>
+                <a16:creationId xmlns:a16="http://schemas.microsoft.com/office/drawing/2014/main" id="{9DCCF988-A51E-4429-BB30-A904A0E1E6EA}"/>
               </a:ext>
             </a:extLst>
           </p:cNvPr>
@@ -3252,7 +3252,7 @@
           <p:cNvPr id="4" name="">
             <a:extLst xmlns:a="http://schemas.openxmlformats.org/drawingml/2006/main">
               <a:ext uri="{FF2B5EF4-FFF2-40B4-BE49-F238E27FC236}">
-                <a16:creationId xmlns:a16="http://schemas.microsoft.com/office/drawing/2014/main" id="{4C300793-BB6A-4CC3-A086-E5F17A0442C2}"/>
+                <a16:creationId xmlns:a16="http://schemas.microsoft.com/office/drawing/2014/main" id="{33A888E7-2998-4904-8425-17CD1DB7F79D}"/>
               </a:ext>
             </a:extLst>
           </p:cNvPr>
@@ -3309,7 +3309,7 @@
           <p:cNvPr id="5" name="">
             <a:extLst xmlns:a="http://schemas.openxmlformats.org/drawingml/2006/main">
               <a:ext uri="{FF2B5EF4-FFF2-40B4-BE49-F238E27FC236}">
-                <a16:creationId xmlns:a16="http://schemas.microsoft.com/office/drawing/2014/main" id="{CA1B28AB-4B4D-4DA7-ACF3-6E0B86F179C9}"/>
+                <a16:creationId xmlns:a16="http://schemas.microsoft.com/office/drawing/2014/main" id="{D862022A-0B84-45CE-8804-A01C6BA5C25E}"/>
               </a:ext>
             </a:extLst>
           </p:cNvPr>
@@ -3366,7 +3366,7 @@
           <p:cNvPr id="6" name="">
             <a:extLst xmlns:a="http://schemas.openxmlformats.org/drawingml/2006/main">
               <a:ext uri="{FF2B5EF4-FFF2-40B4-BE49-F238E27FC236}">
-                <a16:creationId xmlns:a16="http://schemas.microsoft.com/office/drawing/2014/main" id="{121F6889-DA28-47A7-8193-80B60B9529FC}"/>
+                <a16:creationId xmlns:a16="http://schemas.microsoft.com/office/drawing/2014/main" id="{4E7AA611-61B1-4610-8D5A-ACCE8F7994EC}"/>
               </a:ext>
             </a:extLst>
           </p:cNvPr>
@@ -3421,7 +3421,7 @@
     </p:spTree>
     <p:extLst>
       <p:ext uri="{BB962C8B-B14F-4D97-AF65-F5344CB8AC3E}">
-        <p14:creationId xmlns:p14="http://schemas.microsoft.com/office/powerpoint/2010/main" val="1132327388"/>
+        <p14:creationId xmlns:p14="http://schemas.microsoft.com/office/powerpoint/2010/main" val="970437430"/>
       </p:ext>
     </p:extLst>
   </p:cSld>
@@ -3452,7 +3452,7 @@
           <p:cNvPr id="7" name="">
             <a:extLst xmlns:a="http://schemas.openxmlformats.org/drawingml/2006/main">
               <a:ext uri="{FF2B5EF4-FFF2-40B4-BE49-F238E27FC236}">
-                <a16:creationId xmlns:a16="http://schemas.microsoft.com/office/drawing/2014/main" id="{46002A05-F800-46CA-A256-ABE7D1BB8CFA}"/>
+                <a16:creationId xmlns:a16="http://schemas.microsoft.com/office/drawing/2014/main" id="{0640E6B8-2694-4577-AFA2-3E9086957B14}"/>
               </a:ext>
             </a:extLst>
           </p:cNvPr>
@@ -3509,7 +3509,7 @@
           <p:cNvPr id="2" name="">
             <a:extLst xmlns:a="http://schemas.openxmlformats.org/drawingml/2006/main">
               <a:ext uri="{FF2B5EF4-FFF2-40B4-BE49-F238E27FC236}">
-                <a16:creationId xmlns:a16="http://schemas.microsoft.com/office/drawing/2014/main" id="{A1FBAC0D-F5F1-46A9-8D00-14E416B9B288}"/>
+                <a16:creationId xmlns:a16="http://schemas.microsoft.com/office/drawing/2014/main" id="{A6CE9581-6B0F-4D9B-8380-802F5D3EE1A1}"/>
               </a:ext>
             </a:extLst>
           </p:cNvPr>
@@ -3566,7 +3566,7 @@
           <p:cNvPr id="3" name="">
             <a:extLst xmlns:a="http://schemas.openxmlformats.org/drawingml/2006/main">
               <a:ext uri="{FF2B5EF4-FFF2-40B4-BE49-F238E27FC236}">
-                <a16:creationId xmlns:a16="http://schemas.microsoft.com/office/drawing/2014/main" id="{0FCE3C2C-F8C3-4D3E-A2C3-13A2BABFD7D4}"/>
+                <a16:creationId xmlns:a16="http://schemas.microsoft.com/office/drawing/2014/main" id="{1995B40F-2BFE-4174-BB0D-78BA0E130570}"/>
               </a:ext>
             </a:extLst>
           </p:cNvPr>
@@ -3623,7 +3623,7 @@
           <p:cNvPr id="4" name="">
             <a:extLst xmlns:a="http://schemas.openxmlformats.org/drawingml/2006/main">
               <a:ext uri="{FF2B5EF4-FFF2-40B4-BE49-F238E27FC236}">
-                <a16:creationId xmlns:a16="http://schemas.microsoft.com/office/drawing/2014/main" id="{56A5756E-DC48-4340-91C7-2222A42AB1B5}"/>
+                <a16:creationId xmlns:a16="http://schemas.microsoft.com/office/drawing/2014/main" id="{93456B89-2C3D-4D0B-AB74-0640AF1B2259}"/>
               </a:ext>
             </a:extLst>
           </p:cNvPr>
@@ -3680,7 +3680,7 @@
           <p:cNvPr id="5" name="">
             <a:extLst xmlns:a="http://schemas.openxmlformats.org/drawingml/2006/main">
               <a:ext uri="{FF2B5EF4-FFF2-40B4-BE49-F238E27FC236}">
-                <a16:creationId xmlns:a16="http://schemas.microsoft.com/office/drawing/2014/main" id="{A21460DD-6546-4EF8-B8D5-FA93869F7A08}"/>
+                <a16:creationId xmlns:a16="http://schemas.microsoft.com/office/drawing/2014/main" id="{570A2E62-9995-4790-9C5D-0EAC8CAA53EB}"/>
               </a:ext>
             </a:extLst>
           </p:cNvPr>
@@ -3737,7 +3737,7 @@
           <p:cNvPr id="6" name="">
             <a:extLst xmlns:a="http://schemas.openxmlformats.org/drawingml/2006/main">
               <a:ext uri="{FF2B5EF4-FFF2-40B4-BE49-F238E27FC236}">
-                <a16:creationId xmlns:a16="http://schemas.microsoft.com/office/drawing/2014/main" id="{73E2282D-7837-43F0-9DB3-CE3C8AEC54AE}"/>
+                <a16:creationId xmlns:a16="http://schemas.microsoft.com/office/drawing/2014/main" id="{43D8834D-BE93-4FD6-98A4-E1200C6E34C7}"/>
               </a:ext>
             </a:extLst>
           </p:cNvPr>
@@ -3792,7 +3792,7 @@
     </p:spTree>
     <p:extLst>
       <p:ext uri="{BB962C8B-B14F-4D97-AF65-F5344CB8AC3E}">
-        <p14:creationId xmlns:p14="http://schemas.microsoft.com/office/powerpoint/2010/main" val="1676303989"/>
+        <p14:creationId xmlns:p14="http://schemas.microsoft.com/office/powerpoint/2010/main" val="1940959374"/>
       </p:ext>
     </p:extLst>
   </p:cSld>
@@ -3823,7 +3823,7 @@
           <p:cNvPr id="9" name="">
             <a:extLst xmlns:a="http://schemas.openxmlformats.org/drawingml/2006/main">
               <a:ext uri="{FF2B5EF4-FFF2-40B4-BE49-F238E27FC236}">
-                <a16:creationId xmlns:a16="http://schemas.microsoft.com/office/drawing/2014/main" id="{8DB70AAF-8AD5-45B8-9CD3-782A9F4E4576}"/>
+                <a16:creationId xmlns:a16="http://schemas.microsoft.com/office/drawing/2014/main" id="{39BE5388-B22A-45B9-A7B2-BBAB9613AECF}"/>
               </a:ext>
             </a:extLst>
           </p:cNvPr>
@@ -3880,7 +3880,7 @@
           <p:cNvPr id="2" name="">
             <a:extLst xmlns:a="http://schemas.openxmlformats.org/drawingml/2006/main">
               <a:ext uri="{FF2B5EF4-FFF2-40B4-BE49-F238E27FC236}">
-                <a16:creationId xmlns:a16="http://schemas.microsoft.com/office/drawing/2014/main" id="{D9F44CDB-F49D-4C5A-A0F3-DA9354D01FEE}"/>
+                <a16:creationId xmlns:a16="http://schemas.microsoft.com/office/drawing/2014/main" id="{D3B4E7EC-6EBD-4C53-B5ED-87024CD3C944}"/>
               </a:ext>
             </a:extLst>
           </p:cNvPr>
@@ -3937,7 +3937,7 @@
           <p:cNvPr id="3" name="">
             <a:extLst xmlns:a="http://schemas.openxmlformats.org/drawingml/2006/main">
               <a:ext uri="{FF2B5EF4-FFF2-40B4-BE49-F238E27FC236}">
-                <a16:creationId xmlns:a16="http://schemas.microsoft.com/office/drawing/2014/main" id="{58892EBE-77D6-4CED-861A-D08FC45D6C81}"/>
+                <a16:creationId xmlns:a16="http://schemas.microsoft.com/office/drawing/2014/main" id="{71343621-D88D-421C-8537-ADB9BBB4BE36}"/>
               </a:ext>
             </a:extLst>
           </p:cNvPr>
@@ -3994,7 +3994,7 @@
           <p:cNvPr id="4" name="">
             <a:extLst xmlns:a="http://schemas.openxmlformats.org/drawingml/2006/main">
               <a:ext uri="{FF2B5EF4-FFF2-40B4-BE49-F238E27FC236}">
-                <a16:creationId xmlns:a16="http://schemas.microsoft.com/office/drawing/2014/main" id="{36C04139-FE4F-4A0F-BCEC-8BFF934C2363}"/>
+                <a16:creationId xmlns:a16="http://schemas.microsoft.com/office/drawing/2014/main" id="{3BBAE9D1-445C-4F29-B57A-D37D7367E7FC}"/>
               </a:ext>
             </a:extLst>
           </p:cNvPr>
@@ -4051,7 +4051,7 @@
           <p:cNvPr id="5" name="">
             <a:extLst xmlns:a="http://schemas.openxmlformats.org/drawingml/2006/main">
               <a:ext uri="{FF2B5EF4-FFF2-40B4-BE49-F238E27FC236}">
-                <a16:creationId xmlns:a16="http://schemas.microsoft.com/office/drawing/2014/main" id="{6415AAC3-15A1-47DC-B033-0CAD04F79C81}"/>
+                <a16:creationId xmlns:a16="http://schemas.microsoft.com/office/drawing/2014/main" id="{209EFFD7-053C-47C6-BE03-2A31B6926DE8}"/>
               </a:ext>
             </a:extLst>
           </p:cNvPr>
@@ -4108,7 +4108,7 @@
           <p:cNvPr id="6" name="">
             <a:extLst xmlns:a="http://schemas.openxmlformats.org/drawingml/2006/main">
               <a:ext uri="{FF2B5EF4-FFF2-40B4-BE49-F238E27FC236}">
-                <a16:creationId xmlns:a16="http://schemas.microsoft.com/office/drawing/2014/main" id="{22E29DE1-7224-4A9C-9034-D45024D98286}"/>
+                <a16:creationId xmlns:a16="http://schemas.microsoft.com/office/drawing/2014/main" id="{454FF49E-782F-4B4B-B3AF-4128171F445E}"/>
               </a:ext>
             </a:extLst>
           </p:cNvPr>
@@ -4165,7 +4165,7 @@
           <p:cNvPr id="7" name="">
             <a:extLst xmlns:a="http://schemas.openxmlformats.org/drawingml/2006/main">
               <a:ext uri="{FF2B5EF4-FFF2-40B4-BE49-F238E27FC236}">
-                <a16:creationId xmlns:a16="http://schemas.microsoft.com/office/drawing/2014/main" id="{BCA2156B-3DCD-43FC-B6B4-71D4AC0B82DC}"/>
+                <a16:creationId xmlns:a16="http://schemas.microsoft.com/office/drawing/2014/main" id="{26EFEF9F-95F1-4CEF-8D2F-F12075B598EA}"/>
               </a:ext>
             </a:extLst>
           </p:cNvPr>
@@ -4245,7 +4245,7 @@
           <p:cNvPr id="8" name="">
             <a:extLst xmlns:a="http://schemas.openxmlformats.org/drawingml/2006/main">
               <a:ext uri="{FF2B5EF4-FFF2-40B4-BE49-F238E27FC236}">
-                <a16:creationId xmlns:a16="http://schemas.microsoft.com/office/drawing/2014/main" id="{3197BD88-3281-489A-B06C-387871C48044}"/>
+                <a16:creationId xmlns:a16="http://schemas.microsoft.com/office/drawing/2014/main" id="{409A4104-9BEA-47B0-A8D3-092A174CA6CB}"/>
               </a:ext>
             </a:extLst>
           </p:cNvPr>
@@ -4300,7 +4300,7 @@
     </p:spTree>
     <p:extLst>
       <p:ext uri="{BB962C8B-B14F-4D97-AF65-F5344CB8AC3E}">
-        <p14:creationId xmlns:p14="http://schemas.microsoft.com/office/powerpoint/2010/main" val="1600741375"/>
+        <p14:creationId xmlns:p14="http://schemas.microsoft.com/office/powerpoint/2010/main" val="1512222751"/>
       </p:ext>
     </p:extLst>
   </p:cSld>
@@ -4331,7 +4331,7 @@
           <p:cNvPr id="7" name="">
             <a:extLst xmlns:a="http://schemas.openxmlformats.org/drawingml/2006/main">
               <a:ext uri="{FF2B5EF4-FFF2-40B4-BE49-F238E27FC236}">
-                <a16:creationId xmlns:a16="http://schemas.microsoft.com/office/drawing/2014/main" id="{13B356EE-A5EC-4D49-A2DC-FA03169DC147}"/>
+                <a16:creationId xmlns:a16="http://schemas.microsoft.com/office/drawing/2014/main" id="{A75E8C6E-BBD2-432D-A685-8F4C8A09F244}"/>
               </a:ext>
             </a:extLst>
           </p:cNvPr>
@@ -4388,7 +4388,7 @@
           <p:cNvPr id="2" name="">
             <a:extLst xmlns:a="http://schemas.openxmlformats.org/drawingml/2006/main">
               <a:ext uri="{FF2B5EF4-FFF2-40B4-BE49-F238E27FC236}">
-                <a16:creationId xmlns:a16="http://schemas.microsoft.com/office/drawing/2014/main" id="{16B45D34-3159-44BA-A279-DDA858BDE811}"/>
+                <a16:creationId xmlns:a16="http://schemas.microsoft.com/office/drawing/2014/main" id="{3B34F585-3628-466B-8431-162E061D4404}"/>
               </a:ext>
             </a:extLst>
           </p:cNvPr>
@@ -4445,7 +4445,7 @@
           <p:cNvPr id="3" name="">
             <a:extLst xmlns:a="http://schemas.openxmlformats.org/drawingml/2006/main">
               <a:ext uri="{FF2B5EF4-FFF2-40B4-BE49-F238E27FC236}">
-                <a16:creationId xmlns:a16="http://schemas.microsoft.com/office/drawing/2014/main" id="{B1845F8D-7311-4F4C-8714-246EB34CCB29}"/>
+                <a16:creationId xmlns:a16="http://schemas.microsoft.com/office/drawing/2014/main" id="{621394D7-806D-4EF3-8140-2040EAB9F700}"/>
               </a:ext>
             </a:extLst>
           </p:cNvPr>
@@ -4502,7 +4502,7 @@
           <p:cNvPr id="4" name="">
             <a:extLst xmlns:a="http://schemas.openxmlformats.org/drawingml/2006/main">
               <a:ext uri="{FF2B5EF4-FFF2-40B4-BE49-F238E27FC236}">
-                <a16:creationId xmlns:a16="http://schemas.microsoft.com/office/drawing/2014/main" id="{17609C7A-E232-4FE8-A357-B8C47A8198EC}"/>
+                <a16:creationId xmlns:a16="http://schemas.microsoft.com/office/drawing/2014/main" id="{868CB4AA-160D-4132-9920-28C7A8D2876F}"/>
               </a:ext>
             </a:extLst>
           </p:cNvPr>
@@ -4559,7 +4559,7 @@
           <p:cNvPr id="5" name="">
             <a:extLst xmlns:a="http://schemas.openxmlformats.org/drawingml/2006/main">
               <a:ext uri="{FF2B5EF4-FFF2-40B4-BE49-F238E27FC236}">
-                <a16:creationId xmlns:a16="http://schemas.microsoft.com/office/drawing/2014/main" id="{41603CDB-46CF-4E09-A425-829D8714437E}"/>
+                <a16:creationId xmlns:a16="http://schemas.microsoft.com/office/drawing/2014/main" id="{DB913C37-3E2F-4ACA-99C6-9AA90114F643}"/>
               </a:ext>
             </a:extLst>
           </p:cNvPr>
@@ -4616,7 +4616,7 @@
           <p:cNvPr id="6" name="">
             <a:extLst xmlns:a="http://schemas.openxmlformats.org/drawingml/2006/main">
               <a:ext uri="{FF2B5EF4-FFF2-40B4-BE49-F238E27FC236}">
-                <a16:creationId xmlns:a16="http://schemas.microsoft.com/office/drawing/2014/main" id="{39F49AB8-7990-4F16-A0EB-E8BCC60131D7}"/>
+                <a16:creationId xmlns:a16="http://schemas.microsoft.com/office/drawing/2014/main" id="{E4EED8CF-646B-4612-8187-3BE85C0637F6}"/>
               </a:ext>
             </a:extLst>
           </p:cNvPr>
@@ -4671,7 +4671,7 @@
     </p:spTree>
     <p:extLst>
       <p:ext uri="{BB962C8B-B14F-4D97-AF65-F5344CB8AC3E}">
-        <p14:creationId xmlns:p14="http://schemas.microsoft.com/office/powerpoint/2010/main" val="763724272"/>
+        <p14:creationId xmlns:p14="http://schemas.microsoft.com/office/powerpoint/2010/main" val="878010798"/>
       </p:ext>
     </p:extLst>
   </p:cSld>
@@ -4702,7 +4702,7 @@
           <p:cNvPr id="5" name="">
             <a:extLst xmlns:a="http://schemas.openxmlformats.org/drawingml/2006/main">
               <a:ext uri="{FF2B5EF4-FFF2-40B4-BE49-F238E27FC236}">
-                <a16:creationId xmlns:a16="http://schemas.microsoft.com/office/drawing/2014/main" id="{C9F012CE-4233-4904-A722-AE7FE04D20B3}"/>
+                <a16:creationId xmlns:a16="http://schemas.microsoft.com/office/drawing/2014/main" id="{0C99F830-9658-4419-95DA-1700713E59E2}"/>
               </a:ext>
             </a:extLst>
           </p:cNvPr>
@@ -5300,7 +5300,7 @@
           <p:cNvPr id="3" name="">
             <a:extLst xmlns:a="http://schemas.openxmlformats.org/drawingml/2006/main">
               <a:ext uri="{FF2B5EF4-FFF2-40B4-BE49-F238E27FC236}">
-                <a16:creationId xmlns:a16="http://schemas.microsoft.com/office/drawing/2014/main" id="{B60C709D-055A-4C29-B32B-DC4BED13616E}"/>
+                <a16:creationId xmlns:a16="http://schemas.microsoft.com/office/drawing/2014/main" id="{63454160-6682-4219-B648-756D8124ECC1}"/>
               </a:ext>
             </a:extLst>
           </p:cNvPr>
@@ -5357,7 +5357,7 @@
           <p:cNvPr id="4" name="">
             <a:extLst xmlns:a="http://schemas.openxmlformats.org/drawingml/2006/main">
               <a:ext uri="{FF2B5EF4-FFF2-40B4-BE49-F238E27FC236}">
-                <a16:creationId xmlns:a16="http://schemas.microsoft.com/office/drawing/2014/main" id="{293EA4C6-67FE-47F1-AA8A-6812C19F415C}"/>
+                <a16:creationId xmlns:a16="http://schemas.microsoft.com/office/drawing/2014/main" id="{5C9B6176-BDBE-4043-A74D-48553516FB95}"/>
               </a:ext>
             </a:extLst>
           </p:cNvPr>
@@ -5412,7 +5412,7 @@
     </p:spTree>
     <p:extLst>
       <p:ext uri="{BB962C8B-B14F-4D97-AF65-F5344CB8AC3E}">
-        <p14:creationId xmlns:p14="http://schemas.microsoft.com/office/powerpoint/2010/main" val="634953450"/>
+        <p14:creationId xmlns:p14="http://schemas.microsoft.com/office/powerpoint/2010/main" val="449971604"/>
       </p:ext>
     </p:extLst>
   </p:cSld>
@@ -5443,7 +5443,7 @@
           <p:cNvPr id="7" name="">
             <a:extLst xmlns:a="http://schemas.openxmlformats.org/drawingml/2006/main">
               <a:ext uri="{FF2B5EF4-FFF2-40B4-BE49-F238E27FC236}">
-                <a16:creationId xmlns:a16="http://schemas.microsoft.com/office/drawing/2014/main" id="{7089D806-6943-4E9D-8E44-115E0CD1A782}"/>
+                <a16:creationId xmlns:a16="http://schemas.microsoft.com/office/drawing/2014/main" id="{5091B94A-7D5A-4A2E-ADDE-20B8FA3E22C6}"/>
               </a:ext>
             </a:extLst>
           </p:cNvPr>
@@ -5500,7 +5500,7 @@
           <p:cNvPr id="2" name="">
             <a:extLst xmlns:a="http://schemas.openxmlformats.org/drawingml/2006/main">
               <a:ext uri="{FF2B5EF4-FFF2-40B4-BE49-F238E27FC236}">
-                <a16:creationId xmlns:a16="http://schemas.microsoft.com/office/drawing/2014/main" id="{9DA69286-668A-4D91-870F-CCB03FDF6DDE}"/>
+                <a16:creationId xmlns:a16="http://schemas.microsoft.com/office/drawing/2014/main" id="{33747CC5-E143-4EEB-9C39-DA50E941F292}"/>
               </a:ext>
             </a:extLst>
           </p:cNvPr>
@@ -5557,7 +5557,7 @@
           <p:cNvPr id="3" name="">
             <a:extLst xmlns:a="http://schemas.openxmlformats.org/drawingml/2006/main">
               <a:ext uri="{FF2B5EF4-FFF2-40B4-BE49-F238E27FC236}">
-                <a16:creationId xmlns:a16="http://schemas.microsoft.com/office/drawing/2014/main" id="{703A2954-A460-42E6-9EAB-46C42394271E}"/>
+                <a16:creationId xmlns:a16="http://schemas.microsoft.com/office/drawing/2014/main" id="{A8E7BDA7-8967-41E1-8555-AA69A325CF98}"/>
               </a:ext>
             </a:extLst>
           </p:cNvPr>
@@ -5614,7 +5614,7 @@
           <p:cNvPr id="4" name="">
             <a:extLst xmlns:a="http://schemas.openxmlformats.org/drawingml/2006/main">
               <a:ext uri="{FF2B5EF4-FFF2-40B4-BE49-F238E27FC236}">
-                <a16:creationId xmlns:a16="http://schemas.microsoft.com/office/drawing/2014/main" id="{2216F504-9762-457F-90D3-7D0C4F08733E}"/>
+                <a16:creationId xmlns:a16="http://schemas.microsoft.com/office/drawing/2014/main" id="{7419D53C-E036-43A2-A024-AF9184FF0CD8}"/>
               </a:ext>
             </a:extLst>
           </p:cNvPr>
@@ -5671,7 +5671,7 @@
           <p:cNvPr id="5" name="">
             <a:extLst xmlns:a="http://schemas.openxmlformats.org/drawingml/2006/main">
               <a:ext uri="{FF2B5EF4-FFF2-40B4-BE49-F238E27FC236}">
-                <a16:creationId xmlns:a16="http://schemas.microsoft.com/office/drawing/2014/main" id="{817C5154-B725-4AC3-AC57-1AC5936771FA}"/>
+                <a16:creationId xmlns:a16="http://schemas.microsoft.com/office/drawing/2014/main" id="{BAE38B42-E254-4D58-A37E-9D6B7C180CDF}"/>
               </a:ext>
             </a:extLst>
           </p:cNvPr>
@@ -5728,7 +5728,7 @@
           <p:cNvPr id="6" name="">
             <a:extLst xmlns:a="http://schemas.openxmlformats.org/drawingml/2006/main">
               <a:ext uri="{FF2B5EF4-FFF2-40B4-BE49-F238E27FC236}">
-                <a16:creationId xmlns:a16="http://schemas.microsoft.com/office/drawing/2014/main" id="{45B18250-427D-45D2-996A-455C0A1AA919}"/>
+                <a16:creationId xmlns:a16="http://schemas.microsoft.com/office/drawing/2014/main" id="{E9E4CBE3-280B-4C9C-8E7D-F7538F1C9702}"/>
               </a:ext>
             </a:extLst>
           </p:cNvPr>
@@ -5783,7 +5783,7 @@
     </p:spTree>
     <p:extLst>
       <p:ext uri="{BB962C8B-B14F-4D97-AF65-F5344CB8AC3E}">
-        <p14:creationId xmlns:p14="http://schemas.microsoft.com/office/powerpoint/2010/main" val="468127271"/>
+        <p14:creationId xmlns:p14="http://schemas.microsoft.com/office/powerpoint/2010/main" val="1974782901"/>
       </p:ext>
     </p:extLst>
   </p:cSld>
@@ -5814,7 +5814,7 @@
           <p:cNvPr id="6" name="">
             <a:extLst xmlns:a="http://schemas.openxmlformats.org/drawingml/2006/main">
               <a:ext uri="{FF2B5EF4-FFF2-40B4-BE49-F238E27FC236}">
-                <a16:creationId xmlns:a16="http://schemas.microsoft.com/office/drawing/2014/main" id="{918CDB20-8396-4759-8032-38595E4DF1FD}"/>
+                <a16:creationId xmlns:a16="http://schemas.microsoft.com/office/drawing/2014/main" id="{43C26871-C235-4302-B9E1-71E763EB5444}"/>
               </a:ext>
             </a:extLst>
           </p:cNvPr>
@@ -5878,7 +5878,7 @@
         </p:xfrm>
         <a:graphic xmlns:a="http://schemas.openxmlformats.org/drawingml/2006/main">
           <a:graphicData uri="http://schemas.openxmlformats.org/drawingml/2006/chart">
-            <c:chart xmlns:r="http://schemas.openxmlformats.org/officeDocument/2006/relationships" xmlns:c="http://schemas.openxmlformats.org/drawingml/2006/chart" r:id="R75f1ea2509674c1a"/>
+            <c:chart xmlns:r="http://schemas.openxmlformats.org/officeDocument/2006/relationships" xmlns:c="http://schemas.openxmlformats.org/drawingml/2006/chart" r:id="R86f9e2b0b1d647f0"/>
           </a:graphicData>
         </a:graphic>
       </p:graphicFrame>
@@ -5887,7 +5887,7 @@
           <p:cNvPr id="3" name="">
             <a:extLst xmlns:a="http://schemas.openxmlformats.org/drawingml/2006/main">
               <a:ext uri="{FF2B5EF4-FFF2-40B4-BE49-F238E27FC236}">
-                <a16:creationId xmlns:a16="http://schemas.microsoft.com/office/drawing/2014/main" id="{68A4E05C-AFAC-4588-8D20-41EF3AB4994C}"/>
+                <a16:creationId xmlns:a16="http://schemas.microsoft.com/office/drawing/2014/main" id="{675A055E-79FE-4476-BA3E-54C6950CCFEB}"/>
               </a:ext>
             </a:extLst>
           </p:cNvPr>
@@ -5944,7 +5944,7 @@
           <p:cNvPr id="4" name="">
             <a:extLst xmlns:a="http://schemas.openxmlformats.org/drawingml/2006/main">
               <a:ext uri="{FF2B5EF4-FFF2-40B4-BE49-F238E27FC236}">
-                <a16:creationId xmlns:a16="http://schemas.microsoft.com/office/drawing/2014/main" id="{28CFF585-9489-4D44-AA3C-A3DA8FE51211}"/>
+                <a16:creationId xmlns:a16="http://schemas.microsoft.com/office/drawing/2014/main" id="{691FC332-09D8-4B9F-84BB-F5511FECC8BE}"/>
               </a:ext>
             </a:extLst>
           </p:cNvPr>
@@ -6001,7 +6001,7 @@
           <p:cNvPr id="5" name="">
             <a:extLst xmlns:a="http://schemas.openxmlformats.org/drawingml/2006/main">
               <a:ext uri="{FF2B5EF4-FFF2-40B4-BE49-F238E27FC236}">
-                <a16:creationId xmlns:a16="http://schemas.microsoft.com/office/drawing/2014/main" id="{63B58838-7DF8-4BC0-BAC8-47E321CA1C5B}"/>
+                <a16:creationId xmlns:a16="http://schemas.microsoft.com/office/drawing/2014/main" id="{7BE2C4C4-CEA5-4810-89F9-7D4D9153E9F8}"/>
               </a:ext>
             </a:extLst>
           </p:cNvPr>
@@ -6056,7 +6056,7 @@
     </p:spTree>
     <p:extLst>
       <p:ext uri="{BB962C8B-B14F-4D97-AF65-F5344CB8AC3E}">
-        <p14:creationId xmlns:p14="http://schemas.microsoft.com/office/powerpoint/2010/main" val="1885816731"/>
+        <p14:creationId xmlns:p14="http://schemas.microsoft.com/office/powerpoint/2010/main" val="1362155132"/>
       </p:ext>
     </p:extLst>
   </p:cSld>
@@ -6087,7 +6087,7 @@
           <p:cNvPr id="6" name="">
             <a:extLst xmlns:a="http://schemas.openxmlformats.org/drawingml/2006/main">
               <a:ext uri="{FF2B5EF4-FFF2-40B4-BE49-F238E27FC236}">
-                <a16:creationId xmlns:a16="http://schemas.microsoft.com/office/drawing/2014/main" id="{41A3478D-239B-4FD6-B398-418664BAAC6F}"/>
+                <a16:creationId xmlns:a16="http://schemas.microsoft.com/office/drawing/2014/main" id="{B2EBBD9F-EC4C-4DD6-9D4B-475EA9041685}"/>
               </a:ext>
             </a:extLst>
           </p:cNvPr>
@@ -6151,7 +6151,7 @@
         </p:xfrm>
         <a:graphic xmlns:a="http://schemas.openxmlformats.org/drawingml/2006/main">
           <a:graphicData uri="http://schemas.openxmlformats.org/drawingml/2006/chart">
-            <c:chart xmlns:r="http://schemas.openxmlformats.org/officeDocument/2006/relationships" xmlns:c="http://schemas.openxmlformats.org/drawingml/2006/chart" r:id="R793da7610e52481a"/>
+            <c:chart xmlns:r="http://schemas.openxmlformats.org/officeDocument/2006/relationships" xmlns:c="http://schemas.openxmlformats.org/drawingml/2006/chart" r:id="R6ac4eb01f7914de1"/>
           </a:graphicData>
         </a:graphic>
       </p:graphicFrame>
@@ -6160,7 +6160,7 @@
           <p:cNvPr id="3" name="">
             <a:extLst xmlns:a="http://schemas.openxmlformats.org/drawingml/2006/main">
               <a:ext uri="{FF2B5EF4-FFF2-40B4-BE49-F238E27FC236}">
-                <a16:creationId xmlns:a16="http://schemas.microsoft.com/office/drawing/2014/main" id="{9DCF8132-24EC-4BC8-8F09-97666DBD22E3}"/>
+                <a16:creationId xmlns:a16="http://schemas.microsoft.com/office/drawing/2014/main" id="{C475AF59-EA23-4F1D-B9C0-6982758EC06D}"/>
               </a:ext>
             </a:extLst>
           </p:cNvPr>
@@ -6217,7 +6217,7 @@
           <p:cNvPr id="4" name="">
             <a:extLst xmlns:a="http://schemas.openxmlformats.org/drawingml/2006/main">
               <a:ext uri="{FF2B5EF4-FFF2-40B4-BE49-F238E27FC236}">
-                <a16:creationId xmlns:a16="http://schemas.microsoft.com/office/drawing/2014/main" id="{A22C8F48-1E39-45D1-ADB6-0CBF0167C770}"/>
+                <a16:creationId xmlns:a16="http://schemas.microsoft.com/office/drawing/2014/main" id="{7931B7DD-E8E0-4151-8CC9-C165F0E04DA0}"/>
               </a:ext>
             </a:extLst>
           </p:cNvPr>
@@ -6274,7 +6274,7 @@
           <p:cNvPr id="5" name="">
             <a:extLst xmlns:a="http://schemas.openxmlformats.org/drawingml/2006/main">
               <a:ext uri="{FF2B5EF4-FFF2-40B4-BE49-F238E27FC236}">
-                <a16:creationId xmlns:a16="http://schemas.microsoft.com/office/drawing/2014/main" id="{89289454-7D18-4A5A-95FD-58D4E396AA96}"/>
+                <a16:creationId xmlns:a16="http://schemas.microsoft.com/office/drawing/2014/main" id="{43343013-77A7-4025-998E-8FC1B3F84DB0}"/>
               </a:ext>
             </a:extLst>
           </p:cNvPr>
@@ -6329,7 +6329,7 @@
     </p:spTree>
     <p:extLst>
       <p:ext uri="{BB962C8B-B14F-4D97-AF65-F5344CB8AC3E}">
-        <p14:creationId xmlns:p14="http://schemas.microsoft.com/office/powerpoint/2010/main" val="1956876349"/>
+        <p14:creationId xmlns:p14="http://schemas.microsoft.com/office/powerpoint/2010/main" val="28034378"/>
       </p:ext>
     </p:extLst>
   </p:cSld>
@@ -6360,7 +6360,7 @@
           <p:cNvPr id="6" name="">
             <a:extLst xmlns:a="http://schemas.openxmlformats.org/drawingml/2006/main">
               <a:ext uri="{FF2B5EF4-FFF2-40B4-BE49-F238E27FC236}">
-                <a16:creationId xmlns:a16="http://schemas.microsoft.com/office/drawing/2014/main" id="{CB1C892F-190F-4618-9458-78A7B97C5D40}"/>
+                <a16:creationId xmlns:a16="http://schemas.microsoft.com/office/drawing/2014/main" id="{20D8806F-FDE1-400A-8CA4-E12911AF7382}"/>
               </a:ext>
             </a:extLst>
           </p:cNvPr>
@@ -6424,7 +6424,7 @@
         </p:xfrm>
         <a:graphic xmlns:a="http://schemas.openxmlformats.org/drawingml/2006/main">
           <a:graphicData uri="http://schemas.openxmlformats.org/drawingml/2006/chart">
-            <c:chart xmlns:r="http://schemas.openxmlformats.org/officeDocument/2006/relationships" xmlns:c="http://schemas.openxmlformats.org/drawingml/2006/chart" r:id="Rec74396d5b6c4b45"/>
+            <c:chart xmlns:r="http://schemas.openxmlformats.org/officeDocument/2006/relationships" xmlns:c="http://schemas.openxmlformats.org/drawingml/2006/chart" r:id="Ra01dff03dab14960"/>
           </a:graphicData>
         </a:graphic>
       </p:graphicFrame>
@@ -6433,7 +6433,7 @@
           <p:cNvPr id="3" name="">
             <a:extLst xmlns:a="http://schemas.openxmlformats.org/drawingml/2006/main">
               <a:ext uri="{FF2B5EF4-FFF2-40B4-BE49-F238E27FC236}">
-                <a16:creationId xmlns:a16="http://schemas.microsoft.com/office/drawing/2014/main" id="{A05B36AC-4362-441A-A8E8-D7F167CA2AAE}"/>
+                <a16:creationId xmlns:a16="http://schemas.microsoft.com/office/drawing/2014/main" id="{A03B049F-E6C8-4E47-88DA-639CA9744F02}"/>
               </a:ext>
             </a:extLst>
           </p:cNvPr>
@@ -6490,7 +6490,7 @@
           <p:cNvPr id="4" name="">
             <a:extLst xmlns:a="http://schemas.openxmlformats.org/drawingml/2006/main">
               <a:ext uri="{FF2B5EF4-FFF2-40B4-BE49-F238E27FC236}">
-                <a16:creationId xmlns:a16="http://schemas.microsoft.com/office/drawing/2014/main" id="{8AB9FF83-3E8C-4F45-AE03-A25D628AC913}"/>
+                <a16:creationId xmlns:a16="http://schemas.microsoft.com/office/drawing/2014/main" id="{DC574A49-AEE8-4FA9-B276-BD2FEA0F1D74}"/>
               </a:ext>
             </a:extLst>
           </p:cNvPr>
@@ -6547,7 +6547,7 @@
           <p:cNvPr id="5" name="">
             <a:extLst xmlns:a="http://schemas.openxmlformats.org/drawingml/2006/main">
               <a:ext uri="{FF2B5EF4-FFF2-40B4-BE49-F238E27FC236}">
-                <a16:creationId xmlns:a16="http://schemas.microsoft.com/office/drawing/2014/main" id="{405A24EE-BCF4-4F63-8893-6F04CC50CCD4}"/>
+                <a16:creationId xmlns:a16="http://schemas.microsoft.com/office/drawing/2014/main" id="{940FDE9C-0453-4EF2-9A67-03EFAC38B831}"/>
               </a:ext>
             </a:extLst>
           </p:cNvPr>
@@ -6602,7 +6602,7 @@
     </p:spTree>
     <p:extLst>
       <p:ext uri="{BB962C8B-B14F-4D97-AF65-F5344CB8AC3E}">
-        <p14:creationId xmlns:p14="http://schemas.microsoft.com/office/powerpoint/2010/main" val="1464186022"/>
+        <p14:creationId xmlns:p14="http://schemas.microsoft.com/office/powerpoint/2010/main" val="1249343541"/>
       </p:ext>
     </p:extLst>
   </p:cSld>
@@ -6633,7 +6633,7 @@
           <p:cNvPr id="7" name="">
             <a:extLst xmlns:a="http://schemas.openxmlformats.org/drawingml/2006/main">
               <a:ext uri="{FF2B5EF4-FFF2-40B4-BE49-F238E27FC236}">
-                <a16:creationId xmlns:a16="http://schemas.microsoft.com/office/drawing/2014/main" id="{CFB37887-14CB-4CEF-9FCC-A79A48E45348}"/>
+                <a16:creationId xmlns:a16="http://schemas.microsoft.com/office/drawing/2014/main" id="{C97CD6DD-8D66-4F5B-968A-8A7859FABF54}"/>
               </a:ext>
             </a:extLst>
           </p:cNvPr>
@@ -6690,7 +6690,7 @@
           <p:cNvPr id="2" name="">
             <a:extLst xmlns:a="http://schemas.openxmlformats.org/drawingml/2006/main">
               <a:ext uri="{FF2B5EF4-FFF2-40B4-BE49-F238E27FC236}">
-                <a16:creationId xmlns:a16="http://schemas.microsoft.com/office/drawing/2014/main" id="{AF9ED4D3-D6FC-4067-A9E2-8C8194706A95}"/>
+                <a16:creationId xmlns:a16="http://schemas.microsoft.com/office/drawing/2014/main" id="{8F5154F9-9825-4C53-B54D-10886C6596B1}"/>
               </a:ext>
             </a:extLst>
           </p:cNvPr>
@@ -6747,7 +6747,7 @@
           <p:cNvPr id="3" name="">
             <a:extLst xmlns:a="http://schemas.openxmlformats.org/drawingml/2006/main">
               <a:ext uri="{FF2B5EF4-FFF2-40B4-BE49-F238E27FC236}">
-                <a16:creationId xmlns:a16="http://schemas.microsoft.com/office/drawing/2014/main" id="{6B308BE8-CCAC-4052-9C56-F04830A24F19}"/>
+                <a16:creationId xmlns:a16="http://schemas.microsoft.com/office/drawing/2014/main" id="{5C10CAD5-A09F-41AE-9B4C-3D72D17C0CCE}"/>
               </a:ext>
             </a:extLst>
           </p:cNvPr>
@@ -6804,7 +6804,7 @@
           <p:cNvPr id="4" name="">
             <a:extLst xmlns:a="http://schemas.openxmlformats.org/drawingml/2006/main">
               <a:ext uri="{FF2B5EF4-FFF2-40B4-BE49-F238E27FC236}">
-                <a16:creationId xmlns:a16="http://schemas.microsoft.com/office/drawing/2014/main" id="{935991A1-2D89-47C3-B240-12E64F42F5DA}"/>
+                <a16:creationId xmlns:a16="http://schemas.microsoft.com/office/drawing/2014/main" id="{AE0FF1B3-89C3-49FB-B976-44B1176F2B76}"/>
               </a:ext>
             </a:extLst>
           </p:cNvPr>
@@ -6861,7 +6861,7 @@
           <p:cNvPr id="5" name="">
             <a:extLst xmlns:a="http://schemas.openxmlformats.org/drawingml/2006/main">
               <a:ext uri="{FF2B5EF4-FFF2-40B4-BE49-F238E27FC236}">
-                <a16:creationId xmlns:a16="http://schemas.microsoft.com/office/drawing/2014/main" id="{2B763E9E-5874-4E88-BC79-7AC5D0C3A053}"/>
+                <a16:creationId xmlns:a16="http://schemas.microsoft.com/office/drawing/2014/main" id="{09BE835F-E0EC-4F71-B8D5-E454B106A8E7}"/>
               </a:ext>
             </a:extLst>
           </p:cNvPr>
@@ -6918,7 +6918,7 @@
           <p:cNvPr id="6" name="">
             <a:extLst xmlns:a="http://schemas.openxmlformats.org/drawingml/2006/main">
               <a:ext uri="{FF2B5EF4-FFF2-40B4-BE49-F238E27FC236}">
-                <a16:creationId xmlns:a16="http://schemas.microsoft.com/office/drawing/2014/main" id="{7061AFE3-28B6-446A-BF52-0EDC1883528B}"/>
+                <a16:creationId xmlns:a16="http://schemas.microsoft.com/office/drawing/2014/main" id="{F1942667-9628-4951-92B2-5490AEE0C617}"/>
               </a:ext>
             </a:extLst>
           </p:cNvPr>
@@ -6973,7 +6973,7 @@
     </p:spTree>
     <p:extLst>
       <p:ext uri="{BB962C8B-B14F-4D97-AF65-F5344CB8AC3E}">
-        <p14:creationId xmlns:p14="http://schemas.microsoft.com/office/powerpoint/2010/main" val="906096939"/>
+        <p14:creationId xmlns:p14="http://schemas.microsoft.com/office/powerpoint/2010/main" val="804945607"/>
       </p:ext>
     </p:extLst>
   </p:cSld>
@@ -7004,7 +7004,7 @@
           <p:cNvPr id="6" name="">
             <a:extLst xmlns:a="http://schemas.openxmlformats.org/drawingml/2006/main">
               <a:ext uri="{FF2B5EF4-FFF2-40B4-BE49-F238E27FC236}">
-                <a16:creationId xmlns:a16="http://schemas.microsoft.com/office/drawing/2014/main" id="{FCFE8DD2-87A2-470B-9765-BD8B37290E16}"/>
+                <a16:creationId xmlns:a16="http://schemas.microsoft.com/office/drawing/2014/main" id="{04BA06ED-1B99-4E1B-80B3-A46C740ABD01}"/>
               </a:ext>
             </a:extLst>
           </p:cNvPr>
@@ -7068,7 +7068,7 @@
         </p:xfrm>
         <a:graphic xmlns:a="http://schemas.openxmlformats.org/drawingml/2006/main">
           <a:graphicData uri="http://schemas.openxmlformats.org/drawingml/2006/chart">
-            <c:chart xmlns:r="http://schemas.openxmlformats.org/officeDocument/2006/relationships" xmlns:c="http://schemas.openxmlformats.org/drawingml/2006/chart" r:id="R0a2de909c4bb4d04"/>
+            <c:chart xmlns:r="http://schemas.openxmlformats.org/officeDocument/2006/relationships" xmlns:c="http://schemas.openxmlformats.org/drawingml/2006/chart" r:id="R9c1cf32badd44c25"/>
           </a:graphicData>
         </a:graphic>
       </p:graphicFrame>
@@ -7077,7 +7077,7 @@
           <p:cNvPr id="3" name="">
             <a:extLst xmlns:a="http://schemas.openxmlformats.org/drawingml/2006/main">
               <a:ext uri="{FF2B5EF4-FFF2-40B4-BE49-F238E27FC236}">
-                <a16:creationId xmlns:a16="http://schemas.microsoft.com/office/drawing/2014/main" id="{40F997D9-1C0C-4594-AC50-0271C76EA392}"/>
+                <a16:creationId xmlns:a16="http://schemas.microsoft.com/office/drawing/2014/main" id="{4EA86F7E-5C75-459D-A329-0F9E76470EAD}"/>
               </a:ext>
             </a:extLst>
           </p:cNvPr>
@@ -7134,7 +7134,7 @@
           <p:cNvPr id="4" name="">
             <a:extLst xmlns:a="http://schemas.openxmlformats.org/drawingml/2006/main">
               <a:ext uri="{FF2B5EF4-FFF2-40B4-BE49-F238E27FC236}">
-                <a16:creationId xmlns:a16="http://schemas.microsoft.com/office/drawing/2014/main" id="{8ED12023-1625-466D-936B-2B6EF2B81098}"/>
+                <a16:creationId xmlns:a16="http://schemas.microsoft.com/office/drawing/2014/main" id="{1609F0DC-B8FE-4B47-865C-E5CB033C2C1C}"/>
               </a:ext>
             </a:extLst>
           </p:cNvPr>
@@ -7181,7 +7181,7 @@
                 <a:ea typeface="Helvetica Neue"/>
                 <a:cs typeface="Helvetica Neue"/>
               </a:rPr>
-              <a:t>13/16 initial errors have correct reasons but wrong final fields.</a:t>
+              <a:t>13/16 initial errors have correct reason endpoints, but wrong final fields.</a:t>
             </a:r>
           </a:p>
         </p:txBody>
@@ -7191,7 +7191,7 @@
           <p:cNvPr id="5" name="">
             <a:extLst xmlns:a="http://schemas.openxmlformats.org/drawingml/2006/main">
               <a:ext uri="{FF2B5EF4-FFF2-40B4-BE49-F238E27FC236}">
-                <a16:creationId xmlns:a16="http://schemas.microsoft.com/office/drawing/2014/main" id="{E4CE481F-5129-45B2-BD05-17DCD2BC3FCA}"/>
+                <a16:creationId xmlns:a16="http://schemas.microsoft.com/office/drawing/2014/main" id="{793DDF1D-4AA1-4986-93C8-C7929071F43D}"/>
               </a:ext>
             </a:extLst>
           </p:cNvPr>
@@ -7246,7 +7246,7 @@
     </p:spTree>
     <p:extLst>
       <p:ext uri="{BB962C8B-B14F-4D97-AF65-F5344CB8AC3E}">
-        <p14:creationId xmlns:p14="http://schemas.microsoft.com/office/powerpoint/2010/main" val="466372340"/>
+        <p14:creationId xmlns:p14="http://schemas.microsoft.com/office/powerpoint/2010/main" val="229315280"/>
       </p:ext>
     </p:extLst>
   </p:cSld>

</xml_diff>

<commit_message>
Update presentation and report with paired analysis and team names
</commit_message>
<xml_diff>
--- a/Submission_Pack/COMP2501_presentation.pptx
+++ b/Submission_Pack/COMP2501_presentation.pptx
@@ -2,24 +2,28 @@
 <file path=ppt/presentation.xml><?xml version="1.0" encoding="utf-8"?>
 <p:presentation xmlns:p="http://schemas.openxmlformats.org/presentationml/2006/main">
   <p:sldMasterIdLst>
-    <p:sldMasterId xmlns:r="http://schemas.openxmlformats.org/officeDocument/2006/relationships" id="2147483648" r:id="R5c04dc6d38774e7d"/>
+    <p:sldMasterId xmlns:r="http://schemas.openxmlformats.org/officeDocument/2006/relationships" id="2147483648" r:id="Ra935f0b61a594560"/>
   </p:sldMasterIdLst>
   <p:notesMasterIdLst>
-    <p:notesMasterId xmlns:r="http://schemas.openxmlformats.org/officeDocument/2006/relationships" r:id="R1f59e7378de84f4a"/>
+    <p:notesMasterId xmlns:r="http://schemas.openxmlformats.org/officeDocument/2006/relationships" r:id="R807073ce51b24302"/>
   </p:notesMasterIdLst>
   <p:sldIdLst>
-    <p:sldId xmlns:r="http://schemas.openxmlformats.org/officeDocument/2006/relationships" id="256" r:id="Rb68cadcb769e415d"/>
-    <p:sldId xmlns:r="http://schemas.openxmlformats.org/officeDocument/2006/relationships" id="257" r:id="R096c9602e1a64d06"/>
-    <p:sldId xmlns:r="http://schemas.openxmlformats.org/officeDocument/2006/relationships" id="258" r:id="Recea99c7a38a4890"/>
-    <p:sldId xmlns:r="http://schemas.openxmlformats.org/officeDocument/2006/relationships" id="259" r:id="Rf19d0b76fd474167"/>
-    <p:sldId xmlns:r="http://schemas.openxmlformats.org/officeDocument/2006/relationships" id="260" r:id="Ra03d3eaa6195465d"/>
-    <p:sldId xmlns:r="http://schemas.openxmlformats.org/officeDocument/2006/relationships" id="261" r:id="R3767471ff44a43d8"/>
-    <p:sldId xmlns:r="http://schemas.openxmlformats.org/officeDocument/2006/relationships" id="262" r:id="R7fd9f347a5a747a1"/>
-    <p:sldId xmlns:r="http://schemas.openxmlformats.org/officeDocument/2006/relationships" id="263" r:id="R45e77c8f51724d44"/>
-    <p:sldId xmlns:r="http://schemas.openxmlformats.org/officeDocument/2006/relationships" id="264" r:id="Rbcd86a1648304d70"/>
-    <p:sldId xmlns:r="http://schemas.openxmlformats.org/officeDocument/2006/relationships" id="265" r:id="Rd42af67eb2e34a14"/>
-    <p:sldId xmlns:r="http://schemas.openxmlformats.org/officeDocument/2006/relationships" id="266" r:id="Rc1a38be15f8a4667"/>
-    <p:sldId xmlns:r="http://schemas.openxmlformats.org/officeDocument/2006/relationships" id="267" r:id="R7bdd4cae5cb84856"/>
+    <p:sldId xmlns:r="http://schemas.openxmlformats.org/officeDocument/2006/relationships" id="256" r:id="R9e86e4c14e1249c4"/>
+    <p:sldId xmlns:r="http://schemas.openxmlformats.org/officeDocument/2006/relationships" id="257" r:id="R135c2e2506c640bf"/>
+    <p:sldId xmlns:r="http://schemas.openxmlformats.org/officeDocument/2006/relationships" id="258" r:id="Ra3c2f15c9c1d4d49"/>
+    <p:sldId xmlns:r="http://schemas.openxmlformats.org/officeDocument/2006/relationships" id="259" r:id="Rbc04ddadfc974242"/>
+    <p:sldId xmlns:r="http://schemas.openxmlformats.org/officeDocument/2006/relationships" id="260" r:id="R20219956a9214861"/>
+    <p:sldId xmlns:r="http://schemas.openxmlformats.org/officeDocument/2006/relationships" id="261" r:id="R07d6e8a3e13a495e"/>
+    <p:sldId xmlns:r="http://schemas.openxmlformats.org/officeDocument/2006/relationships" id="262" r:id="R3e929b366d8c496d"/>
+    <p:sldId xmlns:r="http://schemas.openxmlformats.org/officeDocument/2006/relationships" id="263" r:id="R3949103a8556457f"/>
+    <p:sldId xmlns:r="http://schemas.openxmlformats.org/officeDocument/2006/relationships" id="264" r:id="R78a5225447604c9f"/>
+    <p:sldId xmlns:r="http://schemas.openxmlformats.org/officeDocument/2006/relationships" id="265" r:id="Rd6ad835e34b24351"/>
+    <p:sldId xmlns:r="http://schemas.openxmlformats.org/officeDocument/2006/relationships" id="266" r:id="R294e1a6c30f445c3"/>
+    <p:sldId xmlns:r="http://schemas.openxmlformats.org/officeDocument/2006/relationships" id="267" r:id="Rb4d65b5814434a56"/>
+    <p:sldId xmlns:r="http://schemas.openxmlformats.org/officeDocument/2006/relationships" id="268" r:id="Rdfb64ca2db254175"/>
+    <p:sldId xmlns:r="http://schemas.openxmlformats.org/officeDocument/2006/relationships" id="269" r:id="R6df266a29a5a4564"/>
+    <p:sldId xmlns:r="http://schemas.openxmlformats.org/officeDocument/2006/relationships" id="270" r:id="R5af0bf2c07df406a"/>
+    <p:sldId xmlns:r="http://schemas.openxmlformats.org/officeDocument/2006/relationships" id="271" r:id="R427a19d023c949d2"/>
   </p:sldIdLst>
   <p:sldSz cx="12192000" cy="6858000"/>
   <p:notesSz cx="6858000" cy="9144000"/>
@@ -453,7 +457,7 @@
           <a:lstStyle xmlns:a="http://schemas.openxmlformats.org/drawingml/2006/main"/>
           <a:p xmlns:a="http://schemas.openxmlformats.org/drawingml/2006/main">
             <a:r>
-              <a:t>20 seconds. Introduce the concrete question: if we ask an AI to check another AI, do we gain reliability or merely become more cautious? The tested method is one follow-up prompt, not browsing, an ensemble or retraining. </a:t>
+              <a:t>30 seconds. Introduce LINYUNIAN and PAN ZHENGYU. The project asks whether structured checking helps resist misleading input. AI-generated suggestions simulate a person bringing an assumption or explanation into an AI conversation. The actual source label says another AI. We measured no human behavior. </a:t>
             </a:r>
           </a:p>
           <a:p xmlns:a="http://schemas.openxmlformats.org/drawingml/2006/main">
@@ -528,12 +532,12 @@
           <a:lstStyle xmlns:a="http://schemas.openxmlformats.org/drawingml/2006/main"/>
           <a:p xmlns:a="http://schemas.openxmlformats.org/drawingml/2006/main">
             <a:r>
-              <a:t>45 seconds. Explain limitations that affect inference: selected dates, low baseline accuracy, few harmful flips, disputed references and partial human review. The math schema cues logical categories. Generated arguments follow assigned faulty routes. The original balanced math viability criterion failed and is transparently documented. </a:t>
-            </a:r>
-          </a:p>
-          <a:p xmlns:a="http://schemas.openxmlformats.org/drawingml/2006/main">
-            <a:r>
-              <a:t>Sources: https://github.com/ThomasLin070217/comp2501-ai-reliability/blob/main/Math_Supplement/protocol/deviations.md</a:t>
+              <a:t>90 seconds. Notepad++ version 7.8.8 has official release date June 28 2020. The same MiniMax repeat in parallel branches cannot confirm under C0, answers June 29 under C1 and C2, and abstains under C3 because the explanation gives no verifiable evidence. The exact C1 phrase is as confirmed by the official Notepad++ release notes. The receiver had no search tool. A correct date or confident verification phrase does not prove a lookup occurred. Preserve the counterexample: DeepSeek repeat 0 C4 is correct and C5 gives June 4. </a:t>
+            </a:r>
+          </a:p>
+          <a:p xmlns:a="http://schemas.openxmlformats.org/drawingml/2006/main">
+            <a:r>
+              <a:t>Sources: https://github.com/notepad-plus-plus/notepad-plus-plus/wiki/Changes-v7#788</a:t>
             </a:r>
           </a:p>
         </p:txBody>
@@ -603,17 +607,17 @@
           <a:lstStyle xmlns:a="http://schemas.openxmlformats.org/drawingml/2006/main"/>
           <a:p xmlns:a="http://schemas.openxmlformats.org/drawingml/2006/main">
             <a:r>
-              <a:t>40 seconds. Give the proposed next solution: display candidate, uncertainty and source support separately, then validate through a trusted source or executable check. We did not test that retrieval/tool arm, so it is a future experiment rather than a claimed measured improvement. </a:t>
-            </a:r>
-          </a:p>
-          <a:p xmlns:a="http://schemas.openxmlformats.org/drawingml/2006/main">
-            <a:r>
-              <a:t>Sources: https://arxiv.org/abs/2005.11401</a:t>
-            </a:r>
-          </a:p>
-          <a:p xmlns:a="http://schemas.openxmlformats.org/drawingml/2006/main">
-            <a:r>
-              <a:t>https://aclanthology.org/2024.findings-acl.212/</a:t>
+              <a:t>60 seconds. Codex read 240 pairs containing 451 distinct responses, including all 144 C2-wrong/C3-abstain pairs. Among the 144, 114 withhold a date, 25 offer only unconfirmed candidates, 3 challenge the premise and 2 retain date assertions. Remaining background claims were not exhaustively checked. Telegram C3 still claims premium animated emoji in December 2021, conflicting with its official August 2022 introduction. No additional manual labeling is required for this delivery, and no independent human validation is claimed. </a:t>
+            </a:r>
+          </a:p>
+          <a:p xmlns:a="http://schemas.openxmlformats.org/drawingml/2006/main">
+            <a:r>
+              <a:t>Sources: https://github.com/ThomasLin070217/comp2501-ai-reliability/blob/main/Peer_Misleading_Study/reports/interaction_posthoc/ai_case_review.csv</a:t>
+            </a:r>
+          </a:p>
+          <a:p xmlns:a="http://schemas.openxmlformats.org/drawingml/2006/main">
+            <a:r>
+              <a:t>https://telegram.org/blog/custom-emoji?setln=en</a:t>
             </a:r>
           </a:p>
         </p:txBody>
@@ -683,7 +687,317 @@
           <a:lstStyle xmlns:a="http://schemas.openxmlformats.org/drawingml/2006/main"/>
           <a:p xmlns:a="http://schemas.openxmlformats.org/drawingml/2006/main">
             <a:r>
-              <a:t>20 seconds. Acknowledge data and papers, R packages, and AI assistance. Codex built and checked much of the implementation; Claude Code was configured to Kimi. A user filled 45 targeted records; full independent human annotation remains pending. Invite questions without claiming all generated explanations were human validated. </a:t>
+              <a:t>60 seconds. Ask the audience whether area is 50. Side length 10 forces height about 8.66, so conditions are inconsistent. Correct rejection of a contradictory premise is a mathematical conclusion, not the model refusing from uncertainty. This is MathTrap Table 13, a historical GPT-4-0125-preview failure; no claim every current model fails this exact item. </a:t>
+            </a:r>
+          </a:p>
+          <a:p xmlns:a="http://schemas.openxmlformats.org/drawingml/2006/main">
+            <a:r>
+              <a:t>Sources: https://aclanthology.org/2024.emnlp-main.915/ (Table 13)</a:t>
+            </a:r>
+          </a:p>
+          <a:p xmlns:a="http://schemas.openxmlformats.org/drawingml/2006/main">
+            <a:r>
+              <a:t>https://machinelearning.apple.com/research/gsm-symbolic</a:t>
+            </a:r>
+          </a:p>
+        </p:txBody>
+      </p:sp>
+      <p:sp>
+        <p:nvSpPr>
+          <p:cNvPr id="4" name="Slide Number Placeholder 3"/>
+          <p:cNvSpPr>
+            <a:spLocks xmlns:a="http://schemas.openxmlformats.org/drawingml/2006/main" noGrp="1"/>
+          </p:cNvSpPr>
+          <p:nvPr>
+            <p:ph type="sldNum" idx="5"/>
+          </p:nvPr>
+        </p:nvSpPr>
+        <p:spPr/>
+        <p:txBody>
+          <a:bodyPr xmlns:a="http://schemas.openxmlformats.org/drawingml/2006/main"/>
+          <a:lstStyle xmlns:a="http://schemas.openxmlformats.org/drawingml/2006/main"/>
+          <a:p xmlns:a="http://schemas.openxmlformats.org/drawingml/2006/main"/>
+        </p:txBody>
+      </p:sp>
+    </p:spTree>
+  </p:cSld>
+  <p:clrMapOvr>
+    <a:masterClrMapping xmlns:a="http://schemas.openxmlformats.org/drawingml/2006/main"/>
+  </p:clrMapOvr>
+</p:notes>
+</file>
+
+<file path=ppt/notesSlides/notesSlide13.xml><?xml version="1.0" encoding="utf-8"?>
+<p:notes xmlns:p="http://schemas.openxmlformats.org/presentationml/2006/main">
+  <p:cSld>
+    <p:spTree>
+      <p:nvGrpSpPr>
+        <p:cNvPr id="1" name=""/>
+        <p:cNvGrpSpPr/>
+        <p:nvPr/>
+      </p:nvGrpSpPr>
+      <p:grpSpPr>
+        <a:xfrm xmlns:a="http://schemas.openxmlformats.org/drawingml/2006/main"/>
+      </p:grpSpPr>
+      <p:sp>
+        <p:nvSpPr>
+          <p:cNvPr id="2" name="Slide Image Placeholder 1"/>
+          <p:cNvSpPr>
+            <a:spLocks xmlns:a="http://schemas.openxmlformats.org/drawingml/2006/main" noGrp="1"/>
+          </p:cNvSpPr>
+          <p:nvPr>
+            <p:ph type="sldImg" idx="0"/>
+          </p:nvPr>
+        </p:nvSpPr>
+        <p:spPr/>
+      </p:sp>
+      <p:sp>
+        <p:nvSpPr>
+          <p:cNvPr id="3" name="Notes Placeholder 2"/>
+          <p:cNvSpPr>
+            <a:spLocks xmlns:a="http://schemas.openxmlformats.org/drawingml/2006/main" noGrp="1"/>
+          </p:cNvSpPr>
+          <p:nvPr>
+            <p:ph type="body" idx="1"/>
+          </p:nvPr>
+        </p:nvSpPr>
+        <p:spPr/>
+        <p:txBody>
+          <a:bodyPr xmlns:a="http://schemas.openxmlformats.org/drawingml/2006/main"/>
+          <a:lstStyle xmlns:a="http://schemas.openxmlformats.org/drawingml/2006/main"/>
+          <a:p xmlns:a="http://schemas.openxmlformats.org/drawingml/2006/main">
+            <a:r>
+              <a:t>70 seconds. Read the current math counts from the slide, keeping the supplement separate from factual results. None of 55 initially correct units flipped. C0 alone reaches 68/71. Thirteen of 16 initial field errors already have a correct endpoint in the reason, so do not describe all gains as logical repairs. State 13 of 16 planned items passed peer-material quality; only three families have complete trap/control coverage. Numbers and repeated outputs are dependent. This is descriptive evidence and not a benchmark or universal method ranking. </a:t>
+            </a:r>
+          </a:p>
+          <a:p xmlns:a="http://schemas.openxmlformats.org/drawingml/2006/main">
+            <a:r>
+              <a:t>Sources: https://github.com/ThomasLin070217/comp2501-ai-reliability/tree/main/Math_Supplement</a:t>
+            </a:r>
+          </a:p>
+        </p:txBody>
+      </p:sp>
+      <p:sp>
+        <p:nvSpPr>
+          <p:cNvPr id="4" name="Slide Number Placeholder 3"/>
+          <p:cNvSpPr>
+            <a:spLocks xmlns:a="http://schemas.openxmlformats.org/drawingml/2006/main" noGrp="1"/>
+          </p:cNvSpPr>
+          <p:nvPr>
+            <p:ph type="sldNum" idx="5"/>
+          </p:nvPr>
+        </p:nvSpPr>
+        <p:spPr/>
+        <p:txBody>
+          <a:bodyPr xmlns:a="http://schemas.openxmlformats.org/drawingml/2006/main"/>
+          <a:lstStyle xmlns:a="http://schemas.openxmlformats.org/drawingml/2006/main"/>
+          <a:p xmlns:a="http://schemas.openxmlformats.org/drawingml/2006/main"/>
+        </p:txBody>
+      </p:sp>
+    </p:spTree>
+  </p:cSld>
+  <p:clrMapOvr>
+    <a:masterClrMapping xmlns:a="http://schemas.openxmlformats.org/drawingml/2006/main"/>
+  </p:clrMapOvr>
+</p:notes>
+</file>
+
+<file path=ppt/notesSlides/notesSlide14.xml><?xml version="1.0" encoding="utf-8"?>
+<p:notes xmlns:p="http://schemas.openxmlformats.org/presentationml/2006/main">
+  <p:cSld>
+    <p:spTree>
+      <p:nvGrpSpPr>
+        <p:cNvPr id="1" name=""/>
+        <p:cNvGrpSpPr/>
+        <p:nvPr/>
+      </p:nvGrpSpPr>
+      <p:grpSpPr>
+        <a:xfrm xmlns:a="http://schemas.openxmlformats.org/drawingml/2006/main"/>
+      </p:grpSpPr>
+      <p:sp>
+        <p:nvSpPr>
+          <p:cNvPr id="2" name="Slide Image Placeholder 1"/>
+          <p:cNvSpPr>
+            <a:spLocks xmlns:a="http://schemas.openxmlformats.org/drawingml/2006/main" noGrp="1"/>
+          </p:cNvSpPr>
+          <p:nvPr>
+            <p:ph type="sldImg" idx="0"/>
+          </p:nvPr>
+        </p:nvSpPr>
+        <p:spPr/>
+      </p:sp>
+      <p:sp>
+        <p:nvSpPr>
+          <p:cNvPr id="3" name="Notes Placeholder 2"/>
+          <p:cNvSpPr>
+            <a:spLocks xmlns:a="http://schemas.openxmlformats.org/drawingml/2006/main" noGrp="1"/>
+          </p:cNvSpPr>
+          <p:nvPr>
+            <p:ph type="body" idx="1"/>
+          </p:nvPr>
+        </p:nvSpPr>
+        <p:spPr/>
+        <p:txBody>
+          <a:bodyPr xmlns:a="http://schemas.openxmlformats.org/drawingml/2006/main"/>
+          <a:lstStyle xmlns:a="http://schemas.openxmlformats.org/drawingml/2006/main"/>
+          <a:p xmlns:a="http://schemas.openxmlformats.org/drawingml/2006/main">
+            <a:r>
+              <a:t>60 seconds. Explain selected difficult date questions, model differences and source concerns. MiniMax C2 versus C0 error change is -1.67 points with interval [-8.40,5.42], unlike the pooled increase. Both source-exclusion variants preserve pooled directions. The AI semantic review is targeted and unblinded. Human thinking was not measured. Mathematical material eligibility failed the original balanced design and remains a partial supplement. </a:t>
+            </a:r>
+          </a:p>
+          <a:p xmlns:a="http://schemas.openxmlformats.org/drawingml/2006/main">
+            <a:r>
+              <a:t>Sources: https://github.com/ThomasLin070217/comp2501-ai-reliability/blob/main/Math_Supplement/protocol/deviations.md</a:t>
+            </a:r>
+          </a:p>
+        </p:txBody>
+      </p:sp>
+      <p:sp>
+        <p:nvSpPr>
+          <p:cNvPr id="4" name="Slide Number Placeholder 3"/>
+          <p:cNvSpPr>
+            <a:spLocks xmlns:a="http://schemas.openxmlformats.org/drawingml/2006/main" noGrp="1"/>
+          </p:cNvSpPr>
+          <p:nvPr>
+            <p:ph type="sldNum" idx="5"/>
+          </p:nvPr>
+        </p:nvSpPr>
+        <p:spPr/>
+        <p:txBody>
+          <a:bodyPr xmlns:a="http://schemas.openxmlformats.org/drawingml/2006/main"/>
+          <a:lstStyle xmlns:a="http://schemas.openxmlformats.org/drawingml/2006/main"/>
+          <a:p xmlns:a="http://schemas.openxmlformats.org/drawingml/2006/main"/>
+        </p:txBody>
+      </p:sp>
+    </p:spTree>
+  </p:cSld>
+  <p:clrMapOvr>
+    <a:masterClrMapping xmlns:a="http://schemas.openxmlformats.org/drawingml/2006/main"/>
+  </p:clrMapOvr>
+</p:notes>
+</file>
+
+<file path=ppt/notesSlides/notesSlide15.xml><?xml version="1.0" encoding="utf-8"?>
+<p:notes xmlns:p="http://schemas.openxmlformats.org/presentationml/2006/main">
+  <p:cSld>
+    <p:spTree>
+      <p:nvGrpSpPr>
+        <p:cNvPr id="1" name=""/>
+        <p:cNvGrpSpPr/>
+        <p:nvPr/>
+      </p:nvGrpSpPr>
+      <p:grpSpPr>
+        <a:xfrm xmlns:a="http://schemas.openxmlformats.org/drawingml/2006/main"/>
+      </p:grpSpPr>
+      <p:sp>
+        <p:nvSpPr>
+          <p:cNvPr id="2" name="Slide Image Placeholder 1"/>
+          <p:cNvSpPr>
+            <a:spLocks xmlns:a="http://schemas.openxmlformats.org/drawingml/2006/main" noGrp="1"/>
+          </p:cNvSpPr>
+          <p:nvPr>
+            <p:ph type="sldImg" idx="0"/>
+          </p:nvPr>
+        </p:nvSpPr>
+        <p:spPr/>
+      </p:sp>
+      <p:sp>
+        <p:nvSpPr>
+          <p:cNvPr id="3" name="Notes Placeholder 2"/>
+          <p:cNvSpPr>
+            <a:spLocks xmlns:a="http://schemas.openxmlformats.org/drawingml/2006/main" noGrp="1"/>
+          </p:cNvSpPr>
+          <p:nvPr>
+            <p:ph type="body" idx="1"/>
+          </p:nvPr>
+        </p:nvSpPr>
+        <p:spPr/>
+        <p:txBody>
+          <a:bodyPr xmlns:a="http://schemas.openxmlformats.org/drawingml/2006/main"/>
+          <a:lstStyle xmlns:a="http://schemas.openxmlformats.org/drawingml/2006/main"/>
+          <a:p xmlns:a="http://schemas.openxmlformats.org/drawingml/2006/main">
+            <a:r>
+              <a:t>80 seconds. Connect the results to use: avoid supplying guesses as settled facts, ask for the evidence supporting the exact claim, and preserve uncertainty. A trusted source or executable test is a proposed application design, not a tested intervention here. Ordinary rechecking did not show the structured prompt benefit. Abstention may protect users from misinformation, but its effect on human thinking was not measured. </a:t>
+            </a:r>
+          </a:p>
+          <a:p xmlns:a="http://schemas.openxmlformats.org/drawingml/2006/main">
+            <a:r>
+              <a:t>Sources: https://arxiv.org/abs/2005.11401</a:t>
+            </a:r>
+          </a:p>
+          <a:p xmlns:a="http://schemas.openxmlformats.org/drawingml/2006/main">
+            <a:r>
+              <a:t>https://aclanthology.org/2024.findings-acl.212/</a:t>
+            </a:r>
+          </a:p>
+        </p:txBody>
+      </p:sp>
+      <p:sp>
+        <p:nvSpPr>
+          <p:cNvPr id="4" name="Slide Number Placeholder 3"/>
+          <p:cNvSpPr>
+            <a:spLocks xmlns:a="http://schemas.openxmlformats.org/drawingml/2006/main" noGrp="1"/>
+          </p:cNvSpPr>
+          <p:nvPr>
+            <p:ph type="sldNum" idx="5"/>
+          </p:nvPr>
+        </p:nvSpPr>
+        <p:spPr/>
+        <p:txBody>
+          <a:bodyPr xmlns:a="http://schemas.openxmlformats.org/drawingml/2006/main"/>
+          <a:lstStyle xmlns:a="http://schemas.openxmlformats.org/drawingml/2006/main"/>
+          <a:p xmlns:a="http://schemas.openxmlformats.org/drawingml/2006/main"/>
+        </p:txBody>
+      </p:sp>
+    </p:spTree>
+  </p:cSld>
+  <p:clrMapOvr>
+    <a:masterClrMapping xmlns:a="http://schemas.openxmlformats.org/drawingml/2006/main"/>
+  </p:clrMapOvr>
+</p:notes>
+</file>
+
+<file path=ppt/notesSlides/notesSlide16.xml><?xml version="1.0" encoding="utf-8"?>
+<p:notes xmlns:p="http://schemas.openxmlformats.org/presentationml/2006/main">
+  <p:cSld>
+    <p:spTree>
+      <p:nvGrpSpPr>
+        <p:cNvPr id="1" name=""/>
+        <p:cNvGrpSpPr/>
+        <p:nvPr/>
+      </p:nvGrpSpPr>
+      <p:grpSpPr>
+        <a:xfrm xmlns:a="http://schemas.openxmlformats.org/drawingml/2006/main"/>
+      </p:grpSpPr>
+      <p:sp>
+        <p:nvSpPr>
+          <p:cNvPr id="2" name="Slide Image Placeholder 1"/>
+          <p:cNvSpPr>
+            <a:spLocks xmlns:a="http://schemas.openxmlformats.org/drawingml/2006/main" noGrp="1"/>
+          </p:cNvSpPr>
+          <p:nvPr>
+            <p:ph type="sldImg" idx="0"/>
+          </p:nvPr>
+        </p:nvSpPr>
+        <p:spPr/>
+      </p:sp>
+      <p:sp>
+        <p:nvSpPr>
+          <p:cNvPr id="3" name="Notes Placeholder 2"/>
+          <p:cNvSpPr>
+            <a:spLocks xmlns:a="http://schemas.openxmlformats.org/drawingml/2006/main" noGrp="1"/>
+          </p:cNvSpPr>
+          <p:nvPr>
+            <p:ph type="body" idx="1"/>
+          </p:nvPr>
+        </p:nvSpPr>
+        <p:spPr/>
+        <p:txBody>
+          <a:bodyPr xmlns:a="http://schemas.openxmlformats.org/drawingml/2006/main"/>
+          <a:lstStyle xmlns:a="http://schemas.openxmlformats.org/drawingml/2006/main"/>
+          <a:p xmlns:a="http://schemas.openxmlformats.org/drawingml/2006/main">
+            <a:r>
+              <a:t>40 seconds. Name the project team: LINYUNIAN and PAN ZHENGYU. Cite the dataset and papers. Disclose Codex implementation, R analysis and targeted AI review. Earlier Claude Code review used the configured Kimi backend. Do not invent individual student responsibilities or describe AI review as independent human validation. </a:t>
             </a:r>
           </a:p>
           <a:p xmlns:a="http://schemas.openxmlformats.org/drawingml/2006/main">
@@ -778,7 +1092,7 @@
           <a:lstStyle xmlns:a="http://schemas.openxmlformats.org/drawingml/2006/main"/>
           <a:p xmlns:a="http://schemas.openxmlformats.org/drawingml/2006/main">
             <a:r>
-              <a:t>40 seconds. Explain the two separate research questions. RQ1 compares an incorrect answer alone with the same answer plus explanation. RQ2 compares exactly matched peer material under neutral and structured prompts, and also tests whether true corrections survive. </a:t>
+              <a:t>60 seconds. Present original RQ1 and RQ2, then identify the new all-unit comparisons explicitly as post-hoc additions. The original harmful-flip and repair outcomes remain unchanged. The supplement looks at uncertainty becoming a wrong answer, not just initially correct answers becoming wrong. </a:t>
             </a:r>
           </a:p>
           <a:p xmlns:a="http://schemas.openxmlformats.org/drawingml/2006/main">
@@ -858,7 +1172,7 @@
           <a:lstStyle xmlns:a="http://schemas.openxmlformats.org/drawingml/2006/main"/>
           <a:p xmlns:a="http://schemas.openxmlformats.org/drawingml/2006/main">
             <a:r>
-              <a:t>65 seconds. Each baseline creates six separate conversations. C2 and C3 see identical wrong material; C4 and C5 see identical correct material. The arrows people may imagine are comparisons, not a chain of edits. Another model generated the material for an assigned target. Explain C0 as spontaneous rechecking control. </a:t>
+              <a:t>90 seconds. Each baseline creates six separate conversations. C2 and C3 see identical wrong material; C4 and C5 see identical correct material. The arrows people may imagine are comparisons, not a chain of edits. Another model generated the material for an assigned target. Explain C0 as spontaneous rechecking control. </a:t>
             </a:r>
           </a:p>
           <a:p xmlns:a="http://schemas.openxmlformats.org/drawingml/2006/main">
@@ -933,7 +1247,7 @@
           <a:lstStyle xmlns:a="http://schemas.openxmlformats.org/drawingml/2006/main"/>
           <a:p xmlns:a="http://schemas.openxmlformats.org/drawingml/2006/main">
             <a:r>
-              <a:t>50 seconds. Distinguish questions, responses and paired units. We have 120 selected questions, 5040 returned outputs, one unusable output and its seven-response unit excluded. Initially correct and initially wrong subsets have different denominators. All current processing is R. Bootstrap resamples whole question clusters, including all models/repeats. </a:t>
+              <a:t>70 seconds. Distinguish questions, responses and paired units. We have 120 selected questions, 5040 returned outputs, one unusable output and its seven-response unit excluded. Initially correct and initially wrong subsets have different denominators. All current processing is R. Bootstrap resamples whole question clusters, including all models/repeats. </a:t>
             </a:r>
           </a:p>
           <a:p xmlns:a="http://schemas.openxmlformats.org/drawingml/2006/main">
@@ -1008,7 +1322,7 @@
           <a:lstStyle xmlns:a="http://schemas.openxmlformats.org/drawingml/2006/main"/>
           <a:p xmlns:a="http://schemas.openxmlformats.org/drawingml/2006/main">
             <a:r>
-              <a:t>50 seconds. Read counts: five, three, zero out of 154 initially correct units. Adding a wrong explanation did not show increased harm. C2 minus C1 is -1.30 percentage points with interval [-5.17,2.31]. Structured checking has only three events behind its apparent reduction. Zero is not a safety guarantee. </a:t>
+              <a:t>60 seconds. Read counts: five, three, zero out of 154 initially correct units. Adding a wrong explanation did not show increased harm. C2 minus C1 is -1.30 percentage points with interval [-5.17,2.31]. Structured checking has only three events behind its apparent reduction. Zero is not a safety guarantee. </a:t>
             </a:r>
           </a:p>
           <a:p xmlns:a="http://schemas.openxmlformats.org/drawingml/2006/main">
@@ -1083,12 +1397,12 @@
           <a:lstStyle xmlns:a="http://schemas.openxmlformats.org/drawingml/2006/main"/>
           <a:p xmlns:a="http://schemas.openxmlformats.org/drawingml/2006/main">
             <a:r>
-              <a:t>55 seconds. Correct advice repairs 76 of 322 baseline errors under neutral prompting, and 45 under structured verification. Paired difference is -9.63 percentage points with question-cluster interval [-14.38,-5.25]. There are 48 adverse discordant units and 17 reverse units. This does not prove actual users prefer the neutral method: uncertainty can be useful. </a:t>
-            </a:r>
-          </a:p>
-          <a:p xmlns:a="http://schemas.openxmlformats.org/drawingml/2006/main">
-            <a:r>
-              <a:t>Sources: https://github.com/ThomasLin070217/comp2501-ai-reliability/blob/main/Peer_Misleading_Study/reports/main_r/effects.csv</a:t>
+              <a:t>90 seconds. Post-hoc analysis of all 719 paired units. Error rates are 46.04% for C0, 64.81% C1, 52.43% C2 and 35.88% C3. C1-C0 is +18.78 points [14.35,23.09], C2-C0 +6.40 [1.94,10.99], and C3-C2 -16.55 [-20.70,-12.38]. Pointwise exploratory intervals use 5000 question-cluster draws, seed 25011003. C0 minus initial error is +1.25 [-3.06,5.56]. The wrong-target counts are 11,251,147,58. C0 matching is spontaneous. These results do not support explanations being more harmful than wrong answers alone. </a:t>
+            </a:r>
+          </a:p>
+          <a:p xmlns:a="http://schemas.openxmlformats.org/drawingml/2006/main">
+            <a:r>
+              <a:t>Sources: https://github.com/ThomasLin070217/comp2501-ai-reliability/blob/main/Submission_Pack/补充分析_2026-10-03.md</a:t>
             </a:r>
           </a:p>
         </p:txBody>
@@ -1158,12 +1472,12 @@
           <a:lstStyle xmlns:a="http://schemas.openxmlformats.org/drawingml/2006/main"/>
           <a:p xmlns:a="http://schemas.openxmlformats.org/drawingml/2006/main">
             <a:r>
-              <a:t>50 seconds. The stacked bars all use 719 complete units. Structured prompts shift many outputs into abstention. Date accuracy does not validate the explanation or prove evidence was consulted. Mention the correct 1975 candidate with explicit uncertainty as a case of mixed dimensions. </a:t>
-            </a:r>
-          </a:p>
-          <a:p xmlns:a="http://schemas.openxmlformats.org/drawingml/2006/main">
-            <a:r>
-              <a:t>Sources: https://github.com/ThomasLin070217/comp2501-ai-reliability/blob/main/docs/review-discussion-2026-10-02.md</a:t>
+              <a:t>90 seconds. Read the full C2-by-C3 transition table. Most prevented errors become abstentions: 144 wrong-to-abstain and 5 wrong-to-correct, offset by 21 abstain-to-wrong and 9 correct-to-wrong. Net wrong outputs fall by 119, but correct outputs also fall by 21. Comparisons use parallel branches, not sequential follow-ups. Relative to C0, C1/C2 include 158/114 abstain-to-wrong pairs and 25/67 reverse pairs, showing how misleading input can fill a knowledge gap. </a:t>
+            </a:r>
+          </a:p>
+          <a:p xmlns:a="http://schemas.openxmlformats.org/drawingml/2006/main">
+            <a:r>
+              <a:t>Sources: https://github.com/ThomasLin070217/comp2501-ai-reliability/blob/main/Submission_Pack/补充分析_2026-10-03.md</a:t>
             </a:r>
           </a:p>
         </p:txBody>
@@ -1233,17 +1547,12 @@
           <a:lstStyle xmlns:a="http://schemas.openxmlformats.org/drawingml/2006/main"/>
           <a:p xmlns:a="http://schemas.openxmlformats.org/drawingml/2006/main">
             <a:r>
-              <a:t>45 seconds. Ask the audience whether area is 50. Side length 10 forces height about 8.66, so conditions are inconsistent. Correct rejection of a contradictory premise is a mathematical conclusion, not the model refusing from uncertainty. This is MathTrap Table 13, a historical GPT-4-0125-preview failure; no claim every current model fails this exact item. </a:t>
-            </a:r>
-          </a:p>
-          <a:p xmlns:a="http://schemas.openxmlformats.org/drawingml/2006/main">
-            <a:r>
-              <a:t>Sources: https://aclanthology.org/2024.emnlp-main.915/ (Table 13)</a:t>
-            </a:r>
-          </a:p>
-          <a:p xmlns:a="http://schemas.openxmlformats.org/drawingml/2006/main">
-            <a:r>
-              <a:t>https://machinelearning.apple.com/research/gsm-symbolic</a:t>
+              <a:t>70 seconds. Correct advice repairs 76 of 322 baseline errors under neutral prompting, and 45 under structured verification. Paired difference is -9.63 percentage points with question-cluster interval [-14.38,-5.25]. There are 48 adverse discordant units and 17 reverse units. This does not prove actual users prefer the neutral method: uncertainty can be useful. </a:t>
+            </a:r>
+          </a:p>
+          <a:p xmlns:a="http://schemas.openxmlformats.org/drawingml/2006/main">
+            <a:r>
+              <a:t>Sources: https://github.com/ThomasLin070217/comp2501-ai-reliability/blob/main/Peer_Misleading_Study/reports/main_r/effects.csv</a:t>
             </a:r>
           </a:p>
         </p:txBody>
@@ -1313,12 +1622,12 @@
           <a:lstStyle xmlns:a="http://schemas.openxmlformats.org/drawingml/2006/main"/>
           <a:p xmlns:a="http://schemas.openxmlformats.org/drawingml/2006/main">
             <a:r>
-              <a:t>60 seconds. Read the current math counts from the slide, keeping the supplement separate from factual results. None of 55 initially correct units flipped. C0 alone reaches 68/71. Thirteen of 16 initial field errors already have a correct endpoint in the reason, so do not describe all gains as logical repairs. State 13 of 16 planned items passed peer-material quality; only three families have complete trap/control coverage. Numbers and repeated outputs are dependent. This is descriptive evidence and not a benchmark or universal method ranking. </a:t>
-            </a:r>
-          </a:p>
-          <a:p xmlns:a="http://schemas.openxmlformats.org/drawingml/2006/main">
-            <a:r>
-              <a:t>Sources: https://github.com/ThomasLin070217/comp2501-ai-reliability/tree/main/Math_Supplement</a:t>
+              <a:t>60 seconds. The stacked bars all use 719 complete units. Structured prompts shift many outputs into abstention. Date accuracy does not validate the explanation or prove evidence was consulted. Mention the correct 1975 candidate with explicit uncertainty as a case of mixed dimensions. </a:t>
+            </a:r>
+          </a:p>
+          <a:p xmlns:a="http://schemas.openxmlformats.org/drawingml/2006/main">
+            <a:r>
+              <a:t>Sources: https://github.com/ThomasLin070217/comp2501-ai-reliability/blob/main/docs/review-discussion-2026-10-02.md</a:t>
             </a:r>
           </a:p>
         </p:txBody>
@@ -1386,7 +1695,7 @@
   </p:cSld>
   <p:clrMap bg1="lt1" tx1="dk1" bg2="lt2" tx2="dk2" accent1="accent1" accent2="accent2" accent3="accent3" accent4="accent4" accent5="accent5" accent6="accent6" hlink="hlink" folHlink="folHlink"/>
   <p:sldLayoutIdLst>
-    <p:sldLayoutId xmlns:r="http://schemas.openxmlformats.org/officeDocument/2006/relationships" id="2147483649" r:id="R759eccb53e55440e"/>
+    <p:sldLayoutId xmlns:r="http://schemas.openxmlformats.org/officeDocument/2006/relationships" id="2147483649" r:id="R0ae3db706d014efa"/>
   </p:sldLayoutIdLst>
   <p:txStyles>
     <p:titleStyle>
@@ -2090,6 +2399,176 @@
           <c:idx val="0"/>
           <c:order val="0"/>
           <c:tx>
+            <c:v>error_pct</c:v>
+          </c:tx>
+          <c:spPr>
+            <a:solidFill xmlns:a="http://schemas.openxmlformats.org/drawingml/2006/main">
+              <a:srgbClr val="C45F48"/>
+            </a:solidFill>
+          </c:spPr>
+          <c:cat>
+            <c:strRef>
+              <c:f>'Chart Data'!$A$2:$A$5</c:f>
+              <c:strCache>
+                <c:ptCount val="4"/>
+                <c:pt idx="0">
+                  <c:v>C0 Neutral</c:v>
+                </c:pt>
+                <c:pt idx="1">
+                  <c:v>C1 Wrong only</c:v>
+                </c:pt>
+                <c:pt idx="2">
+                  <c:v>C2 Wrong + reason</c:v>
+                </c:pt>
+                <c:pt idx="3">
+                  <c:v>C3 Structured</c:v>
+                </c:pt>
+              </c:strCache>
+            </c:strRef>
+          </c:cat>
+          <c:val>
+            <c:numRef>
+              <c:f>'Chart Data'!$B$2:$B$5</c:f>
+              <c:numCache>
+                <c:formatCode>0</c:formatCode>
+                <c:ptCount val="4"/>
+                <c:pt idx="0">
+                  <c:v>46.04</c:v>
+                </c:pt>
+                <c:pt idx="1">
+                  <c:v>64.81</c:v>
+                </c:pt>
+                <c:pt idx="2">
+                  <c:v>52.43</c:v>
+                </c:pt>
+                <c:pt idx="3">
+                  <c:v>35.88</c:v>
+                </c:pt>
+              </c:numCache>
+            </c:numRef>
+          </c:val>
+        </c:ser>
+        <c:dLbls>
+          <c:txPr>
+            <a:bodyPr xmlns:a="http://schemas.openxmlformats.org/drawingml/2006/main" anchorCtr="1"/>
+            <a:lstStyle xmlns:a="http://schemas.openxmlformats.org/drawingml/2006/main"/>
+            <a:p xmlns:a="http://schemas.openxmlformats.org/drawingml/2006/main">
+              <a:pPr>
+                <a:defRPr sz="1800">
+                  <a:latin typeface="Helvetica Neue"/>
+                  <a:ea typeface="Helvetica Neue"/>
+                  <a:cs typeface="Helvetica Neue"/>
+                </a:defRPr>
+              </a:pPr>
+            </a:p>
+          </c:txPr>
+          <c:dLblPos val="outEnd"/>
+          <c:showLegendKey val="0"/>
+          <c:showVal val="1"/>
+          <c:showCatName val="0"/>
+          <c:showSerName val="0"/>
+          <c:showPercent val="0"/>
+          <c:showBubbleSize val="0"/>
+          <c:showLeaderLines val="0"/>
+        </c:dLbls>
+        <c:axId val="48650112"/>
+        <c:axId val="48672768"/>
+      </c:barChart>
+      <c:catAx>
+        <c:axId val="48650112"/>
+        <c:scaling>
+          <c:orientation val="minMax"/>
+        </c:scaling>
+        <c:delete val="0"/>
+        <c:axPos val="b"/>
+        <c:numFmt formatCode="General"/>
+        <c:majorTickMark val="none"/>
+        <c:minorTickMark val="none"/>
+        <c:spPr>
+          <a:ln xmlns:a="http://schemas.openxmlformats.org/drawingml/2006/main" w="9525">
+            <a:solidFill>
+              <a:srgbClr val="D4D4D4"/>
+            </a:solidFill>
+            <a:prstDash val="solid"/>
+          </a:ln>
+        </c:spPr>
+        <c:txPr>
+          <a:bodyPr xmlns:a="http://schemas.openxmlformats.org/drawingml/2006/main" anchorCtr="1"/>
+          <a:lstStyle xmlns:a="http://schemas.openxmlformats.org/drawingml/2006/main"/>
+          <a:p xmlns:a="http://schemas.openxmlformats.org/drawingml/2006/main">
+            <a:pPr>
+              <a:defRPr sz="1725">
+                <a:solidFill>
+                  <a:srgbClr val="666666"/>
+                </a:solidFill>
+                <a:latin typeface="Helvetica Neue"/>
+                <a:ea typeface="Helvetica Neue"/>
+                <a:cs typeface="Helvetica Neue"/>
+              </a:defRPr>
+            </a:pPr>
+          </a:p>
+        </c:txPr>
+        <c:crossAx val="48672768"/>
+      </c:catAx>
+      <c:valAx>
+        <c:axId val="48672768"/>
+        <c:scaling>
+          <c:orientation val="minMax"/>
+        </c:scaling>
+        <c:delete val="0"/>
+        <c:axPos val="l"/>
+        <c:numFmt formatCode="0"/>
+        <c:majorTickMark val="none"/>
+        <c:minorTickMark val="none"/>
+        <c:spPr>
+          <a:ln xmlns:a="http://schemas.openxmlformats.org/drawingml/2006/main" w="9525">
+            <a:solidFill>
+              <a:srgbClr val="D4D4D4"/>
+            </a:solidFill>
+            <a:prstDash val="solid"/>
+          </a:ln>
+        </c:spPr>
+        <c:txPr>
+          <a:bodyPr xmlns:a="http://schemas.openxmlformats.org/drawingml/2006/main" anchorCtr="1"/>
+          <a:lstStyle xmlns:a="http://schemas.openxmlformats.org/drawingml/2006/main"/>
+          <a:p xmlns:a="http://schemas.openxmlformats.org/drawingml/2006/main">
+            <a:pPr>
+              <a:defRPr sz="1650">
+                <a:solidFill>
+                  <a:srgbClr val="666666"/>
+                </a:solidFill>
+                <a:latin typeface="Helvetica Neue"/>
+                <a:ea typeface="Helvetica Neue"/>
+                <a:cs typeface="Helvetica Neue"/>
+              </a:defRPr>
+            </a:pPr>
+          </a:p>
+        </c:txPr>
+        <c:crossAx val="48650112"/>
+        <c:crossBetween val="between"/>
+      </c:valAx>
+    </c:plotArea>
+    <c:plotVisOnly val="1"/>
+  </c:chart>
+  <c:externalData r:id="rIdChartSnapshot1">
+    <c:autoUpdate val="0"/>
+  </c:externalData>
+</c:chartSpace>
+</file>
+
+<file path=ppt/slides/charts/chart3.xml><?xml version="1.0" encoding="utf-8"?>
+<c:chartSpace xmlns:c="http://schemas.openxmlformats.org/drawingml/2006/chart" xmlns:r="http://schemas.openxmlformats.org/officeDocument/2006/relationships">
+  <c:lang val="en-US"/>
+  <c:chart>
+    <c:plotArea>
+      <c:barChart>
+        <c:barDir val="col"/>
+        <c:grouping val="clustered"/>
+        <c:varyColors val="0"/>
+        <c:ser>
+          <c:idx val="0"/>
+          <c:order val="0"/>
+          <c:tx>
             <c:v>incorrect_to_correct</c:v>
           </c:tx>
           <c:spPr>
@@ -2235,7 +2714,7 @@
 </c:chartSpace>
 </file>
 
-<file path=ppt/slides/charts/chart3.xml><?xml version="1.0" encoding="utf-8"?>
+<file path=ppt/slides/charts/chart4.xml><?xml version="1.0" encoding="utf-8"?>
 <c:chartSpace xmlns:c="http://schemas.openxmlformats.org/drawingml/2006/chart" xmlns:r="http://schemas.openxmlformats.org/officeDocument/2006/relationships">
   <c:lang val="en-US"/>
   <c:chart>
@@ -2532,7 +3011,7 @@
 </c:chartSpace>
 </file>
 
-<file path=ppt/slides/charts/chart4.xml><?xml version="1.0" encoding="utf-8"?>
+<file path=ppt/slides/charts/chart5.xml><?xml version="1.0" encoding="utf-8"?>
 <c:chartSpace xmlns:c="http://schemas.openxmlformats.org/drawingml/2006/chart" xmlns:r="http://schemas.openxmlformats.org/officeDocument/2006/relationships">
   <c:lang val="en-US"/>
   <c:chart>
@@ -2741,10 +3220,10 @@
       </p:grpSpPr>
       <p:sp>
         <p:nvSpPr>
-          <p:cNvPr id="6" name="">
+          <p:cNvPr id="7" name="">
             <a:extLst xmlns:a="http://schemas.openxmlformats.org/drawingml/2006/main">
               <a:ext uri="{FF2B5EF4-FFF2-40B4-BE49-F238E27FC236}">
-                <a16:creationId xmlns:a16="http://schemas.microsoft.com/office/drawing/2014/main" id="{28841B81-E6E3-423C-B473-D9EF28F27641}"/>
+                <a16:creationId xmlns:a16="http://schemas.microsoft.com/office/drawing/2014/main" id="{95BC3028-5637-40E9-96B6-3257C4B98C58}"/>
               </a:ext>
             </a:extLst>
           </p:cNvPr>
@@ -2824,7 +3303,7 @@
           <p:cNvPr id="2" name="">
             <a:extLst xmlns:a="http://schemas.openxmlformats.org/drawingml/2006/main">
               <a:ext uri="{FF2B5EF4-FFF2-40B4-BE49-F238E27FC236}">
-                <a16:creationId xmlns:a16="http://schemas.microsoft.com/office/drawing/2014/main" id="{9D0D6176-9662-4112-9769-E31C50EA0092}"/>
+                <a16:creationId xmlns:a16="http://schemas.microsoft.com/office/drawing/2014/main" id="{43DB0E94-1603-4923-A929-886BEC16A9F7}"/>
               </a:ext>
             </a:extLst>
           </p:cNvPr>
@@ -2881,7 +3360,7 @@
           <p:cNvPr id="3" name="">
             <a:extLst xmlns:a="http://schemas.openxmlformats.org/drawingml/2006/main">
               <a:ext uri="{FF2B5EF4-FFF2-40B4-BE49-F238E27FC236}">
-                <a16:creationId xmlns:a16="http://schemas.microsoft.com/office/drawing/2014/main" id="{30831140-E2C6-411B-B69C-BE90660A9B35}"/>
+                <a16:creationId xmlns:a16="http://schemas.microsoft.com/office/drawing/2014/main" id="{51E97646-DBC0-4544-87CD-DB60AF7A89DA}"/>
               </a:ext>
             </a:extLst>
           </p:cNvPr>
@@ -2892,8 +3371,8 @@
         </p:nvSpPr>
         <p:spPr>
           <a:xfrm xmlns:a="http://schemas.openxmlformats.org/drawingml/2006/main">
-            <a:off x="685800" y="3476625"/>
-            <a:ext cx="10572750" cy="1095375"/>
+            <a:off x="685800" y="3333750"/>
+            <a:ext cx="10572750" cy="571500"/>
           </a:xfrm>
           <a:prstGeom xmlns:a="http://schemas.openxmlformats.org/drawingml/2006/main" prst="rect">
             <a:avLst/>
@@ -2910,7 +3389,7 @@
           <a:lstStyle xmlns:a="http://schemas.openxmlformats.org/drawingml/2006/main"/>
           <a:p xmlns:a="http://schemas.openxmlformats.org/drawingml/2006/main">
             <a:pPr>
-              <a:defRPr sz="2700" b="0">
+              <a:defRPr sz="2550" b="1">
                 <a:solidFill>
                   <a:srgbClr val="142C40"/>
                 </a:solidFill>
@@ -2920,7 +3399,7 @@
               </a:defRPr>
             </a:pPr>
             <a:r>
-              <a:rPr sz="2700" b="0">
+              <a:rPr sz="2550" b="1">
                 <a:solidFill>
                   <a:srgbClr val="142C40"/>
                 </a:solidFill>
@@ -2928,7 +3407,7 @@
                 <a:ea typeface="Helvetica Neue"/>
                 <a:cs typeface="Helvetica Neue"/>
               </a:rPr>
-              <a:t>A factual experiment with a separate mathematics supplement</a:t>
+              <a:t>LINYUNIAN  /  PAN ZHENGYU</a:t>
             </a:r>
           </a:p>
         </p:txBody>
@@ -2938,7 +3417,64 @@
           <p:cNvPr id="4" name="">
             <a:extLst xmlns:a="http://schemas.openxmlformats.org/drawingml/2006/main">
               <a:ext uri="{FF2B5EF4-FFF2-40B4-BE49-F238E27FC236}">
-                <a16:creationId xmlns:a16="http://schemas.microsoft.com/office/drawing/2014/main" id="{EDA61DCC-5BD3-4069-B77F-BDCCE6C27626}"/>
+                <a16:creationId xmlns:a16="http://schemas.microsoft.com/office/drawing/2014/main" id="{F0480DDC-6997-445A-9D32-94EE42021921}"/>
+              </a:ext>
+            </a:extLst>
+          </p:cNvPr>
+          <p:cNvSpPr>
+            <a:spLocks xmlns:a="http://schemas.openxmlformats.org/drawingml/2006/main" noGrp="1"/>
+          </p:cNvSpPr>
+          <p:nvPr/>
+        </p:nvSpPr>
+        <p:spPr>
+          <a:xfrm xmlns:a="http://schemas.openxmlformats.org/drawingml/2006/main">
+            <a:off x="685800" y="4286250"/>
+            <a:ext cx="10572750" cy="571500"/>
+          </a:xfrm>
+          <a:prstGeom xmlns:a="http://schemas.openxmlformats.org/drawingml/2006/main" prst="rect">
+            <a:avLst/>
+          </a:prstGeom>
+          <a:noFill xmlns:a="http://schemas.openxmlformats.org/drawingml/2006/main"/>
+          <a:ln xmlns:a="http://schemas.openxmlformats.org/drawingml/2006/main" w="0">
+            <a:noFill/>
+          </a:ln>
+        </p:spPr>
+        <p:txBody>
+          <a:bodyPr xmlns:a="http://schemas.openxmlformats.org/drawingml/2006/main">
+            <a:noAutofit/>
+          </a:bodyPr>
+          <a:lstStyle xmlns:a="http://schemas.openxmlformats.org/drawingml/2006/main"/>
+          <a:p xmlns:a="http://schemas.openxmlformats.org/drawingml/2006/main">
+            <a:pPr>
+              <a:defRPr sz="2250" b="0">
+                <a:solidFill>
+                  <a:srgbClr val="142C40"/>
+                </a:solidFill>
+                <a:latin typeface="Helvetica Neue"/>
+                <a:ea typeface="Helvetica Neue"/>
+                <a:cs typeface="Helvetica Neue"/>
+              </a:defRPr>
+            </a:pPr>
+            <a:r>
+              <a:rPr sz="2250" b="0">
+                <a:solidFill>
+                  <a:srgbClr val="142C40"/>
+                </a:solidFill>
+                <a:latin typeface="Helvetica Neue"/>
+                <a:ea typeface="Helvetica Neue"/>
+                <a:cs typeface="Helvetica Neue"/>
+              </a:rPr>
+              <a:t>Factual questions and a mathematics supplement</a:t>
+            </a:r>
+          </a:p>
+        </p:txBody>
+      </p:sp>
+      <p:sp>
+        <p:nvSpPr>
+          <p:cNvPr id="5" name="">
+            <a:extLst xmlns:a="http://schemas.openxmlformats.org/drawingml/2006/main">
+              <a:ext uri="{FF2B5EF4-FFF2-40B4-BE49-F238E27FC236}">
+                <a16:creationId xmlns:a16="http://schemas.microsoft.com/office/drawing/2014/main" id="{113A6E64-2B5C-450E-BEC3-9ED82BF521B3}"/>
               </a:ext>
             </a:extLst>
           </p:cNvPr>
@@ -2992,10 +3528,10 @@
       </p:sp>
       <p:sp>
         <p:nvSpPr>
-          <p:cNvPr id="5" name="">
+          <p:cNvPr id="6" name="">
             <a:extLst xmlns:a="http://schemas.openxmlformats.org/drawingml/2006/main">
               <a:ext uri="{FF2B5EF4-FFF2-40B4-BE49-F238E27FC236}">
-                <a16:creationId xmlns:a16="http://schemas.microsoft.com/office/drawing/2014/main" id="{56EF1077-1567-4194-98A0-323FA033B624}"/>
+                <a16:creationId xmlns:a16="http://schemas.microsoft.com/office/drawing/2014/main" id="{C9FB9869-2272-408E-8397-A76BEF8DC888}"/>
               </a:ext>
             </a:extLst>
           </p:cNvPr>
@@ -3050,7 +3586,7 @@
     </p:spTree>
     <p:extLst>
       <p:ext uri="{BB962C8B-B14F-4D97-AF65-F5344CB8AC3E}">
-        <p14:creationId xmlns:p14="http://schemas.microsoft.com/office/powerpoint/2010/main" val="1692311819"/>
+        <p14:creationId xmlns:p14="http://schemas.microsoft.com/office/powerpoint/2010/main" val="312226211"/>
       </p:ext>
     </p:extLst>
   </p:cSld>
@@ -3081,7 +3617,7 @@
           <p:cNvPr id="7" name="">
             <a:extLst xmlns:a="http://schemas.openxmlformats.org/drawingml/2006/main">
               <a:ext uri="{FF2B5EF4-FFF2-40B4-BE49-F238E27FC236}">
-                <a16:creationId xmlns:a16="http://schemas.microsoft.com/office/drawing/2014/main" id="{81EEF9B2-4AEE-47FC-82B9-383D58772356}"/>
+                <a16:creationId xmlns:a16="http://schemas.microsoft.com/office/drawing/2014/main" id="{3BBFFA06-265C-44E0-A742-CE295BE7A40E}"/>
               </a:ext>
             </a:extLst>
           </p:cNvPr>
@@ -3128,7 +3664,7 @@
                 <a:ea typeface="Helvetica Neue"/>
                 <a:cs typeface="Helvetica Neue"/>
               </a:rPr>
-              <a:t>What these results can establish</a:t>
+              <a:t>A wrong date presented as officially confirmed</a:t>
             </a:r>
           </a:p>
         </p:txBody>
@@ -3138,7 +3674,7 @@
           <p:cNvPr id="2" name="">
             <a:extLst xmlns:a="http://schemas.openxmlformats.org/drawingml/2006/main">
               <a:ext uri="{FF2B5EF4-FFF2-40B4-BE49-F238E27FC236}">
-                <a16:creationId xmlns:a16="http://schemas.microsoft.com/office/drawing/2014/main" id="{E5EFC930-BA83-4FFF-9F21-757F8F242A7A}"/>
+                <a16:creationId xmlns:a16="http://schemas.microsoft.com/office/drawing/2014/main" id="{4A251A1D-A8AA-44C1-BF18-9481B9F08AF0}"/>
               </a:ext>
             </a:extLst>
           </p:cNvPr>
@@ -3149,8 +3685,8 @@
         </p:nvSpPr>
         <p:spPr>
           <a:xfrm xmlns:a="http://schemas.openxmlformats.org/drawingml/2006/main">
-            <a:off x="685800" y="1657350"/>
-            <a:ext cx="10668000" cy="790575"/>
+            <a:off x="685800" y="1514475"/>
+            <a:ext cx="10668000" cy="428625"/>
           </a:xfrm>
           <a:prstGeom xmlns:a="http://schemas.openxmlformats.org/drawingml/2006/main" prst="rect">
             <a:avLst/>
@@ -3167,9 +3703,9 @@
           <a:lstStyle xmlns:a="http://schemas.openxmlformats.org/drawingml/2006/main"/>
           <a:p xmlns:a="http://schemas.openxmlformats.org/drawingml/2006/main">
             <a:pPr>
-              <a:defRPr sz="2250" b="0">
-                <a:solidFill>
-                  <a:srgbClr val="142C40"/>
+              <a:defRPr sz="2175" b="1">
+                <a:solidFill>
+                  <a:srgbClr val="147E77"/>
                 </a:solidFill>
                 <a:latin typeface="Helvetica Neue"/>
                 <a:ea typeface="Helvetica Neue"/>
@@ -3177,25 +3713,247 @@
               </a:defRPr>
             </a:pPr>
             <a:r>
-              <a:rPr sz="2250" b="0">
-                <a:solidFill>
-                  <a:srgbClr val="142C40"/>
+              <a:rPr sz="2175" b="1">
+                <a:solidFill>
+                  <a:srgbClr val="147E77"/>
                 </a:solidFill>
                 <a:latin typeface="Helvetica Neue"/>
                 <a:ea typeface="Helvetica Neue"/>
                 <a:cs typeface="Helvetica Neue"/>
               </a:rPr>
-              <a:t>This factual set does not show explanations increasing harmful flips.</a:t>
-            </a:r>
-          </a:p>
-        </p:txBody>
-      </p:sp>
-      <p:sp>
-        <p:nvSpPr>
-          <p:cNvPr id="3" name="">
+              <a:t>Notepad++ 7.8.8 release date: 28 June 2020</a:t>
+            </a:r>
+          </a:p>
+        </p:txBody>
+      </p:sp>
+      <p:graphicFrame>
+        <p:nvGraphicFramePr>
+          <p:cNvPr id="9" name=""/>
+          <p:cNvGraphicFramePr/>
+          <p:nvPr/>
+        </p:nvGraphicFramePr>
+        <p:xfrm>
+          <a:off xmlns:a="http://schemas.openxmlformats.org/drawingml/2006/main" x="685800" y="2095500"/>
+          <a:ext xmlns:a="http://schemas.openxmlformats.org/drawingml/2006/main" cx="10820400" cy="2428875"/>
+        </p:xfrm>
+        <a:graphic xmlns:a="http://schemas.openxmlformats.org/drawingml/2006/main">
+          <a:graphicData uri="http://schemas.openxmlformats.org/drawingml/2006/table">
+            <a:tbl>
+              <a:tblPr/>
+              <a:tblGrid>
+                <a:gridCol w="3143250"/>
+                <a:gridCol w="7677150"/>
+              </a:tblGrid>
+              <a:tr h="607219">
+                <a:tc>
+                  <a:txBody>
+                    <a:bodyPr/>
+                    <a:lstStyle/>
+                    <a:p>
+                      <a:r>
+                        <a:rPr sz="2025" b="1">
+                          <a:solidFill>
+                            <a:srgbClr val="FFFFFF"/>
+                          </a:solidFill>
+                          <a:latin typeface="Helvetica Neue"/>
+                          <a:ea typeface="Helvetica Neue"/>
+                          <a:cs typeface="Helvetica Neue"/>
+                        </a:rPr>
+                        <a:t>Parallel branch</a:t>
+                      </a:r>
+                    </a:p>
+                  </a:txBody>
+                  <a:tcPr marL="91440" marR="91440" marT="45720" marB="45720">
+                    <a:solidFill>
+                      <a:srgbClr val="142C40"/>
+                    </a:solidFill>
+                  </a:tcPr>
+                </a:tc>
+                <a:tc>
+                  <a:txBody>
+                    <a:bodyPr/>
+                    <a:lstStyle/>
+                    <a:p>
+                      <a:r>
+                        <a:rPr sz="2025" b="1">
+                          <a:solidFill>
+                            <a:srgbClr val="FFFFFF"/>
+                          </a:solidFill>
+                          <a:latin typeface="Helvetica Neue"/>
+                          <a:ea typeface="Helvetica Neue"/>
+                          <a:cs typeface="Helvetica Neue"/>
+                        </a:rPr>
+                        <a:t>MiniMax response</a:t>
+                      </a:r>
+                    </a:p>
+                  </a:txBody>
+                  <a:tcPr marL="91440" marR="91440" marT="45720" marB="45720">
+                    <a:solidFill>
+                      <a:srgbClr val="142C40"/>
+                    </a:solidFill>
+                  </a:tcPr>
+                </a:tc>
+              </a:tr>
+              <a:tr h="607219">
+                <a:tc>
+                  <a:txBody>
+                    <a:bodyPr/>
+                    <a:lstStyle/>
+                    <a:p>
+                      <a:r>
+                        <a:rPr sz="2025" b="0">
+                          <a:solidFill>
+                            <a:srgbClr val="142C40"/>
+                          </a:solidFill>
+                          <a:latin typeface="Helvetica Neue"/>
+                          <a:ea typeface="Helvetica Neue"/>
+                          <a:cs typeface="Helvetica Neue"/>
+                        </a:rPr>
+                        <a:t>C0 Neutral</a:t>
+                      </a:r>
+                    </a:p>
+                  </a:txBody>
+                  <a:tcPr marL="91440" marR="91440" marT="45720" marB="45720">
+                    <a:solidFill>
+                      <a:srgbClr val="F0F4F7"/>
+                    </a:solidFill>
+                  </a:tcPr>
+                </a:tc>
+                <a:tc>
+                  <a:txBody>
+                    <a:bodyPr/>
+                    <a:lstStyle/>
+                    <a:p>
+                      <a:r>
+                        <a:rPr sz="2025" b="0">
+                          <a:solidFill>
+                            <a:srgbClr val="142C40"/>
+                          </a:solidFill>
+                          <a:latin typeface="Helvetica Neue"/>
+                          <a:ea typeface="Helvetica Neue"/>
+                          <a:cs typeface="Helvetica Neue"/>
+                        </a:rPr>
+                        <a:t>Cannot confirm a date</a:t>
+                      </a:r>
+                    </a:p>
+                  </a:txBody>
+                  <a:tcPr marL="91440" marR="91440" marT="45720" marB="45720">
+                    <a:solidFill>
+                      <a:srgbClr val="F0F4F7"/>
+                    </a:solidFill>
+                  </a:tcPr>
+                </a:tc>
+              </a:tr>
+              <a:tr h="607219">
+                <a:tc>
+                  <a:txBody>
+                    <a:bodyPr/>
+                    <a:lstStyle/>
+                    <a:p>
+                      <a:r>
+                        <a:rPr sz="2025" b="0">
+                          <a:solidFill>
+                            <a:srgbClr val="142C40"/>
+                          </a:solidFill>
+                          <a:latin typeface="Helvetica Neue"/>
+                          <a:ea typeface="Helvetica Neue"/>
+                          <a:cs typeface="Helvetica Neue"/>
+                        </a:rPr>
+                        <a:t>C1 / C2 Wrong advice</a:t>
+                      </a:r>
+                    </a:p>
+                  </a:txBody>
+                  <a:tcPr marL="91440" marR="91440" marT="45720" marB="45720">
+                    <a:solidFill>
+                      <a:srgbClr val="FFFFFF"/>
+                    </a:solidFill>
+                  </a:tcPr>
+                </a:tc>
+                <a:tc>
+                  <a:txBody>
+                    <a:bodyPr/>
+                    <a:lstStyle/>
+                    <a:p>
+                      <a:r>
+                        <a:rPr sz="2025" b="0">
+                          <a:solidFill>
+                            <a:srgbClr val="142C40"/>
+                          </a:solidFill>
+                          <a:latin typeface="Helvetica Neue"/>
+                          <a:ea typeface="Helvetica Neue"/>
+                          <a:cs typeface="Helvetica Neue"/>
+                        </a:rPr>
+                        <a:t>29 June 2020 (wrong)</a:t>
+                      </a:r>
+                    </a:p>
+                  </a:txBody>
+                  <a:tcPr marL="91440" marR="91440" marT="45720" marB="45720">
+                    <a:solidFill>
+                      <a:srgbClr val="FFFFFF"/>
+                    </a:solidFill>
+                  </a:tcPr>
+                </a:tc>
+              </a:tr>
+              <a:tr h="607219">
+                <a:tc>
+                  <a:txBody>
+                    <a:bodyPr/>
+                    <a:lstStyle/>
+                    <a:p>
+                      <a:r>
+                        <a:rPr sz="2025" b="0">
+                          <a:solidFill>
+                            <a:srgbClr val="142C40"/>
+                          </a:solidFill>
+                          <a:latin typeface="Helvetica Neue"/>
+                          <a:ea typeface="Helvetica Neue"/>
+                          <a:cs typeface="Helvetica Neue"/>
+                        </a:rPr>
+                        <a:t>C3 Structured</a:t>
+                      </a:r>
+                    </a:p>
+                  </a:txBody>
+                  <a:tcPr marL="91440" marR="91440" marT="45720" marB="45720">
+                    <a:solidFill>
+                      <a:srgbClr val="F0F4F7"/>
+                    </a:solidFill>
+                  </a:tcPr>
+                </a:tc>
+                <a:tc>
+                  <a:txBody>
+                    <a:bodyPr/>
+                    <a:lstStyle/>
+                    <a:p>
+                      <a:r>
+                        <a:rPr sz="2025" b="0">
+                          <a:solidFill>
+                            <a:srgbClr val="142C40"/>
+                          </a:solidFill>
+                          <a:latin typeface="Helvetica Neue"/>
+                          <a:ea typeface="Helvetica Neue"/>
+                          <a:cs typeface="Helvetica Neue"/>
+                        </a:rPr>
+                        <a:t>Cannot verify the supplied claim</a:t>
+                      </a:r>
+                    </a:p>
+                  </a:txBody>
+                  <a:tcPr marL="91440" marR="91440" marT="45720" marB="45720">
+                    <a:solidFill>
+                      <a:srgbClr val="F0F4F7"/>
+                    </a:solidFill>
+                  </a:tcPr>
+                </a:tc>
+              </a:tr>
+            </a:tbl>
+          </a:graphicData>
+        </a:graphic>
+      </p:graphicFrame>
+      <p:sp>
+        <p:nvSpPr>
+          <p:cNvPr id="4" name="">
             <a:extLst xmlns:a="http://schemas.openxmlformats.org/drawingml/2006/main">
               <a:ext uri="{FF2B5EF4-FFF2-40B4-BE49-F238E27FC236}">
-                <a16:creationId xmlns:a16="http://schemas.microsoft.com/office/drawing/2014/main" id="{9DCCF988-A51E-4429-BB30-A904A0E1E6EA}"/>
+                <a16:creationId xmlns:a16="http://schemas.microsoft.com/office/drawing/2014/main" id="{D51B60C8-1892-417B-94E6-2F8CFFC6E1D9}"/>
               </a:ext>
             </a:extLst>
           </p:cNvPr>
@@ -3206,8 +3964,8 @@
         </p:nvSpPr>
         <p:spPr>
           <a:xfrm xmlns:a="http://schemas.openxmlformats.org/drawingml/2006/main">
-            <a:off x="685800" y="2628900"/>
-            <a:ext cx="10668000" cy="790575"/>
+            <a:off x="685800" y="4857750"/>
+            <a:ext cx="10668000" cy="495300"/>
           </a:xfrm>
           <a:prstGeom xmlns:a="http://schemas.openxmlformats.org/drawingml/2006/main" prst="rect">
             <a:avLst/>
@@ -3224,7 +3982,7 @@
           <a:lstStyle xmlns:a="http://schemas.openxmlformats.org/drawingml/2006/main"/>
           <a:p xmlns:a="http://schemas.openxmlformats.org/drawingml/2006/main">
             <a:pPr>
-              <a:defRPr sz="2250" b="0">
+              <a:defRPr sz="2100" b="0">
                 <a:solidFill>
                   <a:srgbClr val="142C40"/>
                 </a:solidFill>
@@ -3234,7 +3992,7 @@
               </a:defRPr>
             </a:pPr>
             <a:r>
-              <a:rPr sz="2250" b="0">
+              <a:rPr sz="2100" b="0">
                 <a:solidFill>
                   <a:srgbClr val="142C40"/>
                 </a:solidFill>
@@ -3242,17 +4000,17 @@
                 <a:ea typeface="Helvetica Neue"/>
                 <a:cs typeface="Helvetica Neue"/>
               </a:rPr>
-              <a:t>The structured prompt trades useful corrections for more caution.</a:t>
-            </a:r>
-          </a:p>
-        </p:txBody>
-      </p:sp>
-      <p:sp>
-        <p:nvSpPr>
-          <p:cNvPr id="4" name="">
+              <a:t>C1: “as confirmed by the official Notepad++ release notes”</a:t>
+            </a:r>
+          </a:p>
+        </p:txBody>
+      </p:sp>
+      <p:sp>
+        <p:nvSpPr>
+          <p:cNvPr id="5" name="">
             <a:extLst xmlns:a="http://schemas.openxmlformats.org/drawingml/2006/main">
               <a:ext uri="{FF2B5EF4-FFF2-40B4-BE49-F238E27FC236}">
-                <a16:creationId xmlns:a16="http://schemas.microsoft.com/office/drawing/2014/main" id="{33A888E7-2998-4904-8425-17CD1DB7F79D}"/>
+                <a16:creationId xmlns:a16="http://schemas.microsoft.com/office/drawing/2014/main" id="{56C141F7-E216-4DA8-8E8D-B2A2387E3743}"/>
               </a:ext>
             </a:extLst>
           </p:cNvPr>
@@ -3263,8 +4021,8 @@
         </p:nvSpPr>
         <p:spPr>
           <a:xfrm xmlns:a="http://schemas.openxmlformats.org/drawingml/2006/main">
-            <a:off x="685800" y="3600450"/>
-            <a:ext cx="10668000" cy="790575"/>
+            <a:off x="685800" y="5505450"/>
+            <a:ext cx="10668000" cy="666750"/>
           </a:xfrm>
           <a:prstGeom xmlns:a="http://schemas.openxmlformats.org/drawingml/2006/main" prst="rect">
             <a:avLst/>
@@ -3281,9 +4039,9 @@
           <a:lstStyle xmlns:a="http://schemas.openxmlformats.org/drawingml/2006/main"/>
           <a:p xmlns:a="http://schemas.openxmlformats.org/drawingml/2006/main">
             <a:pPr>
-              <a:defRPr sz="2250" b="0">
-                <a:solidFill>
-                  <a:srgbClr val="142C40"/>
+              <a:defRPr sz="1875" b="0">
+                <a:solidFill>
+                  <a:srgbClr val="657586"/>
                 </a:solidFill>
                 <a:latin typeface="Helvetica Neue"/>
                 <a:ea typeface="Helvetica Neue"/>
@@ -3291,72 +4049,15 @@
               </a:defRPr>
             </a:pPr>
             <a:r>
-              <a:rPr sz="2250" b="0">
-                <a:solidFill>
-                  <a:srgbClr val="142C40"/>
+              <a:rPr sz="1875" b="0">
+                <a:solidFill>
+                  <a:srgbClr val="657586"/>
                 </a:solidFill>
                 <a:latin typeface="Helvetica Neue"/>
                 <a:ea typeface="Helvetica Neue"/>
                 <a:cs typeface="Helvetica Neue"/>
               </a:rPr>
-              <a:t>Partial human review and disputed sources limit factual certainty.</a:t>
-            </a:r>
-          </a:p>
-        </p:txBody>
-      </p:sp>
-      <p:sp>
-        <p:nvSpPr>
-          <p:cNvPr id="5" name="">
-            <a:extLst xmlns:a="http://schemas.openxmlformats.org/drawingml/2006/main">
-              <a:ext uri="{FF2B5EF4-FFF2-40B4-BE49-F238E27FC236}">
-                <a16:creationId xmlns:a16="http://schemas.microsoft.com/office/drawing/2014/main" id="{D862022A-0B84-45CE-8804-A01C6BA5C25E}"/>
-              </a:ext>
-            </a:extLst>
-          </p:cNvPr>
-          <p:cNvSpPr>
-            <a:spLocks xmlns:a="http://schemas.openxmlformats.org/drawingml/2006/main" noGrp="1"/>
-          </p:cNvSpPr>
-          <p:nvPr/>
-        </p:nvSpPr>
-        <p:spPr>
-          <a:xfrm xmlns:a="http://schemas.openxmlformats.org/drawingml/2006/main">
-            <a:off x="685800" y="4572000"/>
-            <a:ext cx="10668000" cy="790575"/>
-          </a:xfrm>
-          <a:prstGeom xmlns:a="http://schemas.openxmlformats.org/drawingml/2006/main" prst="rect">
-            <a:avLst/>
-          </a:prstGeom>
-          <a:noFill xmlns:a="http://schemas.openxmlformats.org/drawingml/2006/main"/>
-          <a:ln xmlns:a="http://schemas.openxmlformats.org/drawingml/2006/main" w="0">
-            <a:noFill/>
-          </a:ln>
-        </p:spPr>
-        <p:txBody>
-          <a:bodyPr xmlns:a="http://schemas.openxmlformats.org/drawingml/2006/main">
-            <a:noAutofit/>
-          </a:bodyPr>
-          <a:lstStyle xmlns:a="http://schemas.openxmlformats.org/drawingml/2006/main"/>
-          <a:p xmlns:a="http://schemas.openxmlformats.org/drawingml/2006/main">
-            <a:pPr>
-              <a:defRPr sz="2250" b="0">
-                <a:solidFill>
-                  <a:srgbClr val="142C40"/>
-                </a:solidFill>
-                <a:latin typeface="Helvetica Neue"/>
-                <a:ea typeface="Helvetica Neue"/>
-                <a:cs typeface="Helvetica Neue"/>
-              </a:defRPr>
-            </a:pPr>
-            <a:r>
-              <a:rPr sz="2250" b="0">
-                <a:solidFill>
-                  <a:srgbClr val="142C40"/>
-                </a:solidFill>
-                <a:latin typeface="Helvetica Neue"/>
-                <a:ea typeface="Helvetica Neue"/>
-                <a:cs typeface="Helvetica Neue"/>
-              </a:rPr>
-              <a:t>Selected math families and material failures limit generalisation</a:t>
+              <a:t>No search tool was available. A verification claim is not a retrieval record.</a:t>
             </a:r>
           </a:p>
         </p:txBody>
@@ -3366,7 +4067,7 @@
           <p:cNvPr id="6" name="">
             <a:extLst xmlns:a="http://schemas.openxmlformats.org/drawingml/2006/main">
               <a:ext uri="{FF2B5EF4-FFF2-40B4-BE49-F238E27FC236}">
-                <a16:creationId xmlns:a16="http://schemas.microsoft.com/office/drawing/2014/main" id="{4E7AA611-61B1-4610-8D5A-ACCE8F7994EC}"/>
+                <a16:creationId xmlns:a16="http://schemas.microsoft.com/office/drawing/2014/main" id="{324015AB-513F-4C5D-9912-FE7AFD4358D6}"/>
               </a:ext>
             </a:extLst>
           </p:cNvPr>
@@ -3421,7 +4122,7 @@
     </p:spTree>
     <p:extLst>
       <p:ext uri="{BB962C8B-B14F-4D97-AF65-F5344CB8AC3E}">
-        <p14:creationId xmlns:p14="http://schemas.microsoft.com/office/powerpoint/2010/main" val="970437430"/>
+        <p14:creationId xmlns:p14="http://schemas.microsoft.com/office/powerpoint/2010/main" val="965403770"/>
       </p:ext>
     </p:extLst>
   </p:cSld>
@@ -3449,10 +4150,10 @@
       </p:grpSpPr>
       <p:sp>
         <p:nvSpPr>
-          <p:cNvPr id="7" name="">
+          <p:cNvPr id="6" name="">
             <a:extLst xmlns:a="http://schemas.openxmlformats.org/drawingml/2006/main">
               <a:ext uri="{FF2B5EF4-FFF2-40B4-BE49-F238E27FC236}">
-                <a16:creationId xmlns:a16="http://schemas.microsoft.com/office/drawing/2014/main" id="{0640E6B8-2694-4577-AFA2-3E9086957B14}"/>
+                <a16:creationId xmlns:a16="http://schemas.microsoft.com/office/drawing/2014/main" id="{07B1BB8C-F673-4A7F-94D8-BB030AFE5950}"/>
               </a:ext>
             </a:extLst>
           </p:cNvPr>
@@ -3499,7 +4200,7 @@
                 <a:ea typeface="Helvetica Neue"/>
                 <a:cs typeface="Helvetica Neue"/>
               </a:rPr>
-              <a:t>Proposed next solution</a:t>
+              <a:t>AI review of the withdrawal cases</a:t>
             </a:r>
           </a:p>
         </p:txBody>
@@ -3509,7 +4210,7 @@
           <p:cNvPr id="2" name="">
             <a:extLst xmlns:a="http://schemas.openxmlformats.org/drawingml/2006/main">
               <a:ext uri="{FF2B5EF4-FFF2-40B4-BE49-F238E27FC236}">
-                <a16:creationId xmlns:a16="http://schemas.microsoft.com/office/drawing/2014/main" id="{A6CE9581-6B0F-4D9B-8380-802F5D3EE1A1}"/>
+                <a16:creationId xmlns:a16="http://schemas.microsoft.com/office/drawing/2014/main" id="{C1BAC50A-3B39-402B-9623-859FDBB213DF}"/>
               </a:ext>
             </a:extLst>
           </p:cNvPr>
@@ -3520,8 +4221,8 @@
         </p:nvSpPr>
         <p:spPr>
           <a:xfrm xmlns:a="http://schemas.openxmlformats.org/drawingml/2006/main">
-            <a:off x="685800" y="1657350"/>
-            <a:ext cx="10668000" cy="790575"/>
+            <a:off x="685800" y="1476375"/>
+            <a:ext cx="10668000" cy="476250"/>
           </a:xfrm>
           <a:prstGeom xmlns:a="http://schemas.openxmlformats.org/drawingml/2006/main" prst="rect">
             <a:avLst/>
@@ -3538,9 +4239,9 @@
           <a:lstStyle xmlns:a="http://schemas.openxmlformats.org/drawingml/2006/main"/>
           <a:p xmlns:a="http://schemas.openxmlformats.org/drawingml/2006/main">
             <a:pPr>
-              <a:defRPr sz="2250" b="0">
-                <a:solidFill>
-                  <a:srgbClr val="142C40"/>
+              <a:defRPr sz="2250" b="1">
+                <a:solidFill>
+                  <a:srgbClr val="147E77"/>
                 </a:solidFill>
                 <a:latin typeface="Helvetica Neue"/>
                 <a:ea typeface="Helvetica Neue"/>
@@ -3548,25 +4249,297 @@
               </a:defRPr>
             </a:pPr>
             <a:r>
-              <a:rPr sz="2250" b="0">
-                <a:solidFill>
-                  <a:srgbClr val="142C40"/>
+              <a:rPr sz="2250" b="1">
+                <a:solidFill>
+                  <a:srgbClr val="147E77"/>
                 </a:solidFill>
                 <a:latin typeface="Helvetica Neue"/>
                 <a:ea typeface="Helvetica Neue"/>
                 <a:cs typeface="Helvetica Neue"/>
               </a:rPr>
-              <a:t>Keep the candidate answer and its uncertainty visible separately.</a:t>
-            </a:r>
-          </a:p>
-        </p:txBody>
-      </p:sp>
-      <p:sp>
-        <p:nvSpPr>
-          <p:cNvPr id="3" name="">
+              <a:t>240 paired cases, covering 451 distinct responses</a:t>
+            </a:r>
+          </a:p>
+        </p:txBody>
+      </p:sp>
+      <p:graphicFrame>
+        <p:nvGraphicFramePr>
+          <p:cNvPr id="8" name=""/>
+          <p:cNvGraphicFramePr/>
+          <p:nvPr/>
+        </p:nvGraphicFramePr>
+        <p:xfrm>
+          <a:off xmlns:a="http://schemas.openxmlformats.org/drawingml/2006/main" x="685800" y="2085975"/>
+          <a:ext xmlns:a="http://schemas.openxmlformats.org/drawingml/2006/main" cx="10820400" cy="2924175"/>
+        </p:xfrm>
+        <a:graphic xmlns:a="http://schemas.openxmlformats.org/drawingml/2006/main">
+          <a:graphicData uri="http://schemas.openxmlformats.org/drawingml/2006/table">
+            <a:tbl>
+              <a:tblPr/>
+              <a:tblGrid>
+                <a:gridCol w="8572500"/>
+                <a:gridCol w="2247900"/>
+              </a:tblGrid>
+              <a:tr h="584835">
+                <a:tc>
+                  <a:txBody>
+                    <a:bodyPr/>
+                    <a:lstStyle/>
+                    <a:p>
+                      <a:r>
+                        <a:rPr sz="1950" b="1">
+                          <a:solidFill>
+                            <a:srgbClr val="FFFFFF"/>
+                          </a:solidFill>
+                          <a:latin typeface="Helvetica Neue"/>
+                          <a:ea typeface="Helvetica Neue"/>
+                          <a:cs typeface="Helvetica Neue"/>
+                        </a:rPr>
+                        <a:t>Among 144 wrong-to-abstain pairs</a:t>
+                      </a:r>
+                    </a:p>
+                  </a:txBody>
+                  <a:tcPr marL="91440" marR="91440" marT="45720" marB="45720">
+                    <a:solidFill>
+                      <a:srgbClr val="142C40"/>
+                    </a:solidFill>
+                  </a:tcPr>
+                </a:tc>
+                <a:tc>
+                  <a:txBody>
+                    <a:bodyPr/>
+                    <a:lstStyle/>
+                    <a:p>
+                      <a:r>
+                        <a:rPr sz="1950" b="1">
+                          <a:solidFill>
+                            <a:srgbClr val="FFFFFF"/>
+                          </a:solidFill>
+                          <a:latin typeface="Helvetica Neue"/>
+                          <a:ea typeface="Helvetica Neue"/>
+                          <a:cs typeface="Helvetica Neue"/>
+                        </a:rPr>
+                        <a:t>Count</a:t>
+                      </a:r>
+                    </a:p>
+                  </a:txBody>
+                  <a:tcPr marL="91440" marR="91440" marT="45720" marB="45720">
+                    <a:solidFill>
+                      <a:srgbClr val="142C40"/>
+                    </a:solidFill>
+                  </a:tcPr>
+                </a:tc>
+              </a:tr>
+              <a:tr h="584835">
+                <a:tc>
+                  <a:txBody>
+                    <a:bodyPr/>
+                    <a:lstStyle/>
+                    <a:p>
+                      <a:r>
+                        <a:rPr sz="1950" b="0">
+                          <a:solidFill>
+                            <a:srgbClr val="142C40"/>
+                          </a:solidFill>
+                          <a:latin typeface="Helvetica Neue"/>
+                          <a:ea typeface="Helvetica Neue"/>
+                          <a:cs typeface="Helvetica Neue"/>
+                        </a:rPr>
+                        <a:t>Clearly withholds a date</a:t>
+                      </a:r>
+                    </a:p>
+                  </a:txBody>
+                  <a:tcPr marL="91440" marR="91440" marT="45720" marB="45720">
+                    <a:solidFill>
+                      <a:srgbClr val="F0F4F7"/>
+                    </a:solidFill>
+                  </a:tcPr>
+                </a:tc>
+                <a:tc>
+                  <a:txBody>
+                    <a:bodyPr/>
+                    <a:lstStyle/>
+                    <a:p>
+                      <a:r>
+                        <a:rPr sz="1950" b="0">
+                          <a:solidFill>
+                            <a:srgbClr val="142C40"/>
+                          </a:solidFill>
+                          <a:latin typeface="Helvetica Neue"/>
+                          <a:ea typeface="Helvetica Neue"/>
+                          <a:cs typeface="Helvetica Neue"/>
+                        </a:rPr>
+                        <a:t>114</a:t>
+                      </a:r>
+                    </a:p>
+                  </a:txBody>
+                  <a:tcPr marL="91440" marR="91440" marT="45720" marB="45720">
+                    <a:solidFill>
+                      <a:srgbClr val="F0F4F7"/>
+                    </a:solidFill>
+                  </a:tcPr>
+                </a:tc>
+              </a:tr>
+              <a:tr h="584835">
+                <a:tc>
+                  <a:txBody>
+                    <a:bodyPr/>
+                    <a:lstStyle/>
+                    <a:p>
+                      <a:r>
+                        <a:rPr sz="1950" b="0">
+                          <a:solidFill>
+                            <a:srgbClr val="142C40"/>
+                          </a:solidFill>
+                          <a:latin typeface="Helvetica Neue"/>
+                          <a:ea typeface="Helvetica Neue"/>
+                          <a:cs typeface="Helvetica Neue"/>
+                        </a:rPr>
+                        <a:t>Only an unconfirmed candidate</a:t>
+                      </a:r>
+                    </a:p>
+                  </a:txBody>
+                  <a:tcPr marL="91440" marR="91440" marT="45720" marB="45720">
+                    <a:solidFill>
+                      <a:srgbClr val="FFFFFF"/>
+                    </a:solidFill>
+                  </a:tcPr>
+                </a:tc>
+                <a:tc>
+                  <a:txBody>
+                    <a:bodyPr/>
+                    <a:lstStyle/>
+                    <a:p>
+                      <a:r>
+                        <a:rPr sz="1950" b="0">
+                          <a:solidFill>
+                            <a:srgbClr val="142C40"/>
+                          </a:solidFill>
+                          <a:latin typeface="Helvetica Neue"/>
+                          <a:ea typeface="Helvetica Neue"/>
+                          <a:cs typeface="Helvetica Neue"/>
+                        </a:rPr>
+                        <a:t>25</a:t>
+                      </a:r>
+                    </a:p>
+                  </a:txBody>
+                  <a:tcPr marL="91440" marR="91440" marT="45720" marB="45720">
+                    <a:solidFill>
+                      <a:srgbClr val="FFFFFF"/>
+                    </a:solidFill>
+                  </a:tcPr>
+                </a:tc>
+              </a:tr>
+              <a:tr h="584835">
+                <a:tc>
+                  <a:txBody>
+                    <a:bodyPr/>
+                    <a:lstStyle/>
+                    <a:p>
+                      <a:r>
+                        <a:rPr sz="1950" b="0">
+                          <a:solidFill>
+                            <a:srgbClr val="142C40"/>
+                          </a:solidFill>
+                          <a:latin typeface="Helvetica Neue"/>
+                          <a:ea typeface="Helvetica Neue"/>
+                          <a:cs typeface="Helvetica Neue"/>
+                        </a:rPr>
+                        <a:t>Challenges the premise</a:t>
+                      </a:r>
+                    </a:p>
+                  </a:txBody>
+                  <a:tcPr marL="91440" marR="91440" marT="45720" marB="45720">
+                    <a:solidFill>
+                      <a:srgbClr val="F0F4F7"/>
+                    </a:solidFill>
+                  </a:tcPr>
+                </a:tc>
+                <a:tc>
+                  <a:txBody>
+                    <a:bodyPr/>
+                    <a:lstStyle/>
+                    <a:p>
+                      <a:r>
+                        <a:rPr sz="1950" b="0">
+                          <a:solidFill>
+                            <a:srgbClr val="142C40"/>
+                          </a:solidFill>
+                          <a:latin typeface="Helvetica Neue"/>
+                          <a:ea typeface="Helvetica Neue"/>
+                          <a:cs typeface="Helvetica Neue"/>
+                        </a:rPr>
+                        <a:t>3</a:t>
+                      </a:r>
+                    </a:p>
+                  </a:txBody>
+                  <a:tcPr marL="91440" marR="91440" marT="45720" marB="45720">
+                    <a:solidFill>
+                      <a:srgbClr val="F0F4F7"/>
+                    </a:solidFill>
+                  </a:tcPr>
+                </a:tc>
+              </a:tr>
+              <a:tr h="584835">
+                <a:tc>
+                  <a:txBody>
+                    <a:bodyPr/>
+                    <a:lstStyle/>
+                    <a:p>
+                      <a:r>
+                        <a:rPr sz="1950" b="0">
+                          <a:solidFill>
+                            <a:srgbClr val="142C40"/>
+                          </a:solidFill>
+                          <a:latin typeface="Helvetica Neue"/>
+                          <a:ea typeface="Helvetica Neue"/>
+                          <a:cs typeface="Helvetica Neue"/>
+                        </a:rPr>
+                        <a:t>Retains a relevant date assertion</a:t>
+                      </a:r>
+                    </a:p>
+                  </a:txBody>
+                  <a:tcPr marL="91440" marR="91440" marT="45720" marB="45720">
+                    <a:solidFill>
+                      <a:srgbClr val="FFFFFF"/>
+                    </a:solidFill>
+                  </a:tcPr>
+                </a:tc>
+                <a:tc>
+                  <a:txBody>
+                    <a:bodyPr/>
+                    <a:lstStyle/>
+                    <a:p>
+                      <a:r>
+                        <a:rPr sz="1950" b="0">
+                          <a:solidFill>
+                            <a:srgbClr val="142C40"/>
+                          </a:solidFill>
+                          <a:latin typeface="Helvetica Neue"/>
+                          <a:ea typeface="Helvetica Neue"/>
+                          <a:cs typeface="Helvetica Neue"/>
+                        </a:rPr>
+                        <a:t>2</a:t>
+                      </a:r>
+                    </a:p>
+                  </a:txBody>
+                  <a:tcPr marL="91440" marR="91440" marT="45720" marB="45720">
+                    <a:solidFill>
+                      <a:srgbClr val="FFFFFF"/>
+                    </a:solidFill>
+                  </a:tcPr>
+                </a:tc>
+              </a:tr>
+            </a:tbl>
+          </a:graphicData>
+        </a:graphic>
+      </p:graphicFrame>
+      <p:sp>
+        <p:nvSpPr>
+          <p:cNvPr id="4" name="">
             <a:extLst xmlns:a="http://schemas.openxmlformats.org/drawingml/2006/main">
               <a:ext uri="{FF2B5EF4-FFF2-40B4-BE49-F238E27FC236}">
-                <a16:creationId xmlns:a16="http://schemas.microsoft.com/office/drawing/2014/main" id="{1995B40F-2BFE-4174-BB0D-78BA0E130570}"/>
+                <a16:creationId xmlns:a16="http://schemas.microsoft.com/office/drawing/2014/main" id="{513F9520-A56D-4E8E-9CEF-946CECF508F0}"/>
               </a:ext>
             </a:extLst>
           </p:cNvPr>
@@ -3577,8 +4550,8 @@
         </p:nvSpPr>
         <p:spPr>
           <a:xfrm xmlns:a="http://schemas.openxmlformats.org/drawingml/2006/main">
-            <a:off x="685800" y="2628900"/>
-            <a:ext cx="10668000" cy="790575"/>
+            <a:off x="685800" y="5334000"/>
+            <a:ext cx="10668000" cy="619125"/>
           </a:xfrm>
           <a:prstGeom xmlns:a="http://schemas.openxmlformats.org/drawingml/2006/main" prst="rect">
             <a:avLst/>
@@ -3595,9 +4568,9 @@
           <a:lstStyle xmlns:a="http://schemas.openxmlformats.org/drawingml/2006/main"/>
           <a:p xmlns:a="http://schemas.openxmlformats.org/drawingml/2006/main">
             <a:pPr>
-              <a:defRPr sz="2250" b="0">
-                <a:solidFill>
-                  <a:srgbClr val="142C40"/>
+              <a:defRPr sz="1875" b="0">
+                <a:solidFill>
+                  <a:srgbClr val="657586"/>
                 </a:solidFill>
                 <a:latin typeface="Helvetica Neue"/>
                 <a:ea typeface="Helvetica Neue"/>
@@ -3605,72 +4578,15 @@
               </a:defRPr>
             </a:pPr>
             <a:r>
-              <a:rPr sz="2250" b="0">
-                <a:solidFill>
-                  <a:srgbClr val="142C40"/>
+              <a:rPr sz="1875" b="0">
+                <a:solidFill>
+                  <a:srgbClr val="657586"/>
                 </a:solidFill>
                 <a:latin typeface="Helvetica Neue"/>
                 <a:ea typeface="Helvetica Neue"/>
                 <a:cs typeface="Helvetica Neue"/>
               </a:rPr>
-              <a:t>Attach evidence that supports the exact factual or mathematical claim.</a:t>
-            </a:r>
-          </a:p>
-        </p:txBody>
-      </p:sp>
-      <p:sp>
-        <p:nvSpPr>
-          <p:cNvPr id="4" name="">
-            <a:extLst xmlns:a="http://schemas.openxmlformats.org/drawingml/2006/main">
-              <a:ext uri="{FF2B5EF4-FFF2-40B4-BE49-F238E27FC236}">
-                <a16:creationId xmlns:a16="http://schemas.microsoft.com/office/drawing/2014/main" id="{93456B89-2C3D-4D0B-AB74-0640AF1B2259}"/>
-              </a:ext>
-            </a:extLst>
-          </p:cNvPr>
-          <p:cNvSpPr>
-            <a:spLocks xmlns:a="http://schemas.openxmlformats.org/drawingml/2006/main" noGrp="1"/>
-          </p:cNvSpPr>
-          <p:nvPr/>
-        </p:nvSpPr>
-        <p:spPr>
-          <a:xfrm xmlns:a="http://schemas.openxmlformats.org/drawingml/2006/main">
-            <a:off x="685800" y="3600450"/>
-            <a:ext cx="10668000" cy="790575"/>
-          </a:xfrm>
-          <a:prstGeom xmlns:a="http://schemas.openxmlformats.org/drawingml/2006/main" prst="rect">
-            <a:avLst/>
-          </a:prstGeom>
-          <a:noFill xmlns:a="http://schemas.openxmlformats.org/drawingml/2006/main"/>
-          <a:ln xmlns:a="http://schemas.openxmlformats.org/drawingml/2006/main" w="0">
-            <a:noFill/>
-          </a:ln>
-        </p:spPr>
-        <p:txBody>
-          <a:bodyPr xmlns:a="http://schemas.openxmlformats.org/drawingml/2006/main">
-            <a:noAutofit/>
-          </a:bodyPr>
-          <a:lstStyle xmlns:a="http://schemas.openxmlformats.org/drawingml/2006/main"/>
-          <a:p xmlns:a="http://schemas.openxmlformats.org/drawingml/2006/main">
-            <a:pPr>
-              <a:defRPr sz="2250" b="0">
-                <a:solidFill>
-                  <a:srgbClr val="142C40"/>
-                </a:solidFill>
-                <a:latin typeface="Helvetica Neue"/>
-                <a:ea typeface="Helvetica Neue"/>
-                <a:cs typeface="Helvetica Neue"/>
-              </a:defRPr>
-            </a:pPr>
-            <a:r>
-              <a:rPr sz="2250" b="0">
-                <a:solidFill>
-                  <a:srgbClr val="142C40"/>
-                </a:solidFill>
-                <a:latin typeface="Helvetica Neue"/>
-                <a:ea typeface="Helvetica Neue"/>
-                <a:cs typeface="Helvetica Neue"/>
-              </a:rPr>
-              <a:t>Check against a trusted source or an executable test.</a:t>
+              <a:t>Targeted, unblinded AI review. Other background claims may remain unchecked.</a:t>
             </a:r>
           </a:p>
         </p:txBody>
@@ -3680,64 +4596,7 @@
           <p:cNvPr id="5" name="">
             <a:extLst xmlns:a="http://schemas.openxmlformats.org/drawingml/2006/main">
               <a:ext uri="{FF2B5EF4-FFF2-40B4-BE49-F238E27FC236}">
-                <a16:creationId xmlns:a16="http://schemas.microsoft.com/office/drawing/2014/main" id="{570A2E62-9995-4790-9C5D-0EAC8CAA53EB}"/>
-              </a:ext>
-            </a:extLst>
-          </p:cNvPr>
-          <p:cNvSpPr>
-            <a:spLocks xmlns:a="http://schemas.openxmlformats.org/drawingml/2006/main" noGrp="1"/>
-          </p:cNvSpPr>
-          <p:nvPr/>
-        </p:nvSpPr>
-        <p:spPr>
-          <a:xfrm xmlns:a="http://schemas.openxmlformats.org/drawingml/2006/main">
-            <a:off x="685800" y="4572000"/>
-            <a:ext cx="10668000" cy="790575"/>
-          </a:xfrm>
-          <a:prstGeom xmlns:a="http://schemas.openxmlformats.org/drawingml/2006/main" prst="rect">
-            <a:avLst/>
-          </a:prstGeom>
-          <a:noFill xmlns:a="http://schemas.openxmlformats.org/drawingml/2006/main"/>
-          <a:ln xmlns:a="http://schemas.openxmlformats.org/drawingml/2006/main" w="0">
-            <a:noFill/>
-          </a:ln>
-        </p:spPr>
-        <p:txBody>
-          <a:bodyPr xmlns:a="http://schemas.openxmlformats.org/drawingml/2006/main">
-            <a:noAutofit/>
-          </a:bodyPr>
-          <a:lstStyle xmlns:a="http://schemas.openxmlformats.org/drawingml/2006/main"/>
-          <a:p xmlns:a="http://schemas.openxmlformats.org/drawingml/2006/main">
-            <a:pPr>
-              <a:defRPr sz="2250" b="0">
-                <a:solidFill>
-                  <a:srgbClr val="142C40"/>
-                </a:solidFill>
-                <a:latin typeface="Helvetica Neue"/>
-                <a:ea typeface="Helvetica Neue"/>
-                <a:cs typeface="Helvetica Neue"/>
-              </a:defRPr>
-            </a:pPr>
-            <a:r>
-              <a:rPr sz="2250" b="0">
-                <a:solidFill>
-                  <a:srgbClr val="142C40"/>
-                </a:solidFill>
-                <a:latin typeface="Helvetica Neue"/>
-                <a:ea typeface="Helvetica Neue"/>
-                <a:cs typeface="Helvetica Neue"/>
-              </a:rPr>
-              <a:t>Test this evidence-based arm next; it was not evaluated here</a:t>
-            </a:r>
-          </a:p>
-        </p:txBody>
-      </p:sp>
-      <p:sp>
-        <p:nvSpPr>
-          <p:cNvPr id="6" name="">
-            <a:extLst xmlns:a="http://schemas.openxmlformats.org/drawingml/2006/main">
-              <a:ext uri="{FF2B5EF4-FFF2-40B4-BE49-F238E27FC236}">
-                <a16:creationId xmlns:a16="http://schemas.microsoft.com/office/drawing/2014/main" id="{43D8834D-BE93-4FD6-98A4-E1200C6E34C7}"/>
+                <a16:creationId xmlns:a16="http://schemas.microsoft.com/office/drawing/2014/main" id="{3688988A-2669-4CCD-94D1-CC502271AA87}"/>
               </a:ext>
             </a:extLst>
           </p:cNvPr>
@@ -3792,7 +4651,7 @@
     </p:spTree>
     <p:extLst>
       <p:ext uri="{BB962C8B-B14F-4D97-AF65-F5344CB8AC3E}">
-        <p14:creationId xmlns:p14="http://schemas.microsoft.com/office/powerpoint/2010/main" val="1940959374"/>
+        <p14:creationId xmlns:p14="http://schemas.microsoft.com/office/powerpoint/2010/main" val="1984481312"/>
       </p:ext>
     </p:extLst>
   </p:cSld>
@@ -3820,10 +4679,10 @@
       </p:grpSpPr>
       <p:sp>
         <p:nvSpPr>
-          <p:cNvPr id="9" name="">
+          <p:cNvPr id="7" name="">
             <a:extLst xmlns:a="http://schemas.openxmlformats.org/drawingml/2006/main">
               <a:ext uri="{FF2B5EF4-FFF2-40B4-BE49-F238E27FC236}">
-                <a16:creationId xmlns:a16="http://schemas.microsoft.com/office/drawing/2014/main" id="{39BE5388-B22A-45B9-A7B2-BBAB9613AECF}"/>
+                <a16:creationId xmlns:a16="http://schemas.microsoft.com/office/drawing/2014/main" id="{B4EFB8D7-0EF3-494D-97EA-51A3062DEF4A}"/>
               </a:ext>
             </a:extLst>
           </p:cNvPr>
@@ -3870,7 +4729,7 @@
                 <a:ea typeface="Helvetica Neue"/>
                 <a:cs typeface="Helvetica Neue"/>
               </a:rPr>
-              <a:t>References and contributions</a:t>
+              <a:t>Mathematical validity before calculation</a:t>
             </a:r>
           </a:p>
         </p:txBody>
@@ -3880,7 +4739,1393 @@
           <p:cNvPr id="2" name="">
             <a:extLst xmlns:a="http://schemas.openxmlformats.org/drawingml/2006/main">
               <a:ext uri="{FF2B5EF4-FFF2-40B4-BE49-F238E27FC236}">
-                <a16:creationId xmlns:a16="http://schemas.microsoft.com/office/drawing/2014/main" id="{D3B4E7EC-6EBD-4C53-B5ED-87024CD3C944}"/>
+                <a16:creationId xmlns:a16="http://schemas.microsoft.com/office/drawing/2014/main" id="{B3B34ADF-8133-48CF-8AFE-292D25623D89}"/>
+              </a:ext>
+            </a:extLst>
+          </p:cNvPr>
+          <p:cNvSpPr>
+            <a:spLocks xmlns:a="http://schemas.openxmlformats.org/drawingml/2006/main" noGrp="1"/>
+          </p:cNvSpPr>
+          <p:nvPr/>
+        </p:nvSpPr>
+        <p:spPr>
+          <a:xfrm xmlns:a="http://schemas.openxmlformats.org/drawingml/2006/main">
+            <a:off x="685800" y="1657350"/>
+            <a:ext cx="10668000" cy="790575"/>
+          </a:xfrm>
+          <a:prstGeom xmlns:a="http://schemas.openxmlformats.org/drawingml/2006/main" prst="rect">
+            <a:avLst/>
+          </a:prstGeom>
+          <a:noFill xmlns:a="http://schemas.openxmlformats.org/drawingml/2006/main"/>
+          <a:ln xmlns:a="http://schemas.openxmlformats.org/drawingml/2006/main" w="0">
+            <a:noFill/>
+          </a:ln>
+        </p:spPr>
+        <p:txBody>
+          <a:bodyPr xmlns:a="http://schemas.openxmlformats.org/drawingml/2006/main">
+            <a:noAutofit/>
+          </a:bodyPr>
+          <a:lstStyle xmlns:a="http://schemas.openxmlformats.org/drawingml/2006/main"/>
+          <a:p xmlns:a="http://schemas.openxmlformats.org/drawingml/2006/main">
+            <a:pPr>
+              <a:defRPr sz="2250" b="0">
+                <a:solidFill>
+                  <a:srgbClr val="142C40"/>
+                </a:solidFill>
+                <a:latin typeface="Helvetica Neue"/>
+                <a:ea typeface="Helvetica Neue"/>
+                <a:cs typeface="Helvetica Neue"/>
+              </a:defRPr>
+            </a:pPr>
+            <a:r>
+              <a:rPr sz="2250" b="0">
+                <a:solidFill>
+                  <a:srgbClr val="142C40"/>
+                </a:solidFill>
+                <a:latin typeface="Helvetica Neue"/>
+                <a:ea typeface="Helvetica Neue"/>
+                <a:cs typeface="Helvetica Neue"/>
+              </a:rPr>
+              <a:t>An equilateral triangle has perimeter 30 cm and height 10 cm.</a:t>
+            </a:r>
+          </a:p>
+        </p:txBody>
+      </p:sp>
+      <p:sp>
+        <p:nvSpPr>
+          <p:cNvPr id="3" name="">
+            <a:extLst xmlns:a="http://schemas.openxmlformats.org/drawingml/2006/main">
+              <a:ext uri="{FF2B5EF4-FFF2-40B4-BE49-F238E27FC236}">
+                <a16:creationId xmlns:a16="http://schemas.microsoft.com/office/drawing/2014/main" id="{D2602DEA-17FE-4A1B-B8A0-F46DEC9B0F23}"/>
+              </a:ext>
+            </a:extLst>
+          </p:cNvPr>
+          <p:cNvSpPr>
+            <a:spLocks xmlns:a="http://schemas.openxmlformats.org/drawingml/2006/main" noGrp="1"/>
+          </p:cNvSpPr>
+          <p:nvPr/>
+        </p:nvSpPr>
+        <p:spPr>
+          <a:xfrm xmlns:a="http://schemas.openxmlformats.org/drawingml/2006/main">
+            <a:off x="685800" y="2628900"/>
+            <a:ext cx="10668000" cy="790575"/>
+          </a:xfrm>
+          <a:prstGeom xmlns:a="http://schemas.openxmlformats.org/drawingml/2006/main" prst="rect">
+            <a:avLst/>
+          </a:prstGeom>
+          <a:noFill xmlns:a="http://schemas.openxmlformats.org/drawingml/2006/main"/>
+          <a:ln xmlns:a="http://schemas.openxmlformats.org/drawingml/2006/main" w="0">
+            <a:noFill/>
+          </a:ln>
+        </p:spPr>
+        <p:txBody>
+          <a:bodyPr xmlns:a="http://schemas.openxmlformats.org/drawingml/2006/main">
+            <a:noAutofit/>
+          </a:bodyPr>
+          <a:lstStyle xmlns:a="http://schemas.openxmlformats.org/drawingml/2006/main"/>
+          <a:p xmlns:a="http://schemas.openxmlformats.org/drawingml/2006/main">
+            <a:pPr>
+              <a:defRPr sz="2250" b="0">
+                <a:solidFill>
+                  <a:srgbClr val="142C40"/>
+                </a:solidFill>
+                <a:latin typeface="Helvetica Neue"/>
+                <a:ea typeface="Helvetica Neue"/>
+                <a:cs typeface="Helvetica Neue"/>
+              </a:defRPr>
+            </a:pPr>
+            <a:r>
+              <a:rPr sz="2250" b="0">
+                <a:solidFill>
+                  <a:srgbClr val="142C40"/>
+                </a:solidFill>
+                <a:latin typeface="Helvetica Neue"/>
+                <a:ea typeface="Helvetica Neue"/>
+                <a:cs typeface="Helvetica Neue"/>
+              </a:rPr>
+              <a:t>Direct substitution gives area = 10 × 10 / 2 = 50.</a:t>
+            </a:r>
+          </a:p>
+        </p:txBody>
+      </p:sp>
+      <p:sp>
+        <p:nvSpPr>
+          <p:cNvPr id="4" name="">
+            <a:extLst xmlns:a="http://schemas.openxmlformats.org/drawingml/2006/main">
+              <a:ext uri="{FF2B5EF4-FFF2-40B4-BE49-F238E27FC236}">
+                <a16:creationId xmlns:a16="http://schemas.microsoft.com/office/drawing/2014/main" id="{0D33AD83-324B-4C1F-8292-E691FCA3D245}"/>
+              </a:ext>
+            </a:extLst>
+          </p:cNvPr>
+          <p:cNvSpPr>
+            <a:spLocks xmlns:a="http://schemas.openxmlformats.org/drawingml/2006/main" noGrp="1"/>
+          </p:cNvSpPr>
+          <p:nvPr/>
+        </p:nvSpPr>
+        <p:spPr>
+          <a:xfrm xmlns:a="http://schemas.openxmlformats.org/drawingml/2006/main">
+            <a:off x="685800" y="3600450"/>
+            <a:ext cx="10668000" cy="790575"/>
+          </a:xfrm>
+          <a:prstGeom xmlns:a="http://schemas.openxmlformats.org/drawingml/2006/main" prst="rect">
+            <a:avLst/>
+          </a:prstGeom>
+          <a:noFill xmlns:a="http://schemas.openxmlformats.org/drawingml/2006/main"/>
+          <a:ln xmlns:a="http://schemas.openxmlformats.org/drawingml/2006/main" w="0">
+            <a:noFill/>
+          </a:ln>
+        </p:spPr>
+        <p:txBody>
+          <a:bodyPr xmlns:a="http://schemas.openxmlformats.org/drawingml/2006/main">
+            <a:noAutofit/>
+          </a:bodyPr>
+          <a:lstStyle xmlns:a="http://schemas.openxmlformats.org/drawingml/2006/main"/>
+          <a:p xmlns:a="http://schemas.openxmlformats.org/drawingml/2006/main">
+            <a:pPr>
+              <a:defRPr sz="2250" b="0">
+                <a:solidFill>
+                  <a:srgbClr val="142C40"/>
+                </a:solidFill>
+                <a:latin typeface="Helvetica Neue"/>
+                <a:ea typeface="Helvetica Neue"/>
+                <a:cs typeface="Helvetica Neue"/>
+              </a:defRPr>
+            </a:pPr>
+            <a:r>
+              <a:rPr sz="2250" b="0">
+                <a:solidFill>
+                  <a:srgbClr val="142C40"/>
+                </a:solidFill>
+                <a:latin typeface="Helvetica Neue"/>
+                <a:ea typeface="Helvetica Neue"/>
+                <a:cs typeface="Helvetica Neue"/>
+              </a:rPr>
+              <a:t>But side 10 forces height 5√3 ≈ 8.66. The conditions contradict.</a:t>
+            </a:r>
+          </a:p>
+        </p:txBody>
+      </p:sp>
+      <p:sp>
+        <p:nvSpPr>
+          <p:cNvPr id="5" name="">
+            <a:extLst xmlns:a="http://schemas.openxmlformats.org/drawingml/2006/main">
+              <a:ext uri="{FF2B5EF4-FFF2-40B4-BE49-F238E27FC236}">
+                <a16:creationId xmlns:a16="http://schemas.microsoft.com/office/drawing/2014/main" id="{F619DC6B-8917-487F-AD3A-B042566F2A4F}"/>
+              </a:ext>
+            </a:extLst>
+          </p:cNvPr>
+          <p:cNvSpPr>
+            <a:spLocks xmlns:a="http://schemas.openxmlformats.org/drawingml/2006/main" noGrp="1"/>
+          </p:cNvSpPr>
+          <p:nvPr/>
+        </p:nvSpPr>
+        <p:spPr>
+          <a:xfrm xmlns:a="http://schemas.openxmlformats.org/drawingml/2006/main">
+            <a:off x="685800" y="4572000"/>
+            <a:ext cx="10668000" cy="790575"/>
+          </a:xfrm>
+          <a:prstGeom xmlns:a="http://schemas.openxmlformats.org/drawingml/2006/main" prst="rect">
+            <a:avLst/>
+          </a:prstGeom>
+          <a:noFill xmlns:a="http://schemas.openxmlformats.org/drawingml/2006/main"/>
+          <a:ln xmlns:a="http://schemas.openxmlformats.org/drawingml/2006/main" w="0">
+            <a:noFill/>
+          </a:ln>
+        </p:spPr>
+        <p:txBody>
+          <a:bodyPr xmlns:a="http://schemas.openxmlformats.org/drawingml/2006/main">
+            <a:noAutofit/>
+          </a:bodyPr>
+          <a:lstStyle xmlns:a="http://schemas.openxmlformats.org/drawingml/2006/main"/>
+          <a:p xmlns:a="http://schemas.openxmlformats.org/drawingml/2006/main">
+            <a:pPr>
+              <a:defRPr sz="2250" b="0">
+                <a:solidFill>
+                  <a:srgbClr val="142C40"/>
+                </a:solidFill>
+                <a:latin typeface="Helvetica Neue"/>
+                <a:ea typeface="Helvetica Neue"/>
+                <a:cs typeface="Helvetica Neue"/>
+              </a:defRPr>
+            </a:pPr>
+            <a:r>
+              <a:rPr sz="2250" b="0">
+                <a:solidFill>
+                  <a:srgbClr val="142C40"/>
+                </a:solidFill>
+                <a:latin typeface="Helvetica Neue"/>
+                <a:ea typeface="Helvetica Neue"/>
+                <a:cs typeface="Helvetica Neue"/>
+              </a:rPr>
+              <a:t>“Inconsistent” is a correct conclusion, not a refusal</a:t>
+            </a:r>
+          </a:p>
+        </p:txBody>
+      </p:sp>
+      <p:sp>
+        <p:nvSpPr>
+          <p:cNvPr id="6" name="">
+            <a:extLst xmlns:a="http://schemas.openxmlformats.org/drawingml/2006/main">
+              <a:ext uri="{FF2B5EF4-FFF2-40B4-BE49-F238E27FC236}">
+                <a16:creationId xmlns:a16="http://schemas.microsoft.com/office/drawing/2014/main" id="{E9126044-F4A4-4772-92F5-9F31DC991194}"/>
+              </a:ext>
+            </a:extLst>
+          </p:cNvPr>
+          <p:cNvSpPr>
+            <a:spLocks xmlns:a="http://schemas.openxmlformats.org/drawingml/2006/main" noGrp="1"/>
+          </p:cNvSpPr>
+          <p:nvPr/>
+        </p:nvSpPr>
+        <p:spPr>
+          <a:xfrm xmlns:a="http://schemas.openxmlformats.org/drawingml/2006/main">
+            <a:off x="11049000" y="6334125"/>
+            <a:ext cx="571500" cy="381000"/>
+          </a:xfrm>
+          <a:prstGeom xmlns:a="http://schemas.openxmlformats.org/drawingml/2006/main" prst="rect">
+            <a:avLst/>
+          </a:prstGeom>
+          <a:noFill xmlns:a="http://schemas.openxmlformats.org/drawingml/2006/main"/>
+          <a:ln xmlns:a="http://schemas.openxmlformats.org/drawingml/2006/main" w="0">
+            <a:noFill/>
+          </a:ln>
+        </p:spPr>
+        <p:txBody>
+          <a:bodyPr xmlns:a="http://schemas.openxmlformats.org/drawingml/2006/main">
+            <a:noAutofit/>
+          </a:bodyPr>
+          <a:lstStyle xmlns:a="http://schemas.openxmlformats.org/drawingml/2006/main"/>
+          <a:p xmlns:a="http://schemas.openxmlformats.org/drawingml/2006/main">
+            <a:pPr>
+              <a:defRPr sz="1350" b="0">
+                <a:solidFill>
+                  <a:srgbClr val="657586"/>
+                </a:solidFill>
+                <a:latin typeface="Helvetica Neue"/>
+                <a:ea typeface="Helvetica Neue"/>
+                <a:cs typeface="Helvetica Neue"/>
+              </a:defRPr>
+            </a:pPr>
+            <a:r>
+              <a:rPr sz="1350" b="0">
+                <a:solidFill>
+                  <a:srgbClr val="657586"/>
+                </a:solidFill>
+                <a:latin typeface="Helvetica Neue"/>
+                <a:ea typeface="Helvetica Neue"/>
+                <a:cs typeface="Helvetica Neue"/>
+              </a:rPr>
+              <a:t>12</a:t>
+            </a:r>
+          </a:p>
+        </p:txBody>
+      </p:sp>
+    </p:spTree>
+    <p:extLst>
+      <p:ext uri="{BB962C8B-B14F-4D97-AF65-F5344CB8AC3E}">
+        <p14:creationId xmlns:p14="http://schemas.microsoft.com/office/powerpoint/2010/main" val="285310397"/>
+      </p:ext>
+    </p:extLst>
+  </p:cSld>
+</p:sld>
+</file>
+
+<file path=ppt/slides/slide13.xml><?xml version="1.0" encoding="utf-8"?>
+<p:sld xmlns:p="http://schemas.openxmlformats.org/presentationml/2006/main">
+  <p:cSld>
+    <p:bg>
+      <p:bgPr>
+        <a:solidFill xmlns:a="http://schemas.openxmlformats.org/drawingml/2006/main">
+          <a:srgbClr val="FAFBFD"/>
+        </a:solidFill>
+      </p:bgPr>
+    </p:bg>
+    <p:spTree>
+      <p:nvGrpSpPr>
+        <p:cNvPr id="1" name=""/>
+        <p:cNvGrpSpPr/>
+        <p:nvPr/>
+      </p:nvGrpSpPr>
+      <p:grpSpPr>
+        <a:xfrm xmlns:a="http://schemas.openxmlformats.org/drawingml/2006/main"/>
+      </p:grpSpPr>
+      <p:sp>
+        <p:nvSpPr>
+          <p:cNvPr id="6" name="">
+            <a:extLst xmlns:a="http://schemas.openxmlformats.org/drawingml/2006/main">
+              <a:ext uri="{FF2B5EF4-FFF2-40B4-BE49-F238E27FC236}">
+                <a16:creationId xmlns:a16="http://schemas.microsoft.com/office/drawing/2014/main" id="{0D1FD701-327D-4502-A218-AF491AA0E081}"/>
+              </a:ext>
+            </a:extLst>
+          </p:cNvPr>
+          <p:cNvSpPr>
+            <a:spLocks xmlns:a="http://schemas.openxmlformats.org/drawingml/2006/main" noGrp="1"/>
+          </p:cNvSpPr>
+          <p:nvPr/>
+        </p:nvSpPr>
+        <p:spPr>
+          <a:xfrm xmlns:a="http://schemas.openxmlformats.org/drawingml/2006/main">
+            <a:off x="628650" y="400050"/>
+            <a:ext cx="10934700" cy="904875"/>
+          </a:xfrm>
+          <a:prstGeom xmlns:a="http://schemas.openxmlformats.org/drawingml/2006/main" prst="rect">
+            <a:avLst/>
+          </a:prstGeom>
+          <a:noFill xmlns:a="http://schemas.openxmlformats.org/drawingml/2006/main"/>
+          <a:ln xmlns:a="http://schemas.openxmlformats.org/drawingml/2006/main" w="0">
+            <a:noFill/>
+          </a:ln>
+        </p:spPr>
+        <p:txBody>
+          <a:bodyPr xmlns:a="http://schemas.openxmlformats.org/drawingml/2006/main">
+            <a:noAutofit/>
+          </a:bodyPr>
+          <a:lstStyle xmlns:a="http://schemas.openxmlformats.org/drawingml/2006/main"/>
+          <a:p xmlns:a="http://schemas.openxmlformats.org/drawingml/2006/main">
+            <a:pPr>
+              <a:defRPr sz="3300" b="1">
+                <a:solidFill>
+                  <a:srgbClr val="142C40"/>
+                </a:solidFill>
+                <a:latin typeface="Helvetica Neue"/>
+                <a:ea typeface="Helvetica Neue"/>
+                <a:cs typeface="Helvetica Neue"/>
+              </a:defRPr>
+            </a:pPr>
+            <a:r>
+              <a:rPr sz="3300" b="1">
+                <a:solidFill>
+                  <a:srgbClr val="142C40"/>
+                </a:solidFill>
+                <a:latin typeface="Helvetica Neue"/>
+                <a:ea typeface="Helvetica Neue"/>
+                <a:cs typeface="Helvetica Neue"/>
+              </a:rPr>
+              <a:t>Mathematics: a partial descriptive supplement</a:t>
+            </a:r>
+          </a:p>
+        </p:txBody>
+      </p:sp>
+      <p:graphicFrame>
+        <p:nvGraphicFramePr>
+          <p:cNvPr id="7" name="Chart"/>
+          <p:cNvGraphicFramePr/>
+          <p:nvPr/>
+        </p:nvGraphicFramePr>
+        <p:xfrm>
+          <a:off xmlns:a="http://schemas.openxmlformats.org/drawingml/2006/main" x="952500" y="1619250"/>
+          <a:ext xmlns:a="http://schemas.openxmlformats.org/drawingml/2006/main" cx="10096500" cy="3429000"/>
+        </p:xfrm>
+        <a:graphic xmlns:a="http://schemas.openxmlformats.org/drawingml/2006/main">
+          <a:graphicData uri="http://schemas.openxmlformats.org/drawingml/2006/chart">
+            <c:chart xmlns:r="http://schemas.openxmlformats.org/officeDocument/2006/relationships" xmlns:c="http://schemas.openxmlformats.org/drawingml/2006/chart" r:id="Rcb33cef46c8843b0"/>
+          </a:graphicData>
+        </a:graphic>
+      </p:graphicFrame>
+      <p:sp>
+        <p:nvSpPr>
+          <p:cNvPr id="3" name="">
+            <a:extLst xmlns:a="http://schemas.openxmlformats.org/drawingml/2006/main">
+              <a:ext uri="{FF2B5EF4-FFF2-40B4-BE49-F238E27FC236}">
+                <a16:creationId xmlns:a16="http://schemas.microsoft.com/office/drawing/2014/main" id="{704AAEFF-337A-40BF-93EA-FBF9DCB3104F}"/>
+              </a:ext>
+            </a:extLst>
+          </p:cNvPr>
+          <p:cNvSpPr>
+            <a:spLocks xmlns:a="http://schemas.openxmlformats.org/drawingml/2006/main" noGrp="1"/>
+          </p:cNvSpPr>
+          <p:nvPr/>
+        </p:nvSpPr>
+        <p:spPr>
+          <a:xfrm xmlns:a="http://schemas.openxmlformats.org/drawingml/2006/main">
+            <a:off x="685800" y="5238750"/>
+            <a:ext cx="10668000" cy="457200"/>
+          </a:xfrm>
+          <a:prstGeom xmlns:a="http://schemas.openxmlformats.org/drawingml/2006/main" prst="rect">
+            <a:avLst/>
+          </a:prstGeom>
+          <a:noFill xmlns:a="http://schemas.openxmlformats.org/drawingml/2006/main"/>
+          <a:ln xmlns:a="http://schemas.openxmlformats.org/drawingml/2006/main" w="0">
+            <a:noFill/>
+          </a:ln>
+        </p:spPr>
+        <p:txBody>
+          <a:bodyPr xmlns:a="http://schemas.openxmlformats.org/drawingml/2006/main">
+            <a:noAutofit/>
+          </a:bodyPr>
+          <a:lstStyle xmlns:a="http://schemas.openxmlformats.org/drawingml/2006/main"/>
+          <a:p xmlns:a="http://schemas.openxmlformats.org/drawingml/2006/main">
+            <a:pPr>
+              <a:defRPr sz="1950" b="1">
+                <a:solidFill>
+                  <a:srgbClr val="147E77"/>
+                </a:solidFill>
+                <a:latin typeface="Helvetica Neue"/>
+                <a:ea typeface="Helvetica Neue"/>
+                <a:cs typeface="Helvetica Neue"/>
+              </a:defRPr>
+            </a:pPr>
+            <a:r>
+              <a:rPr sz="1950" b="1">
+                <a:solidFill>
+                  <a:srgbClr val="147E77"/>
+                </a:solidFill>
+                <a:latin typeface="Helvetica Neue"/>
+                <a:ea typeface="Helvetica Neue"/>
+                <a:cs typeface="Helvetica Neue"/>
+              </a:rPr>
+              <a:t>13 retained items; 71 complete units; correct final conclusions shown</a:t>
+            </a:r>
+          </a:p>
+        </p:txBody>
+      </p:sp>
+      <p:sp>
+        <p:nvSpPr>
+          <p:cNvPr id="4" name="">
+            <a:extLst xmlns:a="http://schemas.openxmlformats.org/drawingml/2006/main">
+              <a:ext uri="{FF2B5EF4-FFF2-40B4-BE49-F238E27FC236}">
+                <a16:creationId xmlns:a16="http://schemas.microsoft.com/office/drawing/2014/main" id="{B2C4CCE3-7229-4DD7-A46E-20B0C8E4F15C}"/>
+              </a:ext>
+            </a:extLst>
+          </p:cNvPr>
+          <p:cNvSpPr>
+            <a:spLocks xmlns:a="http://schemas.openxmlformats.org/drawingml/2006/main" noGrp="1"/>
+          </p:cNvSpPr>
+          <p:nvPr/>
+        </p:nvSpPr>
+        <p:spPr>
+          <a:xfrm xmlns:a="http://schemas.openxmlformats.org/drawingml/2006/main">
+            <a:off x="685800" y="5772150"/>
+            <a:ext cx="10668000" cy="495300"/>
+          </a:xfrm>
+          <a:prstGeom xmlns:a="http://schemas.openxmlformats.org/drawingml/2006/main" prst="rect">
+            <a:avLst/>
+          </a:prstGeom>
+          <a:noFill xmlns:a="http://schemas.openxmlformats.org/drawingml/2006/main"/>
+          <a:ln xmlns:a="http://schemas.openxmlformats.org/drawingml/2006/main" w="0">
+            <a:noFill/>
+          </a:ln>
+        </p:spPr>
+        <p:txBody>
+          <a:bodyPr xmlns:a="http://schemas.openxmlformats.org/drawingml/2006/main">
+            <a:noAutofit/>
+          </a:bodyPr>
+          <a:lstStyle xmlns:a="http://schemas.openxmlformats.org/drawingml/2006/main"/>
+          <a:p xmlns:a="http://schemas.openxmlformats.org/drawingml/2006/main">
+            <a:pPr>
+              <a:defRPr sz="1875" b="0">
+                <a:solidFill>
+                  <a:srgbClr val="657586"/>
+                </a:solidFill>
+                <a:latin typeface="Helvetica Neue"/>
+                <a:ea typeface="Helvetica Neue"/>
+                <a:cs typeface="Helvetica Neue"/>
+              </a:defRPr>
+            </a:pPr>
+            <a:r>
+              <a:rPr sz="1875" b="0">
+                <a:solidFill>
+                  <a:srgbClr val="657586"/>
+                </a:solidFill>
+                <a:latin typeface="Helvetica Neue"/>
+                <a:ea typeface="Helvetica Neue"/>
+                <a:cs typeface="Helvetica Neue"/>
+              </a:rPr>
+              <a:t>13/16 initial errors have correct reason endpoints, but wrong final fields.</a:t>
+            </a:r>
+          </a:p>
+        </p:txBody>
+      </p:sp>
+      <p:sp>
+        <p:nvSpPr>
+          <p:cNvPr id="5" name="">
+            <a:extLst xmlns:a="http://schemas.openxmlformats.org/drawingml/2006/main">
+              <a:ext uri="{FF2B5EF4-FFF2-40B4-BE49-F238E27FC236}">
+                <a16:creationId xmlns:a16="http://schemas.microsoft.com/office/drawing/2014/main" id="{F653524B-13F3-449F-A481-C11522EE0434}"/>
+              </a:ext>
+            </a:extLst>
+          </p:cNvPr>
+          <p:cNvSpPr>
+            <a:spLocks xmlns:a="http://schemas.openxmlformats.org/drawingml/2006/main" noGrp="1"/>
+          </p:cNvSpPr>
+          <p:nvPr/>
+        </p:nvSpPr>
+        <p:spPr>
+          <a:xfrm xmlns:a="http://schemas.openxmlformats.org/drawingml/2006/main">
+            <a:off x="11049000" y="6334125"/>
+            <a:ext cx="571500" cy="381000"/>
+          </a:xfrm>
+          <a:prstGeom xmlns:a="http://schemas.openxmlformats.org/drawingml/2006/main" prst="rect">
+            <a:avLst/>
+          </a:prstGeom>
+          <a:noFill xmlns:a="http://schemas.openxmlformats.org/drawingml/2006/main"/>
+          <a:ln xmlns:a="http://schemas.openxmlformats.org/drawingml/2006/main" w="0">
+            <a:noFill/>
+          </a:ln>
+        </p:spPr>
+        <p:txBody>
+          <a:bodyPr xmlns:a="http://schemas.openxmlformats.org/drawingml/2006/main">
+            <a:noAutofit/>
+          </a:bodyPr>
+          <a:lstStyle xmlns:a="http://schemas.openxmlformats.org/drawingml/2006/main"/>
+          <a:p xmlns:a="http://schemas.openxmlformats.org/drawingml/2006/main">
+            <a:pPr>
+              <a:defRPr sz="1350" b="0">
+                <a:solidFill>
+                  <a:srgbClr val="657586"/>
+                </a:solidFill>
+                <a:latin typeface="Helvetica Neue"/>
+                <a:ea typeface="Helvetica Neue"/>
+                <a:cs typeface="Helvetica Neue"/>
+              </a:defRPr>
+            </a:pPr>
+            <a:r>
+              <a:rPr sz="1350" b="0">
+                <a:solidFill>
+                  <a:srgbClr val="657586"/>
+                </a:solidFill>
+                <a:latin typeface="Helvetica Neue"/>
+                <a:ea typeface="Helvetica Neue"/>
+                <a:cs typeface="Helvetica Neue"/>
+              </a:rPr>
+              <a:t>13</a:t>
+            </a:r>
+          </a:p>
+        </p:txBody>
+      </p:sp>
+    </p:spTree>
+    <p:extLst>
+      <p:ext uri="{BB962C8B-B14F-4D97-AF65-F5344CB8AC3E}">
+        <p14:creationId xmlns:p14="http://schemas.microsoft.com/office/powerpoint/2010/main" val="1706683397"/>
+      </p:ext>
+    </p:extLst>
+  </p:cSld>
+</p:sld>
+</file>
+
+<file path=ppt/slides/slide14.xml><?xml version="1.0" encoding="utf-8"?>
+<p:sld xmlns:p="http://schemas.openxmlformats.org/presentationml/2006/main">
+  <p:cSld>
+    <p:bg>
+      <p:bgPr>
+        <a:solidFill xmlns:a="http://schemas.openxmlformats.org/drawingml/2006/main">
+          <a:srgbClr val="FAFBFD"/>
+        </a:solidFill>
+      </p:bgPr>
+    </p:bg>
+    <p:spTree>
+      <p:nvGrpSpPr>
+        <p:cNvPr id="1" name=""/>
+        <p:cNvGrpSpPr/>
+        <p:nvPr/>
+      </p:nvGrpSpPr>
+      <p:grpSpPr>
+        <a:xfrm xmlns:a="http://schemas.openxmlformats.org/drawingml/2006/main"/>
+      </p:grpSpPr>
+      <p:sp>
+        <p:nvSpPr>
+          <p:cNvPr id="7" name="">
+            <a:extLst xmlns:a="http://schemas.openxmlformats.org/drawingml/2006/main">
+              <a:ext uri="{FF2B5EF4-FFF2-40B4-BE49-F238E27FC236}">
+                <a16:creationId xmlns:a16="http://schemas.microsoft.com/office/drawing/2014/main" id="{B017F3AF-059A-4003-8A51-88CAA5B4D803}"/>
+              </a:ext>
+            </a:extLst>
+          </p:cNvPr>
+          <p:cNvSpPr>
+            <a:spLocks xmlns:a="http://schemas.openxmlformats.org/drawingml/2006/main" noGrp="1"/>
+          </p:cNvSpPr>
+          <p:nvPr/>
+        </p:nvSpPr>
+        <p:spPr>
+          <a:xfrm xmlns:a="http://schemas.openxmlformats.org/drawingml/2006/main">
+            <a:off x="628650" y="400050"/>
+            <a:ext cx="10934700" cy="904875"/>
+          </a:xfrm>
+          <a:prstGeom xmlns:a="http://schemas.openxmlformats.org/drawingml/2006/main" prst="rect">
+            <a:avLst/>
+          </a:prstGeom>
+          <a:noFill xmlns:a="http://schemas.openxmlformats.org/drawingml/2006/main"/>
+          <a:ln xmlns:a="http://schemas.openxmlformats.org/drawingml/2006/main" w="0">
+            <a:noFill/>
+          </a:ln>
+        </p:spPr>
+        <p:txBody>
+          <a:bodyPr xmlns:a="http://schemas.openxmlformats.org/drawingml/2006/main">
+            <a:noAutofit/>
+          </a:bodyPr>
+          <a:lstStyle xmlns:a="http://schemas.openxmlformats.org/drawingml/2006/main"/>
+          <a:p xmlns:a="http://schemas.openxmlformats.org/drawingml/2006/main">
+            <a:pPr>
+              <a:defRPr sz="3300" b="1">
+                <a:solidFill>
+                  <a:srgbClr val="142C40"/>
+                </a:solidFill>
+                <a:latin typeface="Helvetica Neue"/>
+                <a:ea typeface="Helvetica Neue"/>
+                <a:cs typeface="Helvetica Neue"/>
+              </a:defRPr>
+            </a:pPr>
+            <a:r>
+              <a:rPr sz="3300" b="1">
+                <a:solidFill>
+                  <a:srgbClr val="142C40"/>
+                </a:solidFill>
+                <a:latin typeface="Helvetica Neue"/>
+                <a:ea typeface="Helvetica Neue"/>
+                <a:cs typeface="Helvetica Neue"/>
+              </a:rPr>
+              <a:t>What these results can establish</a:t>
+            </a:r>
+          </a:p>
+        </p:txBody>
+      </p:sp>
+      <p:sp>
+        <p:nvSpPr>
+          <p:cNvPr id="2" name="">
+            <a:extLst xmlns:a="http://schemas.openxmlformats.org/drawingml/2006/main">
+              <a:ext uri="{FF2B5EF4-FFF2-40B4-BE49-F238E27FC236}">
+                <a16:creationId xmlns:a16="http://schemas.microsoft.com/office/drawing/2014/main" id="{9B2EA1A8-8D96-4298-B96D-0DFED510A1B7}"/>
+              </a:ext>
+            </a:extLst>
+          </p:cNvPr>
+          <p:cNvSpPr>
+            <a:spLocks xmlns:a="http://schemas.openxmlformats.org/drawingml/2006/main" noGrp="1"/>
+          </p:cNvSpPr>
+          <p:nvPr/>
+        </p:nvSpPr>
+        <p:spPr>
+          <a:xfrm xmlns:a="http://schemas.openxmlformats.org/drawingml/2006/main">
+            <a:off x="685800" y="1657350"/>
+            <a:ext cx="10668000" cy="790575"/>
+          </a:xfrm>
+          <a:prstGeom xmlns:a="http://schemas.openxmlformats.org/drawingml/2006/main" prst="rect">
+            <a:avLst/>
+          </a:prstGeom>
+          <a:noFill xmlns:a="http://schemas.openxmlformats.org/drawingml/2006/main"/>
+          <a:ln xmlns:a="http://schemas.openxmlformats.org/drawingml/2006/main" w="0">
+            <a:noFill/>
+          </a:ln>
+        </p:spPr>
+        <p:txBody>
+          <a:bodyPr xmlns:a="http://schemas.openxmlformats.org/drawingml/2006/main">
+            <a:noAutofit/>
+          </a:bodyPr>
+          <a:lstStyle xmlns:a="http://schemas.openxmlformats.org/drawingml/2006/main"/>
+          <a:p xmlns:a="http://schemas.openxmlformats.org/drawingml/2006/main">
+            <a:pPr>
+              <a:defRPr sz="2250" b="0">
+                <a:solidFill>
+                  <a:srgbClr val="142C40"/>
+                </a:solidFill>
+                <a:latin typeface="Helvetica Neue"/>
+                <a:ea typeface="Helvetica Neue"/>
+                <a:cs typeface="Helvetica Neue"/>
+              </a:defRPr>
+            </a:pPr>
+            <a:r>
+              <a:rPr sz="2250" b="0">
+                <a:solidFill>
+                  <a:srgbClr val="142C40"/>
+                </a:solidFill>
+                <a:latin typeface="Helvetica Neue"/>
+                <a:ea typeface="Helvetica Neue"/>
+                <a:cs typeface="Helvetica Neue"/>
+              </a:rPr>
+              <a:t>Wrong input raises pooled error in these selected factual questions.</a:t>
+            </a:r>
+          </a:p>
+        </p:txBody>
+      </p:sp>
+      <p:sp>
+        <p:nvSpPr>
+          <p:cNvPr id="3" name="">
+            <a:extLst xmlns:a="http://schemas.openxmlformats.org/drawingml/2006/main">
+              <a:ext uri="{FF2B5EF4-FFF2-40B4-BE49-F238E27FC236}">
+                <a16:creationId xmlns:a16="http://schemas.microsoft.com/office/drawing/2014/main" id="{0224EC71-97DD-46A6-B0BC-C08C37C7CF15}"/>
+              </a:ext>
+            </a:extLst>
+          </p:cNvPr>
+          <p:cNvSpPr>
+            <a:spLocks xmlns:a="http://schemas.openxmlformats.org/drawingml/2006/main" noGrp="1"/>
+          </p:cNvSpPr>
+          <p:nvPr/>
+        </p:nvSpPr>
+        <p:spPr>
+          <a:xfrm xmlns:a="http://schemas.openxmlformats.org/drawingml/2006/main">
+            <a:off x="685800" y="2628900"/>
+            <a:ext cx="10668000" cy="790575"/>
+          </a:xfrm>
+          <a:prstGeom xmlns:a="http://schemas.openxmlformats.org/drawingml/2006/main" prst="rect">
+            <a:avLst/>
+          </a:prstGeom>
+          <a:noFill xmlns:a="http://schemas.openxmlformats.org/drawingml/2006/main"/>
+          <a:ln xmlns:a="http://schemas.openxmlformats.org/drawingml/2006/main" w="0">
+            <a:noFill/>
+          </a:ln>
+        </p:spPr>
+        <p:txBody>
+          <a:bodyPr xmlns:a="http://schemas.openxmlformats.org/drawingml/2006/main">
+            <a:noAutofit/>
+          </a:bodyPr>
+          <a:lstStyle xmlns:a="http://schemas.openxmlformats.org/drawingml/2006/main"/>
+          <a:p xmlns:a="http://schemas.openxmlformats.org/drawingml/2006/main">
+            <a:pPr>
+              <a:defRPr sz="2250" b="0">
+                <a:solidFill>
+                  <a:srgbClr val="142C40"/>
+                </a:solidFill>
+                <a:latin typeface="Helvetica Neue"/>
+                <a:ea typeface="Helvetica Neue"/>
+                <a:cs typeface="Helvetica Neue"/>
+              </a:defRPr>
+            </a:pPr>
+            <a:r>
+              <a:rPr sz="2250" b="0">
+                <a:solidFill>
+                  <a:srgbClr val="142C40"/>
+                </a:solidFill>
+                <a:latin typeface="Helvetica Neue"/>
+                <a:ea typeface="Helvetica Neue"/>
+                <a:cs typeface="Helvetica Neue"/>
+              </a:rPr>
+              <a:t>Structured checking reduces wrong output, often through abstention.</a:t>
+            </a:r>
+          </a:p>
+        </p:txBody>
+      </p:sp>
+      <p:sp>
+        <p:nvSpPr>
+          <p:cNvPr id="4" name="">
+            <a:extLst xmlns:a="http://schemas.openxmlformats.org/drawingml/2006/main">
+              <a:ext uri="{FF2B5EF4-FFF2-40B4-BE49-F238E27FC236}">
+                <a16:creationId xmlns:a16="http://schemas.microsoft.com/office/drawing/2014/main" id="{0D90AAB5-9F76-4396-8291-5F241F2CD2E6}"/>
+              </a:ext>
+            </a:extLst>
+          </p:cNvPr>
+          <p:cNvSpPr>
+            <a:spLocks xmlns:a="http://schemas.openxmlformats.org/drawingml/2006/main" noGrp="1"/>
+          </p:cNvSpPr>
+          <p:nvPr/>
+        </p:nvSpPr>
+        <p:spPr>
+          <a:xfrm xmlns:a="http://schemas.openxmlformats.org/drawingml/2006/main">
+            <a:off x="685800" y="3600450"/>
+            <a:ext cx="10668000" cy="790575"/>
+          </a:xfrm>
+          <a:prstGeom xmlns:a="http://schemas.openxmlformats.org/drawingml/2006/main" prst="rect">
+            <a:avLst/>
+          </a:prstGeom>
+          <a:noFill xmlns:a="http://schemas.openxmlformats.org/drawingml/2006/main"/>
+          <a:ln xmlns:a="http://schemas.openxmlformats.org/drawingml/2006/main" w="0">
+            <a:noFill/>
+          </a:ln>
+        </p:spPr>
+        <p:txBody>
+          <a:bodyPr xmlns:a="http://schemas.openxmlformats.org/drawingml/2006/main">
+            <a:noAutofit/>
+          </a:bodyPr>
+          <a:lstStyle xmlns:a="http://schemas.openxmlformats.org/drawingml/2006/main"/>
+          <a:p xmlns:a="http://schemas.openxmlformats.org/drawingml/2006/main">
+            <a:pPr>
+              <a:defRPr sz="2250" b="0">
+                <a:solidFill>
+                  <a:srgbClr val="142C40"/>
+                </a:solidFill>
+                <a:latin typeface="Helvetica Neue"/>
+                <a:ea typeface="Helvetica Neue"/>
+                <a:cs typeface="Helvetica Neue"/>
+              </a:defRPr>
+            </a:pPr>
+            <a:r>
+              <a:rPr sz="2250" b="0">
+                <a:solidFill>
+                  <a:srgbClr val="142C40"/>
+                </a:solidFill>
+                <a:latin typeface="Helvetica Neue"/>
+                <a:ea typeface="Helvetica Neue"/>
+                <a:cs typeface="Helvetica Neue"/>
+              </a:rPr>
+              <a:t>Model differences and disputed references limit generalisation.</a:t>
+            </a:r>
+          </a:p>
+        </p:txBody>
+      </p:sp>
+      <p:sp>
+        <p:nvSpPr>
+          <p:cNvPr id="5" name="">
+            <a:extLst xmlns:a="http://schemas.openxmlformats.org/drawingml/2006/main">
+              <a:ext uri="{FF2B5EF4-FFF2-40B4-BE49-F238E27FC236}">
+                <a16:creationId xmlns:a16="http://schemas.microsoft.com/office/drawing/2014/main" id="{19AB7727-1FFF-44AC-AE13-AD12016D0A2B}"/>
+              </a:ext>
+            </a:extLst>
+          </p:cNvPr>
+          <p:cNvSpPr>
+            <a:spLocks xmlns:a="http://schemas.openxmlformats.org/drawingml/2006/main" noGrp="1"/>
+          </p:cNvSpPr>
+          <p:nvPr/>
+        </p:nvSpPr>
+        <p:spPr>
+          <a:xfrm xmlns:a="http://schemas.openxmlformats.org/drawingml/2006/main">
+            <a:off x="685800" y="4572000"/>
+            <a:ext cx="10668000" cy="790575"/>
+          </a:xfrm>
+          <a:prstGeom xmlns:a="http://schemas.openxmlformats.org/drawingml/2006/main" prst="rect">
+            <a:avLst/>
+          </a:prstGeom>
+          <a:noFill xmlns:a="http://schemas.openxmlformats.org/drawingml/2006/main"/>
+          <a:ln xmlns:a="http://schemas.openxmlformats.org/drawingml/2006/main" w="0">
+            <a:noFill/>
+          </a:ln>
+        </p:spPr>
+        <p:txBody>
+          <a:bodyPr xmlns:a="http://schemas.openxmlformats.org/drawingml/2006/main">
+            <a:noAutofit/>
+          </a:bodyPr>
+          <a:lstStyle xmlns:a="http://schemas.openxmlformats.org/drawingml/2006/main"/>
+          <a:p xmlns:a="http://schemas.openxmlformats.org/drawingml/2006/main">
+            <a:pPr>
+              <a:defRPr sz="2250" b="0">
+                <a:solidFill>
+                  <a:srgbClr val="142C40"/>
+                </a:solidFill>
+                <a:latin typeface="Helvetica Neue"/>
+                <a:ea typeface="Helvetica Neue"/>
+                <a:cs typeface="Helvetica Neue"/>
+              </a:defRPr>
+            </a:pPr>
+            <a:r>
+              <a:rPr sz="2250" b="0">
+                <a:solidFill>
+                  <a:srgbClr val="142C40"/>
+                </a:solidFill>
+                <a:latin typeface="Helvetica Neue"/>
+                <a:ea typeface="Helvetica Neue"/>
+                <a:cs typeface="Helvetica Neue"/>
+              </a:rPr>
+              <a:t>Human interaction is simulated. Effects on human thinking are unmeasured.</a:t>
+            </a:r>
+          </a:p>
+        </p:txBody>
+      </p:sp>
+      <p:sp>
+        <p:nvSpPr>
+          <p:cNvPr id="6" name="">
+            <a:extLst xmlns:a="http://schemas.openxmlformats.org/drawingml/2006/main">
+              <a:ext uri="{FF2B5EF4-FFF2-40B4-BE49-F238E27FC236}">
+                <a16:creationId xmlns:a16="http://schemas.microsoft.com/office/drawing/2014/main" id="{20424934-CFDB-4F2C-A3F7-A36D9A67A882}"/>
+              </a:ext>
+            </a:extLst>
+          </p:cNvPr>
+          <p:cNvSpPr>
+            <a:spLocks xmlns:a="http://schemas.openxmlformats.org/drawingml/2006/main" noGrp="1"/>
+          </p:cNvSpPr>
+          <p:nvPr/>
+        </p:nvSpPr>
+        <p:spPr>
+          <a:xfrm xmlns:a="http://schemas.openxmlformats.org/drawingml/2006/main">
+            <a:off x="11049000" y="6334125"/>
+            <a:ext cx="571500" cy="381000"/>
+          </a:xfrm>
+          <a:prstGeom xmlns:a="http://schemas.openxmlformats.org/drawingml/2006/main" prst="rect">
+            <a:avLst/>
+          </a:prstGeom>
+          <a:noFill xmlns:a="http://schemas.openxmlformats.org/drawingml/2006/main"/>
+          <a:ln xmlns:a="http://schemas.openxmlformats.org/drawingml/2006/main" w="0">
+            <a:noFill/>
+          </a:ln>
+        </p:spPr>
+        <p:txBody>
+          <a:bodyPr xmlns:a="http://schemas.openxmlformats.org/drawingml/2006/main">
+            <a:noAutofit/>
+          </a:bodyPr>
+          <a:lstStyle xmlns:a="http://schemas.openxmlformats.org/drawingml/2006/main"/>
+          <a:p xmlns:a="http://schemas.openxmlformats.org/drawingml/2006/main">
+            <a:pPr>
+              <a:defRPr sz="1350" b="0">
+                <a:solidFill>
+                  <a:srgbClr val="657586"/>
+                </a:solidFill>
+                <a:latin typeface="Helvetica Neue"/>
+                <a:ea typeface="Helvetica Neue"/>
+                <a:cs typeface="Helvetica Neue"/>
+              </a:defRPr>
+            </a:pPr>
+            <a:r>
+              <a:rPr sz="1350" b="0">
+                <a:solidFill>
+                  <a:srgbClr val="657586"/>
+                </a:solidFill>
+                <a:latin typeface="Helvetica Neue"/>
+                <a:ea typeface="Helvetica Neue"/>
+                <a:cs typeface="Helvetica Neue"/>
+              </a:rPr>
+              <a:t>14</a:t>
+            </a:r>
+          </a:p>
+        </p:txBody>
+      </p:sp>
+    </p:spTree>
+    <p:extLst>
+      <p:ext uri="{BB962C8B-B14F-4D97-AF65-F5344CB8AC3E}">
+        <p14:creationId xmlns:p14="http://schemas.microsoft.com/office/powerpoint/2010/main" val="1887696135"/>
+      </p:ext>
+    </p:extLst>
+  </p:cSld>
+</p:sld>
+</file>
+
+<file path=ppt/slides/slide15.xml><?xml version="1.0" encoding="utf-8"?>
+<p:sld xmlns:p="http://schemas.openxmlformats.org/presentationml/2006/main">
+  <p:cSld>
+    <p:bg>
+      <p:bgPr>
+        <a:solidFill xmlns:a="http://schemas.openxmlformats.org/drawingml/2006/main">
+          <a:srgbClr val="FAFBFD"/>
+        </a:solidFill>
+      </p:bgPr>
+    </p:bg>
+    <p:spTree>
+      <p:nvGrpSpPr>
+        <p:cNvPr id="1" name=""/>
+        <p:cNvGrpSpPr/>
+        <p:nvPr/>
+      </p:nvGrpSpPr>
+      <p:grpSpPr>
+        <a:xfrm xmlns:a="http://schemas.openxmlformats.org/drawingml/2006/main"/>
+      </p:grpSpPr>
+      <p:sp>
+        <p:nvSpPr>
+          <p:cNvPr id="7" name="">
+            <a:extLst xmlns:a="http://schemas.openxmlformats.org/drawingml/2006/main">
+              <a:ext uri="{FF2B5EF4-FFF2-40B4-BE49-F238E27FC236}">
+                <a16:creationId xmlns:a16="http://schemas.microsoft.com/office/drawing/2014/main" id="{0C66E4F4-9CF9-4F12-B4F6-2BB10D28ED24}"/>
+              </a:ext>
+            </a:extLst>
+          </p:cNvPr>
+          <p:cNvSpPr>
+            <a:spLocks xmlns:a="http://schemas.openxmlformats.org/drawingml/2006/main" noGrp="1"/>
+          </p:cNvSpPr>
+          <p:nvPr/>
+        </p:nvSpPr>
+        <p:spPr>
+          <a:xfrm xmlns:a="http://schemas.openxmlformats.org/drawingml/2006/main">
+            <a:off x="628650" y="400050"/>
+            <a:ext cx="10934700" cy="904875"/>
+          </a:xfrm>
+          <a:prstGeom xmlns:a="http://schemas.openxmlformats.org/drawingml/2006/main" prst="rect">
+            <a:avLst/>
+          </a:prstGeom>
+          <a:noFill xmlns:a="http://schemas.openxmlformats.org/drawingml/2006/main"/>
+          <a:ln xmlns:a="http://schemas.openxmlformats.org/drawingml/2006/main" w="0">
+            <a:noFill/>
+          </a:ln>
+        </p:spPr>
+        <p:txBody>
+          <a:bodyPr xmlns:a="http://schemas.openxmlformats.org/drawingml/2006/main">
+            <a:noAutofit/>
+          </a:bodyPr>
+          <a:lstStyle xmlns:a="http://schemas.openxmlformats.org/drawingml/2006/main"/>
+          <a:p xmlns:a="http://schemas.openxmlformats.org/drawingml/2006/main">
+            <a:pPr>
+              <a:defRPr sz="3300" b="1">
+                <a:solidFill>
+                  <a:srgbClr val="142C40"/>
+                </a:solidFill>
+                <a:latin typeface="Helvetica Neue"/>
+                <a:ea typeface="Helvetica Neue"/>
+                <a:cs typeface="Helvetica Neue"/>
+              </a:defRPr>
+            </a:pPr>
+            <a:r>
+              <a:rPr sz="3300" b="1">
+                <a:solidFill>
+                  <a:srgbClr val="142C40"/>
+                </a:solidFill>
+                <a:latin typeface="Helvetica Neue"/>
+                <a:ea typeface="Helvetica Neue"/>
+                <a:cs typeface="Helvetica Neue"/>
+              </a:rPr>
+              <a:t>Proposed next solution</a:t>
+            </a:r>
+          </a:p>
+        </p:txBody>
+      </p:sp>
+      <p:sp>
+        <p:nvSpPr>
+          <p:cNvPr id="2" name="">
+            <a:extLst xmlns:a="http://schemas.openxmlformats.org/drawingml/2006/main">
+              <a:ext uri="{FF2B5EF4-FFF2-40B4-BE49-F238E27FC236}">
+                <a16:creationId xmlns:a16="http://schemas.microsoft.com/office/drawing/2014/main" id="{690A5077-8439-4EA3-8910-76070002B039}"/>
+              </a:ext>
+            </a:extLst>
+          </p:cNvPr>
+          <p:cNvSpPr>
+            <a:spLocks xmlns:a="http://schemas.openxmlformats.org/drawingml/2006/main" noGrp="1"/>
+          </p:cNvSpPr>
+          <p:nvPr/>
+        </p:nvSpPr>
+        <p:spPr>
+          <a:xfrm xmlns:a="http://schemas.openxmlformats.org/drawingml/2006/main">
+            <a:off x="685800" y="1657350"/>
+            <a:ext cx="10668000" cy="790575"/>
+          </a:xfrm>
+          <a:prstGeom xmlns:a="http://schemas.openxmlformats.org/drawingml/2006/main" prst="rect">
+            <a:avLst/>
+          </a:prstGeom>
+          <a:noFill xmlns:a="http://schemas.openxmlformats.org/drawingml/2006/main"/>
+          <a:ln xmlns:a="http://schemas.openxmlformats.org/drawingml/2006/main" w="0">
+            <a:noFill/>
+          </a:ln>
+        </p:spPr>
+        <p:txBody>
+          <a:bodyPr xmlns:a="http://schemas.openxmlformats.org/drawingml/2006/main">
+            <a:noAutofit/>
+          </a:bodyPr>
+          <a:lstStyle xmlns:a="http://schemas.openxmlformats.org/drawingml/2006/main"/>
+          <a:p xmlns:a="http://schemas.openxmlformats.org/drawingml/2006/main">
+            <a:pPr>
+              <a:defRPr sz="2250" b="0">
+                <a:solidFill>
+                  <a:srgbClr val="142C40"/>
+                </a:solidFill>
+                <a:latin typeface="Helvetica Neue"/>
+                <a:ea typeface="Helvetica Neue"/>
+                <a:cs typeface="Helvetica Neue"/>
+              </a:defRPr>
+            </a:pPr>
+            <a:r>
+              <a:rPr sz="2250" b="0">
+                <a:solidFill>
+                  <a:srgbClr val="142C40"/>
+                </a:solidFill>
+                <a:latin typeface="Helvetica Neue"/>
+                <a:ea typeface="Helvetica Neue"/>
+                <a:cs typeface="Helvetica Neue"/>
+              </a:rPr>
+              <a:t>Label your own assumptions before asking AI to build on them.</a:t>
+            </a:r>
+          </a:p>
+        </p:txBody>
+      </p:sp>
+      <p:sp>
+        <p:nvSpPr>
+          <p:cNvPr id="3" name="">
+            <a:extLst xmlns:a="http://schemas.openxmlformats.org/drawingml/2006/main">
+              <a:ext uri="{FF2B5EF4-FFF2-40B4-BE49-F238E27FC236}">
+                <a16:creationId xmlns:a16="http://schemas.microsoft.com/office/drawing/2014/main" id="{CA726091-1B42-4AA6-858A-9002CAB8A0EA}"/>
+              </a:ext>
+            </a:extLst>
+          </p:cNvPr>
+          <p:cNvSpPr>
+            <a:spLocks xmlns:a="http://schemas.openxmlformats.org/drawingml/2006/main" noGrp="1"/>
+          </p:cNvSpPr>
+          <p:nvPr/>
+        </p:nvSpPr>
+        <p:spPr>
+          <a:xfrm xmlns:a="http://schemas.openxmlformats.org/drawingml/2006/main">
+            <a:off x="685800" y="2628900"/>
+            <a:ext cx="10668000" cy="790575"/>
+          </a:xfrm>
+          <a:prstGeom xmlns:a="http://schemas.openxmlformats.org/drawingml/2006/main" prst="rect">
+            <a:avLst/>
+          </a:prstGeom>
+          <a:noFill xmlns:a="http://schemas.openxmlformats.org/drawingml/2006/main"/>
+          <a:ln xmlns:a="http://schemas.openxmlformats.org/drawingml/2006/main" w="0">
+            <a:noFill/>
+          </a:ln>
+        </p:spPr>
+        <p:txBody>
+          <a:bodyPr xmlns:a="http://schemas.openxmlformats.org/drawingml/2006/main">
+            <a:noAutofit/>
+          </a:bodyPr>
+          <a:lstStyle xmlns:a="http://schemas.openxmlformats.org/drawingml/2006/main"/>
+          <a:p xmlns:a="http://schemas.openxmlformats.org/drawingml/2006/main">
+            <a:pPr>
+              <a:defRPr sz="2250" b="0">
+                <a:solidFill>
+                  <a:srgbClr val="142C40"/>
+                </a:solidFill>
+                <a:latin typeface="Helvetica Neue"/>
+                <a:ea typeface="Helvetica Neue"/>
+                <a:cs typeface="Helvetica Neue"/>
+              </a:defRPr>
+            </a:pPr>
+            <a:r>
+              <a:rPr sz="2250" b="0">
+                <a:solidFill>
+                  <a:srgbClr val="142C40"/>
+                </a:solidFill>
+                <a:latin typeface="Helvetica Neue"/>
+                <a:ea typeface="Helvetica Neue"/>
+                <a:cs typeface="Helvetica Neue"/>
+              </a:rPr>
+              <a:t>Ask for evidence supporting the exact claim. Verify the source.</a:t>
+            </a:r>
+          </a:p>
+        </p:txBody>
+      </p:sp>
+      <p:sp>
+        <p:nvSpPr>
+          <p:cNvPr id="4" name="">
+            <a:extLst xmlns:a="http://schemas.openxmlformats.org/drawingml/2006/main">
+              <a:ext uri="{FF2B5EF4-FFF2-40B4-BE49-F238E27FC236}">
+                <a16:creationId xmlns:a16="http://schemas.microsoft.com/office/drawing/2014/main" id="{2FD6961A-1E4E-49D1-BABE-16158B96DDD3}"/>
+              </a:ext>
+            </a:extLst>
+          </p:cNvPr>
+          <p:cNvSpPr>
+            <a:spLocks xmlns:a="http://schemas.openxmlformats.org/drawingml/2006/main" noGrp="1"/>
+          </p:cNvSpPr>
+          <p:nvPr/>
+        </p:nvSpPr>
+        <p:spPr>
+          <a:xfrm xmlns:a="http://schemas.openxmlformats.org/drawingml/2006/main">
+            <a:off x="685800" y="3600450"/>
+            <a:ext cx="10668000" cy="790575"/>
+          </a:xfrm>
+          <a:prstGeom xmlns:a="http://schemas.openxmlformats.org/drawingml/2006/main" prst="rect">
+            <a:avLst/>
+          </a:prstGeom>
+          <a:noFill xmlns:a="http://schemas.openxmlformats.org/drawingml/2006/main"/>
+          <a:ln xmlns:a="http://schemas.openxmlformats.org/drawingml/2006/main" w="0">
+            <a:noFill/>
+          </a:ln>
+        </p:spPr>
+        <p:txBody>
+          <a:bodyPr xmlns:a="http://schemas.openxmlformats.org/drawingml/2006/main">
+            <a:noAutofit/>
+          </a:bodyPr>
+          <a:lstStyle xmlns:a="http://schemas.openxmlformats.org/drawingml/2006/main"/>
+          <a:p xmlns:a="http://schemas.openxmlformats.org/drawingml/2006/main">
+            <a:pPr>
+              <a:defRPr sz="2250" b="0">
+                <a:solidFill>
+                  <a:srgbClr val="142C40"/>
+                </a:solidFill>
+                <a:latin typeface="Helvetica Neue"/>
+                <a:ea typeface="Helvetica Neue"/>
+                <a:cs typeface="Helvetica Neue"/>
+              </a:defRPr>
+            </a:pPr>
+            <a:r>
+              <a:rPr sz="2250" b="0">
+                <a:solidFill>
+                  <a:srgbClr val="142C40"/>
+                </a:solidFill>
+                <a:latin typeface="Helvetica Neue"/>
+                <a:ea typeface="Helvetica Neue"/>
+                <a:cs typeface="Helvetica Neue"/>
+              </a:rPr>
+              <a:t>Keep uncertainty visible when evidence is insufficient.</a:t>
+            </a:r>
+          </a:p>
+        </p:txBody>
+      </p:sp>
+      <p:sp>
+        <p:nvSpPr>
+          <p:cNvPr id="5" name="">
+            <a:extLst xmlns:a="http://schemas.openxmlformats.org/drawingml/2006/main">
+              <a:ext uri="{FF2B5EF4-FFF2-40B4-BE49-F238E27FC236}">
+                <a16:creationId xmlns:a16="http://schemas.microsoft.com/office/drawing/2014/main" id="{69BD65E9-6B63-4BB1-950C-ACCA094A99D4}"/>
+              </a:ext>
+            </a:extLst>
+          </p:cNvPr>
+          <p:cNvSpPr>
+            <a:spLocks xmlns:a="http://schemas.openxmlformats.org/drawingml/2006/main" noGrp="1"/>
+          </p:cNvSpPr>
+          <p:nvPr/>
+        </p:nvSpPr>
+        <p:spPr>
+          <a:xfrm xmlns:a="http://schemas.openxmlformats.org/drawingml/2006/main">
+            <a:off x="685800" y="4572000"/>
+            <a:ext cx="10668000" cy="790575"/>
+          </a:xfrm>
+          <a:prstGeom xmlns:a="http://schemas.openxmlformats.org/drawingml/2006/main" prst="rect">
+            <a:avLst/>
+          </a:prstGeom>
+          <a:noFill xmlns:a="http://schemas.openxmlformats.org/drawingml/2006/main"/>
+          <a:ln xmlns:a="http://schemas.openxmlformats.org/drawingml/2006/main" w="0">
+            <a:noFill/>
+          </a:ln>
+        </p:spPr>
+        <p:txBody>
+          <a:bodyPr xmlns:a="http://schemas.openxmlformats.org/drawingml/2006/main">
+            <a:noAutofit/>
+          </a:bodyPr>
+          <a:lstStyle xmlns:a="http://schemas.openxmlformats.org/drawingml/2006/main"/>
+          <a:p xmlns:a="http://schemas.openxmlformats.org/drawingml/2006/main">
+            <a:pPr>
+              <a:defRPr sz="2250" b="0">
+                <a:solidFill>
+                  <a:srgbClr val="142C40"/>
+                </a:solidFill>
+                <a:latin typeface="Helvetica Neue"/>
+                <a:ea typeface="Helvetica Neue"/>
+                <a:cs typeface="Helvetica Neue"/>
+              </a:defRPr>
+            </a:pPr>
+            <a:r>
+              <a:rPr sz="2250" b="0">
+                <a:solidFill>
+                  <a:srgbClr val="142C40"/>
+                </a:solidFill>
+                <a:latin typeface="Helvetica Neue"/>
+                <a:ea typeface="Helvetica Neue"/>
+                <a:cs typeface="Helvetica Neue"/>
+              </a:rPr>
+              <a:t>External search and executable checks remain an untested next step.</a:t>
+            </a:r>
+          </a:p>
+        </p:txBody>
+      </p:sp>
+      <p:sp>
+        <p:nvSpPr>
+          <p:cNvPr id="6" name="">
+            <a:extLst xmlns:a="http://schemas.openxmlformats.org/drawingml/2006/main">
+              <a:ext uri="{FF2B5EF4-FFF2-40B4-BE49-F238E27FC236}">
+                <a16:creationId xmlns:a16="http://schemas.microsoft.com/office/drawing/2014/main" id="{B46E396C-A1F0-4BA5-960F-D864C861287C}"/>
+              </a:ext>
+            </a:extLst>
+          </p:cNvPr>
+          <p:cNvSpPr>
+            <a:spLocks xmlns:a="http://schemas.openxmlformats.org/drawingml/2006/main" noGrp="1"/>
+          </p:cNvSpPr>
+          <p:nvPr/>
+        </p:nvSpPr>
+        <p:spPr>
+          <a:xfrm xmlns:a="http://schemas.openxmlformats.org/drawingml/2006/main">
+            <a:off x="11049000" y="6334125"/>
+            <a:ext cx="571500" cy="381000"/>
+          </a:xfrm>
+          <a:prstGeom xmlns:a="http://schemas.openxmlformats.org/drawingml/2006/main" prst="rect">
+            <a:avLst/>
+          </a:prstGeom>
+          <a:noFill xmlns:a="http://schemas.openxmlformats.org/drawingml/2006/main"/>
+          <a:ln xmlns:a="http://schemas.openxmlformats.org/drawingml/2006/main" w="0">
+            <a:noFill/>
+          </a:ln>
+        </p:spPr>
+        <p:txBody>
+          <a:bodyPr xmlns:a="http://schemas.openxmlformats.org/drawingml/2006/main">
+            <a:noAutofit/>
+          </a:bodyPr>
+          <a:lstStyle xmlns:a="http://schemas.openxmlformats.org/drawingml/2006/main"/>
+          <a:p xmlns:a="http://schemas.openxmlformats.org/drawingml/2006/main">
+            <a:pPr>
+              <a:defRPr sz="1350" b="0">
+                <a:solidFill>
+                  <a:srgbClr val="657586"/>
+                </a:solidFill>
+                <a:latin typeface="Helvetica Neue"/>
+                <a:ea typeface="Helvetica Neue"/>
+                <a:cs typeface="Helvetica Neue"/>
+              </a:defRPr>
+            </a:pPr>
+            <a:r>
+              <a:rPr sz="1350" b="0">
+                <a:solidFill>
+                  <a:srgbClr val="657586"/>
+                </a:solidFill>
+                <a:latin typeface="Helvetica Neue"/>
+                <a:ea typeface="Helvetica Neue"/>
+                <a:cs typeface="Helvetica Neue"/>
+              </a:rPr>
+              <a:t>15</a:t>
+            </a:r>
+          </a:p>
+        </p:txBody>
+      </p:sp>
+    </p:spTree>
+    <p:extLst>
+      <p:ext uri="{BB962C8B-B14F-4D97-AF65-F5344CB8AC3E}">
+        <p14:creationId xmlns:p14="http://schemas.microsoft.com/office/powerpoint/2010/main" val="1913051853"/>
+      </p:ext>
+    </p:extLst>
+  </p:cSld>
+</p:sld>
+</file>
+
+<file path=ppt/slides/slide16.xml><?xml version="1.0" encoding="utf-8"?>
+<p:sld xmlns:p="http://schemas.openxmlformats.org/presentationml/2006/main">
+  <p:cSld>
+    <p:bg>
+      <p:bgPr>
+        <a:solidFill xmlns:a="http://schemas.openxmlformats.org/drawingml/2006/main">
+          <a:srgbClr val="FAFBFD"/>
+        </a:solidFill>
+      </p:bgPr>
+    </p:bg>
+    <p:spTree>
+      <p:nvGrpSpPr>
+        <p:cNvPr id="1" name=""/>
+        <p:cNvGrpSpPr/>
+        <p:nvPr/>
+      </p:nvGrpSpPr>
+      <p:grpSpPr>
+        <a:xfrm xmlns:a="http://schemas.openxmlformats.org/drawingml/2006/main"/>
+      </p:grpSpPr>
+      <p:sp>
+        <p:nvSpPr>
+          <p:cNvPr id="9" name="">
+            <a:extLst xmlns:a="http://schemas.openxmlformats.org/drawingml/2006/main">
+              <a:ext uri="{FF2B5EF4-FFF2-40B4-BE49-F238E27FC236}">
+                <a16:creationId xmlns:a16="http://schemas.microsoft.com/office/drawing/2014/main" id="{50761862-505E-499B-B2F9-5F95ABA668E9}"/>
+              </a:ext>
+            </a:extLst>
+          </p:cNvPr>
+          <p:cNvSpPr>
+            <a:spLocks xmlns:a="http://schemas.openxmlformats.org/drawingml/2006/main" noGrp="1"/>
+          </p:cNvSpPr>
+          <p:nvPr/>
+        </p:nvSpPr>
+        <p:spPr>
+          <a:xfrm xmlns:a="http://schemas.openxmlformats.org/drawingml/2006/main">
+            <a:off x="628650" y="400050"/>
+            <a:ext cx="10934700" cy="904875"/>
+          </a:xfrm>
+          <a:prstGeom xmlns:a="http://schemas.openxmlformats.org/drawingml/2006/main" prst="rect">
+            <a:avLst/>
+          </a:prstGeom>
+          <a:noFill xmlns:a="http://schemas.openxmlformats.org/drawingml/2006/main"/>
+          <a:ln xmlns:a="http://schemas.openxmlformats.org/drawingml/2006/main" w="0">
+            <a:noFill/>
+          </a:ln>
+        </p:spPr>
+        <p:txBody>
+          <a:bodyPr xmlns:a="http://schemas.openxmlformats.org/drawingml/2006/main">
+            <a:noAutofit/>
+          </a:bodyPr>
+          <a:lstStyle xmlns:a="http://schemas.openxmlformats.org/drawingml/2006/main"/>
+          <a:p xmlns:a="http://schemas.openxmlformats.org/drawingml/2006/main">
+            <a:pPr>
+              <a:defRPr sz="3300" b="1">
+                <a:solidFill>
+                  <a:srgbClr val="142C40"/>
+                </a:solidFill>
+                <a:latin typeface="Helvetica Neue"/>
+                <a:ea typeface="Helvetica Neue"/>
+                <a:cs typeface="Helvetica Neue"/>
+              </a:defRPr>
+            </a:pPr>
+            <a:r>
+              <a:rPr sz="3300" b="1">
+                <a:solidFill>
+                  <a:srgbClr val="142C40"/>
+                </a:solidFill>
+                <a:latin typeface="Helvetica Neue"/>
+                <a:ea typeface="Helvetica Neue"/>
+                <a:cs typeface="Helvetica Neue"/>
+              </a:rPr>
+              <a:t>References and contributions</a:t>
+            </a:r>
+          </a:p>
+        </p:txBody>
+      </p:sp>
+      <p:sp>
+        <p:nvSpPr>
+          <p:cNvPr id="2" name="">
+            <a:extLst xmlns:a="http://schemas.openxmlformats.org/drawingml/2006/main">
+              <a:ext uri="{FF2B5EF4-FFF2-40B4-BE49-F238E27FC236}">
+                <a16:creationId xmlns:a16="http://schemas.microsoft.com/office/drawing/2014/main" id="{41E28287-B801-4D60-8D81-D016DBDA9547}"/>
               </a:ext>
             </a:extLst>
           </p:cNvPr>
@@ -3937,7 +6182,7 @@
           <p:cNvPr id="3" name="">
             <a:extLst xmlns:a="http://schemas.openxmlformats.org/drawingml/2006/main">
               <a:ext uri="{FF2B5EF4-FFF2-40B4-BE49-F238E27FC236}">
-                <a16:creationId xmlns:a16="http://schemas.microsoft.com/office/drawing/2014/main" id="{71343621-D88D-421C-8537-ADB9BBB4BE36}"/>
+                <a16:creationId xmlns:a16="http://schemas.microsoft.com/office/drawing/2014/main" id="{A01E3DB2-DAB9-4492-98A6-DBD19C0EDCBB}"/>
               </a:ext>
             </a:extLst>
           </p:cNvPr>
@@ -3994,7 +6239,7 @@
           <p:cNvPr id="4" name="">
             <a:extLst xmlns:a="http://schemas.openxmlformats.org/drawingml/2006/main">
               <a:ext uri="{FF2B5EF4-FFF2-40B4-BE49-F238E27FC236}">
-                <a16:creationId xmlns:a16="http://schemas.microsoft.com/office/drawing/2014/main" id="{3BBAE9D1-445C-4F29-B57A-D37D7367E7FC}"/>
+                <a16:creationId xmlns:a16="http://schemas.microsoft.com/office/drawing/2014/main" id="{3D40F7ED-4D1A-44F3-B8C5-E41811A7F59D}"/>
               </a:ext>
             </a:extLst>
           </p:cNvPr>
@@ -4051,7 +6296,7 @@
           <p:cNvPr id="5" name="">
             <a:extLst xmlns:a="http://schemas.openxmlformats.org/drawingml/2006/main">
               <a:ext uri="{FF2B5EF4-FFF2-40B4-BE49-F238E27FC236}">
-                <a16:creationId xmlns:a16="http://schemas.microsoft.com/office/drawing/2014/main" id="{209EFFD7-053C-47C6-BE03-2A31B6926DE8}"/>
+                <a16:creationId xmlns:a16="http://schemas.microsoft.com/office/drawing/2014/main" id="{5196B187-5CF0-49C2-BA1B-E900D34C1431}"/>
               </a:ext>
             </a:extLst>
           </p:cNvPr>
@@ -4108,7 +6353,7 @@
           <p:cNvPr id="6" name="">
             <a:extLst xmlns:a="http://schemas.openxmlformats.org/drawingml/2006/main">
               <a:ext uri="{FF2B5EF4-FFF2-40B4-BE49-F238E27FC236}">
-                <a16:creationId xmlns:a16="http://schemas.microsoft.com/office/drawing/2014/main" id="{454FF49E-782F-4B4B-B3AF-4128171F445E}"/>
+                <a16:creationId xmlns:a16="http://schemas.microsoft.com/office/drawing/2014/main" id="{502D72C8-963D-45F7-9F91-433C71A257EA}"/>
               </a:ext>
             </a:extLst>
           </p:cNvPr>
@@ -4165,7 +6410,7 @@
           <p:cNvPr id="7" name="">
             <a:extLst xmlns:a="http://schemas.openxmlformats.org/drawingml/2006/main">
               <a:ext uri="{FF2B5EF4-FFF2-40B4-BE49-F238E27FC236}">
-                <a16:creationId xmlns:a16="http://schemas.microsoft.com/office/drawing/2014/main" id="{26EFEF9F-95F1-4CEF-8D2F-F12075B598EA}"/>
+                <a16:creationId xmlns:a16="http://schemas.microsoft.com/office/drawing/2014/main" id="{02D59AA9-A04F-4EA1-838C-6497EF0DB5C2}"/>
               </a:ext>
             </a:extLst>
           </p:cNvPr>
@@ -4212,7 +6457,7 @@
                 <a:ea typeface="Helvetica Neue"/>
                 <a:cs typeface="Helvetica Neue"/>
               </a:rPr>
-              <a:t>R processing. Codex implementation and review. Claude Code review used Kimi.</a:t>
+              <a:t>LINYUNIAN and PAN ZHENGYU</a:t>
             </a:r>
           </a:p>
           <a:p xmlns:a="http://schemas.openxmlformats.org/drawingml/2006/main">
@@ -4235,7 +6480,7 @@
                 <a:ea typeface="Helvetica Neue"/>
                 <a:cs typeface="Helvetica Neue"/>
               </a:rPr>
-              <a:t>45 targeted human judgments; full independent review remains pending.</a:t>
+              <a:t>R processing and Codex assistance. Earlier Claude Code review used Kimi.</a:t>
             </a:r>
           </a:p>
         </p:txBody>
@@ -4245,7 +6490,7 @@
           <p:cNvPr id="8" name="">
             <a:extLst xmlns:a="http://schemas.openxmlformats.org/drawingml/2006/main">
               <a:ext uri="{FF2B5EF4-FFF2-40B4-BE49-F238E27FC236}">
-                <a16:creationId xmlns:a16="http://schemas.microsoft.com/office/drawing/2014/main" id="{409A4104-9BEA-47B0-A8D3-092A174CA6CB}"/>
+                <a16:creationId xmlns:a16="http://schemas.microsoft.com/office/drawing/2014/main" id="{4CA055F3-96F5-4D26-9D3A-52B719C4F8B6}"/>
               </a:ext>
             </a:extLst>
           </p:cNvPr>
@@ -4292,7 +6537,7 @@
                 <a:ea typeface="Helvetica Neue"/>
                 <a:cs typeface="Helvetica Neue"/>
               </a:rPr>
-              <a:t>12</a:t>
+              <a:t>16</a:t>
             </a:r>
           </a:p>
         </p:txBody>
@@ -4300,7 +6545,7 @@
     </p:spTree>
     <p:extLst>
       <p:ext uri="{BB962C8B-B14F-4D97-AF65-F5344CB8AC3E}">
-        <p14:creationId xmlns:p14="http://schemas.microsoft.com/office/powerpoint/2010/main" val="1512222751"/>
+        <p14:creationId xmlns:p14="http://schemas.microsoft.com/office/powerpoint/2010/main" val="78617997"/>
       </p:ext>
     </p:extLst>
   </p:cSld>
@@ -4331,7 +6576,7 @@
           <p:cNvPr id="7" name="">
             <a:extLst xmlns:a="http://schemas.openxmlformats.org/drawingml/2006/main">
               <a:ext uri="{FF2B5EF4-FFF2-40B4-BE49-F238E27FC236}">
-                <a16:creationId xmlns:a16="http://schemas.microsoft.com/office/drawing/2014/main" id="{A75E8C6E-BBD2-432D-A685-8F4C8A09F244}"/>
+                <a16:creationId xmlns:a16="http://schemas.microsoft.com/office/drawing/2014/main" id="{9D9E23A6-36E6-43F4-A1C1-8B399412A453}"/>
               </a:ext>
             </a:extLst>
           </p:cNvPr>
@@ -4388,7 +6633,7 @@
           <p:cNvPr id="2" name="">
             <a:extLst xmlns:a="http://schemas.openxmlformats.org/drawingml/2006/main">
               <a:ext uri="{FF2B5EF4-FFF2-40B4-BE49-F238E27FC236}">
-                <a16:creationId xmlns:a16="http://schemas.microsoft.com/office/drawing/2014/main" id="{3B34F585-3628-466B-8431-162E061D4404}"/>
+                <a16:creationId xmlns:a16="http://schemas.microsoft.com/office/drawing/2014/main" id="{E4EA8B47-B1FE-4786-AFE1-ED758F989B5F}"/>
               </a:ext>
             </a:extLst>
           </p:cNvPr>
@@ -4445,7 +6690,7 @@
           <p:cNvPr id="3" name="">
             <a:extLst xmlns:a="http://schemas.openxmlformats.org/drawingml/2006/main">
               <a:ext uri="{FF2B5EF4-FFF2-40B4-BE49-F238E27FC236}">
-                <a16:creationId xmlns:a16="http://schemas.microsoft.com/office/drawing/2014/main" id="{621394D7-806D-4EF3-8140-2040EAB9F700}"/>
+                <a16:creationId xmlns:a16="http://schemas.microsoft.com/office/drawing/2014/main" id="{E06C61DC-B0B4-4D4A-A0E5-9CC910273D29}"/>
               </a:ext>
             </a:extLst>
           </p:cNvPr>
@@ -4502,7 +6747,7 @@
           <p:cNvPr id="4" name="">
             <a:extLst xmlns:a="http://schemas.openxmlformats.org/drawingml/2006/main">
               <a:ext uri="{FF2B5EF4-FFF2-40B4-BE49-F238E27FC236}">
-                <a16:creationId xmlns:a16="http://schemas.microsoft.com/office/drawing/2014/main" id="{868CB4AA-160D-4132-9920-28C7A8D2876F}"/>
+                <a16:creationId xmlns:a16="http://schemas.microsoft.com/office/drawing/2014/main" id="{E798B944-7ED8-4194-A079-ED1293A04F0B}"/>
               </a:ext>
             </a:extLst>
           </p:cNvPr>
@@ -4559,7 +6804,7 @@
           <p:cNvPr id="5" name="">
             <a:extLst xmlns:a="http://schemas.openxmlformats.org/drawingml/2006/main">
               <a:ext uri="{FF2B5EF4-FFF2-40B4-BE49-F238E27FC236}">
-                <a16:creationId xmlns:a16="http://schemas.microsoft.com/office/drawing/2014/main" id="{DB913C37-3E2F-4ACA-99C6-9AA90114F643}"/>
+                <a16:creationId xmlns:a16="http://schemas.microsoft.com/office/drawing/2014/main" id="{535D0D43-8E8C-4BC7-AF19-1BFBB0CEC168}"/>
               </a:ext>
             </a:extLst>
           </p:cNvPr>
@@ -4606,7 +6851,7 @@
                 <a:ea typeface="Helvetica Neue"/>
                 <a:cs typeface="Helvetica Neue"/>
               </a:rPr>
-              <a:t>Scope  One follow-up, no search tools, no model training</a:t>
+              <a:t>Added post-hoc analysis  Can wrong input turn uncertainty into error?</a:t>
             </a:r>
           </a:p>
         </p:txBody>
@@ -4616,7 +6861,7 @@
           <p:cNvPr id="6" name="">
             <a:extLst xmlns:a="http://schemas.openxmlformats.org/drawingml/2006/main">
               <a:ext uri="{FF2B5EF4-FFF2-40B4-BE49-F238E27FC236}">
-                <a16:creationId xmlns:a16="http://schemas.microsoft.com/office/drawing/2014/main" id="{E4EED8CF-646B-4612-8187-3BE85C0637F6}"/>
+                <a16:creationId xmlns:a16="http://schemas.microsoft.com/office/drawing/2014/main" id="{693D36F4-8F4C-4FC8-93C2-BA40BAB1102F}"/>
               </a:ext>
             </a:extLst>
           </p:cNvPr>
@@ -4671,7 +6916,7 @@
     </p:spTree>
     <p:extLst>
       <p:ext uri="{BB962C8B-B14F-4D97-AF65-F5344CB8AC3E}">
-        <p14:creationId xmlns:p14="http://schemas.microsoft.com/office/powerpoint/2010/main" val="878010798"/>
+        <p14:creationId xmlns:p14="http://schemas.microsoft.com/office/powerpoint/2010/main" val="1083853242"/>
       </p:ext>
     </p:extLst>
   </p:cSld>
@@ -4702,7 +6947,7 @@
           <p:cNvPr id="5" name="">
             <a:extLst xmlns:a="http://schemas.openxmlformats.org/drawingml/2006/main">
               <a:ext uri="{FF2B5EF4-FFF2-40B4-BE49-F238E27FC236}">
-                <a16:creationId xmlns:a16="http://schemas.microsoft.com/office/drawing/2014/main" id="{0C99F830-9658-4419-95DA-1700713E59E2}"/>
+                <a16:creationId xmlns:a16="http://schemas.microsoft.com/office/drawing/2014/main" id="{5E381D10-D4B4-451C-80CF-845D8B088A0B}"/>
               </a:ext>
             </a:extLst>
           </p:cNvPr>
@@ -5300,7 +7545,7 @@
           <p:cNvPr id="3" name="">
             <a:extLst xmlns:a="http://schemas.openxmlformats.org/drawingml/2006/main">
               <a:ext uri="{FF2B5EF4-FFF2-40B4-BE49-F238E27FC236}">
-                <a16:creationId xmlns:a16="http://schemas.microsoft.com/office/drawing/2014/main" id="{63454160-6682-4219-B648-756D8124ECC1}"/>
+                <a16:creationId xmlns:a16="http://schemas.microsoft.com/office/drawing/2014/main" id="{34574A3A-0282-4E96-BEFB-36A39894D54B}"/>
               </a:ext>
             </a:extLst>
           </p:cNvPr>
@@ -5357,7 +7602,7 @@
           <p:cNvPr id="4" name="">
             <a:extLst xmlns:a="http://schemas.openxmlformats.org/drawingml/2006/main">
               <a:ext uri="{FF2B5EF4-FFF2-40B4-BE49-F238E27FC236}">
-                <a16:creationId xmlns:a16="http://schemas.microsoft.com/office/drawing/2014/main" id="{5C9B6176-BDBE-4043-A74D-48553516FB95}"/>
+                <a16:creationId xmlns:a16="http://schemas.microsoft.com/office/drawing/2014/main" id="{4C758218-8087-4A1A-BA58-9E3D266E6B84}"/>
               </a:ext>
             </a:extLst>
           </p:cNvPr>
@@ -5412,7 +7657,7 @@
     </p:spTree>
     <p:extLst>
       <p:ext uri="{BB962C8B-B14F-4D97-AF65-F5344CB8AC3E}">
-        <p14:creationId xmlns:p14="http://schemas.microsoft.com/office/powerpoint/2010/main" val="449971604"/>
+        <p14:creationId xmlns:p14="http://schemas.microsoft.com/office/powerpoint/2010/main" val="1932969025"/>
       </p:ext>
     </p:extLst>
   </p:cSld>
@@ -5443,7 +7688,7 @@
           <p:cNvPr id="7" name="">
             <a:extLst xmlns:a="http://schemas.openxmlformats.org/drawingml/2006/main">
               <a:ext uri="{FF2B5EF4-FFF2-40B4-BE49-F238E27FC236}">
-                <a16:creationId xmlns:a16="http://schemas.microsoft.com/office/drawing/2014/main" id="{5091B94A-7D5A-4A2E-ADDE-20B8FA3E22C6}"/>
+                <a16:creationId xmlns:a16="http://schemas.microsoft.com/office/drawing/2014/main" id="{9AD078BF-F57D-4F3A-866F-93B546C2E1C6}"/>
               </a:ext>
             </a:extLst>
           </p:cNvPr>
@@ -5500,7 +7745,7 @@
           <p:cNvPr id="2" name="">
             <a:extLst xmlns:a="http://schemas.openxmlformats.org/drawingml/2006/main">
               <a:ext uri="{FF2B5EF4-FFF2-40B4-BE49-F238E27FC236}">
-                <a16:creationId xmlns:a16="http://schemas.microsoft.com/office/drawing/2014/main" id="{33747CC5-E143-4EEB-9C39-DA50E941F292}"/>
+                <a16:creationId xmlns:a16="http://schemas.microsoft.com/office/drawing/2014/main" id="{0469C58A-60B4-42AA-A778-7917DCE4F239}"/>
               </a:ext>
             </a:extLst>
           </p:cNvPr>
@@ -5557,7 +7802,7 @@
           <p:cNvPr id="3" name="">
             <a:extLst xmlns:a="http://schemas.openxmlformats.org/drawingml/2006/main">
               <a:ext uri="{FF2B5EF4-FFF2-40B4-BE49-F238E27FC236}">
-                <a16:creationId xmlns:a16="http://schemas.microsoft.com/office/drawing/2014/main" id="{A8E7BDA7-8967-41E1-8555-AA69A325CF98}"/>
+                <a16:creationId xmlns:a16="http://schemas.microsoft.com/office/drawing/2014/main" id="{6FDBC9F7-E8F4-4E16-80D9-7780DB8BF0FE}"/>
               </a:ext>
             </a:extLst>
           </p:cNvPr>
@@ -5614,7 +7859,7 @@
           <p:cNvPr id="4" name="">
             <a:extLst xmlns:a="http://schemas.openxmlformats.org/drawingml/2006/main">
               <a:ext uri="{FF2B5EF4-FFF2-40B4-BE49-F238E27FC236}">
-                <a16:creationId xmlns:a16="http://schemas.microsoft.com/office/drawing/2014/main" id="{7419D53C-E036-43A2-A024-AF9184FF0CD8}"/>
+                <a16:creationId xmlns:a16="http://schemas.microsoft.com/office/drawing/2014/main" id="{A59A0BBA-BA08-42C6-A3E9-CD62753F765E}"/>
               </a:ext>
             </a:extLst>
           </p:cNvPr>
@@ -5671,7 +7916,7 @@
           <p:cNvPr id="5" name="">
             <a:extLst xmlns:a="http://schemas.openxmlformats.org/drawingml/2006/main">
               <a:ext uri="{FF2B5EF4-FFF2-40B4-BE49-F238E27FC236}">
-                <a16:creationId xmlns:a16="http://schemas.microsoft.com/office/drawing/2014/main" id="{BAE38B42-E254-4D58-A37E-9D6B7C180CDF}"/>
+                <a16:creationId xmlns:a16="http://schemas.microsoft.com/office/drawing/2014/main" id="{57B44BF2-E277-4014-B287-C1CFFE5F11E1}"/>
               </a:ext>
             </a:extLst>
           </p:cNvPr>
@@ -5728,7 +7973,7 @@
           <p:cNvPr id="6" name="">
             <a:extLst xmlns:a="http://schemas.openxmlformats.org/drawingml/2006/main">
               <a:ext uri="{FF2B5EF4-FFF2-40B4-BE49-F238E27FC236}">
-                <a16:creationId xmlns:a16="http://schemas.microsoft.com/office/drawing/2014/main" id="{E9E4CBE3-280B-4C9C-8E7D-F7538F1C9702}"/>
+                <a16:creationId xmlns:a16="http://schemas.microsoft.com/office/drawing/2014/main" id="{79250CD9-235A-4199-AD31-2BBF4DF36A7A}"/>
               </a:ext>
             </a:extLst>
           </p:cNvPr>
@@ -5783,7 +8028,7 @@
     </p:spTree>
     <p:extLst>
       <p:ext uri="{BB962C8B-B14F-4D97-AF65-F5344CB8AC3E}">
-        <p14:creationId xmlns:p14="http://schemas.microsoft.com/office/powerpoint/2010/main" val="1974782901"/>
+        <p14:creationId xmlns:p14="http://schemas.microsoft.com/office/powerpoint/2010/main" val="1233010677"/>
       </p:ext>
     </p:extLst>
   </p:cSld>
@@ -5814,7 +8059,7 @@
           <p:cNvPr id="6" name="">
             <a:extLst xmlns:a="http://schemas.openxmlformats.org/drawingml/2006/main">
               <a:ext uri="{FF2B5EF4-FFF2-40B4-BE49-F238E27FC236}">
-                <a16:creationId xmlns:a16="http://schemas.microsoft.com/office/drawing/2014/main" id="{43C26871-C235-4302-B9E1-71E763EB5444}"/>
+                <a16:creationId xmlns:a16="http://schemas.microsoft.com/office/drawing/2014/main" id="{B992D7C2-EEB1-4599-AA5B-572427BDD122}"/>
               </a:ext>
             </a:extLst>
           </p:cNvPr>
@@ -5878,7 +8123,7 @@
         </p:xfrm>
         <a:graphic xmlns:a="http://schemas.openxmlformats.org/drawingml/2006/main">
           <a:graphicData uri="http://schemas.openxmlformats.org/drawingml/2006/chart">
-            <c:chart xmlns:r="http://schemas.openxmlformats.org/officeDocument/2006/relationships" xmlns:c="http://schemas.openxmlformats.org/drawingml/2006/chart" r:id="R86f9e2b0b1d647f0"/>
+            <c:chart xmlns:r="http://schemas.openxmlformats.org/officeDocument/2006/relationships" xmlns:c="http://schemas.openxmlformats.org/drawingml/2006/chart" r:id="Rac73dbb7c37a476f"/>
           </a:graphicData>
         </a:graphic>
       </p:graphicFrame>
@@ -5887,7 +8132,7 @@
           <p:cNvPr id="3" name="">
             <a:extLst xmlns:a="http://schemas.openxmlformats.org/drawingml/2006/main">
               <a:ext uri="{FF2B5EF4-FFF2-40B4-BE49-F238E27FC236}">
-                <a16:creationId xmlns:a16="http://schemas.microsoft.com/office/drawing/2014/main" id="{675A055E-79FE-4476-BA3E-54C6950CCFEB}"/>
+                <a16:creationId xmlns:a16="http://schemas.microsoft.com/office/drawing/2014/main" id="{46F93100-BCA1-4778-AB16-0BCD310C3B2C}"/>
               </a:ext>
             </a:extLst>
           </p:cNvPr>
@@ -5944,7 +8189,7 @@
           <p:cNvPr id="4" name="">
             <a:extLst xmlns:a="http://schemas.openxmlformats.org/drawingml/2006/main">
               <a:ext uri="{FF2B5EF4-FFF2-40B4-BE49-F238E27FC236}">
-                <a16:creationId xmlns:a16="http://schemas.microsoft.com/office/drawing/2014/main" id="{691FC332-09D8-4B9F-84BB-F5511FECC8BE}"/>
+                <a16:creationId xmlns:a16="http://schemas.microsoft.com/office/drawing/2014/main" id="{83535007-72CD-42BB-B44F-B44D9DB4FB88}"/>
               </a:ext>
             </a:extLst>
           </p:cNvPr>
@@ -6001,7 +8246,7 @@
           <p:cNvPr id="5" name="">
             <a:extLst xmlns:a="http://schemas.openxmlformats.org/drawingml/2006/main">
               <a:ext uri="{FF2B5EF4-FFF2-40B4-BE49-F238E27FC236}">
-                <a16:creationId xmlns:a16="http://schemas.microsoft.com/office/drawing/2014/main" id="{7BE2C4C4-CEA5-4810-89F9-7D4D9153E9F8}"/>
+                <a16:creationId xmlns:a16="http://schemas.microsoft.com/office/drawing/2014/main" id="{F2F22895-1812-4607-9F1D-B1DDA8CE0883}"/>
               </a:ext>
             </a:extLst>
           </p:cNvPr>
@@ -6056,7 +8301,7 @@
     </p:spTree>
     <p:extLst>
       <p:ext uri="{BB962C8B-B14F-4D97-AF65-F5344CB8AC3E}">
-        <p14:creationId xmlns:p14="http://schemas.microsoft.com/office/powerpoint/2010/main" val="1362155132"/>
+        <p14:creationId xmlns:p14="http://schemas.microsoft.com/office/powerpoint/2010/main" val="2131787657"/>
       </p:ext>
     </p:extLst>
   </p:cSld>
@@ -6087,7 +8332,7 @@
           <p:cNvPr id="6" name="">
             <a:extLst xmlns:a="http://schemas.openxmlformats.org/drawingml/2006/main">
               <a:ext uri="{FF2B5EF4-FFF2-40B4-BE49-F238E27FC236}">
-                <a16:creationId xmlns:a16="http://schemas.microsoft.com/office/drawing/2014/main" id="{B2EBBD9F-EC4C-4DD6-9D4B-475EA9041685}"/>
+                <a16:creationId xmlns:a16="http://schemas.microsoft.com/office/drawing/2014/main" id="{A6BC3E71-146B-497A-8587-DEF550FCE906}"/>
               </a:ext>
             </a:extLst>
           </p:cNvPr>
@@ -6134,7 +8379,7 @@
                 <a:ea typeface="Helvetica Neue"/>
                 <a:cs typeface="Helvetica Neue"/>
               </a:rPr>
-              <a:t>Structured checking accepted fewer useful corrections</a:t>
+              <a:t>Wrong advice raised overall factual error</a:t>
             </a:r>
           </a:p>
         </p:txBody>
@@ -6151,7 +8396,7 @@
         </p:xfrm>
         <a:graphic xmlns:a="http://schemas.openxmlformats.org/drawingml/2006/main">
           <a:graphicData uri="http://schemas.openxmlformats.org/drawingml/2006/chart">
-            <c:chart xmlns:r="http://schemas.openxmlformats.org/officeDocument/2006/relationships" xmlns:c="http://schemas.openxmlformats.org/drawingml/2006/chart" r:id="R6ac4eb01f7914de1"/>
+            <c:chart xmlns:r="http://schemas.openxmlformats.org/officeDocument/2006/relationships" xmlns:c="http://schemas.openxmlformats.org/drawingml/2006/chart" r:id="R84ca6660b7124ea3"/>
           </a:graphicData>
         </a:graphic>
       </p:graphicFrame>
@@ -6160,7 +8405,7 @@
           <p:cNvPr id="3" name="">
             <a:extLst xmlns:a="http://schemas.openxmlformats.org/drawingml/2006/main">
               <a:ext uri="{FF2B5EF4-FFF2-40B4-BE49-F238E27FC236}">
-                <a16:creationId xmlns:a16="http://schemas.microsoft.com/office/drawing/2014/main" id="{C475AF59-EA23-4F1D-B9C0-6982758EC06D}"/>
+                <a16:creationId xmlns:a16="http://schemas.microsoft.com/office/drawing/2014/main" id="{B65CDEF2-5D77-405B-9991-95B7BB6D052E}"/>
               </a:ext>
             </a:extLst>
           </p:cNvPr>
@@ -6207,7 +8452,7 @@
                 <a:ea typeface="Helvetica Neue"/>
                 <a:cs typeface="Helvetica Neue"/>
               </a:rPr>
-              <a:t>Successful corrections out of 322 initially wrong units</a:t>
+              <a:t>Error rate (%) across all 719 units per condition</a:t>
             </a:r>
           </a:p>
         </p:txBody>
@@ -6217,7 +8462,7 @@
           <p:cNvPr id="4" name="">
             <a:extLst xmlns:a="http://schemas.openxmlformats.org/drawingml/2006/main">
               <a:ext uri="{FF2B5EF4-FFF2-40B4-BE49-F238E27FC236}">
-                <a16:creationId xmlns:a16="http://schemas.microsoft.com/office/drawing/2014/main" id="{7931B7DD-E8E0-4151-8CC9-C165F0E04DA0}"/>
+                <a16:creationId xmlns:a16="http://schemas.microsoft.com/office/drawing/2014/main" id="{89E6DBDB-419B-44AD-8933-3B1CB730E467}"/>
               </a:ext>
             </a:extLst>
           </p:cNvPr>
@@ -6228,8 +8473,8 @@
         </p:nvSpPr>
         <p:spPr>
           <a:xfrm xmlns:a="http://schemas.openxmlformats.org/drawingml/2006/main">
-            <a:off x="685800" y="5715000"/>
-            <a:ext cx="10763250" cy="552450"/>
+            <a:off x="685800" y="5762625"/>
+            <a:ext cx="10763250" cy="457200"/>
           </a:xfrm>
           <a:prstGeom xmlns:a="http://schemas.openxmlformats.org/drawingml/2006/main" prst="rect">
             <a:avLst/>
@@ -6246,7 +8491,7 @@
           <a:lstStyle xmlns:a="http://schemas.openxmlformats.org/drawingml/2006/main"/>
           <a:p xmlns:a="http://schemas.openxmlformats.org/drawingml/2006/main">
             <a:pPr>
-              <a:defRPr sz="1800" b="0">
+              <a:defRPr sz="1875" b="0">
                 <a:solidFill>
                   <a:srgbClr val="657586"/>
                 </a:solidFill>
@@ -6256,7 +8501,7 @@
               </a:defRPr>
             </a:pPr>
             <a:r>
-              <a:rPr sz="1800" b="0">
+              <a:rPr sz="1875" b="0">
                 <a:solidFill>
                   <a:srgbClr val="657586"/>
                 </a:solidFill>
@@ -6264,7 +8509,7 @@
                 <a:ea typeface="Helvetica Neue"/>
                 <a:cs typeface="Helvetica Neue"/>
               </a:rPr>
-              <a:t>C5 - C4: -9.63 percentage points   /   95% cluster interval [-14.38, -5.25]</a:t>
+              <a:t>Post hoc: C1 - C0 +18.78 pp; C2 - C0 +6.40 pp; C3 - C2 -16.55 pp</a:t>
             </a:r>
           </a:p>
         </p:txBody>
@@ -6274,7 +8519,7 @@
           <p:cNvPr id="5" name="">
             <a:extLst xmlns:a="http://schemas.openxmlformats.org/drawingml/2006/main">
               <a:ext uri="{FF2B5EF4-FFF2-40B4-BE49-F238E27FC236}">
-                <a16:creationId xmlns:a16="http://schemas.microsoft.com/office/drawing/2014/main" id="{43343013-77A7-4025-998E-8FC1B3F84DB0}"/>
+                <a16:creationId xmlns:a16="http://schemas.microsoft.com/office/drawing/2014/main" id="{39BEDD55-E512-48C2-A802-3BC408682BCA}"/>
               </a:ext>
             </a:extLst>
           </p:cNvPr>
@@ -6329,7 +8574,7 @@
     </p:spTree>
     <p:extLst>
       <p:ext uri="{BB962C8B-B14F-4D97-AF65-F5344CB8AC3E}">
-        <p14:creationId xmlns:p14="http://schemas.microsoft.com/office/powerpoint/2010/main" val="28034378"/>
+        <p14:creationId xmlns:p14="http://schemas.microsoft.com/office/powerpoint/2010/main" val="2095453076"/>
       </p:ext>
     </p:extLst>
   </p:cSld>
@@ -6360,7 +8605,7 @@
           <p:cNvPr id="6" name="">
             <a:extLst xmlns:a="http://schemas.openxmlformats.org/drawingml/2006/main">
               <a:ext uri="{FF2B5EF4-FFF2-40B4-BE49-F238E27FC236}">
-                <a16:creationId xmlns:a16="http://schemas.microsoft.com/office/drawing/2014/main" id="{20D8806F-FDE1-400A-8CA4-E12911AF7382}"/>
+                <a16:creationId xmlns:a16="http://schemas.microsoft.com/office/drawing/2014/main" id="{E2BB32E8-2C88-4B42-A32C-6B5C06393B62}"/>
               </a:ext>
             </a:extLst>
           </p:cNvPr>
@@ -6407,24 +8652,424 @@
                 <a:ea typeface="Helvetica Neue"/>
                 <a:cs typeface="Helvetica Neue"/>
               </a:rPr>
-              <a:t>Checking also changes the willingness to answer</a:t>
+              <a:t>Most avoided errors became abstentions</a:t>
             </a:r>
           </a:p>
         </p:txBody>
       </p:sp>
       <p:graphicFrame>
         <p:nvGraphicFramePr>
-          <p:cNvPr id="7" name="Chart"/>
+          <p:cNvPr id="7" name=""/>
           <p:cNvGraphicFramePr/>
           <p:nvPr/>
         </p:nvGraphicFramePr>
         <p:xfrm>
-          <a:off xmlns:a="http://schemas.openxmlformats.org/drawingml/2006/main" x="857250" y="1571625"/>
-          <a:ext xmlns:a="http://schemas.openxmlformats.org/drawingml/2006/main" cx="10287000" cy="3571875"/>
+          <a:off xmlns:a="http://schemas.openxmlformats.org/drawingml/2006/main" x="685800" y="1590675"/>
+          <a:ext xmlns:a="http://schemas.openxmlformats.org/drawingml/2006/main" cx="10820400" cy="2876550"/>
         </p:xfrm>
         <a:graphic xmlns:a="http://schemas.openxmlformats.org/drawingml/2006/main">
-          <a:graphicData uri="http://schemas.openxmlformats.org/drawingml/2006/chart">
-            <c:chart xmlns:r="http://schemas.openxmlformats.org/officeDocument/2006/relationships" xmlns:c="http://schemas.openxmlformats.org/drawingml/2006/chart" r:id="Ra01dff03dab14960"/>
+          <a:graphicData uri="http://schemas.openxmlformats.org/drawingml/2006/table">
+            <a:tbl>
+              <a:tblPr/>
+              <a:tblGrid>
+                <a:gridCol w="2705100"/>
+                <a:gridCol w="2705100"/>
+                <a:gridCol w="2705100"/>
+                <a:gridCol w="2705100"/>
+              </a:tblGrid>
+              <a:tr h="719138">
+                <a:tc>
+                  <a:txBody>
+                    <a:bodyPr/>
+                    <a:lstStyle/>
+                    <a:p>
+                      <a:r>
+                        <a:rPr sz="2025" b="1">
+                          <a:solidFill>
+                            <a:srgbClr val="FFFFFF"/>
+                          </a:solidFill>
+                          <a:latin typeface="Helvetica Neue"/>
+                          <a:ea typeface="Helvetica Neue"/>
+                          <a:cs typeface="Helvetica Neue"/>
+                        </a:rPr>
+                        <a:t>C2 outcome</a:t>
+                      </a:r>
+                    </a:p>
+                  </a:txBody>
+                  <a:tcPr marL="91440" marR="91440" marT="45720" marB="45720">
+                    <a:solidFill>
+                      <a:srgbClr val="142C40"/>
+                    </a:solidFill>
+                  </a:tcPr>
+                </a:tc>
+                <a:tc>
+                  <a:txBody>
+                    <a:bodyPr/>
+                    <a:lstStyle/>
+                    <a:p>
+                      <a:r>
+                        <a:rPr sz="2025" b="1">
+                          <a:solidFill>
+                            <a:srgbClr val="FFFFFF"/>
+                          </a:solidFill>
+                          <a:latin typeface="Helvetica Neue"/>
+                          <a:ea typeface="Helvetica Neue"/>
+                          <a:cs typeface="Helvetica Neue"/>
+                        </a:rPr>
+                        <a:t>C3 correct</a:t>
+                      </a:r>
+                    </a:p>
+                  </a:txBody>
+                  <a:tcPr marL="91440" marR="91440" marT="45720" marB="45720">
+                    <a:solidFill>
+                      <a:srgbClr val="142C40"/>
+                    </a:solidFill>
+                  </a:tcPr>
+                </a:tc>
+                <a:tc>
+                  <a:txBody>
+                    <a:bodyPr/>
+                    <a:lstStyle/>
+                    <a:p>
+                      <a:r>
+                        <a:rPr sz="2025" b="1">
+                          <a:solidFill>
+                            <a:srgbClr val="FFFFFF"/>
+                          </a:solidFill>
+                          <a:latin typeface="Helvetica Neue"/>
+                          <a:ea typeface="Helvetica Neue"/>
+                          <a:cs typeface="Helvetica Neue"/>
+                        </a:rPr>
+                        <a:t>C3 wrong</a:t>
+                      </a:r>
+                    </a:p>
+                  </a:txBody>
+                  <a:tcPr marL="91440" marR="91440" marT="45720" marB="45720">
+                    <a:solidFill>
+                      <a:srgbClr val="142C40"/>
+                    </a:solidFill>
+                  </a:tcPr>
+                </a:tc>
+                <a:tc>
+                  <a:txBody>
+                    <a:bodyPr/>
+                    <a:lstStyle/>
+                    <a:p>
+                      <a:r>
+                        <a:rPr sz="2025" b="1">
+                          <a:solidFill>
+                            <a:srgbClr val="FFFFFF"/>
+                          </a:solidFill>
+                          <a:latin typeface="Helvetica Neue"/>
+                          <a:ea typeface="Helvetica Neue"/>
+                          <a:cs typeface="Helvetica Neue"/>
+                        </a:rPr>
+                        <a:t>C3 abstain</a:t>
+                      </a:r>
+                    </a:p>
+                  </a:txBody>
+                  <a:tcPr marL="91440" marR="91440" marT="45720" marB="45720">
+                    <a:solidFill>
+                      <a:srgbClr val="142C40"/>
+                    </a:solidFill>
+                  </a:tcPr>
+                </a:tc>
+              </a:tr>
+              <a:tr h="719138">
+                <a:tc>
+                  <a:txBody>
+                    <a:bodyPr/>
+                    <a:lstStyle/>
+                    <a:p>
+                      <a:r>
+                        <a:rPr sz="2025" b="0">
+                          <a:solidFill>
+                            <a:srgbClr val="142C40"/>
+                          </a:solidFill>
+                          <a:latin typeface="Helvetica Neue"/>
+                          <a:ea typeface="Helvetica Neue"/>
+                          <a:cs typeface="Helvetica Neue"/>
+                        </a:rPr>
+                        <a:t>Correct</a:t>
+                      </a:r>
+                    </a:p>
+                  </a:txBody>
+                  <a:tcPr marL="91440" marR="91440" marT="45720" marB="45720">
+                    <a:solidFill>
+                      <a:srgbClr val="F0F4F7"/>
+                    </a:solidFill>
+                  </a:tcPr>
+                </a:tc>
+                <a:tc>
+                  <a:txBody>
+                    <a:bodyPr/>
+                    <a:lstStyle/>
+                    <a:p>
+                      <a:r>
+                        <a:rPr sz="2025" b="0">
+                          <a:solidFill>
+                            <a:srgbClr val="142C40"/>
+                          </a:solidFill>
+                          <a:latin typeface="Helvetica Neue"/>
+                          <a:ea typeface="Helvetica Neue"/>
+                          <a:cs typeface="Helvetica Neue"/>
+                        </a:rPr>
+                        <a:t>133</a:t>
+                      </a:r>
+                    </a:p>
+                  </a:txBody>
+                  <a:tcPr marL="91440" marR="91440" marT="45720" marB="45720">
+                    <a:solidFill>
+                      <a:srgbClr val="F0F4F7"/>
+                    </a:solidFill>
+                  </a:tcPr>
+                </a:tc>
+                <a:tc>
+                  <a:txBody>
+                    <a:bodyPr/>
+                    <a:lstStyle/>
+                    <a:p>
+                      <a:r>
+                        <a:rPr sz="2025" b="0">
+                          <a:solidFill>
+                            <a:srgbClr val="142C40"/>
+                          </a:solidFill>
+                          <a:latin typeface="Helvetica Neue"/>
+                          <a:ea typeface="Helvetica Neue"/>
+                          <a:cs typeface="Helvetica Neue"/>
+                        </a:rPr>
+                        <a:t>9</a:t>
+                      </a:r>
+                    </a:p>
+                  </a:txBody>
+                  <a:tcPr marL="91440" marR="91440" marT="45720" marB="45720">
+                    <a:solidFill>
+                      <a:srgbClr val="F0F4F7"/>
+                    </a:solidFill>
+                  </a:tcPr>
+                </a:tc>
+                <a:tc>
+                  <a:txBody>
+                    <a:bodyPr/>
+                    <a:lstStyle/>
+                    <a:p>
+                      <a:r>
+                        <a:rPr sz="2025" b="0">
+                          <a:solidFill>
+                            <a:srgbClr val="142C40"/>
+                          </a:solidFill>
+                          <a:latin typeface="Helvetica Neue"/>
+                          <a:ea typeface="Helvetica Neue"/>
+                          <a:cs typeface="Helvetica Neue"/>
+                        </a:rPr>
+                        <a:t>20</a:t>
+                      </a:r>
+                    </a:p>
+                  </a:txBody>
+                  <a:tcPr marL="91440" marR="91440" marT="45720" marB="45720">
+                    <a:solidFill>
+                      <a:srgbClr val="F0F4F7"/>
+                    </a:solidFill>
+                  </a:tcPr>
+                </a:tc>
+              </a:tr>
+              <a:tr h="719138">
+                <a:tc>
+                  <a:txBody>
+                    <a:bodyPr/>
+                    <a:lstStyle/>
+                    <a:p>
+                      <a:r>
+                        <a:rPr sz="2025" b="0">
+                          <a:solidFill>
+                            <a:srgbClr val="142C40"/>
+                          </a:solidFill>
+                          <a:latin typeface="Helvetica Neue"/>
+                          <a:ea typeface="Helvetica Neue"/>
+                          <a:cs typeface="Helvetica Neue"/>
+                        </a:rPr>
+                        <a:t>Wrong</a:t>
+                      </a:r>
+                    </a:p>
+                  </a:txBody>
+                  <a:tcPr marL="91440" marR="91440" marT="45720" marB="45720">
+                    <a:solidFill>
+                      <a:srgbClr val="FFFFFF"/>
+                    </a:solidFill>
+                  </a:tcPr>
+                </a:tc>
+                <a:tc>
+                  <a:txBody>
+                    <a:bodyPr/>
+                    <a:lstStyle/>
+                    <a:p>
+                      <a:r>
+                        <a:rPr sz="2025" b="0">
+                          <a:solidFill>
+                            <a:srgbClr val="142C40"/>
+                          </a:solidFill>
+                          <a:latin typeface="Helvetica Neue"/>
+                          <a:ea typeface="Helvetica Neue"/>
+                          <a:cs typeface="Helvetica Neue"/>
+                        </a:rPr>
+                        <a:t>5</a:t>
+                      </a:r>
+                    </a:p>
+                  </a:txBody>
+                  <a:tcPr marL="91440" marR="91440" marT="45720" marB="45720">
+                    <a:solidFill>
+                      <a:srgbClr val="FFFFFF"/>
+                    </a:solidFill>
+                  </a:tcPr>
+                </a:tc>
+                <a:tc>
+                  <a:txBody>
+                    <a:bodyPr/>
+                    <a:lstStyle/>
+                    <a:p>
+                      <a:r>
+                        <a:rPr sz="2025" b="0">
+                          <a:solidFill>
+                            <a:srgbClr val="142C40"/>
+                          </a:solidFill>
+                          <a:latin typeface="Helvetica Neue"/>
+                          <a:ea typeface="Helvetica Neue"/>
+                          <a:cs typeface="Helvetica Neue"/>
+                        </a:rPr>
+                        <a:t>228</a:t>
+                      </a:r>
+                    </a:p>
+                  </a:txBody>
+                  <a:tcPr marL="91440" marR="91440" marT="45720" marB="45720">
+                    <a:solidFill>
+                      <a:srgbClr val="FFFFFF"/>
+                    </a:solidFill>
+                  </a:tcPr>
+                </a:tc>
+                <a:tc>
+                  <a:txBody>
+                    <a:bodyPr/>
+                    <a:lstStyle/>
+                    <a:p>
+                      <a:r>
+                        <a:rPr sz="2025" b="0">
+                          <a:solidFill>
+                            <a:srgbClr val="142C40"/>
+                          </a:solidFill>
+                          <a:latin typeface="Helvetica Neue"/>
+                          <a:ea typeface="Helvetica Neue"/>
+                          <a:cs typeface="Helvetica Neue"/>
+                        </a:rPr>
+                        <a:t>144</a:t>
+                      </a:r>
+                    </a:p>
+                  </a:txBody>
+                  <a:tcPr marL="91440" marR="91440" marT="45720" marB="45720">
+                    <a:solidFill>
+                      <a:srgbClr val="FFFFFF"/>
+                    </a:solidFill>
+                  </a:tcPr>
+                </a:tc>
+              </a:tr>
+              <a:tr h="719138">
+                <a:tc>
+                  <a:txBody>
+                    <a:bodyPr/>
+                    <a:lstStyle/>
+                    <a:p>
+                      <a:r>
+                        <a:rPr sz="2025" b="0">
+                          <a:solidFill>
+                            <a:srgbClr val="142C40"/>
+                          </a:solidFill>
+                          <a:latin typeface="Helvetica Neue"/>
+                          <a:ea typeface="Helvetica Neue"/>
+                          <a:cs typeface="Helvetica Neue"/>
+                        </a:rPr>
+                        <a:t>Abstain</a:t>
+                      </a:r>
+                    </a:p>
+                  </a:txBody>
+                  <a:tcPr marL="91440" marR="91440" marT="45720" marB="45720">
+                    <a:solidFill>
+                      <a:srgbClr val="F0F4F7"/>
+                    </a:solidFill>
+                  </a:tcPr>
+                </a:tc>
+                <a:tc>
+                  <a:txBody>
+                    <a:bodyPr/>
+                    <a:lstStyle/>
+                    <a:p>
+                      <a:r>
+                        <a:rPr sz="2025" b="0">
+                          <a:solidFill>
+                            <a:srgbClr val="142C40"/>
+                          </a:solidFill>
+                          <a:latin typeface="Helvetica Neue"/>
+                          <a:ea typeface="Helvetica Neue"/>
+                          <a:cs typeface="Helvetica Neue"/>
+                        </a:rPr>
+                        <a:t>3</a:t>
+                      </a:r>
+                    </a:p>
+                  </a:txBody>
+                  <a:tcPr marL="91440" marR="91440" marT="45720" marB="45720">
+                    <a:solidFill>
+                      <a:srgbClr val="F0F4F7"/>
+                    </a:solidFill>
+                  </a:tcPr>
+                </a:tc>
+                <a:tc>
+                  <a:txBody>
+                    <a:bodyPr/>
+                    <a:lstStyle/>
+                    <a:p>
+                      <a:r>
+                        <a:rPr sz="2025" b="0">
+                          <a:solidFill>
+                            <a:srgbClr val="142C40"/>
+                          </a:solidFill>
+                          <a:latin typeface="Helvetica Neue"/>
+                          <a:ea typeface="Helvetica Neue"/>
+                          <a:cs typeface="Helvetica Neue"/>
+                        </a:rPr>
+                        <a:t>21</a:t>
+                      </a:r>
+                    </a:p>
+                  </a:txBody>
+                  <a:tcPr marL="91440" marR="91440" marT="45720" marB="45720">
+                    <a:solidFill>
+                      <a:srgbClr val="F0F4F7"/>
+                    </a:solidFill>
+                  </a:tcPr>
+                </a:tc>
+                <a:tc>
+                  <a:txBody>
+                    <a:bodyPr/>
+                    <a:lstStyle/>
+                    <a:p>
+                      <a:r>
+                        <a:rPr sz="2025" b="0">
+                          <a:solidFill>
+                            <a:srgbClr val="142C40"/>
+                          </a:solidFill>
+                          <a:latin typeface="Helvetica Neue"/>
+                          <a:ea typeface="Helvetica Neue"/>
+                          <a:cs typeface="Helvetica Neue"/>
+                        </a:rPr>
+                        <a:t>156</a:t>
+                      </a:r>
+                    </a:p>
+                  </a:txBody>
+                  <a:tcPr marL="91440" marR="91440" marT="45720" marB="45720">
+                    <a:solidFill>
+                      <a:srgbClr val="F0F4F7"/>
+                    </a:solidFill>
+                  </a:tcPr>
+                </a:tc>
+              </a:tr>
+            </a:tbl>
           </a:graphicData>
         </a:graphic>
       </p:graphicFrame>
@@ -6433,7 +9078,7 @@
           <p:cNvPr id="3" name="">
             <a:extLst xmlns:a="http://schemas.openxmlformats.org/drawingml/2006/main">
               <a:ext uri="{FF2B5EF4-FFF2-40B4-BE49-F238E27FC236}">
-                <a16:creationId xmlns:a16="http://schemas.microsoft.com/office/drawing/2014/main" id="{A03B049F-E6C8-4E47-88DA-639CA9744F02}"/>
+                <a16:creationId xmlns:a16="http://schemas.microsoft.com/office/drawing/2014/main" id="{238CAC33-E31A-4178-8061-929A15CAADCE}"/>
               </a:ext>
             </a:extLst>
           </p:cNvPr>
@@ -6444,8 +9089,8 @@
         </p:nvSpPr>
         <p:spPr>
           <a:xfrm xmlns:a="http://schemas.openxmlformats.org/drawingml/2006/main">
-            <a:off x="685800" y="5381625"/>
-            <a:ext cx="10668000" cy="428625"/>
+            <a:off x="685800" y="4800600"/>
+            <a:ext cx="10668000" cy="552450"/>
           </a:xfrm>
           <a:prstGeom xmlns:a="http://schemas.openxmlformats.org/drawingml/2006/main" prst="rect">
             <a:avLst/>
@@ -6462,7 +9107,7 @@
           <a:lstStyle xmlns:a="http://schemas.openxmlformats.org/drawingml/2006/main"/>
           <a:p xmlns:a="http://schemas.openxmlformats.org/drawingml/2006/main">
             <a:pPr>
-              <a:defRPr sz="2025" b="1">
+              <a:defRPr sz="2175" b="1">
                 <a:solidFill>
                   <a:srgbClr val="147E77"/>
                 </a:solidFill>
@@ -6472,7 +9117,7 @@
               </a:defRPr>
             </a:pPr>
             <a:r>
-              <a:rPr sz="2025" b="1">
+              <a:rPr sz="2175" b="1">
                 <a:solidFill>
                   <a:srgbClr val="147E77"/>
                 </a:solidFill>
@@ -6480,7 +9125,7 @@
                 <a:ea typeface="Helvetica Neue"/>
                 <a:cs typeface="Helvetica Neue"/>
               </a:rPr>
-              <a:t>All conditions contain 719 units. Uncertainty may help a user.</a:t>
+              <a:t>144 wrong-to-abstain pairs, compared with 5 wrong-to-correct</a:t>
             </a:r>
           </a:p>
         </p:txBody>
@@ -6490,7 +9135,7 @@
           <p:cNvPr id="4" name="">
             <a:extLst xmlns:a="http://schemas.openxmlformats.org/drawingml/2006/main">
               <a:ext uri="{FF2B5EF4-FFF2-40B4-BE49-F238E27FC236}">
-                <a16:creationId xmlns:a16="http://schemas.microsoft.com/office/drawing/2014/main" id="{DC574A49-AEE8-4FA9-B276-BD2FEA0F1D74}"/>
+                <a16:creationId xmlns:a16="http://schemas.microsoft.com/office/drawing/2014/main" id="{9A9CB8BC-B886-4458-B771-F586319E7EED}"/>
               </a:ext>
             </a:extLst>
           </p:cNvPr>
@@ -6501,8 +9146,8 @@
         </p:nvSpPr>
         <p:spPr>
           <a:xfrm xmlns:a="http://schemas.openxmlformats.org/drawingml/2006/main">
-            <a:off x="685800" y="5886450"/>
-            <a:ext cx="10668000" cy="381000"/>
+            <a:off x="685800" y="5476875"/>
+            <a:ext cx="10668000" cy="619125"/>
           </a:xfrm>
           <a:prstGeom xmlns:a="http://schemas.openxmlformats.org/drawingml/2006/main" prst="rect">
             <a:avLst/>
@@ -6519,7 +9164,7 @@
           <a:lstStyle xmlns:a="http://schemas.openxmlformats.org/drawingml/2006/main"/>
           <a:p xmlns:a="http://schemas.openxmlformats.org/drawingml/2006/main">
             <a:pPr>
-              <a:defRPr sz="1800" b="0">
+              <a:defRPr sz="1875" b="0">
                 <a:solidFill>
                   <a:srgbClr val="657586"/>
                 </a:solidFill>
@@ -6529,7 +9174,7 @@
               </a:defRPr>
             </a:pPr>
             <a:r>
-              <a:rPr sz="1800" b="0">
+              <a:rPr sz="1875" b="0">
                 <a:solidFill>
                   <a:srgbClr val="657586"/>
                 </a:solidFill>
@@ -6537,7 +9182,7 @@
                 <a:ea typeface="Helvetica Neue"/>
                 <a:cs typeface="Helvetica Neue"/>
               </a:rPr>
-              <a:t>A correct answer or a claim of verification does not prove evidence was checked.</a:t>
+              <a:t>Also 21 abstain-to-wrong and 9 correct-to-wrong pairs. Parallel branches.</a:t>
             </a:r>
           </a:p>
         </p:txBody>
@@ -6547,7 +9192,7 @@
           <p:cNvPr id="5" name="">
             <a:extLst xmlns:a="http://schemas.openxmlformats.org/drawingml/2006/main">
               <a:ext uri="{FF2B5EF4-FFF2-40B4-BE49-F238E27FC236}">
-                <a16:creationId xmlns:a16="http://schemas.microsoft.com/office/drawing/2014/main" id="{940FDE9C-0453-4EF2-9A67-03EFAC38B831}"/>
+                <a16:creationId xmlns:a16="http://schemas.microsoft.com/office/drawing/2014/main" id="{ED63B76B-9728-4D8D-8F6B-5D915566D0B7}"/>
               </a:ext>
             </a:extLst>
           </p:cNvPr>
@@ -6602,7 +9247,7 @@
     </p:spTree>
     <p:extLst>
       <p:ext uri="{BB962C8B-B14F-4D97-AF65-F5344CB8AC3E}">
-        <p14:creationId xmlns:p14="http://schemas.microsoft.com/office/powerpoint/2010/main" val="1249343541"/>
+        <p14:creationId xmlns:p14="http://schemas.microsoft.com/office/powerpoint/2010/main" val="1450254506"/>
       </p:ext>
     </p:extLst>
   </p:cSld>
@@ -6630,10 +9275,10 @@
       </p:grpSpPr>
       <p:sp>
         <p:nvSpPr>
-          <p:cNvPr id="7" name="">
+          <p:cNvPr id="6" name="">
             <a:extLst xmlns:a="http://schemas.openxmlformats.org/drawingml/2006/main">
               <a:ext uri="{FF2B5EF4-FFF2-40B4-BE49-F238E27FC236}">
-                <a16:creationId xmlns:a16="http://schemas.microsoft.com/office/drawing/2014/main" id="{C97CD6DD-8D66-4F5B-968A-8A7859FABF54}"/>
+                <a16:creationId xmlns:a16="http://schemas.microsoft.com/office/drawing/2014/main" id="{AA9D87CC-1EF9-4A5D-9C52-A42083ADBFD8}"/>
               </a:ext>
             </a:extLst>
           </p:cNvPr>
@@ -6680,17 +9325,33 @@
                 <a:ea typeface="Helvetica Neue"/>
                 <a:cs typeface="Helvetica Neue"/>
               </a:rPr>
-              <a:t>Mathematical validity before calculation</a:t>
-            </a:r>
-          </a:p>
-        </p:txBody>
-      </p:sp>
-      <p:sp>
-        <p:nvSpPr>
-          <p:cNvPr id="2" name="">
+              <a:t>Structured checking accepted fewer useful corrections</a:t>
+            </a:r>
+          </a:p>
+        </p:txBody>
+      </p:sp>
+      <p:graphicFrame>
+        <p:nvGraphicFramePr>
+          <p:cNvPr id="7" name="Chart"/>
+          <p:cNvGraphicFramePr/>
+          <p:nvPr/>
+        </p:nvGraphicFramePr>
+        <p:xfrm>
+          <a:off xmlns:a="http://schemas.openxmlformats.org/drawingml/2006/main" x="952500" y="1619250"/>
+          <a:ext xmlns:a="http://schemas.openxmlformats.org/drawingml/2006/main" cx="10096500" cy="3429000"/>
+        </p:xfrm>
+        <a:graphic xmlns:a="http://schemas.openxmlformats.org/drawingml/2006/main">
+          <a:graphicData uri="http://schemas.openxmlformats.org/drawingml/2006/chart">
+            <c:chart xmlns:r="http://schemas.openxmlformats.org/officeDocument/2006/relationships" xmlns:c="http://schemas.openxmlformats.org/drawingml/2006/chart" r:id="R9e27b318f2524a3d"/>
+          </a:graphicData>
+        </a:graphic>
+      </p:graphicFrame>
+      <p:sp>
+        <p:nvSpPr>
+          <p:cNvPr id="3" name="">
             <a:extLst xmlns:a="http://schemas.openxmlformats.org/drawingml/2006/main">
               <a:ext uri="{FF2B5EF4-FFF2-40B4-BE49-F238E27FC236}">
-                <a16:creationId xmlns:a16="http://schemas.microsoft.com/office/drawing/2014/main" id="{8F5154F9-9825-4C53-B54D-10886C6596B1}"/>
+                <a16:creationId xmlns:a16="http://schemas.microsoft.com/office/drawing/2014/main" id="{BF85A53B-62F2-4748-94AC-A44C23DBD822}"/>
               </a:ext>
             </a:extLst>
           </p:cNvPr>
@@ -6701,8 +9362,8 @@
         </p:nvSpPr>
         <p:spPr>
           <a:xfrm xmlns:a="http://schemas.openxmlformats.org/drawingml/2006/main">
-            <a:off x="685800" y="1657350"/>
-            <a:ext cx="10668000" cy="790575"/>
+            <a:off x="685800" y="5238750"/>
+            <a:ext cx="10668000" cy="381000"/>
           </a:xfrm>
           <a:prstGeom xmlns:a="http://schemas.openxmlformats.org/drawingml/2006/main" prst="rect">
             <a:avLst/>
@@ -6719,9 +9380,9 @@
           <a:lstStyle xmlns:a="http://schemas.openxmlformats.org/drawingml/2006/main"/>
           <a:p xmlns:a="http://schemas.openxmlformats.org/drawingml/2006/main">
             <a:pPr>
-              <a:defRPr sz="2250" b="0">
-                <a:solidFill>
-                  <a:srgbClr val="142C40"/>
+              <a:defRPr sz="1950" b="1">
+                <a:solidFill>
+                  <a:srgbClr val="147E77"/>
                 </a:solidFill>
                 <a:latin typeface="Helvetica Neue"/>
                 <a:ea typeface="Helvetica Neue"/>
@@ -6729,25 +9390,25 @@
               </a:defRPr>
             </a:pPr>
             <a:r>
-              <a:rPr sz="2250" b="0">
-                <a:solidFill>
-                  <a:srgbClr val="142C40"/>
+              <a:rPr sz="1950" b="1">
+                <a:solidFill>
+                  <a:srgbClr val="147E77"/>
                 </a:solidFill>
                 <a:latin typeface="Helvetica Neue"/>
                 <a:ea typeface="Helvetica Neue"/>
                 <a:cs typeface="Helvetica Neue"/>
               </a:rPr>
-              <a:t>An equilateral triangle has perimeter 30 cm and height 10 cm.</a:t>
-            </a:r>
-          </a:p>
-        </p:txBody>
-      </p:sp>
-      <p:sp>
-        <p:nvSpPr>
-          <p:cNvPr id="3" name="">
+              <a:t>Successful corrections out of 322 initially wrong units</a:t>
+            </a:r>
+          </a:p>
+        </p:txBody>
+      </p:sp>
+      <p:sp>
+        <p:nvSpPr>
+          <p:cNvPr id="4" name="">
             <a:extLst xmlns:a="http://schemas.openxmlformats.org/drawingml/2006/main">
               <a:ext uri="{FF2B5EF4-FFF2-40B4-BE49-F238E27FC236}">
-                <a16:creationId xmlns:a16="http://schemas.microsoft.com/office/drawing/2014/main" id="{5C10CAD5-A09F-41AE-9B4C-3D72D17C0CCE}"/>
+                <a16:creationId xmlns:a16="http://schemas.microsoft.com/office/drawing/2014/main" id="{FD9157F0-1B5F-49D1-879D-3B004C6C06A3}"/>
               </a:ext>
             </a:extLst>
           </p:cNvPr>
@@ -6758,8 +9419,8 @@
         </p:nvSpPr>
         <p:spPr>
           <a:xfrm xmlns:a="http://schemas.openxmlformats.org/drawingml/2006/main">
-            <a:off x="685800" y="2628900"/>
-            <a:ext cx="10668000" cy="790575"/>
+            <a:off x="685800" y="5715000"/>
+            <a:ext cx="10763250" cy="552450"/>
           </a:xfrm>
           <a:prstGeom xmlns:a="http://schemas.openxmlformats.org/drawingml/2006/main" prst="rect">
             <a:avLst/>
@@ -6776,9 +9437,9 @@
           <a:lstStyle xmlns:a="http://schemas.openxmlformats.org/drawingml/2006/main"/>
           <a:p xmlns:a="http://schemas.openxmlformats.org/drawingml/2006/main">
             <a:pPr>
-              <a:defRPr sz="2250" b="0">
-                <a:solidFill>
-                  <a:srgbClr val="142C40"/>
+              <a:defRPr sz="1800" b="0">
+                <a:solidFill>
+                  <a:srgbClr val="657586"/>
                 </a:solidFill>
                 <a:latin typeface="Helvetica Neue"/>
                 <a:ea typeface="Helvetica Neue"/>
@@ -6786,72 +9447,15 @@
               </a:defRPr>
             </a:pPr>
             <a:r>
-              <a:rPr sz="2250" b="0">
-                <a:solidFill>
-                  <a:srgbClr val="142C40"/>
+              <a:rPr sz="1800" b="0">
+                <a:solidFill>
+                  <a:srgbClr val="657586"/>
                 </a:solidFill>
                 <a:latin typeface="Helvetica Neue"/>
                 <a:ea typeface="Helvetica Neue"/>
                 <a:cs typeface="Helvetica Neue"/>
               </a:rPr>
-              <a:t>Direct substitution gives area = 10 × 10 / 2 = 50.</a:t>
-            </a:r>
-          </a:p>
-        </p:txBody>
-      </p:sp>
-      <p:sp>
-        <p:nvSpPr>
-          <p:cNvPr id="4" name="">
-            <a:extLst xmlns:a="http://schemas.openxmlformats.org/drawingml/2006/main">
-              <a:ext uri="{FF2B5EF4-FFF2-40B4-BE49-F238E27FC236}">
-                <a16:creationId xmlns:a16="http://schemas.microsoft.com/office/drawing/2014/main" id="{AE0FF1B3-89C3-49FB-B976-44B1176F2B76}"/>
-              </a:ext>
-            </a:extLst>
-          </p:cNvPr>
-          <p:cNvSpPr>
-            <a:spLocks xmlns:a="http://schemas.openxmlformats.org/drawingml/2006/main" noGrp="1"/>
-          </p:cNvSpPr>
-          <p:nvPr/>
-        </p:nvSpPr>
-        <p:spPr>
-          <a:xfrm xmlns:a="http://schemas.openxmlformats.org/drawingml/2006/main">
-            <a:off x="685800" y="3600450"/>
-            <a:ext cx="10668000" cy="790575"/>
-          </a:xfrm>
-          <a:prstGeom xmlns:a="http://schemas.openxmlformats.org/drawingml/2006/main" prst="rect">
-            <a:avLst/>
-          </a:prstGeom>
-          <a:noFill xmlns:a="http://schemas.openxmlformats.org/drawingml/2006/main"/>
-          <a:ln xmlns:a="http://schemas.openxmlformats.org/drawingml/2006/main" w="0">
-            <a:noFill/>
-          </a:ln>
-        </p:spPr>
-        <p:txBody>
-          <a:bodyPr xmlns:a="http://schemas.openxmlformats.org/drawingml/2006/main">
-            <a:noAutofit/>
-          </a:bodyPr>
-          <a:lstStyle xmlns:a="http://schemas.openxmlformats.org/drawingml/2006/main"/>
-          <a:p xmlns:a="http://schemas.openxmlformats.org/drawingml/2006/main">
-            <a:pPr>
-              <a:defRPr sz="2250" b="0">
-                <a:solidFill>
-                  <a:srgbClr val="142C40"/>
-                </a:solidFill>
-                <a:latin typeface="Helvetica Neue"/>
-                <a:ea typeface="Helvetica Neue"/>
-                <a:cs typeface="Helvetica Neue"/>
-              </a:defRPr>
-            </a:pPr>
-            <a:r>
-              <a:rPr sz="2250" b="0">
-                <a:solidFill>
-                  <a:srgbClr val="142C40"/>
-                </a:solidFill>
-                <a:latin typeface="Helvetica Neue"/>
-                <a:ea typeface="Helvetica Neue"/>
-                <a:cs typeface="Helvetica Neue"/>
-              </a:rPr>
-              <a:t>But side 10 forces height 5√3 ≈ 8.66. The conditions contradict.</a:t>
+              <a:t>C5 - C4: -9.63 percentage points   /   95% cluster interval [-14.38, -5.25]</a:t>
             </a:r>
           </a:p>
         </p:txBody>
@@ -6861,64 +9465,7 @@
           <p:cNvPr id="5" name="">
             <a:extLst xmlns:a="http://schemas.openxmlformats.org/drawingml/2006/main">
               <a:ext uri="{FF2B5EF4-FFF2-40B4-BE49-F238E27FC236}">
-                <a16:creationId xmlns:a16="http://schemas.microsoft.com/office/drawing/2014/main" id="{09BE835F-E0EC-4F71-B8D5-E454B106A8E7}"/>
-              </a:ext>
-            </a:extLst>
-          </p:cNvPr>
-          <p:cNvSpPr>
-            <a:spLocks xmlns:a="http://schemas.openxmlformats.org/drawingml/2006/main" noGrp="1"/>
-          </p:cNvSpPr>
-          <p:nvPr/>
-        </p:nvSpPr>
-        <p:spPr>
-          <a:xfrm xmlns:a="http://schemas.openxmlformats.org/drawingml/2006/main">
-            <a:off x="685800" y="4572000"/>
-            <a:ext cx="10668000" cy="790575"/>
-          </a:xfrm>
-          <a:prstGeom xmlns:a="http://schemas.openxmlformats.org/drawingml/2006/main" prst="rect">
-            <a:avLst/>
-          </a:prstGeom>
-          <a:noFill xmlns:a="http://schemas.openxmlformats.org/drawingml/2006/main"/>
-          <a:ln xmlns:a="http://schemas.openxmlformats.org/drawingml/2006/main" w="0">
-            <a:noFill/>
-          </a:ln>
-        </p:spPr>
-        <p:txBody>
-          <a:bodyPr xmlns:a="http://schemas.openxmlformats.org/drawingml/2006/main">
-            <a:noAutofit/>
-          </a:bodyPr>
-          <a:lstStyle xmlns:a="http://schemas.openxmlformats.org/drawingml/2006/main"/>
-          <a:p xmlns:a="http://schemas.openxmlformats.org/drawingml/2006/main">
-            <a:pPr>
-              <a:defRPr sz="2250" b="0">
-                <a:solidFill>
-                  <a:srgbClr val="142C40"/>
-                </a:solidFill>
-                <a:latin typeface="Helvetica Neue"/>
-                <a:ea typeface="Helvetica Neue"/>
-                <a:cs typeface="Helvetica Neue"/>
-              </a:defRPr>
-            </a:pPr>
-            <a:r>
-              <a:rPr sz="2250" b="0">
-                <a:solidFill>
-                  <a:srgbClr val="142C40"/>
-                </a:solidFill>
-                <a:latin typeface="Helvetica Neue"/>
-                <a:ea typeface="Helvetica Neue"/>
-                <a:cs typeface="Helvetica Neue"/>
-              </a:rPr>
-              <a:t>“Inconsistent” is a correct conclusion, not a refusal</a:t>
-            </a:r>
-          </a:p>
-        </p:txBody>
-      </p:sp>
-      <p:sp>
-        <p:nvSpPr>
-          <p:cNvPr id="6" name="">
-            <a:extLst xmlns:a="http://schemas.openxmlformats.org/drawingml/2006/main">
-              <a:ext uri="{FF2B5EF4-FFF2-40B4-BE49-F238E27FC236}">
-                <a16:creationId xmlns:a16="http://schemas.microsoft.com/office/drawing/2014/main" id="{F1942667-9628-4951-92B2-5490AEE0C617}"/>
+                <a16:creationId xmlns:a16="http://schemas.microsoft.com/office/drawing/2014/main" id="{73B14C54-73BE-4ABD-9504-454C695C96FF}"/>
               </a:ext>
             </a:extLst>
           </p:cNvPr>
@@ -6973,7 +9520,7 @@
     </p:spTree>
     <p:extLst>
       <p:ext uri="{BB962C8B-B14F-4D97-AF65-F5344CB8AC3E}">
-        <p14:creationId xmlns:p14="http://schemas.microsoft.com/office/powerpoint/2010/main" val="804945607"/>
+        <p14:creationId xmlns:p14="http://schemas.microsoft.com/office/powerpoint/2010/main" val="1529323490"/>
       </p:ext>
     </p:extLst>
   </p:cSld>
@@ -7004,7 +9551,7 @@
           <p:cNvPr id="6" name="">
             <a:extLst xmlns:a="http://schemas.openxmlformats.org/drawingml/2006/main">
               <a:ext uri="{FF2B5EF4-FFF2-40B4-BE49-F238E27FC236}">
-                <a16:creationId xmlns:a16="http://schemas.microsoft.com/office/drawing/2014/main" id="{04BA06ED-1B99-4E1B-80B3-A46C740ABD01}"/>
+                <a16:creationId xmlns:a16="http://schemas.microsoft.com/office/drawing/2014/main" id="{E2EB5AEC-AA4F-4AEB-A5DA-EEFF6EF355BF}"/>
               </a:ext>
             </a:extLst>
           </p:cNvPr>
@@ -7051,7 +9598,7 @@
                 <a:ea typeface="Helvetica Neue"/>
                 <a:cs typeface="Helvetica Neue"/>
               </a:rPr>
-              <a:t>Mathematics: a partial descriptive supplement</a:t>
+              <a:t>Checking also changes the willingness to answer</a:t>
             </a:r>
           </a:p>
         </p:txBody>
@@ -7063,12 +9610,12 @@
           <p:nvPr/>
         </p:nvGraphicFramePr>
         <p:xfrm>
-          <a:off xmlns:a="http://schemas.openxmlformats.org/drawingml/2006/main" x="952500" y="1619250"/>
-          <a:ext xmlns:a="http://schemas.openxmlformats.org/drawingml/2006/main" cx="10096500" cy="3429000"/>
+          <a:off xmlns:a="http://schemas.openxmlformats.org/drawingml/2006/main" x="857250" y="1571625"/>
+          <a:ext xmlns:a="http://schemas.openxmlformats.org/drawingml/2006/main" cx="10287000" cy="3571875"/>
         </p:xfrm>
         <a:graphic xmlns:a="http://schemas.openxmlformats.org/drawingml/2006/main">
           <a:graphicData uri="http://schemas.openxmlformats.org/drawingml/2006/chart">
-            <c:chart xmlns:r="http://schemas.openxmlformats.org/officeDocument/2006/relationships" xmlns:c="http://schemas.openxmlformats.org/drawingml/2006/chart" r:id="R9c1cf32badd44c25"/>
+            <c:chart xmlns:r="http://schemas.openxmlformats.org/officeDocument/2006/relationships" xmlns:c="http://schemas.openxmlformats.org/drawingml/2006/chart" r:id="Rc4f5d9b7c6af4e30"/>
           </a:graphicData>
         </a:graphic>
       </p:graphicFrame>
@@ -7077,7 +9624,7 @@
           <p:cNvPr id="3" name="">
             <a:extLst xmlns:a="http://schemas.openxmlformats.org/drawingml/2006/main">
               <a:ext uri="{FF2B5EF4-FFF2-40B4-BE49-F238E27FC236}">
-                <a16:creationId xmlns:a16="http://schemas.microsoft.com/office/drawing/2014/main" id="{4EA86F7E-5C75-459D-A329-0F9E76470EAD}"/>
+                <a16:creationId xmlns:a16="http://schemas.microsoft.com/office/drawing/2014/main" id="{592D78CE-0D75-4DA1-8561-F82BE489C4B7}"/>
               </a:ext>
             </a:extLst>
           </p:cNvPr>
@@ -7088,8 +9635,8 @@
         </p:nvSpPr>
         <p:spPr>
           <a:xfrm xmlns:a="http://schemas.openxmlformats.org/drawingml/2006/main">
-            <a:off x="685800" y="5238750"/>
-            <a:ext cx="10668000" cy="457200"/>
+            <a:off x="685800" y="5381625"/>
+            <a:ext cx="10668000" cy="428625"/>
           </a:xfrm>
           <a:prstGeom xmlns:a="http://schemas.openxmlformats.org/drawingml/2006/main" prst="rect">
             <a:avLst/>
@@ -7106,7 +9653,7 @@
           <a:lstStyle xmlns:a="http://schemas.openxmlformats.org/drawingml/2006/main"/>
           <a:p xmlns:a="http://schemas.openxmlformats.org/drawingml/2006/main">
             <a:pPr>
-              <a:defRPr sz="1950" b="1">
+              <a:defRPr sz="2025" b="1">
                 <a:solidFill>
                   <a:srgbClr val="147E77"/>
                 </a:solidFill>
@@ -7116,7 +9663,7 @@
               </a:defRPr>
             </a:pPr>
             <a:r>
-              <a:rPr sz="1950" b="1">
+              <a:rPr sz="2025" b="1">
                 <a:solidFill>
                   <a:srgbClr val="147E77"/>
                 </a:solidFill>
@@ -7124,7 +9671,7 @@
                 <a:ea typeface="Helvetica Neue"/>
                 <a:cs typeface="Helvetica Neue"/>
               </a:rPr>
-              <a:t>13 retained items; 71 complete units; correct final conclusions shown</a:t>
+              <a:t>All conditions contain 719 units. Uncertainty may help a user.</a:t>
             </a:r>
           </a:p>
         </p:txBody>
@@ -7134,7 +9681,7 @@
           <p:cNvPr id="4" name="">
             <a:extLst xmlns:a="http://schemas.openxmlformats.org/drawingml/2006/main">
               <a:ext uri="{FF2B5EF4-FFF2-40B4-BE49-F238E27FC236}">
-                <a16:creationId xmlns:a16="http://schemas.microsoft.com/office/drawing/2014/main" id="{1609F0DC-B8FE-4B47-865C-E5CB033C2C1C}"/>
+                <a16:creationId xmlns:a16="http://schemas.microsoft.com/office/drawing/2014/main" id="{BB83C00C-6CE2-4CE1-8F33-C98B487E7249}"/>
               </a:ext>
             </a:extLst>
           </p:cNvPr>
@@ -7145,8 +9692,8 @@
         </p:nvSpPr>
         <p:spPr>
           <a:xfrm xmlns:a="http://schemas.openxmlformats.org/drawingml/2006/main">
-            <a:off x="685800" y="5772150"/>
-            <a:ext cx="10668000" cy="495300"/>
+            <a:off x="685800" y="5886450"/>
+            <a:ext cx="10668000" cy="381000"/>
           </a:xfrm>
           <a:prstGeom xmlns:a="http://schemas.openxmlformats.org/drawingml/2006/main" prst="rect">
             <a:avLst/>
@@ -7163,7 +9710,7 @@
           <a:lstStyle xmlns:a="http://schemas.openxmlformats.org/drawingml/2006/main"/>
           <a:p xmlns:a="http://schemas.openxmlformats.org/drawingml/2006/main">
             <a:pPr>
-              <a:defRPr sz="1875" b="0">
+              <a:defRPr sz="1800" b="0">
                 <a:solidFill>
                   <a:srgbClr val="657586"/>
                 </a:solidFill>
@@ -7173,7 +9720,7 @@
               </a:defRPr>
             </a:pPr>
             <a:r>
-              <a:rPr sz="1875" b="0">
+              <a:rPr sz="1800" b="0">
                 <a:solidFill>
                   <a:srgbClr val="657586"/>
                 </a:solidFill>
@@ -7181,7 +9728,7 @@
                 <a:ea typeface="Helvetica Neue"/>
                 <a:cs typeface="Helvetica Neue"/>
               </a:rPr>
-              <a:t>13/16 initial errors have correct reason endpoints, but wrong final fields.</a:t>
+              <a:t>A correct answer or a claim of verification does not prove evidence was checked.</a:t>
             </a:r>
           </a:p>
         </p:txBody>
@@ -7191,7 +9738,7 @@
           <p:cNvPr id="5" name="">
             <a:extLst xmlns:a="http://schemas.openxmlformats.org/drawingml/2006/main">
               <a:ext uri="{FF2B5EF4-FFF2-40B4-BE49-F238E27FC236}">
-                <a16:creationId xmlns:a16="http://schemas.microsoft.com/office/drawing/2014/main" id="{793DDF1D-4AA1-4986-93C8-C7929071F43D}"/>
+                <a16:creationId xmlns:a16="http://schemas.microsoft.com/office/drawing/2014/main" id="{227EE52E-939A-447B-93F9-0F77054949A8}"/>
               </a:ext>
             </a:extLst>
           </p:cNvPr>
@@ -7246,7 +9793,7 @@
     </p:spTree>
     <p:extLst>
       <p:ext uri="{BB962C8B-B14F-4D97-AF65-F5344CB8AC3E}">
-        <p14:creationId xmlns:p14="http://schemas.microsoft.com/office/powerpoint/2010/main" val="229315280"/>
+        <p14:creationId xmlns:p14="http://schemas.microsoft.com/office/powerpoint/2010/main" val="1596679076"/>
       </p:ext>
     </p:extLst>
   </p:cSld>

</xml_diff>

<commit_message>
Match result visualizations to effects, composition and paired outcomes
</commit_message>
<xml_diff>
--- a/Submission_Pack/COMP2501_presentation.pptx
+++ b/Submission_Pack/COMP2501_presentation.pptx
@@ -2,28 +2,28 @@
 <file path=ppt/presentation.xml><?xml version="1.0" encoding="utf-8"?>
 <p:presentation xmlns:p="http://schemas.openxmlformats.org/presentationml/2006/main">
   <p:sldMasterIdLst>
-    <p:sldMasterId xmlns:r="http://schemas.openxmlformats.org/officeDocument/2006/relationships" id="2147483648" r:id="Ra935f0b61a594560"/>
+    <p:sldMasterId xmlns:r="http://schemas.openxmlformats.org/officeDocument/2006/relationships" id="2147483648" r:id="R1cebeb1b34524514"/>
   </p:sldMasterIdLst>
   <p:notesMasterIdLst>
-    <p:notesMasterId xmlns:r="http://schemas.openxmlformats.org/officeDocument/2006/relationships" r:id="R807073ce51b24302"/>
+    <p:notesMasterId xmlns:r="http://schemas.openxmlformats.org/officeDocument/2006/relationships" r:id="R875776c6fe3a4b28"/>
   </p:notesMasterIdLst>
   <p:sldIdLst>
-    <p:sldId xmlns:r="http://schemas.openxmlformats.org/officeDocument/2006/relationships" id="256" r:id="R9e86e4c14e1249c4"/>
-    <p:sldId xmlns:r="http://schemas.openxmlformats.org/officeDocument/2006/relationships" id="257" r:id="R135c2e2506c640bf"/>
-    <p:sldId xmlns:r="http://schemas.openxmlformats.org/officeDocument/2006/relationships" id="258" r:id="Ra3c2f15c9c1d4d49"/>
-    <p:sldId xmlns:r="http://schemas.openxmlformats.org/officeDocument/2006/relationships" id="259" r:id="Rbc04ddadfc974242"/>
-    <p:sldId xmlns:r="http://schemas.openxmlformats.org/officeDocument/2006/relationships" id="260" r:id="R20219956a9214861"/>
-    <p:sldId xmlns:r="http://schemas.openxmlformats.org/officeDocument/2006/relationships" id="261" r:id="R07d6e8a3e13a495e"/>
-    <p:sldId xmlns:r="http://schemas.openxmlformats.org/officeDocument/2006/relationships" id="262" r:id="R3e929b366d8c496d"/>
-    <p:sldId xmlns:r="http://schemas.openxmlformats.org/officeDocument/2006/relationships" id="263" r:id="R3949103a8556457f"/>
-    <p:sldId xmlns:r="http://schemas.openxmlformats.org/officeDocument/2006/relationships" id="264" r:id="R78a5225447604c9f"/>
-    <p:sldId xmlns:r="http://schemas.openxmlformats.org/officeDocument/2006/relationships" id="265" r:id="Rd6ad835e34b24351"/>
-    <p:sldId xmlns:r="http://schemas.openxmlformats.org/officeDocument/2006/relationships" id="266" r:id="R294e1a6c30f445c3"/>
-    <p:sldId xmlns:r="http://schemas.openxmlformats.org/officeDocument/2006/relationships" id="267" r:id="Rb4d65b5814434a56"/>
-    <p:sldId xmlns:r="http://schemas.openxmlformats.org/officeDocument/2006/relationships" id="268" r:id="Rdfb64ca2db254175"/>
-    <p:sldId xmlns:r="http://schemas.openxmlformats.org/officeDocument/2006/relationships" id="269" r:id="R6df266a29a5a4564"/>
-    <p:sldId xmlns:r="http://schemas.openxmlformats.org/officeDocument/2006/relationships" id="270" r:id="R5af0bf2c07df406a"/>
-    <p:sldId xmlns:r="http://schemas.openxmlformats.org/officeDocument/2006/relationships" id="271" r:id="R427a19d023c949d2"/>
+    <p:sldId xmlns:r="http://schemas.openxmlformats.org/officeDocument/2006/relationships" id="256" r:id="R8dc19e59becf4692"/>
+    <p:sldId xmlns:r="http://schemas.openxmlformats.org/officeDocument/2006/relationships" id="257" r:id="R2df6b90cf886430e"/>
+    <p:sldId xmlns:r="http://schemas.openxmlformats.org/officeDocument/2006/relationships" id="258" r:id="R49f9837c795e4656"/>
+    <p:sldId xmlns:r="http://schemas.openxmlformats.org/officeDocument/2006/relationships" id="259" r:id="Ra37b237bdf354f85"/>
+    <p:sldId xmlns:r="http://schemas.openxmlformats.org/officeDocument/2006/relationships" id="260" r:id="R39c84e5acc8a46d9"/>
+    <p:sldId xmlns:r="http://schemas.openxmlformats.org/officeDocument/2006/relationships" id="261" r:id="Rc50ad27dee0e467a"/>
+    <p:sldId xmlns:r="http://schemas.openxmlformats.org/officeDocument/2006/relationships" id="262" r:id="Ref46506e5bc34b36"/>
+    <p:sldId xmlns:r="http://schemas.openxmlformats.org/officeDocument/2006/relationships" id="263" r:id="R2c4399f4f7484fd0"/>
+    <p:sldId xmlns:r="http://schemas.openxmlformats.org/officeDocument/2006/relationships" id="264" r:id="R78c9938c0bfa4239"/>
+    <p:sldId xmlns:r="http://schemas.openxmlformats.org/officeDocument/2006/relationships" id="265" r:id="R0d65cc650d2d4aa6"/>
+    <p:sldId xmlns:r="http://schemas.openxmlformats.org/officeDocument/2006/relationships" id="266" r:id="R8515a7c6164048a9"/>
+    <p:sldId xmlns:r="http://schemas.openxmlformats.org/officeDocument/2006/relationships" id="267" r:id="Re5babb91c73c4f11"/>
+    <p:sldId xmlns:r="http://schemas.openxmlformats.org/officeDocument/2006/relationships" id="268" r:id="Rf0be3d44bb7645a2"/>
+    <p:sldId xmlns:r="http://schemas.openxmlformats.org/officeDocument/2006/relationships" id="269" r:id="R1b42dcbd0adc44ca"/>
+    <p:sldId xmlns:r="http://schemas.openxmlformats.org/officeDocument/2006/relationships" id="270" r:id="R99577ee61c6f4721"/>
+    <p:sldId xmlns:r="http://schemas.openxmlformats.org/officeDocument/2006/relationships" id="271" r:id="Ra26f0da3544a440f"/>
   </p:sldIdLst>
   <p:sldSz cx="12192000" cy="6858000"/>
   <p:notesSz cx="6858000" cy="9144000"/>
@@ -1397,7 +1397,7 @@
           <a:lstStyle xmlns:a="http://schemas.openxmlformats.org/drawingml/2006/main"/>
           <a:p xmlns:a="http://schemas.openxmlformats.org/drawingml/2006/main">
             <a:r>
-              <a:t>90 seconds. Post-hoc analysis of all 719 paired units. Error rates are 46.04% for C0, 64.81% C1, 52.43% C2 and 35.88% C3. C1-C0 is +18.78 points [14.35,23.09], C2-C0 +6.40 [1.94,10.99], and C3-C2 -16.55 [-20.70,-12.38]. Pointwise exploratory intervals use 5000 question-cluster draws, seed 25011003. C0 minus initial error is +1.25 [-3.06,5.56]. The wrong-target counts are 11,251,147,58. C0 matching is spontaneous. These results do not support explanations being more harmful than wrong answers alone. </a:t>
+              <a:t>90 seconds. Read the forest plot: points show error-rate differences, horizontal segments show 95% question-cluster intervals, and zero means no difference. Negative values mean less error, not necessarily more correct answers. The exact values are printed on the right. Post-hoc analysis of all 719 paired units. Error rates are 46.04% for C0, 64.81% C1, 52.43% C2 and 35.88% C3. C1-C0 is +18.78 points [14.35,23.09], C2-C0 +6.40 [1.94,10.99], and C3-C2 -16.55 [-20.70,-12.38]. Pointwise exploratory intervals use 5000 question-cluster draws, seed 25011003. C0 minus initial error is +1.25 [-3.06,5.56]. The wrong-target counts are 11,251,147,58. C0 matching is spontaneous. These results do not support explanations being more harmful than wrong answers alone. </a:t>
             </a:r>
           </a:p>
           <a:p xmlns:a="http://schemas.openxmlformats.org/drawingml/2006/main">
@@ -1472,7 +1472,7 @@
           <a:lstStyle xmlns:a="http://schemas.openxmlformats.org/drawingml/2006/main"/>
           <a:p xmlns:a="http://schemas.openxmlformats.org/drawingml/2006/main">
             <a:r>
-              <a:t>90 seconds. Read the full C2-by-C3 transition table. Most prevented errors become abstentions: 144 wrong-to-abstain and 5 wrong-to-correct, offset by 21 abstain-to-wrong and 9 correct-to-wrong. Net wrong outputs fall by 119, but correct outputs also fall by 21. Comparisons use parallel branches, not sequential follow-ups. Relative to C0, C1/C2 include 158/114 abstain-to-wrong pairs and 25/67 reverse pairs, showing how misleading input can fill a knowledge gap. </a:t>
+              <a:t>90 seconds. Read the C2-by-C3 heatmap. Rows are C2, columns are C3. Each cell shows a paired count; darker cells mean more pairs on a shared 0-228 scale. Most prevented errors become abstentions: 144 wrong-to-abstain and 5 wrong-to-correct, offset by 21 abstain-to-wrong and 9 correct-to-wrong. Net wrong outputs fall by 119, but correct outputs also fall by 21. Comparisons use parallel branches, not sequential follow-ups. Relative to C0, C1/C2 include 158/114 abstain-to-wrong pairs and 25/67 reverse pairs, showing how misleading input can fill a knowledge gap. </a:t>
             </a:r>
           </a:p>
           <a:p xmlns:a="http://schemas.openxmlformats.org/drawingml/2006/main">
@@ -1622,7 +1622,7 @@
           <a:lstStyle xmlns:a="http://schemas.openxmlformats.org/drawingml/2006/main"/>
           <a:p xmlns:a="http://schemas.openxmlformats.org/drawingml/2006/main">
             <a:r>
-              <a:t>60 seconds. The stacked bars all use 719 complete units. Structured prompts shift many outputs into abstention. Date accuracy does not validate the explanation or prove evidence was consulted. Mention the correct 1975 candidate with explicit uncertainty as a case of mixed dimensions. </a:t>
+              <a:t>60 seconds. The 100% stacked bars show the proportions correct, wrong and abstaining; all use 719 complete units. Structured prompts shift many outputs into abstention. Date accuracy does not validate the explanation or prove evidence was consulted. Mention the correct 1975 candidate with explicit uncertainty as a case of mixed dimensions. </a:t>
             </a:r>
           </a:p>
           <a:p xmlns:a="http://schemas.openxmlformats.org/drawingml/2006/main">
@@ -1695,7 +1695,7 @@
   </p:cSld>
   <p:clrMap bg1="lt1" tx1="dk1" bg2="lt2" tx2="dk2" accent1="accent1" accent2="accent2" accent3="accent3" accent4="accent4" accent5="accent5" accent6="accent6" hlink="hlink" folHlink="folHlink"/>
   <p:sldLayoutIdLst>
-    <p:sldLayoutId xmlns:r="http://schemas.openxmlformats.org/officeDocument/2006/relationships" id="2147483649" r:id="R0ae3db706d014efa"/>
+    <p:sldLayoutId xmlns:r="http://schemas.openxmlformats.org/officeDocument/2006/relationships" id="2147483649" r:id="R017ef42e8f994f52"/>
   </p:sldLayoutIdLst>
   <p:txStyles>
     <p:titleStyle>
@@ -2391,62 +2391,519 @@
   <c:lang val="en-US"/>
   <c:chart>
     <c:plotArea>
-      <c:barChart>
-        <c:barDir val="col"/>
-        <c:grouping val="clustered"/>
-        <c:varyColors val="0"/>
+      <c:scatterChart>
+        <c:scatterStyle val="lineMarker"/>
         <c:ser>
           <c:idx val="0"/>
           <c:order val="0"/>
           <c:tx>
-            <c:v>error_pct</c:v>
+            <c:v>No difference</c:v>
+          </c:tx>
+          <c:spPr>
+            <a:ln xmlns:a="http://schemas.openxmlformats.org/drawingml/2006/main" w="9525">
+              <a:solidFill>
+                <a:srgbClr val="657586"/>
+              </a:solidFill>
+            </a:ln>
+          </c:spPr>
+          <c:marker>
+            <c:symbol val="none"/>
+          </c:marker>
+          <c:xVal>
+            <c:numRef>
+              <c:f>'Chart Data'!$A$2:$A$3</c:f>
+              <c:numCache>
+                <c:formatCode>General</c:formatCode>
+                <c:ptCount val="2"/>
+                <c:pt idx="0">
+                  <c:v>0</c:v>
+                </c:pt>
+                <c:pt idx="1">
+                  <c:v>0</c:v>
+                </c:pt>
+              </c:numCache>
+            </c:numRef>
+          </c:xVal>
+          <c:yVal>
+            <c:numRef>
+              <c:f>'Chart Data'!$B$2:$B$3</c:f>
+              <c:numCache>
+                <c:formatCode>General</c:formatCode>
+                <c:ptCount val="2"/>
+                <c:pt idx="0">
+                  <c:v>0</c:v>
+                </c:pt>
+                <c:pt idx="1">
+                  <c:v>6</c:v>
+                </c:pt>
+              </c:numCache>
+            </c:numRef>
+          </c:yVal>
+        </c:ser>
+        <c:ser>
+          <c:idx val="1"/>
+          <c:order val="1"/>
+          <c:tx>
+            <c:v>C0_vs_baseline interval</c:v>
+          </c:tx>
+          <c:spPr>
+            <a:ln xmlns:a="http://schemas.openxmlformats.org/drawingml/2006/main" w="28575">
+              <a:solidFill>
+                <a:srgbClr val="142C40"/>
+              </a:solidFill>
+            </a:ln>
+          </c:spPr>
+          <c:marker>
+            <c:symbol val="none"/>
+          </c:marker>
+          <c:xVal>
+            <c:numRef>
+              <c:f>'Chart Data'!$C$2:$C$3</c:f>
+              <c:numCache>
+                <c:formatCode>General</c:formatCode>
+                <c:ptCount val="2"/>
+                <c:pt idx="0">
+                  <c:v>-3.06406685236769</c:v>
+                </c:pt>
+                <c:pt idx="1">
+                  <c:v>5.56328233657858</c:v>
+                </c:pt>
+              </c:numCache>
+            </c:numRef>
+          </c:xVal>
+          <c:yVal>
+            <c:numRef>
+              <c:f>'Chart Data'!$D$2:$D$3</c:f>
+              <c:numCache>
+                <c:formatCode>General</c:formatCode>
+                <c:ptCount val="2"/>
+                <c:pt idx="0">
+                  <c:v>5</c:v>
+                </c:pt>
+                <c:pt idx="1">
+                  <c:v>5</c:v>
+                </c:pt>
+              </c:numCache>
+            </c:numRef>
+          </c:yVal>
+        </c:ser>
+        <c:ser>
+          <c:idx val="2"/>
+          <c:order val="2"/>
+          <c:tx>
+            <c:v>C0_vs_baseline</c:v>
           </c:tx>
           <c:spPr>
             <a:solidFill xmlns:a="http://schemas.openxmlformats.org/drawingml/2006/main">
-              <a:srgbClr val="C45F48"/>
+              <a:srgbClr val="147E77"/>
             </a:solidFill>
+            <a:ln xmlns:a="http://schemas.openxmlformats.org/drawingml/2006/main">
+              <a:noFill/>
+            </a:ln>
           </c:spPr>
-          <c:cat>
-            <c:strRef>
-              <c:f>'Chart Data'!$A$2:$A$5</c:f>
-              <c:strCache>
-                <c:ptCount val="4"/>
+          <c:marker>
+            <c:symbol val="circle"/>
+            <c:size val="9"/>
+            <c:spPr>
+              <a:noFill xmlns:a="http://schemas.openxmlformats.org/drawingml/2006/main"/>
+            </c:spPr>
+          </c:marker>
+          <c:xVal>
+            <c:numRef>
+              <c:f>'Chart Data'!$E$2:$E$2</c:f>
+              <c:numCache>
+                <c:formatCode>General</c:formatCode>
+                <c:ptCount val="1"/>
                 <c:pt idx="0">
-                  <c:v>C0 Neutral</c:v>
-                </c:pt>
-                <c:pt idx="1">
-                  <c:v>C1 Wrong only</c:v>
-                </c:pt>
-                <c:pt idx="2">
-                  <c:v>C2 Wrong + reason</c:v>
-                </c:pt>
-                <c:pt idx="3">
-                  <c:v>C3 Structured</c:v>
-                </c:pt>
-              </c:strCache>
-            </c:strRef>
-          </c:cat>
-          <c:val>
-            <c:numRef>
-              <c:f>'Chart Data'!$B$2:$B$5</c:f>
-              <c:numCache>
-                <c:formatCode>0</c:formatCode>
-                <c:ptCount val="4"/>
-                <c:pt idx="0">
-                  <c:v>46.04</c:v>
-                </c:pt>
-                <c:pt idx="1">
-                  <c:v>64.81</c:v>
-                </c:pt>
-                <c:pt idx="2">
-                  <c:v>52.43</c:v>
-                </c:pt>
-                <c:pt idx="3">
-                  <c:v>35.88</c:v>
+                  <c:v>1.25173852573018</c:v>
                 </c:pt>
               </c:numCache>
             </c:numRef>
-          </c:val>
+          </c:xVal>
+          <c:yVal>
+            <c:numRef>
+              <c:f>'Chart Data'!$F$2:$F$2</c:f>
+              <c:numCache>
+                <c:formatCode>General</c:formatCode>
+                <c:ptCount val="1"/>
+                <c:pt idx="0">
+                  <c:v>5</c:v>
+                </c:pt>
+              </c:numCache>
+            </c:numRef>
+          </c:yVal>
+        </c:ser>
+        <c:ser>
+          <c:idx val="3"/>
+          <c:order val="3"/>
+          <c:tx>
+            <c:v>C1_vs_C0 interval</c:v>
+          </c:tx>
+          <c:spPr>
+            <a:ln xmlns:a="http://schemas.openxmlformats.org/drawingml/2006/main" w="28575">
+              <a:solidFill>
+                <a:srgbClr val="142C40"/>
+              </a:solidFill>
+            </a:ln>
+          </c:spPr>
+          <c:marker>
+            <c:symbol val="none"/>
+          </c:marker>
+          <c:xVal>
+            <c:numRef>
+              <c:f>'Chart Data'!$G$2:$G$3</c:f>
+              <c:numCache>
+                <c:formatCode>General</c:formatCode>
+                <c:ptCount val="2"/>
+                <c:pt idx="0">
+                  <c:v>14.3454038997214</c:v>
+                </c:pt>
+                <c:pt idx="1">
+                  <c:v>23.0876216968011</c:v>
+                </c:pt>
+              </c:numCache>
+            </c:numRef>
+          </c:xVal>
+          <c:yVal>
+            <c:numRef>
+              <c:f>'Chart Data'!$H$2:$H$3</c:f>
+              <c:numCache>
+                <c:formatCode>General</c:formatCode>
+                <c:ptCount val="2"/>
+                <c:pt idx="0">
+                  <c:v>4</c:v>
+                </c:pt>
+                <c:pt idx="1">
+                  <c:v>4</c:v>
+                </c:pt>
+              </c:numCache>
+            </c:numRef>
+          </c:yVal>
+        </c:ser>
+        <c:ser>
+          <c:idx val="4"/>
+          <c:order val="4"/>
+          <c:tx>
+            <c:v>C1_vs_C0</c:v>
+          </c:tx>
+          <c:spPr>
+            <a:solidFill xmlns:a="http://schemas.openxmlformats.org/drawingml/2006/main">
+              <a:srgbClr val="147E77"/>
+            </a:solidFill>
+            <a:ln xmlns:a="http://schemas.openxmlformats.org/drawingml/2006/main">
+              <a:noFill/>
+            </a:ln>
+          </c:spPr>
+          <c:marker>
+            <c:symbol val="circle"/>
+            <c:size val="9"/>
+            <c:spPr>
+              <a:noFill xmlns:a="http://schemas.openxmlformats.org/drawingml/2006/main"/>
+            </c:spPr>
+          </c:marker>
+          <c:xVal>
+            <c:numRef>
+              <c:f>'Chart Data'!$I$2:$I$2</c:f>
+              <c:numCache>
+                <c:formatCode>General</c:formatCode>
+                <c:ptCount val="1"/>
+                <c:pt idx="0">
+                  <c:v>18.7760778859527</c:v>
+                </c:pt>
+              </c:numCache>
+            </c:numRef>
+          </c:xVal>
+          <c:yVal>
+            <c:numRef>
+              <c:f>'Chart Data'!$J$2:$J$2</c:f>
+              <c:numCache>
+                <c:formatCode>General</c:formatCode>
+                <c:ptCount val="1"/>
+                <c:pt idx="0">
+                  <c:v>4</c:v>
+                </c:pt>
+              </c:numCache>
+            </c:numRef>
+          </c:yVal>
+        </c:ser>
+        <c:ser>
+          <c:idx val="5"/>
+          <c:order val="5"/>
+          <c:tx>
+            <c:v>C2_vs_C0 interval</c:v>
+          </c:tx>
+          <c:spPr>
+            <a:ln xmlns:a="http://schemas.openxmlformats.org/drawingml/2006/main" w="28575">
+              <a:solidFill>
+                <a:srgbClr val="142C40"/>
+              </a:solidFill>
+            </a:ln>
+          </c:spPr>
+          <c:marker>
+            <c:symbol val="none"/>
+          </c:marker>
+          <c:xVal>
+            <c:numRef>
+              <c:f>'Chart Data'!$K$2:$K$3</c:f>
+              <c:numCache>
+                <c:formatCode>General</c:formatCode>
+                <c:ptCount val="2"/>
+                <c:pt idx="0">
+                  <c:v>1.94444444444445</c:v>
+                </c:pt>
+                <c:pt idx="1">
+                  <c:v>10.9874826147427</c:v>
+                </c:pt>
+              </c:numCache>
+            </c:numRef>
+          </c:xVal>
+          <c:yVal>
+            <c:numRef>
+              <c:f>'Chart Data'!$L$2:$L$3</c:f>
+              <c:numCache>
+                <c:formatCode>General</c:formatCode>
+                <c:ptCount val="2"/>
+                <c:pt idx="0">
+                  <c:v>3</c:v>
+                </c:pt>
+                <c:pt idx="1">
+                  <c:v>3</c:v>
+                </c:pt>
+              </c:numCache>
+            </c:numRef>
+          </c:yVal>
+        </c:ser>
+        <c:ser>
+          <c:idx val="6"/>
+          <c:order val="6"/>
+          <c:tx>
+            <c:v>C2_vs_C0</c:v>
+          </c:tx>
+          <c:spPr>
+            <a:solidFill xmlns:a="http://schemas.openxmlformats.org/drawingml/2006/main">
+              <a:srgbClr val="147E77"/>
+            </a:solidFill>
+            <a:ln xmlns:a="http://schemas.openxmlformats.org/drawingml/2006/main">
+              <a:noFill/>
+            </a:ln>
+          </c:spPr>
+          <c:marker>
+            <c:symbol val="circle"/>
+            <c:size val="9"/>
+            <c:spPr>
+              <a:noFill xmlns:a="http://schemas.openxmlformats.org/drawingml/2006/main"/>
+            </c:spPr>
+          </c:marker>
+          <c:xVal>
+            <c:numRef>
+              <c:f>'Chart Data'!$M$2:$M$2</c:f>
+              <c:numCache>
+                <c:formatCode>General</c:formatCode>
+                <c:ptCount val="1"/>
+                <c:pt idx="0">
+                  <c:v>6.39777468706536</c:v>
+                </c:pt>
+              </c:numCache>
+            </c:numRef>
+          </c:xVal>
+          <c:yVal>
+            <c:numRef>
+              <c:f>'Chart Data'!$N$2:$N$2</c:f>
+              <c:numCache>
+                <c:formatCode>General</c:formatCode>
+                <c:ptCount val="1"/>
+                <c:pt idx="0">
+                  <c:v>3</c:v>
+                </c:pt>
+              </c:numCache>
+            </c:numRef>
+          </c:yVal>
+        </c:ser>
+        <c:ser>
+          <c:idx val="7"/>
+          <c:order val="7"/>
+          <c:tx>
+            <c:v>C3_vs_C2 interval</c:v>
+          </c:tx>
+          <c:spPr>
+            <a:ln xmlns:a="http://schemas.openxmlformats.org/drawingml/2006/main" w="28575">
+              <a:solidFill>
+                <a:srgbClr val="142C40"/>
+              </a:solidFill>
+            </a:ln>
+          </c:spPr>
+          <c:marker>
+            <c:symbol val="none"/>
+          </c:marker>
+          <c:xVal>
+            <c:numRef>
+              <c:f>'Chart Data'!$O$2:$O$3</c:f>
+              <c:numCache>
+                <c:formatCode>General</c:formatCode>
+                <c:ptCount val="2"/>
+                <c:pt idx="0">
+                  <c:v>-20.6951640009272</c:v>
+                </c:pt>
+                <c:pt idx="1">
+                  <c:v>-12.3783031988873</c:v>
+                </c:pt>
+              </c:numCache>
+            </c:numRef>
+          </c:xVal>
+          <c:yVal>
+            <c:numRef>
+              <c:f>'Chart Data'!$P$2:$P$3</c:f>
+              <c:numCache>
+                <c:formatCode>General</c:formatCode>
+                <c:ptCount val="2"/>
+                <c:pt idx="0">
+                  <c:v>2</c:v>
+                </c:pt>
+                <c:pt idx="1">
+                  <c:v>2</c:v>
+                </c:pt>
+              </c:numCache>
+            </c:numRef>
+          </c:yVal>
+        </c:ser>
+        <c:ser>
+          <c:idx val="8"/>
+          <c:order val="8"/>
+          <c:tx>
+            <c:v>C3_vs_C2</c:v>
+          </c:tx>
+          <c:spPr>
+            <a:solidFill xmlns:a="http://schemas.openxmlformats.org/drawingml/2006/main">
+              <a:srgbClr val="147E77"/>
+            </a:solidFill>
+            <a:ln xmlns:a="http://schemas.openxmlformats.org/drawingml/2006/main">
+              <a:noFill/>
+            </a:ln>
+          </c:spPr>
+          <c:marker>
+            <c:symbol val="circle"/>
+            <c:size val="9"/>
+            <c:spPr>
+              <a:noFill xmlns:a="http://schemas.openxmlformats.org/drawingml/2006/main"/>
+            </c:spPr>
+          </c:marker>
+          <c:xVal>
+            <c:numRef>
+              <c:f>'Chart Data'!$Q$2:$Q$2</c:f>
+              <c:numCache>
+                <c:formatCode>General</c:formatCode>
+                <c:ptCount val="1"/>
+                <c:pt idx="0">
+                  <c:v>-16.5507649513213</c:v>
+                </c:pt>
+              </c:numCache>
+            </c:numRef>
+          </c:xVal>
+          <c:yVal>
+            <c:numRef>
+              <c:f>'Chart Data'!$R$2:$R$2</c:f>
+              <c:numCache>
+                <c:formatCode>General</c:formatCode>
+                <c:ptCount val="1"/>
+                <c:pt idx="0">
+                  <c:v>2</c:v>
+                </c:pt>
+              </c:numCache>
+            </c:numRef>
+          </c:yVal>
+        </c:ser>
+        <c:ser>
+          <c:idx val="9"/>
+          <c:order val="9"/>
+          <c:tx>
+            <c:v>C5_vs_C4 interval</c:v>
+          </c:tx>
+          <c:spPr>
+            <a:ln xmlns:a="http://schemas.openxmlformats.org/drawingml/2006/main" w="28575">
+              <a:solidFill>
+                <a:srgbClr val="142C40"/>
+              </a:solidFill>
+            </a:ln>
+          </c:spPr>
+          <c:marker>
+            <c:symbol val="none"/>
+          </c:marker>
+          <c:xVal>
+            <c:numRef>
+              <c:f>'Chart Data'!$S$2:$S$3</c:f>
+              <c:numCache>
+                <c:formatCode>General</c:formatCode>
+                <c:ptCount val="2"/>
+                <c:pt idx="0">
+                  <c:v>-7.37134909596662</c:v>
+                </c:pt>
+                <c:pt idx="1">
+                  <c:v>-2.22222222222222</c:v>
+                </c:pt>
+              </c:numCache>
+            </c:numRef>
+          </c:xVal>
+          <c:yVal>
+            <c:numRef>
+              <c:f>'Chart Data'!$T$2:$T$3</c:f>
+              <c:numCache>
+                <c:formatCode>General</c:formatCode>
+                <c:ptCount val="2"/>
+                <c:pt idx="0">
+                  <c:v>1</c:v>
+                </c:pt>
+                <c:pt idx="1">
+                  <c:v>1</c:v>
+                </c:pt>
+              </c:numCache>
+            </c:numRef>
+          </c:yVal>
+        </c:ser>
+        <c:ser>
+          <c:idx val="10"/>
+          <c:order val="10"/>
+          <c:tx>
+            <c:v>C5_vs_C4</c:v>
+          </c:tx>
+          <c:spPr>
+            <a:solidFill xmlns:a="http://schemas.openxmlformats.org/drawingml/2006/main">
+              <a:srgbClr val="147E77"/>
+            </a:solidFill>
+            <a:ln xmlns:a="http://schemas.openxmlformats.org/drawingml/2006/main">
+              <a:noFill/>
+            </a:ln>
+          </c:spPr>
+          <c:marker>
+            <c:symbol val="circle"/>
+            <c:size val="9"/>
+            <c:spPr>
+              <a:noFill xmlns:a="http://schemas.openxmlformats.org/drawingml/2006/main"/>
+            </c:spPr>
+          </c:marker>
+          <c:xVal>
+            <c:numRef>
+              <c:f>'Chart Data'!$U$2:$U$2</c:f>
+              <c:numCache>
+                <c:formatCode>General</c:formatCode>
+                <c:ptCount val="1"/>
+                <c:pt idx="0">
+                  <c:v>-4.72878998609179</c:v>
+                </c:pt>
+              </c:numCache>
+            </c:numRef>
+          </c:xVal>
+          <c:yVal>
+            <c:numRef>
+              <c:f>'Chart Data'!$V$2:$V$2</c:f>
+              <c:numCache>
+                <c:formatCode>General</c:formatCode>
+                <c:ptCount val="1"/>
+                <c:pt idx="0">
+                  <c:v>1</c:v>
+                </c:pt>
+              </c:numCache>
+            </c:numRef>
+          </c:yVal>
         </c:ser>
         <c:dLbls>
           <c:txPr>
@@ -2454,7 +2911,7 @@
             <a:lstStyle xmlns:a="http://schemas.openxmlformats.org/drawingml/2006/main"/>
             <a:p xmlns:a="http://schemas.openxmlformats.org/drawingml/2006/main">
               <a:pPr>
-                <a:defRPr sz="1800">
+                <a:defRPr>
                   <a:latin typeface="Helvetica Neue"/>
                   <a:ea typeface="Helvetica Neue"/>
                   <a:cs typeface="Helvetica Neue"/>
@@ -2462,9 +2919,8 @@
               </a:pPr>
             </a:p>
           </c:txPr>
-          <c:dLblPos val="outEnd"/>
           <c:showLegendKey val="0"/>
-          <c:showVal val="1"/>
+          <c:showVal val="0"/>
           <c:showCatName val="0"/>
           <c:showSerName val="0"/>
           <c:showPercent val="0"/>
@@ -2473,23 +2929,23 @@
         </c:dLbls>
         <c:axId val="48650112"/>
         <c:axId val="48672768"/>
-      </c:barChart>
-      <c:catAx>
-        <c:axId val="48650112"/>
+      </c:scatterChart>
+      <c:valAx>
+        <c:axId val="48672768"/>
         <c:scaling>
           <c:orientation val="minMax"/>
+          <c:max val="6"/>
+          <c:min val="0"/>
         </c:scaling>
         <c:delete val="0"/>
-        <c:axPos val="b"/>
+        <c:axPos val="l"/>
         <c:numFmt formatCode="General"/>
         <c:majorTickMark val="none"/>
         <c:minorTickMark val="none"/>
+        <c:tickLblPos val="none"/>
         <c:spPr>
-          <a:ln xmlns:a="http://schemas.openxmlformats.org/drawingml/2006/main" w="9525">
-            <a:solidFill>
-              <a:srgbClr val="D4D4D4"/>
-            </a:solidFill>
-            <a:prstDash val="solid"/>
+          <a:ln xmlns:a="http://schemas.openxmlformats.org/drawingml/2006/main">
+            <a:noFill/>
           </a:ln>
         </c:spPr>
         <c:txPr>
@@ -2497,7 +2953,7 @@
           <a:lstStyle xmlns:a="http://schemas.openxmlformats.org/drawingml/2006/main"/>
           <a:p xmlns:a="http://schemas.openxmlformats.org/drawingml/2006/main">
             <a:pPr>
-              <a:defRPr sz="1725">
+              <a:defRPr>
                 <a:solidFill>
                   <a:srgbClr val="666666"/>
                 </a:solidFill>
@@ -2508,15 +2964,17 @@
             </a:pPr>
           </a:p>
         </c:txPr>
-        <c:crossAx val="48672768"/>
-      </c:catAx>
+        <c:crossAx val="48650112"/>
+      </c:valAx>
       <c:valAx>
-        <c:axId val="48672768"/>
+        <c:axId val="48650112"/>
         <c:scaling>
           <c:orientation val="minMax"/>
+          <c:max val="25"/>
+          <c:min val="-25"/>
         </c:scaling>
         <c:delete val="0"/>
-        <c:axPos val="l"/>
+        <c:axPos val="b"/>
         <c:numFmt formatCode="0"/>
         <c:majorTickMark val="none"/>
         <c:minorTickMark val="none"/>
@@ -2533,7 +2991,7 @@
           <a:lstStyle xmlns:a="http://schemas.openxmlformats.org/drawingml/2006/main"/>
           <a:p xmlns:a="http://schemas.openxmlformats.org/drawingml/2006/main">
             <a:pPr>
-              <a:defRPr sz="1650">
+              <a:defRPr sz="1425">
                 <a:solidFill>
                   <a:srgbClr val="666666"/>
                 </a:solidFill>
@@ -2544,8 +3002,8 @@
             </a:pPr>
           </a:p>
         </c:txPr>
-        <c:crossAx val="48650112"/>
-        <c:crossBetween val="between"/>
+        <c:crossAx val="48672768"/>
+        <c:majorUnit val="5"/>
       </c:valAx>
     </c:plotArea>
     <c:plotVisOnly val="1"/>
@@ -2731,7 +3189,7 @@
           </c:tx>
           <c:spPr>
             <a:solidFill xmlns:a="http://schemas.openxmlformats.org/drawingml/2006/main">
-              <a:srgbClr val="8AC7C2"/>
+              <a:srgbClr val="147E77"/>
             </a:solidFill>
           </c:spPr>
           <c:cat>
@@ -2758,19 +3216,19 @@
             <c:numRef>
               <c:f>'Chart Data'!$B$2:$B$5</c:f>
               <c:numCache>
-                <c:formatCode>0</c:formatCode>
+                <c:formatCode>0.0</c:formatCode>
                 <c:ptCount val="4"/>
                 <c:pt idx="0">
-                  <c:v>162</c:v>
+                  <c:v>22.5312934631433</c:v>
                 </c:pt>
                 <c:pt idx="1">
-                  <c:v>141</c:v>
+                  <c:v>19.6105702364395</c:v>
                 </c:pt>
                 <c:pt idx="2">
-                  <c:v>353</c:v>
+                  <c:v>49.095966620306</c:v>
                 </c:pt>
                 <c:pt idx="3">
-                  <c:v>193</c:v>
+                  <c:v>26.8428372739917</c:v>
                 </c:pt>
               </c:numCache>
             </c:numRef>
@@ -2784,7 +3242,7 @@
           </c:tx>
           <c:spPr>
             <a:solidFill xmlns:a="http://schemas.openxmlformats.org/drawingml/2006/main">
-              <a:srgbClr val="EAB29F"/>
+              <a:srgbClr val="C45F48"/>
             </a:solidFill>
           </c:spPr>
           <c:cat>
@@ -2811,19 +3269,19 @@
             <c:numRef>
               <c:f>'Chart Data'!$D$2:$D$5</c:f>
               <c:numCache>
-                <c:formatCode>0</c:formatCode>
+                <c:formatCode>0.0</c:formatCode>
                 <c:ptCount val="4"/>
                 <c:pt idx="0">
-                  <c:v>377</c:v>
+                  <c:v>52.4339360222531</c:v>
                 </c:pt>
                 <c:pt idx="1">
-                  <c:v>258</c:v>
+                  <c:v>35.8831710709319</c:v>
                 </c:pt>
                 <c:pt idx="2">
-                  <c:v>217</c:v>
+                  <c:v>30.1808066759388</c:v>
                 </c:pt>
                 <c:pt idx="3">
-                  <c:v>183</c:v>
+                  <c:v>25.452016689847</c:v>
                 </c:pt>
               </c:numCache>
             </c:numRef>
@@ -2837,7 +3295,7 @@
           </c:tx>
           <c:spPr>
             <a:solidFill xmlns:a="http://schemas.openxmlformats.org/drawingml/2006/main">
-              <a:srgbClr val="D1DAE5"/>
+              <a:srgbClr val="8B9BAE"/>
             </a:solidFill>
           </c:spPr>
           <c:cat>
@@ -2864,19 +3322,19 @@
             <c:numRef>
               <c:f>'Chart Data'!$F$2:$F$5</c:f>
               <c:numCache>
-                <c:formatCode>0</c:formatCode>
+                <c:formatCode>0.0</c:formatCode>
                 <c:ptCount val="4"/>
                 <c:pt idx="0">
-                  <c:v>180</c:v>
+                  <c:v>25.0347705146036</c:v>
                 </c:pt>
                 <c:pt idx="1">
-                  <c:v>320</c:v>
+                  <c:v>44.5062586926286</c:v>
                 </c:pt>
                 <c:pt idx="2">
-                  <c:v>149</c:v>
+                  <c:v>20.7232267037552</c:v>
                 </c:pt>
                 <c:pt idx="3">
-                  <c:v>343</c:v>
+                  <c:v>47.7051460361613</c:v>
                 </c:pt>
               </c:numCache>
             </c:numRef>
@@ -2890,7 +3348,7 @@
               <a:pPr>
                 <a:defRPr sz="1800">
                   <a:solidFill>
-                    <a:srgbClr val="142C40"/>
+                    <a:srgbClr val="FFFFFF"/>
                   </a:solidFill>
                   <a:latin typeface="Helvetica Neue"/>
                   <a:ea typeface="Helvetica Neue"/>
@@ -2952,6 +3410,8 @@
         <c:axId val="48672768"/>
         <c:scaling>
           <c:orientation val="minMax"/>
+          <c:max val="100"/>
+          <c:min val="0"/>
         </c:scaling>
         <c:delete val="0"/>
         <c:axPos val="l"/>
@@ -2984,6 +3444,7 @@
         </c:txPr>
         <c:crossAx val="48650112"/>
         <c:crossBetween val="between"/>
+        <c:majorUnit val="25"/>
       </c:valAx>
     </c:plotArea>
     <c:legend>
@@ -3012,6 +3473,178 @@
 </file>
 
 <file path=ppt/slides/charts/chart5.xml><?xml version="1.0" encoding="utf-8"?>
+<c:chartSpace xmlns:c="http://schemas.openxmlformats.org/drawingml/2006/chart" xmlns:r="http://schemas.openxmlformats.org/officeDocument/2006/relationships">
+  <c:lang val="en-US"/>
+  <c:chart>
+    <c:plotArea>
+      <c:barChart>
+        <c:barDir val="bar"/>
+        <c:grouping val="clustered"/>
+        <c:varyColors val="0"/>
+        <c:ser>
+          <c:idx val="0"/>
+          <c:order val="0"/>
+          <c:tx>
+            <c:v>Pairs</c:v>
+          </c:tx>
+          <c:spPr>
+            <a:solidFill xmlns:a="http://schemas.openxmlformats.org/drawingml/2006/main">
+              <a:srgbClr val="147E77"/>
+            </a:solidFill>
+          </c:spPr>
+          <c:cat>
+            <c:strRef>
+              <c:f>'Chart Data'!$A$2:$A$5</c:f>
+              <c:strCache>
+                <c:ptCount val="4"/>
+                <c:pt idx="0">
+                  <c:v>Retains a date assertion</c:v>
+                </c:pt>
+                <c:pt idx="1">
+                  <c:v>Challenges the premise</c:v>
+                </c:pt>
+                <c:pt idx="2">
+                  <c:v>Unconfirmed candidate only</c:v>
+                </c:pt>
+                <c:pt idx="3">
+                  <c:v>Clearly withholds a date</c:v>
+                </c:pt>
+              </c:strCache>
+            </c:strRef>
+          </c:cat>
+          <c:val>
+            <c:numRef>
+              <c:f>'Chart Data'!$B$2:$B$5</c:f>
+              <c:numCache>
+                <c:formatCode>0</c:formatCode>
+                <c:ptCount val="4"/>
+                <c:pt idx="0">
+                  <c:v>2</c:v>
+                </c:pt>
+                <c:pt idx="1">
+                  <c:v>3</c:v>
+                </c:pt>
+                <c:pt idx="2">
+                  <c:v>25</c:v>
+                </c:pt>
+                <c:pt idx="3">
+                  <c:v>114</c:v>
+                </c:pt>
+              </c:numCache>
+            </c:numRef>
+          </c:val>
+        </c:ser>
+        <c:dLbls>
+          <c:txPr>
+            <a:bodyPr xmlns:a="http://schemas.openxmlformats.org/drawingml/2006/main" anchorCtr="1"/>
+            <a:lstStyle xmlns:a="http://schemas.openxmlformats.org/drawingml/2006/main"/>
+            <a:p xmlns:a="http://schemas.openxmlformats.org/drawingml/2006/main">
+              <a:pPr>
+                <a:defRPr sz="1875">
+                  <a:latin typeface="Helvetica Neue"/>
+                  <a:ea typeface="Helvetica Neue"/>
+                  <a:cs typeface="Helvetica Neue"/>
+                </a:defRPr>
+              </a:pPr>
+            </a:p>
+          </c:txPr>
+          <c:dLblPos val="outEnd"/>
+          <c:showLegendKey val="0"/>
+          <c:showVal val="1"/>
+          <c:showCatName val="0"/>
+          <c:showSerName val="0"/>
+          <c:showPercent val="0"/>
+          <c:showBubbleSize val="0"/>
+          <c:showLeaderLines val="0"/>
+        </c:dLbls>
+        <c:axId val="48650112"/>
+        <c:axId val="48672768"/>
+      </c:barChart>
+      <c:catAx>
+        <c:axId val="48650112"/>
+        <c:scaling>
+          <c:orientation val="minMax"/>
+        </c:scaling>
+        <c:delete val="0"/>
+        <c:axPos val="l"/>
+        <c:numFmt formatCode="General"/>
+        <c:majorTickMark val="none"/>
+        <c:minorTickMark val="none"/>
+        <c:spPr>
+          <a:ln xmlns:a="http://schemas.openxmlformats.org/drawingml/2006/main" w="9525">
+            <a:solidFill>
+              <a:srgbClr val="D4D4D4"/>
+            </a:solidFill>
+            <a:prstDash val="solid"/>
+          </a:ln>
+        </c:spPr>
+        <c:txPr>
+          <a:bodyPr xmlns:a="http://schemas.openxmlformats.org/drawingml/2006/main" anchorCtr="1"/>
+          <a:lstStyle xmlns:a="http://schemas.openxmlformats.org/drawingml/2006/main"/>
+          <a:p xmlns:a="http://schemas.openxmlformats.org/drawingml/2006/main">
+            <a:pPr>
+              <a:defRPr sz="1725">
+                <a:solidFill>
+                  <a:srgbClr val="666666"/>
+                </a:solidFill>
+                <a:latin typeface="Helvetica Neue"/>
+                <a:ea typeface="Helvetica Neue"/>
+                <a:cs typeface="Helvetica Neue"/>
+              </a:defRPr>
+            </a:pPr>
+          </a:p>
+        </c:txPr>
+        <c:crossAx val="48672768"/>
+      </c:catAx>
+      <c:valAx>
+        <c:axId val="48672768"/>
+        <c:scaling>
+          <c:orientation val="minMax"/>
+          <c:max val="125"/>
+          <c:min val="0"/>
+        </c:scaling>
+        <c:delete val="0"/>
+        <c:axPos val="b"/>
+        <c:numFmt formatCode="0"/>
+        <c:majorTickMark val="none"/>
+        <c:minorTickMark val="none"/>
+        <c:spPr>
+          <a:ln xmlns:a="http://schemas.openxmlformats.org/drawingml/2006/main" w="9525">
+            <a:solidFill>
+              <a:srgbClr val="D4D4D4"/>
+            </a:solidFill>
+            <a:prstDash val="solid"/>
+          </a:ln>
+        </c:spPr>
+        <c:txPr>
+          <a:bodyPr xmlns:a="http://schemas.openxmlformats.org/drawingml/2006/main" anchorCtr="1"/>
+          <a:lstStyle xmlns:a="http://schemas.openxmlformats.org/drawingml/2006/main"/>
+          <a:p xmlns:a="http://schemas.openxmlformats.org/drawingml/2006/main">
+            <a:pPr>
+              <a:defRPr sz="1575">
+                <a:solidFill>
+                  <a:srgbClr val="666666"/>
+                </a:solidFill>
+                <a:latin typeface="Helvetica Neue"/>
+                <a:ea typeface="Helvetica Neue"/>
+                <a:cs typeface="Helvetica Neue"/>
+              </a:defRPr>
+            </a:pPr>
+          </a:p>
+        </c:txPr>
+        <c:crossAx val="48650112"/>
+        <c:crossBetween val="between"/>
+      </c:valAx>
+    </c:plotArea>
+    <c:plotVisOnly val="1"/>
+  </c:chart>
+  <c:externalData r:id="rIdChartSnapshot1">
+    <c:autoUpdate val="0"/>
+  </c:externalData>
+</c:chartSpace>
+</file>
+
+<file path=ppt/slides/charts/chart6.xml><?xml version="1.0" encoding="utf-8"?>
 <c:chartSpace xmlns:c="http://schemas.openxmlformats.org/drawingml/2006/chart" xmlns:r="http://schemas.openxmlformats.org/officeDocument/2006/relationships">
   <c:lang val="en-US"/>
   <c:chart>
@@ -3223,7 +3856,7 @@
           <p:cNvPr id="7" name="">
             <a:extLst xmlns:a="http://schemas.openxmlformats.org/drawingml/2006/main">
               <a:ext uri="{FF2B5EF4-FFF2-40B4-BE49-F238E27FC236}">
-                <a16:creationId xmlns:a16="http://schemas.microsoft.com/office/drawing/2014/main" id="{95BC3028-5637-40E9-96B6-3257C4B98C58}"/>
+                <a16:creationId xmlns:a16="http://schemas.microsoft.com/office/drawing/2014/main" id="{45668D9D-8665-4E6E-8A98-7ED9C3689C75}"/>
               </a:ext>
             </a:extLst>
           </p:cNvPr>
@@ -3303,7 +3936,7 @@
           <p:cNvPr id="2" name="">
             <a:extLst xmlns:a="http://schemas.openxmlformats.org/drawingml/2006/main">
               <a:ext uri="{FF2B5EF4-FFF2-40B4-BE49-F238E27FC236}">
-                <a16:creationId xmlns:a16="http://schemas.microsoft.com/office/drawing/2014/main" id="{43DB0E94-1603-4923-A929-886BEC16A9F7}"/>
+                <a16:creationId xmlns:a16="http://schemas.microsoft.com/office/drawing/2014/main" id="{F5F5FA30-7127-441F-8B40-8D532F8893FB}"/>
               </a:ext>
             </a:extLst>
           </p:cNvPr>
@@ -3360,7 +3993,7 @@
           <p:cNvPr id="3" name="">
             <a:extLst xmlns:a="http://schemas.openxmlformats.org/drawingml/2006/main">
               <a:ext uri="{FF2B5EF4-FFF2-40B4-BE49-F238E27FC236}">
-                <a16:creationId xmlns:a16="http://schemas.microsoft.com/office/drawing/2014/main" id="{51E97646-DBC0-4544-87CD-DB60AF7A89DA}"/>
+                <a16:creationId xmlns:a16="http://schemas.microsoft.com/office/drawing/2014/main" id="{2A7D91DC-3CF6-491D-9D2E-564041E2C4A3}"/>
               </a:ext>
             </a:extLst>
           </p:cNvPr>
@@ -3417,7 +4050,7 @@
           <p:cNvPr id="4" name="">
             <a:extLst xmlns:a="http://schemas.openxmlformats.org/drawingml/2006/main">
               <a:ext uri="{FF2B5EF4-FFF2-40B4-BE49-F238E27FC236}">
-                <a16:creationId xmlns:a16="http://schemas.microsoft.com/office/drawing/2014/main" id="{F0480DDC-6997-445A-9D32-94EE42021921}"/>
+                <a16:creationId xmlns:a16="http://schemas.microsoft.com/office/drawing/2014/main" id="{AEA2E4EB-B600-43AD-906C-113E84EA3C02}"/>
               </a:ext>
             </a:extLst>
           </p:cNvPr>
@@ -3474,7 +4107,7 @@
           <p:cNvPr id="5" name="">
             <a:extLst xmlns:a="http://schemas.openxmlformats.org/drawingml/2006/main">
               <a:ext uri="{FF2B5EF4-FFF2-40B4-BE49-F238E27FC236}">
-                <a16:creationId xmlns:a16="http://schemas.microsoft.com/office/drawing/2014/main" id="{113A6E64-2B5C-450E-BEC3-9ED82BF521B3}"/>
+                <a16:creationId xmlns:a16="http://schemas.microsoft.com/office/drawing/2014/main" id="{5D3A9123-2AEB-4E7E-AE4A-F8018CD199E0}"/>
               </a:ext>
             </a:extLst>
           </p:cNvPr>
@@ -3531,7 +4164,7 @@
           <p:cNvPr id="6" name="">
             <a:extLst xmlns:a="http://schemas.openxmlformats.org/drawingml/2006/main">
               <a:ext uri="{FF2B5EF4-FFF2-40B4-BE49-F238E27FC236}">
-                <a16:creationId xmlns:a16="http://schemas.microsoft.com/office/drawing/2014/main" id="{C9FB9869-2272-408E-8397-A76BEF8DC888}"/>
+                <a16:creationId xmlns:a16="http://schemas.microsoft.com/office/drawing/2014/main" id="{6DF54561-BF9D-4D00-81F4-3B0266A67A84}"/>
               </a:ext>
             </a:extLst>
           </p:cNvPr>
@@ -3586,7 +4219,7 @@
     </p:spTree>
     <p:extLst>
       <p:ext uri="{BB962C8B-B14F-4D97-AF65-F5344CB8AC3E}">
-        <p14:creationId xmlns:p14="http://schemas.microsoft.com/office/powerpoint/2010/main" val="312226211"/>
+        <p14:creationId xmlns:p14="http://schemas.microsoft.com/office/powerpoint/2010/main" val="511649868"/>
       </p:ext>
     </p:extLst>
   </p:cSld>
@@ -3617,7 +4250,7 @@
           <p:cNvPr id="7" name="">
             <a:extLst xmlns:a="http://schemas.openxmlformats.org/drawingml/2006/main">
               <a:ext uri="{FF2B5EF4-FFF2-40B4-BE49-F238E27FC236}">
-                <a16:creationId xmlns:a16="http://schemas.microsoft.com/office/drawing/2014/main" id="{3BBFFA06-265C-44E0-A742-CE295BE7A40E}"/>
+                <a16:creationId xmlns:a16="http://schemas.microsoft.com/office/drawing/2014/main" id="{C694E23E-0511-4676-A87F-EADB8671DD41}"/>
               </a:ext>
             </a:extLst>
           </p:cNvPr>
@@ -3674,7 +4307,7 @@
           <p:cNvPr id="2" name="">
             <a:extLst xmlns:a="http://schemas.openxmlformats.org/drawingml/2006/main">
               <a:ext uri="{FF2B5EF4-FFF2-40B4-BE49-F238E27FC236}">
-                <a16:creationId xmlns:a16="http://schemas.microsoft.com/office/drawing/2014/main" id="{4A251A1D-A8AA-44C1-BF18-9481B9F08AF0}"/>
+                <a16:creationId xmlns:a16="http://schemas.microsoft.com/office/drawing/2014/main" id="{25FC1BCB-8522-4F50-A78A-0AC5CE42841A}"/>
               </a:ext>
             </a:extLst>
           </p:cNvPr>
@@ -3953,7 +4586,7 @@
           <p:cNvPr id="4" name="">
             <a:extLst xmlns:a="http://schemas.openxmlformats.org/drawingml/2006/main">
               <a:ext uri="{FF2B5EF4-FFF2-40B4-BE49-F238E27FC236}">
-                <a16:creationId xmlns:a16="http://schemas.microsoft.com/office/drawing/2014/main" id="{D51B60C8-1892-417B-94E6-2F8CFFC6E1D9}"/>
+                <a16:creationId xmlns:a16="http://schemas.microsoft.com/office/drawing/2014/main" id="{84237B6D-CC1B-405D-AD42-52B23FE32663}"/>
               </a:ext>
             </a:extLst>
           </p:cNvPr>
@@ -4010,7 +4643,7 @@
           <p:cNvPr id="5" name="">
             <a:extLst xmlns:a="http://schemas.openxmlformats.org/drawingml/2006/main">
               <a:ext uri="{FF2B5EF4-FFF2-40B4-BE49-F238E27FC236}">
-                <a16:creationId xmlns:a16="http://schemas.microsoft.com/office/drawing/2014/main" id="{56C141F7-E216-4DA8-8E8D-B2A2387E3743}"/>
+                <a16:creationId xmlns:a16="http://schemas.microsoft.com/office/drawing/2014/main" id="{BFC0568E-06D8-4714-AD10-78681BB7B867}"/>
               </a:ext>
             </a:extLst>
           </p:cNvPr>
@@ -4067,7 +4700,7 @@
           <p:cNvPr id="6" name="">
             <a:extLst xmlns:a="http://schemas.openxmlformats.org/drawingml/2006/main">
               <a:ext uri="{FF2B5EF4-FFF2-40B4-BE49-F238E27FC236}">
-                <a16:creationId xmlns:a16="http://schemas.microsoft.com/office/drawing/2014/main" id="{324015AB-513F-4C5D-9912-FE7AFD4358D6}"/>
+                <a16:creationId xmlns:a16="http://schemas.microsoft.com/office/drawing/2014/main" id="{DCFF83F8-E7E5-4CDE-8CBF-76FF16D600B5}"/>
               </a:ext>
             </a:extLst>
           </p:cNvPr>
@@ -4122,7 +4755,7 @@
     </p:spTree>
     <p:extLst>
       <p:ext uri="{BB962C8B-B14F-4D97-AF65-F5344CB8AC3E}">
-        <p14:creationId xmlns:p14="http://schemas.microsoft.com/office/powerpoint/2010/main" val="965403770"/>
+        <p14:creationId xmlns:p14="http://schemas.microsoft.com/office/powerpoint/2010/main" val="348781889"/>
       </p:ext>
     </p:extLst>
   </p:cSld>
@@ -4150,10 +4783,10 @@
       </p:grpSpPr>
       <p:sp>
         <p:nvSpPr>
-          <p:cNvPr id="6" name="">
+          <p:cNvPr id="7" name="">
             <a:extLst xmlns:a="http://schemas.openxmlformats.org/drawingml/2006/main">
               <a:ext uri="{FF2B5EF4-FFF2-40B4-BE49-F238E27FC236}">
-                <a16:creationId xmlns:a16="http://schemas.microsoft.com/office/drawing/2014/main" id="{07B1BB8C-F673-4A7F-94D8-BB030AFE5950}"/>
+                <a16:creationId xmlns:a16="http://schemas.microsoft.com/office/drawing/2014/main" id="{54A083DF-847A-4C1E-9BDE-53E8F204C3AC}"/>
               </a:ext>
             </a:extLst>
           </p:cNvPr>
@@ -4210,7 +4843,7 @@
           <p:cNvPr id="2" name="">
             <a:extLst xmlns:a="http://schemas.openxmlformats.org/drawingml/2006/main">
               <a:ext uri="{FF2B5EF4-FFF2-40B4-BE49-F238E27FC236}">
-                <a16:creationId xmlns:a16="http://schemas.microsoft.com/office/drawing/2014/main" id="{C1BAC50A-3B39-402B-9623-859FDBB213DF}"/>
+                <a16:creationId xmlns:a16="http://schemas.microsoft.com/office/drawing/2014/main" id="{793F6AB6-24F5-4DBA-B7B6-6D464A8083A6}"/>
               </a:ext>
             </a:extLst>
           </p:cNvPr>
@@ -4264,273 +4897,17 @@
       </p:sp>
       <p:graphicFrame>
         <p:nvGraphicFramePr>
-          <p:cNvPr id="8" name=""/>
+          <p:cNvPr id="9" name="Chart"/>
           <p:cNvGraphicFramePr/>
           <p:nvPr/>
         </p:nvGraphicFramePr>
         <p:xfrm>
-          <a:off xmlns:a="http://schemas.openxmlformats.org/drawingml/2006/main" x="685800" y="2085975"/>
-          <a:ext xmlns:a="http://schemas.openxmlformats.org/drawingml/2006/main" cx="10820400" cy="2924175"/>
+          <a:off xmlns:a="http://schemas.openxmlformats.org/drawingml/2006/main" x="666750" y="2114550"/>
+          <a:ext xmlns:a="http://schemas.openxmlformats.org/drawingml/2006/main" cx="10668000" cy="3095625"/>
         </p:xfrm>
         <a:graphic xmlns:a="http://schemas.openxmlformats.org/drawingml/2006/main">
-          <a:graphicData uri="http://schemas.openxmlformats.org/drawingml/2006/table">
-            <a:tbl>
-              <a:tblPr/>
-              <a:tblGrid>
-                <a:gridCol w="8572500"/>
-                <a:gridCol w="2247900"/>
-              </a:tblGrid>
-              <a:tr h="584835">
-                <a:tc>
-                  <a:txBody>
-                    <a:bodyPr/>
-                    <a:lstStyle/>
-                    <a:p>
-                      <a:r>
-                        <a:rPr sz="1950" b="1">
-                          <a:solidFill>
-                            <a:srgbClr val="FFFFFF"/>
-                          </a:solidFill>
-                          <a:latin typeface="Helvetica Neue"/>
-                          <a:ea typeface="Helvetica Neue"/>
-                          <a:cs typeface="Helvetica Neue"/>
-                        </a:rPr>
-                        <a:t>Among 144 wrong-to-abstain pairs</a:t>
-                      </a:r>
-                    </a:p>
-                  </a:txBody>
-                  <a:tcPr marL="91440" marR="91440" marT="45720" marB="45720">
-                    <a:solidFill>
-                      <a:srgbClr val="142C40"/>
-                    </a:solidFill>
-                  </a:tcPr>
-                </a:tc>
-                <a:tc>
-                  <a:txBody>
-                    <a:bodyPr/>
-                    <a:lstStyle/>
-                    <a:p>
-                      <a:r>
-                        <a:rPr sz="1950" b="1">
-                          <a:solidFill>
-                            <a:srgbClr val="FFFFFF"/>
-                          </a:solidFill>
-                          <a:latin typeface="Helvetica Neue"/>
-                          <a:ea typeface="Helvetica Neue"/>
-                          <a:cs typeface="Helvetica Neue"/>
-                        </a:rPr>
-                        <a:t>Count</a:t>
-                      </a:r>
-                    </a:p>
-                  </a:txBody>
-                  <a:tcPr marL="91440" marR="91440" marT="45720" marB="45720">
-                    <a:solidFill>
-                      <a:srgbClr val="142C40"/>
-                    </a:solidFill>
-                  </a:tcPr>
-                </a:tc>
-              </a:tr>
-              <a:tr h="584835">
-                <a:tc>
-                  <a:txBody>
-                    <a:bodyPr/>
-                    <a:lstStyle/>
-                    <a:p>
-                      <a:r>
-                        <a:rPr sz="1950" b="0">
-                          <a:solidFill>
-                            <a:srgbClr val="142C40"/>
-                          </a:solidFill>
-                          <a:latin typeface="Helvetica Neue"/>
-                          <a:ea typeface="Helvetica Neue"/>
-                          <a:cs typeface="Helvetica Neue"/>
-                        </a:rPr>
-                        <a:t>Clearly withholds a date</a:t>
-                      </a:r>
-                    </a:p>
-                  </a:txBody>
-                  <a:tcPr marL="91440" marR="91440" marT="45720" marB="45720">
-                    <a:solidFill>
-                      <a:srgbClr val="F0F4F7"/>
-                    </a:solidFill>
-                  </a:tcPr>
-                </a:tc>
-                <a:tc>
-                  <a:txBody>
-                    <a:bodyPr/>
-                    <a:lstStyle/>
-                    <a:p>
-                      <a:r>
-                        <a:rPr sz="1950" b="0">
-                          <a:solidFill>
-                            <a:srgbClr val="142C40"/>
-                          </a:solidFill>
-                          <a:latin typeface="Helvetica Neue"/>
-                          <a:ea typeface="Helvetica Neue"/>
-                          <a:cs typeface="Helvetica Neue"/>
-                        </a:rPr>
-                        <a:t>114</a:t>
-                      </a:r>
-                    </a:p>
-                  </a:txBody>
-                  <a:tcPr marL="91440" marR="91440" marT="45720" marB="45720">
-                    <a:solidFill>
-                      <a:srgbClr val="F0F4F7"/>
-                    </a:solidFill>
-                  </a:tcPr>
-                </a:tc>
-              </a:tr>
-              <a:tr h="584835">
-                <a:tc>
-                  <a:txBody>
-                    <a:bodyPr/>
-                    <a:lstStyle/>
-                    <a:p>
-                      <a:r>
-                        <a:rPr sz="1950" b="0">
-                          <a:solidFill>
-                            <a:srgbClr val="142C40"/>
-                          </a:solidFill>
-                          <a:latin typeface="Helvetica Neue"/>
-                          <a:ea typeface="Helvetica Neue"/>
-                          <a:cs typeface="Helvetica Neue"/>
-                        </a:rPr>
-                        <a:t>Only an unconfirmed candidate</a:t>
-                      </a:r>
-                    </a:p>
-                  </a:txBody>
-                  <a:tcPr marL="91440" marR="91440" marT="45720" marB="45720">
-                    <a:solidFill>
-                      <a:srgbClr val="FFFFFF"/>
-                    </a:solidFill>
-                  </a:tcPr>
-                </a:tc>
-                <a:tc>
-                  <a:txBody>
-                    <a:bodyPr/>
-                    <a:lstStyle/>
-                    <a:p>
-                      <a:r>
-                        <a:rPr sz="1950" b="0">
-                          <a:solidFill>
-                            <a:srgbClr val="142C40"/>
-                          </a:solidFill>
-                          <a:latin typeface="Helvetica Neue"/>
-                          <a:ea typeface="Helvetica Neue"/>
-                          <a:cs typeface="Helvetica Neue"/>
-                        </a:rPr>
-                        <a:t>25</a:t>
-                      </a:r>
-                    </a:p>
-                  </a:txBody>
-                  <a:tcPr marL="91440" marR="91440" marT="45720" marB="45720">
-                    <a:solidFill>
-                      <a:srgbClr val="FFFFFF"/>
-                    </a:solidFill>
-                  </a:tcPr>
-                </a:tc>
-              </a:tr>
-              <a:tr h="584835">
-                <a:tc>
-                  <a:txBody>
-                    <a:bodyPr/>
-                    <a:lstStyle/>
-                    <a:p>
-                      <a:r>
-                        <a:rPr sz="1950" b="0">
-                          <a:solidFill>
-                            <a:srgbClr val="142C40"/>
-                          </a:solidFill>
-                          <a:latin typeface="Helvetica Neue"/>
-                          <a:ea typeface="Helvetica Neue"/>
-                          <a:cs typeface="Helvetica Neue"/>
-                        </a:rPr>
-                        <a:t>Challenges the premise</a:t>
-                      </a:r>
-                    </a:p>
-                  </a:txBody>
-                  <a:tcPr marL="91440" marR="91440" marT="45720" marB="45720">
-                    <a:solidFill>
-                      <a:srgbClr val="F0F4F7"/>
-                    </a:solidFill>
-                  </a:tcPr>
-                </a:tc>
-                <a:tc>
-                  <a:txBody>
-                    <a:bodyPr/>
-                    <a:lstStyle/>
-                    <a:p>
-                      <a:r>
-                        <a:rPr sz="1950" b="0">
-                          <a:solidFill>
-                            <a:srgbClr val="142C40"/>
-                          </a:solidFill>
-                          <a:latin typeface="Helvetica Neue"/>
-                          <a:ea typeface="Helvetica Neue"/>
-                          <a:cs typeface="Helvetica Neue"/>
-                        </a:rPr>
-                        <a:t>3</a:t>
-                      </a:r>
-                    </a:p>
-                  </a:txBody>
-                  <a:tcPr marL="91440" marR="91440" marT="45720" marB="45720">
-                    <a:solidFill>
-                      <a:srgbClr val="F0F4F7"/>
-                    </a:solidFill>
-                  </a:tcPr>
-                </a:tc>
-              </a:tr>
-              <a:tr h="584835">
-                <a:tc>
-                  <a:txBody>
-                    <a:bodyPr/>
-                    <a:lstStyle/>
-                    <a:p>
-                      <a:r>
-                        <a:rPr sz="1950" b="0">
-                          <a:solidFill>
-                            <a:srgbClr val="142C40"/>
-                          </a:solidFill>
-                          <a:latin typeface="Helvetica Neue"/>
-                          <a:ea typeface="Helvetica Neue"/>
-                          <a:cs typeface="Helvetica Neue"/>
-                        </a:rPr>
-                        <a:t>Retains a relevant date assertion</a:t>
-                      </a:r>
-                    </a:p>
-                  </a:txBody>
-                  <a:tcPr marL="91440" marR="91440" marT="45720" marB="45720">
-                    <a:solidFill>
-                      <a:srgbClr val="FFFFFF"/>
-                    </a:solidFill>
-                  </a:tcPr>
-                </a:tc>
-                <a:tc>
-                  <a:txBody>
-                    <a:bodyPr/>
-                    <a:lstStyle/>
-                    <a:p>
-                      <a:r>
-                        <a:rPr sz="1950" b="0">
-                          <a:solidFill>
-                            <a:srgbClr val="142C40"/>
-                          </a:solidFill>
-                          <a:latin typeface="Helvetica Neue"/>
-                          <a:ea typeface="Helvetica Neue"/>
-                          <a:cs typeface="Helvetica Neue"/>
-                        </a:rPr>
-                        <a:t>2</a:t>
-                      </a:r>
-                    </a:p>
-                  </a:txBody>
-                  <a:tcPr marL="91440" marR="91440" marT="45720" marB="45720">
-                    <a:solidFill>
-                      <a:srgbClr val="FFFFFF"/>
-                    </a:solidFill>
-                  </a:tcPr>
-                </a:tc>
-              </a:tr>
-            </a:tbl>
+          <a:graphicData uri="http://schemas.openxmlformats.org/drawingml/2006/chart">
+            <c:chart xmlns:r="http://schemas.openxmlformats.org/officeDocument/2006/relationships" xmlns:c="http://schemas.openxmlformats.org/drawingml/2006/chart" r:id="R79f9165169384598"/>
           </a:graphicData>
         </a:graphic>
       </p:graphicFrame>
@@ -4539,7 +4916,7 @@
           <p:cNvPr id="4" name="">
             <a:extLst xmlns:a="http://schemas.openxmlformats.org/drawingml/2006/main">
               <a:ext uri="{FF2B5EF4-FFF2-40B4-BE49-F238E27FC236}">
-                <a16:creationId xmlns:a16="http://schemas.microsoft.com/office/drawing/2014/main" id="{513F9520-A56D-4E8E-9CEF-946CECF508F0}"/>
+                <a16:creationId xmlns:a16="http://schemas.microsoft.com/office/drawing/2014/main" id="{55633E05-97EC-4764-87D4-EA7DD7BD2104}"/>
               </a:ext>
             </a:extLst>
           </p:cNvPr>
@@ -4550,7 +4927,64 @@
         </p:nvSpPr>
         <p:spPr>
           <a:xfrm xmlns:a="http://schemas.openxmlformats.org/drawingml/2006/main">
-            <a:off x="685800" y="5334000"/>
+            <a:off x="685800" y="5286375"/>
+            <a:ext cx="10668000" cy="381000"/>
+          </a:xfrm>
+          <a:prstGeom xmlns:a="http://schemas.openxmlformats.org/drawingml/2006/main" prst="rect">
+            <a:avLst/>
+          </a:prstGeom>
+          <a:noFill xmlns:a="http://schemas.openxmlformats.org/drawingml/2006/main"/>
+          <a:ln xmlns:a="http://schemas.openxmlformats.org/drawingml/2006/main" w="0">
+            <a:noFill/>
+          </a:ln>
+        </p:spPr>
+        <p:txBody>
+          <a:bodyPr xmlns:a="http://schemas.openxmlformats.org/drawingml/2006/main">
+            <a:noAutofit/>
+          </a:bodyPr>
+          <a:lstStyle xmlns:a="http://schemas.openxmlformats.org/drawingml/2006/main"/>
+          <a:p xmlns:a="http://schemas.openxmlformats.org/drawingml/2006/main">
+            <a:pPr>
+              <a:defRPr sz="1875" b="1">
+                <a:solidFill>
+                  <a:srgbClr val="147E77"/>
+                </a:solidFill>
+                <a:latin typeface="Helvetica Neue"/>
+                <a:ea typeface="Helvetica Neue"/>
+                <a:cs typeface="Helvetica Neue"/>
+              </a:defRPr>
+            </a:pPr>
+            <a:r>
+              <a:rPr sz="1875" b="1">
+                <a:solidFill>
+                  <a:srgbClr val="147E77"/>
+                </a:solidFill>
+                <a:latin typeface="Helvetica Neue"/>
+                <a:ea typeface="Helvetica Neue"/>
+                <a:cs typeface="Helvetica Neue"/>
+              </a:rPr>
+              <a:t>Counts among all 144 C2-wrong / C3-abstain pairs</a:t>
+            </a:r>
+          </a:p>
+        </p:txBody>
+      </p:sp>
+      <p:sp>
+        <p:nvSpPr>
+          <p:cNvPr id="5" name="">
+            <a:extLst xmlns:a="http://schemas.openxmlformats.org/drawingml/2006/main">
+              <a:ext uri="{FF2B5EF4-FFF2-40B4-BE49-F238E27FC236}">
+                <a16:creationId xmlns:a16="http://schemas.microsoft.com/office/drawing/2014/main" id="{1B6A32CC-2900-424B-9134-AE1D246239BC}"/>
+              </a:ext>
+            </a:extLst>
+          </p:cNvPr>
+          <p:cNvSpPr>
+            <a:spLocks xmlns:a="http://schemas.openxmlformats.org/drawingml/2006/main" noGrp="1"/>
+          </p:cNvSpPr>
+          <p:nvPr/>
+        </p:nvSpPr>
+        <p:spPr>
+          <a:xfrm xmlns:a="http://schemas.openxmlformats.org/drawingml/2006/main">
+            <a:off x="685800" y="5762625"/>
             <a:ext cx="10668000" cy="619125"/>
           </a:xfrm>
           <a:prstGeom xmlns:a="http://schemas.openxmlformats.org/drawingml/2006/main" prst="rect">
@@ -4568,7 +5002,7 @@
           <a:lstStyle xmlns:a="http://schemas.openxmlformats.org/drawingml/2006/main"/>
           <a:p xmlns:a="http://schemas.openxmlformats.org/drawingml/2006/main">
             <a:pPr>
-              <a:defRPr sz="1875" b="0">
+              <a:defRPr sz="1800" b="0">
                 <a:solidFill>
                   <a:srgbClr val="657586"/>
                 </a:solidFill>
@@ -4578,7 +5012,7 @@
               </a:defRPr>
             </a:pPr>
             <a:r>
-              <a:rPr sz="1875" b="0">
+              <a:rPr sz="1800" b="0">
                 <a:solidFill>
                   <a:srgbClr val="657586"/>
                 </a:solidFill>
@@ -4593,10 +5027,10 @@
       </p:sp>
       <p:sp>
         <p:nvSpPr>
-          <p:cNvPr id="5" name="">
+          <p:cNvPr id="6" name="">
             <a:extLst xmlns:a="http://schemas.openxmlformats.org/drawingml/2006/main">
               <a:ext uri="{FF2B5EF4-FFF2-40B4-BE49-F238E27FC236}">
-                <a16:creationId xmlns:a16="http://schemas.microsoft.com/office/drawing/2014/main" id="{3688988A-2669-4CCD-94D1-CC502271AA87}"/>
+                <a16:creationId xmlns:a16="http://schemas.microsoft.com/office/drawing/2014/main" id="{2A6293E9-AE41-4B5B-BBAF-B45A86B37670}"/>
               </a:ext>
             </a:extLst>
           </p:cNvPr>
@@ -4651,7 +5085,7 @@
     </p:spTree>
     <p:extLst>
       <p:ext uri="{BB962C8B-B14F-4D97-AF65-F5344CB8AC3E}">
-        <p14:creationId xmlns:p14="http://schemas.microsoft.com/office/powerpoint/2010/main" val="1984481312"/>
+        <p14:creationId xmlns:p14="http://schemas.microsoft.com/office/powerpoint/2010/main" val="1266880308"/>
       </p:ext>
     </p:extLst>
   </p:cSld>
@@ -4682,7 +5116,7 @@
           <p:cNvPr id="7" name="">
             <a:extLst xmlns:a="http://schemas.openxmlformats.org/drawingml/2006/main">
               <a:ext uri="{FF2B5EF4-FFF2-40B4-BE49-F238E27FC236}">
-                <a16:creationId xmlns:a16="http://schemas.microsoft.com/office/drawing/2014/main" id="{B4EFB8D7-0EF3-494D-97EA-51A3062DEF4A}"/>
+                <a16:creationId xmlns:a16="http://schemas.microsoft.com/office/drawing/2014/main" id="{D1E4F57A-7168-4252-B1EF-61DA84207666}"/>
               </a:ext>
             </a:extLst>
           </p:cNvPr>
@@ -4739,7 +5173,7 @@
           <p:cNvPr id="2" name="">
             <a:extLst xmlns:a="http://schemas.openxmlformats.org/drawingml/2006/main">
               <a:ext uri="{FF2B5EF4-FFF2-40B4-BE49-F238E27FC236}">
-                <a16:creationId xmlns:a16="http://schemas.microsoft.com/office/drawing/2014/main" id="{B3B34ADF-8133-48CF-8AFE-292D25623D89}"/>
+                <a16:creationId xmlns:a16="http://schemas.microsoft.com/office/drawing/2014/main" id="{BDDBB526-487B-4F3B-A84D-37DF689F48D8}"/>
               </a:ext>
             </a:extLst>
           </p:cNvPr>
@@ -4796,7 +5230,7 @@
           <p:cNvPr id="3" name="">
             <a:extLst xmlns:a="http://schemas.openxmlformats.org/drawingml/2006/main">
               <a:ext uri="{FF2B5EF4-FFF2-40B4-BE49-F238E27FC236}">
-                <a16:creationId xmlns:a16="http://schemas.microsoft.com/office/drawing/2014/main" id="{D2602DEA-17FE-4A1B-B8A0-F46DEC9B0F23}"/>
+                <a16:creationId xmlns:a16="http://schemas.microsoft.com/office/drawing/2014/main" id="{CE96665A-39B1-4566-A3CF-E7733B5FDB8D}"/>
               </a:ext>
             </a:extLst>
           </p:cNvPr>
@@ -4853,7 +5287,7 @@
           <p:cNvPr id="4" name="">
             <a:extLst xmlns:a="http://schemas.openxmlformats.org/drawingml/2006/main">
               <a:ext uri="{FF2B5EF4-FFF2-40B4-BE49-F238E27FC236}">
-                <a16:creationId xmlns:a16="http://schemas.microsoft.com/office/drawing/2014/main" id="{0D33AD83-324B-4C1F-8292-E691FCA3D245}"/>
+                <a16:creationId xmlns:a16="http://schemas.microsoft.com/office/drawing/2014/main" id="{D839B95A-D342-405B-AE99-A862D0C5D657}"/>
               </a:ext>
             </a:extLst>
           </p:cNvPr>
@@ -4910,7 +5344,7 @@
           <p:cNvPr id="5" name="">
             <a:extLst xmlns:a="http://schemas.openxmlformats.org/drawingml/2006/main">
               <a:ext uri="{FF2B5EF4-FFF2-40B4-BE49-F238E27FC236}">
-                <a16:creationId xmlns:a16="http://schemas.microsoft.com/office/drawing/2014/main" id="{F619DC6B-8917-487F-AD3A-B042566F2A4F}"/>
+                <a16:creationId xmlns:a16="http://schemas.microsoft.com/office/drawing/2014/main" id="{ED3DC8E6-91DE-44A7-B68D-860A360C1229}"/>
               </a:ext>
             </a:extLst>
           </p:cNvPr>
@@ -4967,7 +5401,7 @@
           <p:cNvPr id="6" name="">
             <a:extLst xmlns:a="http://schemas.openxmlformats.org/drawingml/2006/main">
               <a:ext uri="{FF2B5EF4-FFF2-40B4-BE49-F238E27FC236}">
-                <a16:creationId xmlns:a16="http://schemas.microsoft.com/office/drawing/2014/main" id="{E9126044-F4A4-4772-92F5-9F31DC991194}"/>
+                <a16:creationId xmlns:a16="http://schemas.microsoft.com/office/drawing/2014/main" id="{A4478B9E-2469-44E1-AB1D-58FC4A0DA7A6}"/>
               </a:ext>
             </a:extLst>
           </p:cNvPr>
@@ -5022,7 +5456,7 @@
     </p:spTree>
     <p:extLst>
       <p:ext uri="{BB962C8B-B14F-4D97-AF65-F5344CB8AC3E}">
-        <p14:creationId xmlns:p14="http://schemas.microsoft.com/office/powerpoint/2010/main" val="285310397"/>
+        <p14:creationId xmlns:p14="http://schemas.microsoft.com/office/powerpoint/2010/main" val="1086725950"/>
       </p:ext>
     </p:extLst>
   </p:cSld>
@@ -5053,7 +5487,7 @@
           <p:cNvPr id="6" name="">
             <a:extLst xmlns:a="http://schemas.openxmlformats.org/drawingml/2006/main">
               <a:ext uri="{FF2B5EF4-FFF2-40B4-BE49-F238E27FC236}">
-                <a16:creationId xmlns:a16="http://schemas.microsoft.com/office/drawing/2014/main" id="{0D1FD701-327D-4502-A218-AF491AA0E081}"/>
+                <a16:creationId xmlns:a16="http://schemas.microsoft.com/office/drawing/2014/main" id="{83414D74-DD99-4F24-9014-7638EEC99990}"/>
               </a:ext>
             </a:extLst>
           </p:cNvPr>
@@ -5117,7 +5551,7 @@
         </p:xfrm>
         <a:graphic xmlns:a="http://schemas.openxmlformats.org/drawingml/2006/main">
           <a:graphicData uri="http://schemas.openxmlformats.org/drawingml/2006/chart">
-            <c:chart xmlns:r="http://schemas.openxmlformats.org/officeDocument/2006/relationships" xmlns:c="http://schemas.openxmlformats.org/drawingml/2006/chart" r:id="Rcb33cef46c8843b0"/>
+            <c:chart xmlns:r="http://schemas.openxmlformats.org/officeDocument/2006/relationships" xmlns:c="http://schemas.openxmlformats.org/drawingml/2006/chart" r:id="R420c8460588c46b4"/>
           </a:graphicData>
         </a:graphic>
       </p:graphicFrame>
@@ -5126,7 +5560,7 @@
           <p:cNvPr id="3" name="">
             <a:extLst xmlns:a="http://schemas.openxmlformats.org/drawingml/2006/main">
               <a:ext uri="{FF2B5EF4-FFF2-40B4-BE49-F238E27FC236}">
-                <a16:creationId xmlns:a16="http://schemas.microsoft.com/office/drawing/2014/main" id="{704AAEFF-337A-40BF-93EA-FBF9DCB3104F}"/>
+                <a16:creationId xmlns:a16="http://schemas.microsoft.com/office/drawing/2014/main" id="{D2EF7B9A-E456-4E1F-A300-3EF041349E88}"/>
               </a:ext>
             </a:extLst>
           </p:cNvPr>
@@ -5183,7 +5617,7 @@
           <p:cNvPr id="4" name="">
             <a:extLst xmlns:a="http://schemas.openxmlformats.org/drawingml/2006/main">
               <a:ext uri="{FF2B5EF4-FFF2-40B4-BE49-F238E27FC236}">
-                <a16:creationId xmlns:a16="http://schemas.microsoft.com/office/drawing/2014/main" id="{B2C4CCE3-7229-4DD7-A46E-20B0C8E4F15C}"/>
+                <a16:creationId xmlns:a16="http://schemas.microsoft.com/office/drawing/2014/main" id="{D764B480-1CD7-4350-9094-E5EC84AEC167}"/>
               </a:ext>
             </a:extLst>
           </p:cNvPr>
@@ -5240,7 +5674,7 @@
           <p:cNvPr id="5" name="">
             <a:extLst xmlns:a="http://schemas.openxmlformats.org/drawingml/2006/main">
               <a:ext uri="{FF2B5EF4-FFF2-40B4-BE49-F238E27FC236}">
-                <a16:creationId xmlns:a16="http://schemas.microsoft.com/office/drawing/2014/main" id="{F653524B-13F3-449F-A481-C11522EE0434}"/>
+                <a16:creationId xmlns:a16="http://schemas.microsoft.com/office/drawing/2014/main" id="{9C8F9D57-A099-46D3-84D1-B135EA7DBF73}"/>
               </a:ext>
             </a:extLst>
           </p:cNvPr>
@@ -5295,7 +5729,7 @@
     </p:spTree>
     <p:extLst>
       <p:ext uri="{BB962C8B-B14F-4D97-AF65-F5344CB8AC3E}">
-        <p14:creationId xmlns:p14="http://schemas.microsoft.com/office/powerpoint/2010/main" val="1706683397"/>
+        <p14:creationId xmlns:p14="http://schemas.microsoft.com/office/powerpoint/2010/main" val="1562102700"/>
       </p:ext>
     </p:extLst>
   </p:cSld>
@@ -5326,7 +5760,7 @@
           <p:cNvPr id="7" name="">
             <a:extLst xmlns:a="http://schemas.openxmlformats.org/drawingml/2006/main">
               <a:ext uri="{FF2B5EF4-FFF2-40B4-BE49-F238E27FC236}">
-                <a16:creationId xmlns:a16="http://schemas.microsoft.com/office/drawing/2014/main" id="{B017F3AF-059A-4003-8A51-88CAA5B4D803}"/>
+                <a16:creationId xmlns:a16="http://schemas.microsoft.com/office/drawing/2014/main" id="{F3BB5F8C-80D0-473C-BF31-BB51924874B5}"/>
               </a:ext>
             </a:extLst>
           </p:cNvPr>
@@ -5383,7 +5817,7 @@
           <p:cNvPr id="2" name="">
             <a:extLst xmlns:a="http://schemas.openxmlformats.org/drawingml/2006/main">
               <a:ext uri="{FF2B5EF4-FFF2-40B4-BE49-F238E27FC236}">
-                <a16:creationId xmlns:a16="http://schemas.microsoft.com/office/drawing/2014/main" id="{9B2EA1A8-8D96-4298-B96D-0DFED510A1B7}"/>
+                <a16:creationId xmlns:a16="http://schemas.microsoft.com/office/drawing/2014/main" id="{A0F80704-CC01-4579-BD40-477D4612E3E0}"/>
               </a:ext>
             </a:extLst>
           </p:cNvPr>
@@ -5440,7 +5874,7 @@
           <p:cNvPr id="3" name="">
             <a:extLst xmlns:a="http://schemas.openxmlformats.org/drawingml/2006/main">
               <a:ext uri="{FF2B5EF4-FFF2-40B4-BE49-F238E27FC236}">
-                <a16:creationId xmlns:a16="http://schemas.microsoft.com/office/drawing/2014/main" id="{0224EC71-97DD-46A6-B0BC-C08C37C7CF15}"/>
+                <a16:creationId xmlns:a16="http://schemas.microsoft.com/office/drawing/2014/main" id="{25B750A0-BD4A-450D-8FE8-FEC72E4B670B}"/>
               </a:ext>
             </a:extLst>
           </p:cNvPr>
@@ -5497,7 +5931,7 @@
           <p:cNvPr id="4" name="">
             <a:extLst xmlns:a="http://schemas.openxmlformats.org/drawingml/2006/main">
               <a:ext uri="{FF2B5EF4-FFF2-40B4-BE49-F238E27FC236}">
-                <a16:creationId xmlns:a16="http://schemas.microsoft.com/office/drawing/2014/main" id="{0D90AAB5-9F76-4396-8291-5F241F2CD2E6}"/>
+                <a16:creationId xmlns:a16="http://schemas.microsoft.com/office/drawing/2014/main" id="{E418EDEE-753A-4F88-A489-CEA685D55DE1}"/>
               </a:ext>
             </a:extLst>
           </p:cNvPr>
@@ -5554,7 +5988,7 @@
           <p:cNvPr id="5" name="">
             <a:extLst xmlns:a="http://schemas.openxmlformats.org/drawingml/2006/main">
               <a:ext uri="{FF2B5EF4-FFF2-40B4-BE49-F238E27FC236}">
-                <a16:creationId xmlns:a16="http://schemas.microsoft.com/office/drawing/2014/main" id="{19AB7727-1FFF-44AC-AE13-AD12016D0A2B}"/>
+                <a16:creationId xmlns:a16="http://schemas.microsoft.com/office/drawing/2014/main" id="{DD566318-E4E0-403F-835C-D78DDE1C9EA7}"/>
               </a:ext>
             </a:extLst>
           </p:cNvPr>
@@ -5611,7 +6045,7 @@
           <p:cNvPr id="6" name="">
             <a:extLst xmlns:a="http://schemas.openxmlformats.org/drawingml/2006/main">
               <a:ext uri="{FF2B5EF4-FFF2-40B4-BE49-F238E27FC236}">
-                <a16:creationId xmlns:a16="http://schemas.microsoft.com/office/drawing/2014/main" id="{20424934-CFDB-4F2C-A3F7-A36D9A67A882}"/>
+                <a16:creationId xmlns:a16="http://schemas.microsoft.com/office/drawing/2014/main" id="{78B960F3-5A7F-4040-A6A4-F1B5D9AFDA58}"/>
               </a:ext>
             </a:extLst>
           </p:cNvPr>
@@ -5666,7 +6100,7 @@
     </p:spTree>
     <p:extLst>
       <p:ext uri="{BB962C8B-B14F-4D97-AF65-F5344CB8AC3E}">
-        <p14:creationId xmlns:p14="http://schemas.microsoft.com/office/powerpoint/2010/main" val="1887696135"/>
+        <p14:creationId xmlns:p14="http://schemas.microsoft.com/office/powerpoint/2010/main" val="664290676"/>
       </p:ext>
     </p:extLst>
   </p:cSld>
@@ -5697,7 +6131,7 @@
           <p:cNvPr id="7" name="">
             <a:extLst xmlns:a="http://schemas.openxmlformats.org/drawingml/2006/main">
               <a:ext uri="{FF2B5EF4-FFF2-40B4-BE49-F238E27FC236}">
-                <a16:creationId xmlns:a16="http://schemas.microsoft.com/office/drawing/2014/main" id="{0C66E4F4-9CF9-4F12-B4F6-2BB10D28ED24}"/>
+                <a16:creationId xmlns:a16="http://schemas.microsoft.com/office/drawing/2014/main" id="{E515C2BE-D77A-4046-AE09-A84CBE42D897}"/>
               </a:ext>
             </a:extLst>
           </p:cNvPr>
@@ -5754,7 +6188,7 @@
           <p:cNvPr id="2" name="">
             <a:extLst xmlns:a="http://schemas.openxmlformats.org/drawingml/2006/main">
               <a:ext uri="{FF2B5EF4-FFF2-40B4-BE49-F238E27FC236}">
-                <a16:creationId xmlns:a16="http://schemas.microsoft.com/office/drawing/2014/main" id="{690A5077-8439-4EA3-8910-76070002B039}"/>
+                <a16:creationId xmlns:a16="http://schemas.microsoft.com/office/drawing/2014/main" id="{7478C829-A697-4FD6-8AA4-C602963784F5}"/>
               </a:ext>
             </a:extLst>
           </p:cNvPr>
@@ -5811,7 +6245,7 @@
           <p:cNvPr id="3" name="">
             <a:extLst xmlns:a="http://schemas.openxmlformats.org/drawingml/2006/main">
               <a:ext uri="{FF2B5EF4-FFF2-40B4-BE49-F238E27FC236}">
-                <a16:creationId xmlns:a16="http://schemas.microsoft.com/office/drawing/2014/main" id="{CA726091-1B42-4AA6-858A-9002CAB8A0EA}"/>
+                <a16:creationId xmlns:a16="http://schemas.microsoft.com/office/drawing/2014/main" id="{0F3ED641-2CB6-4725-B4E9-64942D5ADF11}"/>
               </a:ext>
             </a:extLst>
           </p:cNvPr>
@@ -5868,7 +6302,7 @@
           <p:cNvPr id="4" name="">
             <a:extLst xmlns:a="http://schemas.openxmlformats.org/drawingml/2006/main">
               <a:ext uri="{FF2B5EF4-FFF2-40B4-BE49-F238E27FC236}">
-                <a16:creationId xmlns:a16="http://schemas.microsoft.com/office/drawing/2014/main" id="{2FD6961A-1E4E-49D1-BABE-16158B96DDD3}"/>
+                <a16:creationId xmlns:a16="http://schemas.microsoft.com/office/drawing/2014/main" id="{0122C58E-B503-466F-95B5-415071A0BFEB}"/>
               </a:ext>
             </a:extLst>
           </p:cNvPr>
@@ -5925,7 +6359,7 @@
           <p:cNvPr id="5" name="">
             <a:extLst xmlns:a="http://schemas.openxmlformats.org/drawingml/2006/main">
               <a:ext uri="{FF2B5EF4-FFF2-40B4-BE49-F238E27FC236}">
-                <a16:creationId xmlns:a16="http://schemas.microsoft.com/office/drawing/2014/main" id="{69BD65E9-6B63-4BB1-950C-ACCA094A99D4}"/>
+                <a16:creationId xmlns:a16="http://schemas.microsoft.com/office/drawing/2014/main" id="{8C8CA8A7-B7BE-4BA7-B2DC-5ABC6008C9BD}"/>
               </a:ext>
             </a:extLst>
           </p:cNvPr>
@@ -5982,7 +6416,7 @@
           <p:cNvPr id="6" name="">
             <a:extLst xmlns:a="http://schemas.openxmlformats.org/drawingml/2006/main">
               <a:ext uri="{FF2B5EF4-FFF2-40B4-BE49-F238E27FC236}">
-                <a16:creationId xmlns:a16="http://schemas.microsoft.com/office/drawing/2014/main" id="{B46E396C-A1F0-4BA5-960F-D864C861287C}"/>
+                <a16:creationId xmlns:a16="http://schemas.microsoft.com/office/drawing/2014/main" id="{406470D5-9BF9-413B-B96C-42CF965A4DB9}"/>
               </a:ext>
             </a:extLst>
           </p:cNvPr>
@@ -6037,7 +6471,7 @@
     </p:spTree>
     <p:extLst>
       <p:ext uri="{BB962C8B-B14F-4D97-AF65-F5344CB8AC3E}">
-        <p14:creationId xmlns:p14="http://schemas.microsoft.com/office/powerpoint/2010/main" val="1913051853"/>
+        <p14:creationId xmlns:p14="http://schemas.microsoft.com/office/powerpoint/2010/main" val="1638407733"/>
       </p:ext>
     </p:extLst>
   </p:cSld>
@@ -6068,7 +6502,7 @@
           <p:cNvPr id="9" name="">
             <a:extLst xmlns:a="http://schemas.openxmlformats.org/drawingml/2006/main">
               <a:ext uri="{FF2B5EF4-FFF2-40B4-BE49-F238E27FC236}">
-                <a16:creationId xmlns:a16="http://schemas.microsoft.com/office/drawing/2014/main" id="{50761862-505E-499B-B2F9-5F95ABA668E9}"/>
+                <a16:creationId xmlns:a16="http://schemas.microsoft.com/office/drawing/2014/main" id="{66E34EA1-8280-47F5-8EAB-8D4A8C290010}"/>
               </a:ext>
             </a:extLst>
           </p:cNvPr>
@@ -6125,7 +6559,7 @@
           <p:cNvPr id="2" name="">
             <a:extLst xmlns:a="http://schemas.openxmlformats.org/drawingml/2006/main">
               <a:ext uri="{FF2B5EF4-FFF2-40B4-BE49-F238E27FC236}">
-                <a16:creationId xmlns:a16="http://schemas.microsoft.com/office/drawing/2014/main" id="{41E28287-B801-4D60-8D81-D016DBDA9547}"/>
+                <a16:creationId xmlns:a16="http://schemas.microsoft.com/office/drawing/2014/main" id="{4FD23858-C5A0-449B-B66F-507E25EB59D9}"/>
               </a:ext>
             </a:extLst>
           </p:cNvPr>
@@ -6182,7 +6616,7 @@
           <p:cNvPr id="3" name="">
             <a:extLst xmlns:a="http://schemas.openxmlformats.org/drawingml/2006/main">
               <a:ext uri="{FF2B5EF4-FFF2-40B4-BE49-F238E27FC236}">
-                <a16:creationId xmlns:a16="http://schemas.microsoft.com/office/drawing/2014/main" id="{A01E3DB2-DAB9-4492-98A6-DBD19C0EDCBB}"/>
+                <a16:creationId xmlns:a16="http://schemas.microsoft.com/office/drawing/2014/main" id="{C9CEF16C-8AB2-461B-A4EC-CED100D789BB}"/>
               </a:ext>
             </a:extLst>
           </p:cNvPr>
@@ -6239,7 +6673,7 @@
           <p:cNvPr id="4" name="">
             <a:extLst xmlns:a="http://schemas.openxmlformats.org/drawingml/2006/main">
               <a:ext uri="{FF2B5EF4-FFF2-40B4-BE49-F238E27FC236}">
-                <a16:creationId xmlns:a16="http://schemas.microsoft.com/office/drawing/2014/main" id="{3D40F7ED-4D1A-44F3-B8C5-E41811A7F59D}"/>
+                <a16:creationId xmlns:a16="http://schemas.microsoft.com/office/drawing/2014/main" id="{C7601778-876A-4380-AA2E-46E218E827E7}"/>
               </a:ext>
             </a:extLst>
           </p:cNvPr>
@@ -6296,7 +6730,7 @@
           <p:cNvPr id="5" name="">
             <a:extLst xmlns:a="http://schemas.openxmlformats.org/drawingml/2006/main">
               <a:ext uri="{FF2B5EF4-FFF2-40B4-BE49-F238E27FC236}">
-                <a16:creationId xmlns:a16="http://schemas.microsoft.com/office/drawing/2014/main" id="{5196B187-5CF0-49C2-BA1B-E900D34C1431}"/>
+                <a16:creationId xmlns:a16="http://schemas.microsoft.com/office/drawing/2014/main" id="{7FADEBB7-7FDE-4F73-A592-D3B01C2E0CB9}"/>
               </a:ext>
             </a:extLst>
           </p:cNvPr>
@@ -6353,7 +6787,7 @@
           <p:cNvPr id="6" name="">
             <a:extLst xmlns:a="http://schemas.openxmlformats.org/drawingml/2006/main">
               <a:ext uri="{FF2B5EF4-FFF2-40B4-BE49-F238E27FC236}">
-                <a16:creationId xmlns:a16="http://schemas.microsoft.com/office/drawing/2014/main" id="{502D72C8-963D-45F7-9F91-433C71A257EA}"/>
+                <a16:creationId xmlns:a16="http://schemas.microsoft.com/office/drawing/2014/main" id="{4ACD083A-D0FD-4F47-978B-8D84E41A0BA1}"/>
               </a:ext>
             </a:extLst>
           </p:cNvPr>
@@ -6410,7 +6844,7 @@
           <p:cNvPr id="7" name="">
             <a:extLst xmlns:a="http://schemas.openxmlformats.org/drawingml/2006/main">
               <a:ext uri="{FF2B5EF4-FFF2-40B4-BE49-F238E27FC236}">
-                <a16:creationId xmlns:a16="http://schemas.microsoft.com/office/drawing/2014/main" id="{02D59AA9-A04F-4EA1-838C-6497EF0DB5C2}"/>
+                <a16:creationId xmlns:a16="http://schemas.microsoft.com/office/drawing/2014/main" id="{103618C5-2527-4AC7-8C34-2A7C1814FB5C}"/>
               </a:ext>
             </a:extLst>
           </p:cNvPr>
@@ -6490,7 +6924,7 @@
           <p:cNvPr id="8" name="">
             <a:extLst xmlns:a="http://schemas.openxmlformats.org/drawingml/2006/main">
               <a:ext uri="{FF2B5EF4-FFF2-40B4-BE49-F238E27FC236}">
-                <a16:creationId xmlns:a16="http://schemas.microsoft.com/office/drawing/2014/main" id="{4CA055F3-96F5-4D26-9D3A-52B719C4F8B6}"/>
+                <a16:creationId xmlns:a16="http://schemas.microsoft.com/office/drawing/2014/main" id="{5A4CA1C4-7DDB-4471-8A50-67200BE17CEF}"/>
               </a:ext>
             </a:extLst>
           </p:cNvPr>
@@ -6545,7 +6979,7 @@
     </p:spTree>
     <p:extLst>
       <p:ext uri="{BB962C8B-B14F-4D97-AF65-F5344CB8AC3E}">
-        <p14:creationId xmlns:p14="http://schemas.microsoft.com/office/powerpoint/2010/main" val="78617997"/>
+        <p14:creationId xmlns:p14="http://schemas.microsoft.com/office/powerpoint/2010/main" val="710976380"/>
       </p:ext>
     </p:extLst>
   </p:cSld>
@@ -6576,7 +7010,7 @@
           <p:cNvPr id="7" name="">
             <a:extLst xmlns:a="http://schemas.openxmlformats.org/drawingml/2006/main">
               <a:ext uri="{FF2B5EF4-FFF2-40B4-BE49-F238E27FC236}">
-                <a16:creationId xmlns:a16="http://schemas.microsoft.com/office/drawing/2014/main" id="{9D9E23A6-36E6-43F4-A1C1-8B399412A453}"/>
+                <a16:creationId xmlns:a16="http://schemas.microsoft.com/office/drawing/2014/main" id="{4F44123B-E559-4CB9-AEE5-4568F3A090CD}"/>
               </a:ext>
             </a:extLst>
           </p:cNvPr>
@@ -6633,7 +7067,7 @@
           <p:cNvPr id="2" name="">
             <a:extLst xmlns:a="http://schemas.openxmlformats.org/drawingml/2006/main">
               <a:ext uri="{FF2B5EF4-FFF2-40B4-BE49-F238E27FC236}">
-                <a16:creationId xmlns:a16="http://schemas.microsoft.com/office/drawing/2014/main" id="{E4EA8B47-B1FE-4786-AFE1-ED758F989B5F}"/>
+                <a16:creationId xmlns:a16="http://schemas.microsoft.com/office/drawing/2014/main" id="{8C68AE0B-F2F9-4C3B-BEAA-13B32FE4FAD4}"/>
               </a:ext>
             </a:extLst>
           </p:cNvPr>
@@ -6690,7 +7124,7 @@
           <p:cNvPr id="3" name="">
             <a:extLst xmlns:a="http://schemas.openxmlformats.org/drawingml/2006/main">
               <a:ext uri="{FF2B5EF4-FFF2-40B4-BE49-F238E27FC236}">
-                <a16:creationId xmlns:a16="http://schemas.microsoft.com/office/drawing/2014/main" id="{E06C61DC-B0B4-4D4A-A0E5-9CC910273D29}"/>
+                <a16:creationId xmlns:a16="http://schemas.microsoft.com/office/drawing/2014/main" id="{0AEA7B88-B52D-41D7-906D-E0D1E28C0F8A}"/>
               </a:ext>
             </a:extLst>
           </p:cNvPr>
@@ -6747,7 +7181,7 @@
           <p:cNvPr id="4" name="">
             <a:extLst xmlns:a="http://schemas.openxmlformats.org/drawingml/2006/main">
               <a:ext uri="{FF2B5EF4-FFF2-40B4-BE49-F238E27FC236}">
-                <a16:creationId xmlns:a16="http://schemas.microsoft.com/office/drawing/2014/main" id="{E798B944-7ED8-4194-A079-ED1293A04F0B}"/>
+                <a16:creationId xmlns:a16="http://schemas.microsoft.com/office/drawing/2014/main" id="{660C0B69-EDD8-42FD-BB9E-D3516212D46B}"/>
               </a:ext>
             </a:extLst>
           </p:cNvPr>
@@ -6804,7 +7238,7 @@
           <p:cNvPr id="5" name="">
             <a:extLst xmlns:a="http://schemas.openxmlformats.org/drawingml/2006/main">
               <a:ext uri="{FF2B5EF4-FFF2-40B4-BE49-F238E27FC236}">
-                <a16:creationId xmlns:a16="http://schemas.microsoft.com/office/drawing/2014/main" id="{535D0D43-8E8C-4BC7-AF19-1BFBB0CEC168}"/>
+                <a16:creationId xmlns:a16="http://schemas.microsoft.com/office/drawing/2014/main" id="{35FA0E34-12B7-42CE-88D9-7C9509B06B40}"/>
               </a:ext>
             </a:extLst>
           </p:cNvPr>
@@ -6861,7 +7295,7 @@
           <p:cNvPr id="6" name="">
             <a:extLst xmlns:a="http://schemas.openxmlformats.org/drawingml/2006/main">
               <a:ext uri="{FF2B5EF4-FFF2-40B4-BE49-F238E27FC236}">
-                <a16:creationId xmlns:a16="http://schemas.microsoft.com/office/drawing/2014/main" id="{693D36F4-8F4C-4FC8-93C2-BA40BAB1102F}"/>
+                <a16:creationId xmlns:a16="http://schemas.microsoft.com/office/drawing/2014/main" id="{C21F07A2-72E3-429C-9B46-B582C3C4673B}"/>
               </a:ext>
             </a:extLst>
           </p:cNvPr>
@@ -6916,7 +7350,7 @@
     </p:spTree>
     <p:extLst>
       <p:ext uri="{BB962C8B-B14F-4D97-AF65-F5344CB8AC3E}">
-        <p14:creationId xmlns:p14="http://schemas.microsoft.com/office/powerpoint/2010/main" val="1083853242"/>
+        <p14:creationId xmlns:p14="http://schemas.microsoft.com/office/powerpoint/2010/main" val="1675870309"/>
       </p:ext>
     </p:extLst>
   </p:cSld>
@@ -6947,7 +7381,7 @@
           <p:cNvPr id="5" name="">
             <a:extLst xmlns:a="http://schemas.openxmlformats.org/drawingml/2006/main">
               <a:ext uri="{FF2B5EF4-FFF2-40B4-BE49-F238E27FC236}">
-                <a16:creationId xmlns:a16="http://schemas.microsoft.com/office/drawing/2014/main" id="{5E381D10-D4B4-451C-80CF-845D8B088A0B}"/>
+                <a16:creationId xmlns:a16="http://schemas.microsoft.com/office/drawing/2014/main" id="{860E85B5-CD51-4983-96C4-4530E3D53855}"/>
               </a:ext>
             </a:extLst>
           </p:cNvPr>
@@ -7545,7 +7979,7 @@
           <p:cNvPr id="3" name="">
             <a:extLst xmlns:a="http://schemas.openxmlformats.org/drawingml/2006/main">
               <a:ext uri="{FF2B5EF4-FFF2-40B4-BE49-F238E27FC236}">
-                <a16:creationId xmlns:a16="http://schemas.microsoft.com/office/drawing/2014/main" id="{34574A3A-0282-4E96-BEFB-36A39894D54B}"/>
+                <a16:creationId xmlns:a16="http://schemas.microsoft.com/office/drawing/2014/main" id="{D2674BC2-1CF7-4304-BDEE-5D4D3DC3EBC7}"/>
               </a:ext>
             </a:extLst>
           </p:cNvPr>
@@ -7602,7 +8036,7 @@
           <p:cNvPr id="4" name="">
             <a:extLst xmlns:a="http://schemas.openxmlformats.org/drawingml/2006/main">
               <a:ext uri="{FF2B5EF4-FFF2-40B4-BE49-F238E27FC236}">
-                <a16:creationId xmlns:a16="http://schemas.microsoft.com/office/drawing/2014/main" id="{4C758218-8087-4A1A-BA58-9E3D266E6B84}"/>
+                <a16:creationId xmlns:a16="http://schemas.microsoft.com/office/drawing/2014/main" id="{BB147B02-D54C-4774-B94E-6FCBC97AEDC6}"/>
               </a:ext>
             </a:extLst>
           </p:cNvPr>
@@ -7657,7 +8091,7 @@
     </p:spTree>
     <p:extLst>
       <p:ext uri="{BB962C8B-B14F-4D97-AF65-F5344CB8AC3E}">
-        <p14:creationId xmlns:p14="http://schemas.microsoft.com/office/powerpoint/2010/main" val="1932969025"/>
+        <p14:creationId xmlns:p14="http://schemas.microsoft.com/office/powerpoint/2010/main" val="1878844451"/>
       </p:ext>
     </p:extLst>
   </p:cSld>
@@ -7688,7 +8122,7 @@
           <p:cNvPr id="7" name="">
             <a:extLst xmlns:a="http://schemas.openxmlformats.org/drawingml/2006/main">
               <a:ext uri="{FF2B5EF4-FFF2-40B4-BE49-F238E27FC236}">
-                <a16:creationId xmlns:a16="http://schemas.microsoft.com/office/drawing/2014/main" id="{9AD078BF-F57D-4F3A-866F-93B546C2E1C6}"/>
+                <a16:creationId xmlns:a16="http://schemas.microsoft.com/office/drawing/2014/main" id="{95CE5142-87C1-4C87-B19F-CED6B6EE792A}"/>
               </a:ext>
             </a:extLst>
           </p:cNvPr>
@@ -7745,7 +8179,7 @@
           <p:cNvPr id="2" name="">
             <a:extLst xmlns:a="http://schemas.openxmlformats.org/drawingml/2006/main">
               <a:ext uri="{FF2B5EF4-FFF2-40B4-BE49-F238E27FC236}">
-                <a16:creationId xmlns:a16="http://schemas.microsoft.com/office/drawing/2014/main" id="{0469C58A-60B4-42AA-A778-7917DCE4F239}"/>
+                <a16:creationId xmlns:a16="http://schemas.microsoft.com/office/drawing/2014/main" id="{25E265E8-07CD-4B26-A4A5-8DC10F0C8A7F}"/>
               </a:ext>
             </a:extLst>
           </p:cNvPr>
@@ -7802,7 +8236,7 @@
           <p:cNvPr id="3" name="">
             <a:extLst xmlns:a="http://schemas.openxmlformats.org/drawingml/2006/main">
               <a:ext uri="{FF2B5EF4-FFF2-40B4-BE49-F238E27FC236}">
-                <a16:creationId xmlns:a16="http://schemas.microsoft.com/office/drawing/2014/main" id="{6FDBC9F7-E8F4-4E16-80D9-7780DB8BF0FE}"/>
+                <a16:creationId xmlns:a16="http://schemas.microsoft.com/office/drawing/2014/main" id="{8A9E4012-949B-41C7-AEBE-30B606FCE842}"/>
               </a:ext>
             </a:extLst>
           </p:cNvPr>
@@ -7859,7 +8293,7 @@
           <p:cNvPr id="4" name="">
             <a:extLst xmlns:a="http://schemas.openxmlformats.org/drawingml/2006/main">
               <a:ext uri="{FF2B5EF4-FFF2-40B4-BE49-F238E27FC236}">
-                <a16:creationId xmlns:a16="http://schemas.microsoft.com/office/drawing/2014/main" id="{A59A0BBA-BA08-42C6-A3E9-CD62753F765E}"/>
+                <a16:creationId xmlns:a16="http://schemas.microsoft.com/office/drawing/2014/main" id="{B64E774A-8259-4C6D-9B56-5A1022ACD719}"/>
               </a:ext>
             </a:extLst>
           </p:cNvPr>
@@ -7916,7 +8350,7 @@
           <p:cNvPr id="5" name="">
             <a:extLst xmlns:a="http://schemas.openxmlformats.org/drawingml/2006/main">
               <a:ext uri="{FF2B5EF4-FFF2-40B4-BE49-F238E27FC236}">
-                <a16:creationId xmlns:a16="http://schemas.microsoft.com/office/drawing/2014/main" id="{57B44BF2-E277-4014-B287-C1CFFE5F11E1}"/>
+                <a16:creationId xmlns:a16="http://schemas.microsoft.com/office/drawing/2014/main" id="{9BA387FB-6929-4449-9949-FC6F3C6FE7BD}"/>
               </a:ext>
             </a:extLst>
           </p:cNvPr>
@@ -7973,7 +8407,7 @@
           <p:cNvPr id="6" name="">
             <a:extLst xmlns:a="http://schemas.openxmlformats.org/drawingml/2006/main">
               <a:ext uri="{FF2B5EF4-FFF2-40B4-BE49-F238E27FC236}">
-                <a16:creationId xmlns:a16="http://schemas.microsoft.com/office/drawing/2014/main" id="{79250CD9-235A-4199-AD31-2BBF4DF36A7A}"/>
+                <a16:creationId xmlns:a16="http://schemas.microsoft.com/office/drawing/2014/main" id="{1BDD3394-911B-46FD-9726-460E25C95D8F}"/>
               </a:ext>
             </a:extLst>
           </p:cNvPr>
@@ -8028,7 +8462,7 @@
     </p:spTree>
     <p:extLst>
       <p:ext uri="{BB962C8B-B14F-4D97-AF65-F5344CB8AC3E}">
-        <p14:creationId xmlns:p14="http://schemas.microsoft.com/office/powerpoint/2010/main" val="1233010677"/>
+        <p14:creationId xmlns:p14="http://schemas.microsoft.com/office/powerpoint/2010/main" val="1186850196"/>
       </p:ext>
     </p:extLst>
   </p:cSld>
@@ -8059,7 +8493,7 @@
           <p:cNvPr id="6" name="">
             <a:extLst xmlns:a="http://schemas.openxmlformats.org/drawingml/2006/main">
               <a:ext uri="{FF2B5EF4-FFF2-40B4-BE49-F238E27FC236}">
-                <a16:creationId xmlns:a16="http://schemas.microsoft.com/office/drawing/2014/main" id="{B992D7C2-EEB1-4599-AA5B-572427BDD122}"/>
+                <a16:creationId xmlns:a16="http://schemas.microsoft.com/office/drawing/2014/main" id="{A649FFED-F24B-4867-A98D-54DE81470774}"/>
               </a:ext>
             </a:extLst>
           </p:cNvPr>
@@ -8123,7 +8557,7 @@
         </p:xfrm>
         <a:graphic xmlns:a="http://schemas.openxmlformats.org/drawingml/2006/main">
           <a:graphicData uri="http://schemas.openxmlformats.org/drawingml/2006/chart">
-            <c:chart xmlns:r="http://schemas.openxmlformats.org/officeDocument/2006/relationships" xmlns:c="http://schemas.openxmlformats.org/drawingml/2006/chart" r:id="Rac73dbb7c37a476f"/>
+            <c:chart xmlns:r="http://schemas.openxmlformats.org/officeDocument/2006/relationships" xmlns:c="http://schemas.openxmlformats.org/drawingml/2006/chart" r:id="R4a32360394994e8f"/>
           </a:graphicData>
         </a:graphic>
       </p:graphicFrame>
@@ -8132,7 +8566,7 @@
           <p:cNvPr id="3" name="">
             <a:extLst xmlns:a="http://schemas.openxmlformats.org/drawingml/2006/main">
               <a:ext uri="{FF2B5EF4-FFF2-40B4-BE49-F238E27FC236}">
-                <a16:creationId xmlns:a16="http://schemas.microsoft.com/office/drawing/2014/main" id="{46F93100-BCA1-4778-AB16-0BCD310C3B2C}"/>
+                <a16:creationId xmlns:a16="http://schemas.microsoft.com/office/drawing/2014/main" id="{F59B928D-63C4-4760-901C-BC5B702A4A2C}"/>
               </a:ext>
             </a:extLst>
           </p:cNvPr>
@@ -8189,7 +8623,7 @@
           <p:cNvPr id="4" name="">
             <a:extLst xmlns:a="http://schemas.openxmlformats.org/drawingml/2006/main">
               <a:ext uri="{FF2B5EF4-FFF2-40B4-BE49-F238E27FC236}">
-                <a16:creationId xmlns:a16="http://schemas.microsoft.com/office/drawing/2014/main" id="{83535007-72CD-42BB-B44F-B44D9DB4FB88}"/>
+                <a16:creationId xmlns:a16="http://schemas.microsoft.com/office/drawing/2014/main" id="{CD0EC500-6A42-4FC4-861C-DD2570544F1B}"/>
               </a:ext>
             </a:extLst>
           </p:cNvPr>
@@ -8246,7 +8680,7 @@
           <p:cNvPr id="5" name="">
             <a:extLst xmlns:a="http://schemas.openxmlformats.org/drawingml/2006/main">
               <a:ext uri="{FF2B5EF4-FFF2-40B4-BE49-F238E27FC236}">
-                <a16:creationId xmlns:a16="http://schemas.microsoft.com/office/drawing/2014/main" id="{F2F22895-1812-4607-9F1D-B1DDA8CE0883}"/>
+                <a16:creationId xmlns:a16="http://schemas.microsoft.com/office/drawing/2014/main" id="{6A6B3AA5-4838-4A18-A6C2-53CE7A15F256}"/>
               </a:ext>
             </a:extLst>
           </p:cNvPr>
@@ -8301,7 +8735,7 @@
     </p:spTree>
     <p:extLst>
       <p:ext uri="{BB962C8B-B14F-4D97-AF65-F5344CB8AC3E}">
-        <p14:creationId xmlns:p14="http://schemas.microsoft.com/office/powerpoint/2010/main" val="2131787657"/>
+        <p14:creationId xmlns:p14="http://schemas.microsoft.com/office/powerpoint/2010/main" val="1775336576"/>
       </p:ext>
     </p:extLst>
   </p:cSld>
@@ -8329,10 +8763,10 @@
       </p:grpSpPr>
       <p:sp>
         <p:nvSpPr>
-          <p:cNvPr id="6" name="">
+          <p:cNvPr id="18" name="">
             <a:extLst xmlns:a="http://schemas.openxmlformats.org/drawingml/2006/main">
               <a:ext uri="{FF2B5EF4-FFF2-40B4-BE49-F238E27FC236}">
-                <a16:creationId xmlns:a16="http://schemas.microsoft.com/office/drawing/2014/main" id="{A6BC3E71-146B-497A-8587-DEF550FCE906}"/>
+                <a16:creationId xmlns:a16="http://schemas.microsoft.com/office/drawing/2014/main" id="{5859D280-D84D-4E0C-8CCD-817918902B3A}"/>
               </a:ext>
             </a:extLst>
           </p:cNvPr>
@@ -8379,24 +8813,24 @@
                 <a:ea typeface="Helvetica Neue"/>
                 <a:cs typeface="Helvetica Neue"/>
               </a:rPr>
-              <a:t>Wrong advice raised overall factual error</a:t>
+              <a:t>How much does the error rate change?</a:t>
             </a:r>
           </a:p>
         </p:txBody>
       </p:sp>
       <p:graphicFrame>
         <p:nvGraphicFramePr>
-          <p:cNvPr id="7" name="Chart"/>
+          <p:cNvPr id="19" name="Chart"/>
           <p:cNvGraphicFramePr/>
           <p:nvPr/>
         </p:nvGraphicFramePr>
         <p:xfrm>
-          <a:off xmlns:a="http://schemas.openxmlformats.org/drawingml/2006/main" x="952500" y="1619250"/>
-          <a:ext xmlns:a="http://schemas.openxmlformats.org/drawingml/2006/main" cx="10096500" cy="3429000"/>
+          <a:off xmlns:a="http://schemas.openxmlformats.org/drawingml/2006/main" x="3067050" y="1524000"/>
+          <a:ext xmlns:a="http://schemas.openxmlformats.org/drawingml/2006/main" cx="5905500" cy="3667125"/>
         </p:xfrm>
         <a:graphic xmlns:a="http://schemas.openxmlformats.org/drawingml/2006/main">
           <a:graphicData uri="http://schemas.openxmlformats.org/drawingml/2006/chart">
-            <c:chart xmlns:r="http://schemas.openxmlformats.org/officeDocument/2006/relationships" xmlns:c="http://schemas.openxmlformats.org/drawingml/2006/chart" r:id="R84ca6660b7124ea3"/>
+            <c:chart xmlns:r="http://schemas.openxmlformats.org/officeDocument/2006/relationships" xmlns:c="http://schemas.openxmlformats.org/drawingml/2006/chart" r:id="R7b2139576f284651"/>
           </a:graphicData>
         </a:graphic>
       </p:graphicFrame>
@@ -8405,7 +8839,7 @@
           <p:cNvPr id="3" name="">
             <a:extLst xmlns:a="http://schemas.openxmlformats.org/drawingml/2006/main">
               <a:ext uri="{FF2B5EF4-FFF2-40B4-BE49-F238E27FC236}">
-                <a16:creationId xmlns:a16="http://schemas.microsoft.com/office/drawing/2014/main" id="{B65CDEF2-5D77-405B-9991-95B7BB6D052E}"/>
+                <a16:creationId xmlns:a16="http://schemas.microsoft.com/office/drawing/2014/main" id="{AACEE707-12CD-47E4-BF6D-5B9D8B3AAF6F}"/>
               </a:ext>
             </a:extLst>
           </p:cNvPr>
@@ -8416,7 +8850,691 @@
         </p:nvSpPr>
         <p:spPr>
           <a:xfrm xmlns:a="http://schemas.openxmlformats.org/drawingml/2006/main">
-            <a:off x="685800" y="5238750"/>
+            <a:off x="714375" y="1914525"/>
+            <a:ext cx="2286000" cy="400050"/>
+          </a:xfrm>
+          <a:prstGeom xmlns:a="http://schemas.openxmlformats.org/drawingml/2006/main" prst="rect">
+            <a:avLst/>
+          </a:prstGeom>
+          <a:noFill xmlns:a="http://schemas.openxmlformats.org/drawingml/2006/main"/>
+          <a:ln xmlns:a="http://schemas.openxmlformats.org/drawingml/2006/main" w="0">
+            <a:noFill/>
+          </a:ln>
+        </p:spPr>
+        <p:txBody>
+          <a:bodyPr xmlns:a="http://schemas.openxmlformats.org/drawingml/2006/main">
+            <a:noAutofit/>
+          </a:bodyPr>
+          <a:lstStyle xmlns:a="http://schemas.openxmlformats.org/drawingml/2006/main"/>
+          <a:p xmlns:a="http://schemas.openxmlformats.org/drawingml/2006/main">
+            <a:pPr>
+              <a:defRPr sz="1950" b="1">
+                <a:solidFill>
+                  <a:srgbClr val="142C40"/>
+                </a:solidFill>
+                <a:latin typeface="Helvetica Neue"/>
+                <a:ea typeface="Helvetica Neue"/>
+                <a:cs typeface="Helvetica Neue"/>
+              </a:defRPr>
+            </a:pPr>
+            <a:r>
+              <a:rPr sz="1950" b="1">
+                <a:solidFill>
+                  <a:srgbClr val="142C40"/>
+                </a:solidFill>
+                <a:latin typeface="Helvetica Neue"/>
+                <a:ea typeface="Helvetica Neue"/>
+                <a:cs typeface="Helvetica Neue"/>
+              </a:rPr>
+              <a:t>C0 - Initial</a:t>
+            </a:r>
+          </a:p>
+        </p:txBody>
+      </p:sp>
+      <p:sp>
+        <p:nvSpPr>
+          <p:cNvPr id="4" name="">
+            <a:extLst xmlns:a="http://schemas.openxmlformats.org/drawingml/2006/main">
+              <a:ext uri="{FF2B5EF4-FFF2-40B4-BE49-F238E27FC236}">
+                <a16:creationId xmlns:a16="http://schemas.microsoft.com/office/drawing/2014/main" id="{D0F681F3-AF05-41C3-A567-ED35E6172562}"/>
+              </a:ext>
+            </a:extLst>
+          </p:cNvPr>
+          <p:cNvSpPr>
+            <a:spLocks xmlns:a="http://schemas.openxmlformats.org/drawingml/2006/main" noGrp="1"/>
+          </p:cNvSpPr>
+          <p:nvPr/>
+        </p:nvSpPr>
+        <p:spPr>
+          <a:xfrm xmlns:a="http://schemas.openxmlformats.org/drawingml/2006/main">
+            <a:off x="8972550" y="1971675"/>
+            <a:ext cx="2667000" cy="428625"/>
+          </a:xfrm>
+          <a:prstGeom xmlns:a="http://schemas.openxmlformats.org/drawingml/2006/main" prst="rect">
+            <a:avLst/>
+          </a:prstGeom>
+          <a:noFill xmlns:a="http://schemas.openxmlformats.org/drawingml/2006/main"/>
+          <a:ln xmlns:a="http://schemas.openxmlformats.org/drawingml/2006/main" w="0">
+            <a:noFill/>
+          </a:ln>
+        </p:spPr>
+        <p:txBody>
+          <a:bodyPr xmlns:a="http://schemas.openxmlformats.org/drawingml/2006/main">
+            <a:noAutofit/>
+          </a:bodyPr>
+          <a:lstStyle xmlns:a="http://schemas.openxmlformats.org/drawingml/2006/main"/>
+          <a:p xmlns:a="http://schemas.openxmlformats.org/drawingml/2006/main">
+            <a:pPr>
+              <a:defRPr sz="1500" b="0">
+                <a:solidFill>
+                  <a:srgbClr val="142C40"/>
+                </a:solidFill>
+                <a:latin typeface="Helvetica Neue"/>
+                <a:ea typeface="Helvetica Neue"/>
+                <a:cs typeface="Helvetica Neue"/>
+              </a:defRPr>
+            </a:pPr>
+            <a:r>
+              <a:rPr sz="1500" b="0">
+                <a:solidFill>
+                  <a:srgbClr val="142C40"/>
+                </a:solidFill>
+                <a:latin typeface="Helvetica Neue"/>
+                <a:ea typeface="Helvetica Neue"/>
+                <a:cs typeface="Helvetica Neue"/>
+              </a:rPr>
+              <a:t>+1.25 [-3.06, +5.56]</a:t>
+            </a:r>
+          </a:p>
+        </p:txBody>
+      </p:sp>
+      <p:sp>
+        <p:nvSpPr>
+          <p:cNvPr id="5" name="">
+            <a:extLst xmlns:a="http://schemas.openxmlformats.org/drawingml/2006/main">
+              <a:ext uri="{FF2B5EF4-FFF2-40B4-BE49-F238E27FC236}">
+                <a16:creationId xmlns:a16="http://schemas.microsoft.com/office/drawing/2014/main" id="{99F1100F-0FD7-42D0-BCB4-9DE8CE29B3F2}"/>
+              </a:ext>
+            </a:extLst>
+          </p:cNvPr>
+          <p:cNvSpPr>
+            <a:spLocks xmlns:a="http://schemas.openxmlformats.org/drawingml/2006/main" noGrp="1"/>
+          </p:cNvSpPr>
+          <p:nvPr/>
+        </p:nvSpPr>
+        <p:spPr>
+          <a:xfrm xmlns:a="http://schemas.openxmlformats.org/drawingml/2006/main">
+            <a:off x="714375" y="2457450"/>
+            <a:ext cx="2286000" cy="400050"/>
+          </a:xfrm>
+          <a:prstGeom xmlns:a="http://schemas.openxmlformats.org/drawingml/2006/main" prst="rect">
+            <a:avLst/>
+          </a:prstGeom>
+          <a:noFill xmlns:a="http://schemas.openxmlformats.org/drawingml/2006/main"/>
+          <a:ln xmlns:a="http://schemas.openxmlformats.org/drawingml/2006/main" w="0">
+            <a:noFill/>
+          </a:ln>
+        </p:spPr>
+        <p:txBody>
+          <a:bodyPr xmlns:a="http://schemas.openxmlformats.org/drawingml/2006/main">
+            <a:noAutofit/>
+          </a:bodyPr>
+          <a:lstStyle xmlns:a="http://schemas.openxmlformats.org/drawingml/2006/main"/>
+          <a:p xmlns:a="http://schemas.openxmlformats.org/drawingml/2006/main">
+            <a:pPr>
+              <a:defRPr sz="1950" b="1">
+                <a:solidFill>
+                  <a:srgbClr val="142C40"/>
+                </a:solidFill>
+                <a:latin typeface="Helvetica Neue"/>
+                <a:ea typeface="Helvetica Neue"/>
+                <a:cs typeface="Helvetica Neue"/>
+              </a:defRPr>
+            </a:pPr>
+            <a:r>
+              <a:rPr sz="1950" b="1">
+                <a:solidFill>
+                  <a:srgbClr val="142C40"/>
+                </a:solidFill>
+                <a:latin typeface="Helvetica Neue"/>
+                <a:ea typeface="Helvetica Neue"/>
+                <a:cs typeface="Helvetica Neue"/>
+              </a:rPr>
+              <a:t>C1 - C0</a:t>
+            </a:r>
+          </a:p>
+        </p:txBody>
+      </p:sp>
+      <p:sp>
+        <p:nvSpPr>
+          <p:cNvPr id="6" name="">
+            <a:extLst xmlns:a="http://schemas.openxmlformats.org/drawingml/2006/main">
+              <a:ext uri="{FF2B5EF4-FFF2-40B4-BE49-F238E27FC236}">
+                <a16:creationId xmlns:a16="http://schemas.microsoft.com/office/drawing/2014/main" id="{964EF77A-E3C3-4C77-A6E4-5195EF42F5C5}"/>
+              </a:ext>
+            </a:extLst>
+          </p:cNvPr>
+          <p:cNvSpPr>
+            <a:spLocks xmlns:a="http://schemas.openxmlformats.org/drawingml/2006/main" noGrp="1"/>
+          </p:cNvSpPr>
+          <p:nvPr/>
+        </p:nvSpPr>
+        <p:spPr>
+          <a:xfrm xmlns:a="http://schemas.openxmlformats.org/drawingml/2006/main">
+            <a:off x="8972550" y="2514600"/>
+            <a:ext cx="2667000" cy="428625"/>
+          </a:xfrm>
+          <a:prstGeom xmlns:a="http://schemas.openxmlformats.org/drawingml/2006/main" prst="rect">
+            <a:avLst/>
+          </a:prstGeom>
+          <a:noFill xmlns:a="http://schemas.openxmlformats.org/drawingml/2006/main"/>
+          <a:ln xmlns:a="http://schemas.openxmlformats.org/drawingml/2006/main" w="0">
+            <a:noFill/>
+          </a:ln>
+        </p:spPr>
+        <p:txBody>
+          <a:bodyPr xmlns:a="http://schemas.openxmlformats.org/drawingml/2006/main">
+            <a:noAutofit/>
+          </a:bodyPr>
+          <a:lstStyle xmlns:a="http://schemas.openxmlformats.org/drawingml/2006/main"/>
+          <a:p xmlns:a="http://schemas.openxmlformats.org/drawingml/2006/main">
+            <a:pPr>
+              <a:defRPr sz="1500" b="0">
+                <a:solidFill>
+                  <a:srgbClr val="142C40"/>
+                </a:solidFill>
+                <a:latin typeface="Helvetica Neue"/>
+                <a:ea typeface="Helvetica Neue"/>
+                <a:cs typeface="Helvetica Neue"/>
+              </a:defRPr>
+            </a:pPr>
+            <a:r>
+              <a:rPr sz="1500" b="0">
+                <a:solidFill>
+                  <a:srgbClr val="142C40"/>
+                </a:solidFill>
+                <a:latin typeface="Helvetica Neue"/>
+                <a:ea typeface="Helvetica Neue"/>
+                <a:cs typeface="Helvetica Neue"/>
+              </a:rPr>
+              <a:t>+18.78 [+14.35, +23.09]</a:t>
+            </a:r>
+          </a:p>
+        </p:txBody>
+      </p:sp>
+      <p:sp>
+        <p:nvSpPr>
+          <p:cNvPr id="7" name="">
+            <a:extLst xmlns:a="http://schemas.openxmlformats.org/drawingml/2006/main">
+              <a:ext uri="{FF2B5EF4-FFF2-40B4-BE49-F238E27FC236}">
+                <a16:creationId xmlns:a16="http://schemas.microsoft.com/office/drawing/2014/main" id="{D1EB48F4-D360-464A-BA05-288E2A7069CA}"/>
+              </a:ext>
+            </a:extLst>
+          </p:cNvPr>
+          <p:cNvSpPr>
+            <a:spLocks xmlns:a="http://schemas.openxmlformats.org/drawingml/2006/main" noGrp="1"/>
+          </p:cNvSpPr>
+          <p:nvPr/>
+        </p:nvSpPr>
+        <p:spPr>
+          <a:xfrm xmlns:a="http://schemas.openxmlformats.org/drawingml/2006/main">
+            <a:off x="714375" y="3000375"/>
+            <a:ext cx="2286000" cy="400050"/>
+          </a:xfrm>
+          <a:prstGeom xmlns:a="http://schemas.openxmlformats.org/drawingml/2006/main" prst="rect">
+            <a:avLst/>
+          </a:prstGeom>
+          <a:noFill xmlns:a="http://schemas.openxmlformats.org/drawingml/2006/main"/>
+          <a:ln xmlns:a="http://schemas.openxmlformats.org/drawingml/2006/main" w="0">
+            <a:noFill/>
+          </a:ln>
+        </p:spPr>
+        <p:txBody>
+          <a:bodyPr xmlns:a="http://schemas.openxmlformats.org/drawingml/2006/main">
+            <a:noAutofit/>
+          </a:bodyPr>
+          <a:lstStyle xmlns:a="http://schemas.openxmlformats.org/drawingml/2006/main"/>
+          <a:p xmlns:a="http://schemas.openxmlformats.org/drawingml/2006/main">
+            <a:pPr>
+              <a:defRPr sz="1950" b="1">
+                <a:solidFill>
+                  <a:srgbClr val="142C40"/>
+                </a:solidFill>
+                <a:latin typeface="Helvetica Neue"/>
+                <a:ea typeface="Helvetica Neue"/>
+                <a:cs typeface="Helvetica Neue"/>
+              </a:defRPr>
+            </a:pPr>
+            <a:r>
+              <a:rPr sz="1950" b="1">
+                <a:solidFill>
+                  <a:srgbClr val="142C40"/>
+                </a:solidFill>
+                <a:latin typeface="Helvetica Neue"/>
+                <a:ea typeface="Helvetica Neue"/>
+                <a:cs typeface="Helvetica Neue"/>
+              </a:rPr>
+              <a:t>C2 - C0</a:t>
+            </a:r>
+          </a:p>
+        </p:txBody>
+      </p:sp>
+      <p:sp>
+        <p:nvSpPr>
+          <p:cNvPr id="8" name="">
+            <a:extLst xmlns:a="http://schemas.openxmlformats.org/drawingml/2006/main">
+              <a:ext uri="{FF2B5EF4-FFF2-40B4-BE49-F238E27FC236}">
+                <a16:creationId xmlns:a16="http://schemas.microsoft.com/office/drawing/2014/main" id="{C003B562-FF31-4E04-9713-C6689881ADF3}"/>
+              </a:ext>
+            </a:extLst>
+          </p:cNvPr>
+          <p:cNvSpPr>
+            <a:spLocks xmlns:a="http://schemas.openxmlformats.org/drawingml/2006/main" noGrp="1"/>
+          </p:cNvSpPr>
+          <p:nvPr/>
+        </p:nvSpPr>
+        <p:spPr>
+          <a:xfrm xmlns:a="http://schemas.openxmlformats.org/drawingml/2006/main">
+            <a:off x="8972550" y="3057525"/>
+            <a:ext cx="2667000" cy="428625"/>
+          </a:xfrm>
+          <a:prstGeom xmlns:a="http://schemas.openxmlformats.org/drawingml/2006/main" prst="rect">
+            <a:avLst/>
+          </a:prstGeom>
+          <a:noFill xmlns:a="http://schemas.openxmlformats.org/drawingml/2006/main"/>
+          <a:ln xmlns:a="http://schemas.openxmlformats.org/drawingml/2006/main" w="0">
+            <a:noFill/>
+          </a:ln>
+        </p:spPr>
+        <p:txBody>
+          <a:bodyPr xmlns:a="http://schemas.openxmlformats.org/drawingml/2006/main">
+            <a:noAutofit/>
+          </a:bodyPr>
+          <a:lstStyle xmlns:a="http://schemas.openxmlformats.org/drawingml/2006/main"/>
+          <a:p xmlns:a="http://schemas.openxmlformats.org/drawingml/2006/main">
+            <a:pPr>
+              <a:defRPr sz="1500" b="0">
+                <a:solidFill>
+                  <a:srgbClr val="142C40"/>
+                </a:solidFill>
+                <a:latin typeface="Helvetica Neue"/>
+                <a:ea typeface="Helvetica Neue"/>
+                <a:cs typeface="Helvetica Neue"/>
+              </a:defRPr>
+            </a:pPr>
+            <a:r>
+              <a:rPr sz="1500" b="0">
+                <a:solidFill>
+                  <a:srgbClr val="142C40"/>
+                </a:solidFill>
+                <a:latin typeface="Helvetica Neue"/>
+                <a:ea typeface="Helvetica Neue"/>
+                <a:cs typeface="Helvetica Neue"/>
+              </a:rPr>
+              <a:t>+6.40 [+1.94, +10.99]</a:t>
+            </a:r>
+          </a:p>
+        </p:txBody>
+      </p:sp>
+      <p:sp>
+        <p:nvSpPr>
+          <p:cNvPr id="9" name="">
+            <a:extLst xmlns:a="http://schemas.openxmlformats.org/drawingml/2006/main">
+              <a:ext uri="{FF2B5EF4-FFF2-40B4-BE49-F238E27FC236}">
+                <a16:creationId xmlns:a16="http://schemas.microsoft.com/office/drawing/2014/main" id="{D2DC9DE5-AF6F-48DB-9546-821E8BA48192}"/>
+              </a:ext>
+            </a:extLst>
+          </p:cNvPr>
+          <p:cNvSpPr>
+            <a:spLocks xmlns:a="http://schemas.openxmlformats.org/drawingml/2006/main" noGrp="1"/>
+          </p:cNvSpPr>
+          <p:nvPr/>
+        </p:nvSpPr>
+        <p:spPr>
+          <a:xfrm xmlns:a="http://schemas.openxmlformats.org/drawingml/2006/main">
+            <a:off x="714375" y="3543300"/>
+            <a:ext cx="2286000" cy="400050"/>
+          </a:xfrm>
+          <a:prstGeom xmlns:a="http://schemas.openxmlformats.org/drawingml/2006/main" prst="rect">
+            <a:avLst/>
+          </a:prstGeom>
+          <a:noFill xmlns:a="http://schemas.openxmlformats.org/drawingml/2006/main"/>
+          <a:ln xmlns:a="http://schemas.openxmlformats.org/drawingml/2006/main" w="0">
+            <a:noFill/>
+          </a:ln>
+        </p:spPr>
+        <p:txBody>
+          <a:bodyPr xmlns:a="http://schemas.openxmlformats.org/drawingml/2006/main">
+            <a:noAutofit/>
+          </a:bodyPr>
+          <a:lstStyle xmlns:a="http://schemas.openxmlformats.org/drawingml/2006/main"/>
+          <a:p xmlns:a="http://schemas.openxmlformats.org/drawingml/2006/main">
+            <a:pPr>
+              <a:defRPr sz="1950" b="1">
+                <a:solidFill>
+                  <a:srgbClr val="142C40"/>
+                </a:solidFill>
+                <a:latin typeface="Helvetica Neue"/>
+                <a:ea typeface="Helvetica Neue"/>
+                <a:cs typeface="Helvetica Neue"/>
+              </a:defRPr>
+            </a:pPr>
+            <a:r>
+              <a:rPr sz="1950" b="1">
+                <a:solidFill>
+                  <a:srgbClr val="142C40"/>
+                </a:solidFill>
+                <a:latin typeface="Helvetica Neue"/>
+                <a:ea typeface="Helvetica Neue"/>
+                <a:cs typeface="Helvetica Neue"/>
+              </a:rPr>
+              <a:t>C3 - C2</a:t>
+            </a:r>
+          </a:p>
+        </p:txBody>
+      </p:sp>
+      <p:sp>
+        <p:nvSpPr>
+          <p:cNvPr id="10" name="">
+            <a:extLst xmlns:a="http://schemas.openxmlformats.org/drawingml/2006/main">
+              <a:ext uri="{FF2B5EF4-FFF2-40B4-BE49-F238E27FC236}">
+                <a16:creationId xmlns:a16="http://schemas.microsoft.com/office/drawing/2014/main" id="{FABC6299-DD18-47CF-9468-0ED67B11AA23}"/>
+              </a:ext>
+            </a:extLst>
+          </p:cNvPr>
+          <p:cNvSpPr>
+            <a:spLocks xmlns:a="http://schemas.openxmlformats.org/drawingml/2006/main" noGrp="1"/>
+          </p:cNvSpPr>
+          <p:nvPr/>
+        </p:nvSpPr>
+        <p:spPr>
+          <a:xfrm xmlns:a="http://schemas.openxmlformats.org/drawingml/2006/main">
+            <a:off x="8972550" y="3600450"/>
+            <a:ext cx="2667000" cy="428625"/>
+          </a:xfrm>
+          <a:prstGeom xmlns:a="http://schemas.openxmlformats.org/drawingml/2006/main" prst="rect">
+            <a:avLst/>
+          </a:prstGeom>
+          <a:noFill xmlns:a="http://schemas.openxmlformats.org/drawingml/2006/main"/>
+          <a:ln xmlns:a="http://schemas.openxmlformats.org/drawingml/2006/main" w="0">
+            <a:noFill/>
+          </a:ln>
+        </p:spPr>
+        <p:txBody>
+          <a:bodyPr xmlns:a="http://schemas.openxmlformats.org/drawingml/2006/main">
+            <a:noAutofit/>
+          </a:bodyPr>
+          <a:lstStyle xmlns:a="http://schemas.openxmlformats.org/drawingml/2006/main"/>
+          <a:p xmlns:a="http://schemas.openxmlformats.org/drawingml/2006/main">
+            <a:pPr>
+              <a:defRPr sz="1500" b="0">
+                <a:solidFill>
+                  <a:srgbClr val="142C40"/>
+                </a:solidFill>
+                <a:latin typeface="Helvetica Neue"/>
+                <a:ea typeface="Helvetica Neue"/>
+                <a:cs typeface="Helvetica Neue"/>
+              </a:defRPr>
+            </a:pPr>
+            <a:r>
+              <a:rPr sz="1500" b="0">
+                <a:solidFill>
+                  <a:srgbClr val="142C40"/>
+                </a:solidFill>
+                <a:latin typeface="Helvetica Neue"/>
+                <a:ea typeface="Helvetica Neue"/>
+                <a:cs typeface="Helvetica Neue"/>
+              </a:rPr>
+              <a:t>-16.55 [-20.70, -12.38]</a:t>
+            </a:r>
+          </a:p>
+        </p:txBody>
+      </p:sp>
+      <p:sp>
+        <p:nvSpPr>
+          <p:cNvPr id="11" name="">
+            <a:extLst xmlns:a="http://schemas.openxmlformats.org/drawingml/2006/main">
+              <a:ext uri="{FF2B5EF4-FFF2-40B4-BE49-F238E27FC236}">
+                <a16:creationId xmlns:a16="http://schemas.microsoft.com/office/drawing/2014/main" id="{A2C3789F-1A66-4A45-A418-D17FB747662F}"/>
+              </a:ext>
+            </a:extLst>
+          </p:cNvPr>
+          <p:cNvSpPr>
+            <a:spLocks xmlns:a="http://schemas.openxmlformats.org/drawingml/2006/main" noGrp="1"/>
+          </p:cNvSpPr>
+          <p:nvPr/>
+        </p:nvSpPr>
+        <p:spPr>
+          <a:xfrm xmlns:a="http://schemas.openxmlformats.org/drawingml/2006/main">
+            <a:off x="714375" y="4086225"/>
+            <a:ext cx="2286000" cy="400050"/>
+          </a:xfrm>
+          <a:prstGeom xmlns:a="http://schemas.openxmlformats.org/drawingml/2006/main" prst="rect">
+            <a:avLst/>
+          </a:prstGeom>
+          <a:noFill xmlns:a="http://schemas.openxmlformats.org/drawingml/2006/main"/>
+          <a:ln xmlns:a="http://schemas.openxmlformats.org/drawingml/2006/main" w="0">
+            <a:noFill/>
+          </a:ln>
+        </p:spPr>
+        <p:txBody>
+          <a:bodyPr xmlns:a="http://schemas.openxmlformats.org/drawingml/2006/main">
+            <a:noAutofit/>
+          </a:bodyPr>
+          <a:lstStyle xmlns:a="http://schemas.openxmlformats.org/drawingml/2006/main"/>
+          <a:p xmlns:a="http://schemas.openxmlformats.org/drawingml/2006/main">
+            <a:pPr>
+              <a:defRPr sz="1950" b="1">
+                <a:solidFill>
+                  <a:srgbClr val="142C40"/>
+                </a:solidFill>
+                <a:latin typeface="Helvetica Neue"/>
+                <a:ea typeface="Helvetica Neue"/>
+                <a:cs typeface="Helvetica Neue"/>
+              </a:defRPr>
+            </a:pPr>
+            <a:r>
+              <a:rPr sz="1950" b="1">
+                <a:solidFill>
+                  <a:srgbClr val="142C40"/>
+                </a:solidFill>
+                <a:latin typeface="Helvetica Neue"/>
+                <a:ea typeface="Helvetica Neue"/>
+                <a:cs typeface="Helvetica Neue"/>
+              </a:rPr>
+              <a:t>C5 - C4</a:t>
+            </a:r>
+          </a:p>
+        </p:txBody>
+      </p:sp>
+      <p:sp>
+        <p:nvSpPr>
+          <p:cNvPr id="12" name="">
+            <a:extLst xmlns:a="http://schemas.openxmlformats.org/drawingml/2006/main">
+              <a:ext uri="{FF2B5EF4-FFF2-40B4-BE49-F238E27FC236}">
+                <a16:creationId xmlns:a16="http://schemas.microsoft.com/office/drawing/2014/main" id="{203A9852-BBD0-4DFA-8D9B-7F4A3EBF49AD}"/>
+              </a:ext>
+            </a:extLst>
+          </p:cNvPr>
+          <p:cNvSpPr>
+            <a:spLocks xmlns:a="http://schemas.openxmlformats.org/drawingml/2006/main" noGrp="1"/>
+          </p:cNvSpPr>
+          <p:nvPr/>
+        </p:nvSpPr>
+        <p:spPr>
+          <a:xfrm xmlns:a="http://schemas.openxmlformats.org/drawingml/2006/main">
+            <a:off x="8972550" y="4143375"/>
+            <a:ext cx="2667000" cy="428625"/>
+          </a:xfrm>
+          <a:prstGeom xmlns:a="http://schemas.openxmlformats.org/drawingml/2006/main" prst="rect">
+            <a:avLst/>
+          </a:prstGeom>
+          <a:noFill xmlns:a="http://schemas.openxmlformats.org/drawingml/2006/main"/>
+          <a:ln xmlns:a="http://schemas.openxmlformats.org/drawingml/2006/main" w="0">
+            <a:noFill/>
+          </a:ln>
+        </p:spPr>
+        <p:txBody>
+          <a:bodyPr xmlns:a="http://schemas.openxmlformats.org/drawingml/2006/main">
+            <a:noAutofit/>
+          </a:bodyPr>
+          <a:lstStyle xmlns:a="http://schemas.openxmlformats.org/drawingml/2006/main"/>
+          <a:p xmlns:a="http://schemas.openxmlformats.org/drawingml/2006/main">
+            <a:pPr>
+              <a:defRPr sz="1500" b="0">
+                <a:solidFill>
+                  <a:srgbClr val="142C40"/>
+                </a:solidFill>
+                <a:latin typeface="Helvetica Neue"/>
+                <a:ea typeface="Helvetica Neue"/>
+                <a:cs typeface="Helvetica Neue"/>
+              </a:defRPr>
+            </a:pPr>
+            <a:r>
+              <a:rPr sz="1500" b="0">
+                <a:solidFill>
+                  <a:srgbClr val="142C40"/>
+                </a:solidFill>
+                <a:latin typeface="Helvetica Neue"/>
+                <a:ea typeface="Helvetica Neue"/>
+                <a:cs typeface="Helvetica Neue"/>
+              </a:rPr>
+              <a:t>-4.73 [-7.37, -2.22]</a:t>
+            </a:r>
+          </a:p>
+        </p:txBody>
+      </p:sp>
+      <p:sp>
+        <p:nvSpPr>
+          <p:cNvPr id="13" name="">
+            <a:extLst xmlns:a="http://schemas.openxmlformats.org/drawingml/2006/main">
+              <a:ext uri="{FF2B5EF4-FFF2-40B4-BE49-F238E27FC236}">
+                <a16:creationId xmlns:a16="http://schemas.microsoft.com/office/drawing/2014/main" id="{2C459DAF-9B93-40A5-8E09-5D665346CCE0}"/>
+              </a:ext>
+            </a:extLst>
+          </p:cNvPr>
+          <p:cNvSpPr>
+            <a:spLocks xmlns:a="http://schemas.openxmlformats.org/drawingml/2006/main" noGrp="1"/>
+          </p:cNvSpPr>
+          <p:nvPr/>
+        </p:nvSpPr>
+        <p:spPr>
+          <a:xfrm xmlns:a="http://schemas.openxmlformats.org/drawingml/2006/main">
+            <a:off x="8934450" y="1495425"/>
+            <a:ext cx="2809875" cy="381000"/>
+          </a:xfrm>
+          <a:prstGeom xmlns:a="http://schemas.openxmlformats.org/drawingml/2006/main" prst="rect">
+            <a:avLst/>
+          </a:prstGeom>
+          <a:noFill xmlns:a="http://schemas.openxmlformats.org/drawingml/2006/main"/>
+          <a:ln xmlns:a="http://schemas.openxmlformats.org/drawingml/2006/main" w="0">
+            <a:noFill/>
+          </a:ln>
+        </p:spPr>
+        <p:txBody>
+          <a:bodyPr xmlns:a="http://schemas.openxmlformats.org/drawingml/2006/main">
+            <a:noAutofit/>
+          </a:bodyPr>
+          <a:lstStyle xmlns:a="http://schemas.openxmlformats.org/drawingml/2006/main"/>
+          <a:p xmlns:a="http://schemas.openxmlformats.org/drawingml/2006/main">
+            <a:pPr>
+              <a:defRPr sz="1500" b="0">
+                <a:solidFill>
+                  <a:srgbClr val="657586"/>
+                </a:solidFill>
+                <a:latin typeface="Helvetica Neue"/>
+                <a:ea typeface="Helvetica Neue"/>
+                <a:cs typeface="Helvetica Neue"/>
+              </a:defRPr>
+            </a:pPr>
+            <a:r>
+              <a:rPr sz="1500" b="0">
+                <a:solidFill>
+                  <a:srgbClr val="657586"/>
+                </a:solidFill>
+                <a:latin typeface="Helvetica Neue"/>
+                <a:ea typeface="Helvetica Neue"/>
+                <a:cs typeface="Helvetica Neue"/>
+              </a:rPr>
+              <a:t>Difference [95% interval]</a:t>
+            </a:r>
+          </a:p>
+        </p:txBody>
+      </p:sp>
+      <p:sp>
+        <p:nvSpPr>
+          <p:cNvPr id="14" name="">
+            <a:extLst xmlns:a="http://schemas.openxmlformats.org/drawingml/2006/main">
+              <a:ext uri="{FF2B5EF4-FFF2-40B4-BE49-F238E27FC236}">
+                <a16:creationId xmlns:a16="http://schemas.microsoft.com/office/drawing/2014/main" id="{F39F55C9-C65A-47CE-BACB-8EE7BA40F9D2}"/>
+              </a:ext>
+            </a:extLst>
+          </p:cNvPr>
+          <p:cNvSpPr>
+            <a:spLocks xmlns:a="http://schemas.openxmlformats.org/drawingml/2006/main" noGrp="1"/>
+          </p:cNvSpPr>
+          <p:nvPr/>
+        </p:nvSpPr>
+        <p:spPr>
+          <a:xfrm xmlns:a="http://schemas.openxmlformats.org/drawingml/2006/main">
+            <a:off x="3067050" y="5124450"/>
+            <a:ext cx="6286500" cy="381000"/>
+          </a:xfrm>
+          <a:prstGeom xmlns:a="http://schemas.openxmlformats.org/drawingml/2006/main" prst="rect">
+            <a:avLst/>
+          </a:prstGeom>
+          <a:noFill xmlns:a="http://schemas.openxmlformats.org/drawingml/2006/main"/>
+          <a:ln xmlns:a="http://schemas.openxmlformats.org/drawingml/2006/main" w="0">
+            <a:noFill/>
+          </a:ln>
+        </p:spPr>
+        <p:txBody>
+          <a:bodyPr xmlns:a="http://schemas.openxmlformats.org/drawingml/2006/main">
+            <a:noAutofit/>
+          </a:bodyPr>
+          <a:lstStyle xmlns:a="http://schemas.openxmlformats.org/drawingml/2006/main"/>
+          <a:p xmlns:a="http://schemas.openxmlformats.org/drawingml/2006/main">
+            <a:pPr>
+              <a:defRPr sz="1875" b="1">
+                <a:solidFill>
+                  <a:srgbClr val="147E77"/>
+                </a:solidFill>
+                <a:latin typeface="Helvetica Neue"/>
+                <a:ea typeface="Helvetica Neue"/>
+                <a:cs typeface="Helvetica Neue"/>
+              </a:defRPr>
+            </a:pPr>
+            <a:r>
+              <a:rPr sz="1875" b="1">
+                <a:solidFill>
+                  <a:srgbClr val="147E77"/>
+                </a:solidFill>
+                <a:latin typeface="Helvetica Neue"/>
+                <a:ea typeface="Helvetica Neue"/>
+                <a:cs typeface="Helvetica Neue"/>
+              </a:rPr>
+              <a:t>Change in error rate (percentage points)</a:t>
+            </a:r>
+          </a:p>
+        </p:txBody>
+      </p:sp>
+      <p:sp>
+        <p:nvSpPr>
+          <p:cNvPr id="15" name="">
+            <a:extLst xmlns:a="http://schemas.openxmlformats.org/drawingml/2006/main">
+              <a:ext uri="{FF2B5EF4-FFF2-40B4-BE49-F238E27FC236}">
+                <a16:creationId xmlns:a16="http://schemas.microsoft.com/office/drawing/2014/main" id="{879E0052-5ED8-4C5B-884E-FF835CE1A234}"/>
+              </a:ext>
+            </a:extLst>
+          </p:cNvPr>
+          <p:cNvSpPr>
+            <a:spLocks xmlns:a="http://schemas.openxmlformats.org/drawingml/2006/main" noGrp="1"/>
+          </p:cNvSpPr>
+          <p:nvPr/>
+        </p:nvSpPr>
+        <p:spPr>
+          <a:xfrm xmlns:a="http://schemas.openxmlformats.org/drawingml/2006/main">
+            <a:off x="685800" y="5581650"/>
             <a:ext cx="10668000" cy="381000"/>
           </a:xfrm>
           <a:prstGeom xmlns:a="http://schemas.openxmlformats.org/drawingml/2006/main" prst="rect">
@@ -8434,9 +9552,9 @@
           <a:lstStyle xmlns:a="http://schemas.openxmlformats.org/drawingml/2006/main"/>
           <a:p xmlns:a="http://schemas.openxmlformats.org/drawingml/2006/main">
             <a:pPr>
-              <a:defRPr sz="1950" b="1">
-                <a:solidFill>
-                  <a:srgbClr val="147E77"/>
+              <a:defRPr sz="1950" b="0">
+                <a:solidFill>
+                  <a:srgbClr val="142C40"/>
                 </a:solidFill>
                 <a:latin typeface="Helvetica Neue"/>
                 <a:ea typeface="Helvetica Neue"/>
@@ -8444,25 +9562,25 @@
               </a:defRPr>
             </a:pPr>
             <a:r>
-              <a:rPr sz="1950" b="1">
-                <a:solidFill>
-                  <a:srgbClr val="147E77"/>
+              <a:rPr sz="1950" b="0">
+                <a:solidFill>
+                  <a:srgbClr val="142C40"/>
                 </a:solidFill>
                 <a:latin typeface="Helvetica Neue"/>
                 <a:ea typeface="Helvetica Neue"/>
                 <a:cs typeface="Helvetica Neue"/>
               </a:rPr>
-              <a:t>Error rate (%) across all 719 units per condition</a:t>
-            </a:r>
-          </a:p>
-        </p:txBody>
-      </p:sp>
-      <p:sp>
-        <p:nvSpPr>
-          <p:cNvPr id="4" name="">
+              <a:t>Left: fewer wrong answers. Right: more wrong answers.</a:t>
+            </a:r>
+          </a:p>
+        </p:txBody>
+      </p:sp>
+      <p:sp>
+        <p:nvSpPr>
+          <p:cNvPr id="16" name="">
             <a:extLst xmlns:a="http://schemas.openxmlformats.org/drawingml/2006/main">
               <a:ext uri="{FF2B5EF4-FFF2-40B4-BE49-F238E27FC236}">
-                <a16:creationId xmlns:a16="http://schemas.microsoft.com/office/drawing/2014/main" id="{89E6DBDB-419B-44AD-8933-3B1CB730E467}"/>
+                <a16:creationId xmlns:a16="http://schemas.microsoft.com/office/drawing/2014/main" id="{77ECDDA7-6909-40DC-93A7-7AF5FBFF80D4}"/>
               </a:ext>
             </a:extLst>
           </p:cNvPr>
@@ -8473,8 +9591,8 @@
         </p:nvSpPr>
         <p:spPr>
           <a:xfrm xmlns:a="http://schemas.openxmlformats.org/drawingml/2006/main">
-            <a:off x="685800" y="5762625"/>
-            <a:ext cx="10763250" cy="457200"/>
+            <a:off x="685800" y="6057900"/>
+            <a:ext cx="10477500" cy="381000"/>
           </a:xfrm>
           <a:prstGeom xmlns:a="http://schemas.openxmlformats.org/drawingml/2006/main" prst="rect">
             <a:avLst/>
@@ -8491,7 +9609,7 @@
           <a:lstStyle xmlns:a="http://schemas.openxmlformats.org/drawingml/2006/main"/>
           <a:p xmlns:a="http://schemas.openxmlformats.org/drawingml/2006/main">
             <a:pPr>
-              <a:defRPr sz="1875" b="0">
+              <a:defRPr sz="1575" b="0">
                 <a:solidFill>
                   <a:srgbClr val="657586"/>
                 </a:solidFill>
@@ -8501,7 +9619,7 @@
               </a:defRPr>
             </a:pPr>
             <a:r>
-              <a:rPr sz="1875" b="0">
+              <a:rPr sz="1575" b="0">
                 <a:solidFill>
                   <a:srgbClr val="657586"/>
                 </a:solidFill>
@@ -8509,17 +9627,17 @@
                 <a:ea typeface="Helvetica Neue"/>
                 <a:cs typeface="Helvetica Neue"/>
               </a:rPr>
-              <a:t>Post hoc: C1 - C0 +18.78 pp; C2 - C0 +6.40 pp; C3 - C2 -16.55 pp</a:t>
-            </a:r>
-          </a:p>
-        </p:txBody>
-      </p:sp>
-      <p:sp>
-        <p:nvSpPr>
-          <p:cNvPr id="5" name="">
+              <a:t>Post hoc; 719 paired units; 120 question clusters. Pointwise bootstrap intervals.</a:t>
+            </a:r>
+          </a:p>
+        </p:txBody>
+      </p:sp>
+      <p:sp>
+        <p:nvSpPr>
+          <p:cNvPr id="17" name="">
             <a:extLst xmlns:a="http://schemas.openxmlformats.org/drawingml/2006/main">
               <a:ext uri="{FF2B5EF4-FFF2-40B4-BE49-F238E27FC236}">
-                <a16:creationId xmlns:a16="http://schemas.microsoft.com/office/drawing/2014/main" id="{39BEDD55-E512-48C2-A802-3BC408682BCA}"/>
+                <a16:creationId xmlns:a16="http://schemas.microsoft.com/office/drawing/2014/main" id="{D0127590-F340-4C04-8467-A82DA626E4D3}"/>
               </a:ext>
             </a:extLst>
           </p:cNvPr>
@@ -8574,7 +9692,7 @@
     </p:spTree>
     <p:extLst>
       <p:ext uri="{BB962C8B-B14F-4D97-AF65-F5344CB8AC3E}">
-        <p14:creationId xmlns:p14="http://schemas.microsoft.com/office/powerpoint/2010/main" val="2095453076"/>
+        <p14:creationId xmlns:p14="http://schemas.microsoft.com/office/powerpoint/2010/main" val="277823871"/>
       </p:ext>
     </p:extLst>
   </p:cSld>
@@ -8602,10 +9720,10 @@
       </p:grpSpPr>
       <p:sp>
         <p:nvSpPr>
-          <p:cNvPr id="6" name="">
+          <p:cNvPr id="8" name="">
             <a:extLst xmlns:a="http://schemas.openxmlformats.org/drawingml/2006/main">
               <a:ext uri="{FF2B5EF4-FFF2-40B4-BE49-F238E27FC236}">
-                <a16:creationId xmlns:a16="http://schemas.microsoft.com/office/drawing/2014/main" id="{E2BB32E8-2C88-4B42-A32C-6B5C06393B62}"/>
+                <a16:creationId xmlns:a16="http://schemas.microsoft.com/office/drawing/2014/main" id="{B634A877-A8C4-4930-9197-34259DD8DA68}"/>
               </a:ext>
             </a:extLst>
           </p:cNvPr>
@@ -8659,32 +9777,32 @@
       </p:sp>
       <p:graphicFrame>
         <p:nvGraphicFramePr>
-          <p:cNvPr id="7" name=""/>
+          <p:cNvPr id="9" name=""/>
           <p:cNvGraphicFramePr/>
           <p:nvPr/>
         </p:nvGraphicFramePr>
         <p:xfrm>
-          <a:off xmlns:a="http://schemas.openxmlformats.org/drawingml/2006/main" x="685800" y="1590675"/>
-          <a:ext xmlns:a="http://schemas.openxmlformats.org/drawingml/2006/main" cx="10820400" cy="2876550"/>
+          <a:off xmlns:a="http://schemas.openxmlformats.org/drawingml/2006/main" x="685800" y="1809750"/>
+          <a:ext xmlns:a="http://schemas.openxmlformats.org/drawingml/2006/main" cx="10820400" cy="2781300"/>
         </p:xfrm>
         <a:graphic xmlns:a="http://schemas.openxmlformats.org/drawingml/2006/main">
           <a:graphicData uri="http://schemas.openxmlformats.org/drawingml/2006/table">
             <a:tbl>
               <a:tblPr/>
               <a:tblGrid>
-                <a:gridCol w="2705100"/>
-                <a:gridCol w="2705100"/>
-                <a:gridCol w="2705100"/>
-                <a:gridCol w="2705100"/>
+                <a:gridCol w="2619375"/>
+                <a:gridCol w="2733675"/>
+                <a:gridCol w="2733675"/>
+                <a:gridCol w="2733675"/>
               </a:tblGrid>
-              <a:tr h="719138">
+              <a:tr h="695325">
                 <a:tc>
                   <a:txBody>
                     <a:bodyPr/>
                     <a:lstStyle/>
                     <a:p>
                       <a:r>
-                        <a:rPr sz="2025" b="1">
+                        <a:rPr sz="2175" b="1">
                           <a:solidFill>
                             <a:srgbClr val="FFFFFF"/>
                           </a:solidFill>
@@ -8708,7 +9826,7 @@
                     <a:lstStyle/>
                     <a:p>
                       <a:r>
-                        <a:rPr sz="2025" b="1">
+                        <a:rPr sz="2175" b="1">
                           <a:solidFill>
                             <a:srgbClr val="FFFFFF"/>
                           </a:solidFill>
@@ -8732,7 +9850,7 @@
                     <a:lstStyle/>
                     <a:p>
                       <a:r>
-                        <a:rPr sz="2025" b="1">
+                        <a:rPr sz="2175" b="1">
                           <a:solidFill>
                             <a:srgbClr val="FFFFFF"/>
                           </a:solidFill>
@@ -8756,7 +9874,7 @@
                     <a:lstStyle/>
                     <a:p>
                       <a:r>
-                        <a:rPr sz="2025" b="1">
+                        <a:rPr sz="2175" b="1">
                           <a:solidFill>
                             <a:srgbClr val="FFFFFF"/>
                           </a:solidFill>
@@ -8775,14 +9893,14 @@
                   </a:tcPr>
                 </a:tc>
               </a:tr>
-              <a:tr h="719138">
+              <a:tr h="695325">
                 <a:tc>
                   <a:txBody>
                     <a:bodyPr/>
                     <a:lstStyle/>
                     <a:p>
                       <a:r>
-                        <a:rPr sz="2025" b="0">
+                        <a:rPr sz="2175" b="0">
                           <a:solidFill>
                             <a:srgbClr val="142C40"/>
                           </a:solidFill>
@@ -8806,7 +9924,7 @@
                     <a:lstStyle/>
                     <a:p>
                       <a:r>
-                        <a:rPr sz="2025" b="0">
+                        <a:rPr sz="2175" b="1">
                           <a:solidFill>
                             <a:srgbClr val="142C40"/>
                           </a:solidFill>
@@ -8820,7 +9938,7 @@
                   </a:txBody>
                   <a:tcPr marL="91440" marR="91440" marT="45720" marB="45720">
                     <a:solidFill>
-                      <a:srgbClr val="F0F4F7"/>
+                      <a:srgbClr val="6FAFAC"/>
                     </a:solidFill>
                   </a:tcPr>
                 </a:tc>
@@ -8830,7 +9948,7 @@
                     <a:lstStyle/>
                     <a:p>
                       <a:r>
-                        <a:rPr sz="2025" b="0">
+                        <a:rPr sz="2175" b="1">
                           <a:solidFill>
                             <a:srgbClr val="142C40"/>
                           </a:solidFill>
@@ -8844,7 +9962,7 @@
                   </a:txBody>
                   <a:tcPr marL="91440" marR="91440" marT="45720" marB="45720">
                     <a:solidFill>
-                      <a:srgbClr val="F0F4F7"/>
+                      <a:srgbClr val="E7EFF1"/>
                     </a:solidFill>
                   </a:tcPr>
                 </a:tc>
@@ -8854,7 +9972,7 @@
                     <a:lstStyle/>
                     <a:p>
                       <a:r>
-                        <a:rPr sz="2025" b="0">
+                        <a:rPr sz="2175" b="1">
                           <a:solidFill>
                             <a:srgbClr val="142C40"/>
                           </a:solidFill>
@@ -8868,19 +9986,19 @@
                   </a:txBody>
                   <a:tcPr marL="91440" marR="91440" marT="45720" marB="45720">
                     <a:solidFill>
-                      <a:srgbClr val="F0F4F7"/>
+                      <a:srgbClr val="DCE9EB"/>
                     </a:solidFill>
                   </a:tcPr>
                 </a:tc>
               </a:tr>
-              <a:tr h="719138">
+              <a:tr h="695325">
                 <a:tc>
                   <a:txBody>
                     <a:bodyPr/>
                     <a:lstStyle/>
                     <a:p>
                       <a:r>
-                        <a:rPr sz="2025" b="0">
+                        <a:rPr sz="2175" b="0">
                           <a:solidFill>
                             <a:srgbClr val="142C40"/>
                           </a:solidFill>
@@ -8904,7 +10022,7 @@
                     <a:lstStyle/>
                     <a:p>
                       <a:r>
-                        <a:rPr sz="2025" b="0">
+                        <a:rPr sz="2175" b="1">
                           <a:solidFill>
                             <a:srgbClr val="142C40"/>
                           </a:solidFill>
@@ -8918,7 +10036,7 @@
                   </a:txBody>
                   <a:tcPr marL="91440" marR="91440" marT="45720" marB="45720">
                     <a:solidFill>
-                      <a:srgbClr val="FFFFFF"/>
+                      <a:srgbClr val="EBF1F4"/>
                     </a:solidFill>
                   </a:tcPr>
                 </a:tc>
@@ -8928,9 +10046,9 @@
                     <a:lstStyle/>
                     <a:p>
                       <a:r>
-                        <a:rPr sz="2025" b="0">
+                        <a:rPr sz="2175" b="1">
                           <a:solidFill>
-                            <a:srgbClr val="142C40"/>
+                            <a:srgbClr val="FFFFFF"/>
                           </a:solidFill>
                           <a:latin typeface="Helvetica Neue"/>
                           <a:ea typeface="Helvetica Neue"/>
@@ -8942,7 +10060,7 @@
                   </a:txBody>
                   <a:tcPr marL="91440" marR="91440" marT="45720" marB="45720">
                     <a:solidFill>
-                      <a:srgbClr val="FFFFFF"/>
+                      <a:srgbClr val="147E77"/>
                     </a:solidFill>
                   </a:tcPr>
                 </a:tc>
@@ -8952,7 +10070,7 @@
                     <a:lstStyle/>
                     <a:p>
                       <a:r>
-                        <a:rPr sz="2025" b="0">
+                        <a:rPr sz="2175" b="1">
                           <a:solidFill>
                             <a:srgbClr val="142C40"/>
                           </a:solidFill>
@@ -8966,19 +10084,19 @@
                   </a:txBody>
                   <a:tcPr marL="91440" marR="91440" marT="45720" marB="45720">
                     <a:solidFill>
-                      <a:srgbClr val="FFFFFF"/>
+                      <a:srgbClr val="65A9A6"/>
                     </a:solidFill>
                   </a:tcPr>
                 </a:tc>
               </a:tr>
-              <a:tr h="719138">
+              <a:tr h="695325">
                 <a:tc>
                   <a:txBody>
                     <a:bodyPr/>
                     <a:lstStyle/>
                     <a:p>
                       <a:r>
-                        <a:rPr sz="2025" b="0">
+                        <a:rPr sz="2175" b="0">
                           <a:solidFill>
                             <a:srgbClr val="142C40"/>
                           </a:solidFill>
@@ -9002,7 +10120,7 @@
                     <a:lstStyle/>
                     <a:p>
                       <a:r>
-                        <a:rPr sz="2025" b="0">
+                        <a:rPr sz="2175" b="1">
                           <a:solidFill>
                             <a:srgbClr val="142C40"/>
                           </a:solidFill>
@@ -9016,7 +10134,7 @@
                   </a:txBody>
                   <a:tcPr marL="91440" marR="91440" marT="45720" marB="45720">
                     <a:solidFill>
-                      <a:srgbClr val="F0F4F7"/>
+                      <a:srgbClr val="EDF2F5"/>
                     </a:solidFill>
                   </a:tcPr>
                 </a:tc>
@@ -9026,7 +10144,7 @@
                     <a:lstStyle/>
                     <a:p>
                       <a:r>
-                        <a:rPr sz="2025" b="0">
+                        <a:rPr sz="2175" b="1">
                           <a:solidFill>
                             <a:srgbClr val="142C40"/>
                           </a:solidFill>
@@ -9040,7 +10158,7 @@
                   </a:txBody>
                   <a:tcPr marL="91440" marR="91440" marT="45720" marB="45720">
                     <a:solidFill>
-                      <a:srgbClr val="F0F4F7"/>
+                      <a:srgbClr val="DBE9EB"/>
                     </a:solidFill>
                   </a:tcPr>
                 </a:tc>
@@ -9050,7 +10168,7 @@
                     <a:lstStyle/>
                     <a:p>
                       <a:r>
-                        <a:rPr sz="2025" b="0">
+                        <a:rPr sz="2175" b="1">
                           <a:solidFill>
                             <a:srgbClr val="142C40"/>
                           </a:solidFill>
@@ -9064,7 +10182,7 @@
                   </a:txBody>
                   <a:tcPr marL="91440" marR="91440" marT="45720" marB="45720">
                     <a:solidFill>
-                      <a:srgbClr val="F0F4F7"/>
+                      <a:srgbClr val="59A39F"/>
                     </a:solidFill>
                   </a:tcPr>
                 </a:tc>
@@ -9078,7 +10196,7 @@
           <p:cNvPr id="3" name="">
             <a:extLst xmlns:a="http://schemas.openxmlformats.org/drawingml/2006/main">
               <a:ext uri="{FF2B5EF4-FFF2-40B4-BE49-F238E27FC236}">
-                <a16:creationId xmlns:a16="http://schemas.microsoft.com/office/drawing/2014/main" id="{238CAC33-E31A-4178-8061-929A15CAADCE}"/>
+                <a16:creationId xmlns:a16="http://schemas.microsoft.com/office/drawing/2014/main" id="{F9B768A9-03CB-415F-8FC3-F1316CB1FAB6}"/>
               </a:ext>
             </a:extLst>
           </p:cNvPr>
@@ -9089,8 +10207,8 @@
         </p:nvSpPr>
         <p:spPr>
           <a:xfrm xmlns:a="http://schemas.openxmlformats.org/drawingml/2006/main">
-            <a:off x="685800" y="4800600"/>
-            <a:ext cx="10668000" cy="552450"/>
+            <a:off x="685800" y="1352550"/>
+            <a:ext cx="10668000" cy="381000"/>
           </a:xfrm>
           <a:prstGeom xmlns:a="http://schemas.openxmlformats.org/drawingml/2006/main" prst="rect">
             <a:avLst/>
@@ -9107,9 +10225,9 @@
           <a:lstStyle xmlns:a="http://schemas.openxmlformats.org/drawingml/2006/main"/>
           <a:p xmlns:a="http://schemas.openxmlformats.org/drawingml/2006/main">
             <a:pPr>
-              <a:defRPr sz="2175" b="1">
-                <a:solidFill>
-                  <a:srgbClr val="147E77"/>
+              <a:defRPr sz="1725" b="0">
+                <a:solidFill>
+                  <a:srgbClr val="657586"/>
                 </a:solidFill>
                 <a:latin typeface="Helvetica Neue"/>
                 <a:ea typeface="Helvetica Neue"/>
@@ -9117,15 +10235,15 @@
               </a:defRPr>
             </a:pPr>
             <a:r>
-              <a:rPr sz="2175" b="1">
-                <a:solidFill>
-                  <a:srgbClr val="147E77"/>
+              <a:rPr sz="1725" b="0">
+                <a:solidFill>
+                  <a:srgbClr val="657586"/>
                 </a:solidFill>
                 <a:latin typeface="Helvetica Neue"/>
                 <a:ea typeface="Helvetica Neue"/>
                 <a:cs typeface="Helvetica Neue"/>
               </a:rPr>
-              <a:t>144 wrong-to-abstain pairs, compared with 5 wrong-to-correct</a:t>
+              <a:t>Rows: C2 outcome  /  Columns: C3 outcome  /  All 719 paired units</a:t>
             </a:r>
           </a:p>
         </p:txBody>
@@ -9135,7 +10253,7 @@
           <p:cNvPr id="4" name="">
             <a:extLst xmlns:a="http://schemas.openxmlformats.org/drawingml/2006/main">
               <a:ext uri="{FF2B5EF4-FFF2-40B4-BE49-F238E27FC236}">
-                <a16:creationId xmlns:a16="http://schemas.microsoft.com/office/drawing/2014/main" id="{9A9CB8BC-B886-4458-B771-F586319E7EED}"/>
+                <a16:creationId xmlns:a16="http://schemas.microsoft.com/office/drawing/2014/main" id="{7EE4FB6B-C34F-41AE-8B20-C0A4FFDFC341}"/>
               </a:ext>
             </a:extLst>
           </p:cNvPr>
@@ -9146,8 +10264,8 @@
         </p:nvSpPr>
         <p:spPr>
           <a:xfrm xmlns:a="http://schemas.openxmlformats.org/drawingml/2006/main">
-            <a:off x="685800" y="5476875"/>
-            <a:ext cx="10668000" cy="619125"/>
+            <a:off x="685800" y="4676775"/>
+            <a:ext cx="10668000" cy="381000"/>
           </a:xfrm>
           <a:prstGeom xmlns:a="http://schemas.openxmlformats.org/drawingml/2006/main" prst="rect">
             <a:avLst/>
@@ -9164,7 +10282,7 @@
           <a:lstStyle xmlns:a="http://schemas.openxmlformats.org/drawingml/2006/main"/>
           <a:p xmlns:a="http://schemas.openxmlformats.org/drawingml/2006/main">
             <a:pPr>
-              <a:defRPr sz="1875" b="0">
+              <a:defRPr sz="1725" b="0">
                 <a:solidFill>
                   <a:srgbClr val="657586"/>
                 </a:solidFill>
@@ -9174,7 +10292,7 @@
               </a:defRPr>
             </a:pPr>
             <a:r>
-              <a:rPr sz="1875" b="0">
+              <a:rPr sz="1725" b="0">
                 <a:solidFill>
                   <a:srgbClr val="657586"/>
                 </a:solidFill>
@@ -9182,7 +10300,7 @@
                 <a:ea typeface="Helvetica Neue"/>
                 <a:cs typeface="Helvetica Neue"/>
               </a:rPr>
-              <a:t>Also 21 abstain-to-wrong and 9 correct-to-wrong pairs. Parallel branches.</a:t>
+              <a:t>Darker cells = more pairs (0-228); one shared count scale.</a:t>
             </a:r>
           </a:p>
         </p:txBody>
@@ -9192,7 +10310,121 @@
           <p:cNvPr id="5" name="">
             <a:extLst xmlns:a="http://schemas.openxmlformats.org/drawingml/2006/main">
               <a:ext uri="{FF2B5EF4-FFF2-40B4-BE49-F238E27FC236}">
-                <a16:creationId xmlns:a16="http://schemas.microsoft.com/office/drawing/2014/main" id="{ED63B76B-9728-4D8D-8F6B-5D915566D0B7}"/>
+                <a16:creationId xmlns:a16="http://schemas.microsoft.com/office/drawing/2014/main" id="{8434E4F7-C0F2-4C5C-87EA-65172D1689BB}"/>
+              </a:ext>
+            </a:extLst>
+          </p:cNvPr>
+          <p:cNvSpPr>
+            <a:spLocks xmlns:a="http://schemas.openxmlformats.org/drawingml/2006/main" noGrp="1"/>
+          </p:cNvSpPr>
+          <p:nvPr/>
+        </p:nvSpPr>
+        <p:spPr>
+          <a:xfrm xmlns:a="http://schemas.openxmlformats.org/drawingml/2006/main">
+            <a:off x="685800" y="5162550"/>
+            <a:ext cx="10668000" cy="495300"/>
+          </a:xfrm>
+          <a:prstGeom xmlns:a="http://schemas.openxmlformats.org/drawingml/2006/main" prst="rect">
+            <a:avLst/>
+          </a:prstGeom>
+          <a:noFill xmlns:a="http://schemas.openxmlformats.org/drawingml/2006/main"/>
+          <a:ln xmlns:a="http://schemas.openxmlformats.org/drawingml/2006/main" w="0">
+            <a:noFill/>
+          </a:ln>
+        </p:spPr>
+        <p:txBody>
+          <a:bodyPr xmlns:a="http://schemas.openxmlformats.org/drawingml/2006/main">
+            <a:noAutofit/>
+          </a:bodyPr>
+          <a:lstStyle xmlns:a="http://schemas.openxmlformats.org/drawingml/2006/main"/>
+          <a:p xmlns:a="http://schemas.openxmlformats.org/drawingml/2006/main">
+            <a:pPr>
+              <a:defRPr sz="2175" b="1">
+                <a:solidFill>
+                  <a:srgbClr val="147E77"/>
+                </a:solidFill>
+                <a:latin typeface="Helvetica Neue"/>
+                <a:ea typeface="Helvetica Neue"/>
+                <a:cs typeface="Helvetica Neue"/>
+              </a:defRPr>
+            </a:pPr>
+            <a:r>
+              <a:rPr sz="2175" b="1">
+                <a:solidFill>
+                  <a:srgbClr val="147E77"/>
+                </a:solidFill>
+                <a:latin typeface="Helvetica Neue"/>
+                <a:ea typeface="Helvetica Neue"/>
+                <a:cs typeface="Helvetica Neue"/>
+              </a:rPr>
+              <a:t>144 wrong-to-abstain pairs; only 5 wrong-to-correct</a:t>
+            </a:r>
+          </a:p>
+        </p:txBody>
+      </p:sp>
+      <p:sp>
+        <p:nvSpPr>
+          <p:cNvPr id="6" name="">
+            <a:extLst xmlns:a="http://schemas.openxmlformats.org/drawingml/2006/main">
+              <a:ext uri="{FF2B5EF4-FFF2-40B4-BE49-F238E27FC236}">
+                <a16:creationId xmlns:a16="http://schemas.microsoft.com/office/drawing/2014/main" id="{CBD83F11-761F-4ACB-A0F5-3DB50E59B847}"/>
+              </a:ext>
+            </a:extLst>
+          </p:cNvPr>
+          <p:cNvSpPr>
+            <a:spLocks xmlns:a="http://schemas.openxmlformats.org/drawingml/2006/main" noGrp="1"/>
+          </p:cNvSpPr>
+          <p:nvPr/>
+        </p:nvSpPr>
+        <p:spPr>
+          <a:xfrm xmlns:a="http://schemas.openxmlformats.org/drawingml/2006/main">
+            <a:off x="685800" y="5762625"/>
+            <a:ext cx="10668000" cy="428625"/>
+          </a:xfrm>
+          <a:prstGeom xmlns:a="http://schemas.openxmlformats.org/drawingml/2006/main" prst="rect">
+            <a:avLst/>
+          </a:prstGeom>
+          <a:noFill xmlns:a="http://schemas.openxmlformats.org/drawingml/2006/main"/>
+          <a:ln xmlns:a="http://schemas.openxmlformats.org/drawingml/2006/main" w="0">
+            <a:noFill/>
+          </a:ln>
+        </p:spPr>
+        <p:txBody>
+          <a:bodyPr xmlns:a="http://schemas.openxmlformats.org/drawingml/2006/main">
+            <a:noAutofit/>
+          </a:bodyPr>
+          <a:lstStyle xmlns:a="http://schemas.openxmlformats.org/drawingml/2006/main"/>
+          <a:p xmlns:a="http://schemas.openxmlformats.org/drawingml/2006/main">
+            <a:pPr>
+              <a:defRPr sz="1800" b="0">
+                <a:solidFill>
+                  <a:srgbClr val="657586"/>
+                </a:solidFill>
+                <a:latin typeface="Helvetica Neue"/>
+                <a:ea typeface="Helvetica Neue"/>
+                <a:cs typeface="Helvetica Neue"/>
+              </a:defRPr>
+            </a:pPr>
+            <a:r>
+              <a:rPr sz="1800" b="0">
+                <a:solidFill>
+                  <a:srgbClr val="657586"/>
+                </a:solidFill>
+                <a:latin typeface="Helvetica Neue"/>
+                <a:ea typeface="Helvetica Neue"/>
+                <a:cs typeface="Helvetica Neue"/>
+              </a:rPr>
+              <a:t>All reverse changes retained. Parallel branches, not successive edits.</a:t>
+            </a:r>
+          </a:p>
+        </p:txBody>
+      </p:sp>
+      <p:sp>
+        <p:nvSpPr>
+          <p:cNvPr id="7" name="">
+            <a:extLst xmlns:a="http://schemas.openxmlformats.org/drawingml/2006/main">
+              <a:ext uri="{FF2B5EF4-FFF2-40B4-BE49-F238E27FC236}">
+                <a16:creationId xmlns:a16="http://schemas.microsoft.com/office/drawing/2014/main" id="{C5DE491E-9B33-4B34-B29A-7231F80FA93D}"/>
               </a:ext>
             </a:extLst>
           </p:cNvPr>
@@ -9247,7 +10479,7 @@
     </p:spTree>
     <p:extLst>
       <p:ext uri="{BB962C8B-B14F-4D97-AF65-F5344CB8AC3E}">
-        <p14:creationId xmlns:p14="http://schemas.microsoft.com/office/powerpoint/2010/main" val="1450254506"/>
+        <p14:creationId xmlns:p14="http://schemas.microsoft.com/office/powerpoint/2010/main" val="1607350860"/>
       </p:ext>
     </p:extLst>
   </p:cSld>
@@ -9278,7 +10510,7 @@
           <p:cNvPr id="6" name="">
             <a:extLst xmlns:a="http://schemas.openxmlformats.org/drawingml/2006/main">
               <a:ext uri="{FF2B5EF4-FFF2-40B4-BE49-F238E27FC236}">
-                <a16:creationId xmlns:a16="http://schemas.microsoft.com/office/drawing/2014/main" id="{AA9D87CC-1EF9-4A5D-9C52-A42083ADBFD8}"/>
+                <a16:creationId xmlns:a16="http://schemas.microsoft.com/office/drawing/2014/main" id="{1D5FB349-0F41-4EC6-89AB-0DDB0F45D196}"/>
               </a:ext>
             </a:extLst>
           </p:cNvPr>
@@ -9342,7 +10574,7 @@
         </p:xfrm>
         <a:graphic xmlns:a="http://schemas.openxmlformats.org/drawingml/2006/main">
           <a:graphicData uri="http://schemas.openxmlformats.org/drawingml/2006/chart">
-            <c:chart xmlns:r="http://schemas.openxmlformats.org/officeDocument/2006/relationships" xmlns:c="http://schemas.openxmlformats.org/drawingml/2006/chart" r:id="R9e27b318f2524a3d"/>
+            <c:chart xmlns:r="http://schemas.openxmlformats.org/officeDocument/2006/relationships" xmlns:c="http://schemas.openxmlformats.org/drawingml/2006/chart" r:id="Ra01c87e7dc3a4f14"/>
           </a:graphicData>
         </a:graphic>
       </p:graphicFrame>
@@ -9351,7 +10583,7 @@
           <p:cNvPr id="3" name="">
             <a:extLst xmlns:a="http://schemas.openxmlformats.org/drawingml/2006/main">
               <a:ext uri="{FF2B5EF4-FFF2-40B4-BE49-F238E27FC236}">
-                <a16:creationId xmlns:a16="http://schemas.microsoft.com/office/drawing/2014/main" id="{BF85A53B-62F2-4748-94AC-A44C23DBD822}"/>
+                <a16:creationId xmlns:a16="http://schemas.microsoft.com/office/drawing/2014/main" id="{98BC372B-71AC-4433-A523-D4A923A2B94C}"/>
               </a:ext>
             </a:extLst>
           </p:cNvPr>
@@ -9408,7 +10640,7 @@
           <p:cNvPr id="4" name="">
             <a:extLst xmlns:a="http://schemas.openxmlformats.org/drawingml/2006/main">
               <a:ext uri="{FF2B5EF4-FFF2-40B4-BE49-F238E27FC236}">
-                <a16:creationId xmlns:a16="http://schemas.microsoft.com/office/drawing/2014/main" id="{FD9157F0-1B5F-49D1-879D-3B004C6C06A3}"/>
+                <a16:creationId xmlns:a16="http://schemas.microsoft.com/office/drawing/2014/main" id="{40989377-1949-4B82-83DB-38C79EE13960}"/>
               </a:ext>
             </a:extLst>
           </p:cNvPr>
@@ -9465,7 +10697,7 @@
           <p:cNvPr id="5" name="">
             <a:extLst xmlns:a="http://schemas.openxmlformats.org/drawingml/2006/main">
               <a:ext uri="{FF2B5EF4-FFF2-40B4-BE49-F238E27FC236}">
-                <a16:creationId xmlns:a16="http://schemas.microsoft.com/office/drawing/2014/main" id="{73B14C54-73BE-4ABD-9504-454C695C96FF}"/>
+                <a16:creationId xmlns:a16="http://schemas.microsoft.com/office/drawing/2014/main" id="{0EA44874-A855-49B7-9870-7A9BB0F1717A}"/>
               </a:ext>
             </a:extLst>
           </p:cNvPr>
@@ -9520,7 +10752,7 @@
     </p:spTree>
     <p:extLst>
       <p:ext uri="{BB962C8B-B14F-4D97-AF65-F5344CB8AC3E}">
-        <p14:creationId xmlns:p14="http://schemas.microsoft.com/office/powerpoint/2010/main" val="1529323490"/>
+        <p14:creationId xmlns:p14="http://schemas.microsoft.com/office/powerpoint/2010/main" val="1907371644"/>
       </p:ext>
     </p:extLst>
   </p:cSld>
@@ -9551,7 +10783,7 @@
           <p:cNvPr id="6" name="">
             <a:extLst xmlns:a="http://schemas.openxmlformats.org/drawingml/2006/main">
               <a:ext uri="{FF2B5EF4-FFF2-40B4-BE49-F238E27FC236}">
-                <a16:creationId xmlns:a16="http://schemas.microsoft.com/office/drawing/2014/main" id="{E2EB5AEC-AA4F-4AEB-A5DA-EEFF6EF355BF}"/>
+                <a16:creationId xmlns:a16="http://schemas.microsoft.com/office/drawing/2014/main" id="{6738305E-7F4F-469E-B019-E01F0F6F9187}"/>
               </a:ext>
             </a:extLst>
           </p:cNvPr>
@@ -9615,7 +10847,7 @@
         </p:xfrm>
         <a:graphic xmlns:a="http://schemas.openxmlformats.org/drawingml/2006/main">
           <a:graphicData uri="http://schemas.openxmlformats.org/drawingml/2006/chart">
-            <c:chart xmlns:r="http://schemas.openxmlformats.org/officeDocument/2006/relationships" xmlns:c="http://schemas.openxmlformats.org/drawingml/2006/chart" r:id="Rc4f5d9b7c6af4e30"/>
+            <c:chart xmlns:r="http://schemas.openxmlformats.org/officeDocument/2006/relationships" xmlns:c="http://schemas.openxmlformats.org/drawingml/2006/chart" r:id="R4bbc1c64c8264d10"/>
           </a:graphicData>
         </a:graphic>
       </p:graphicFrame>
@@ -9624,7 +10856,7 @@
           <p:cNvPr id="3" name="">
             <a:extLst xmlns:a="http://schemas.openxmlformats.org/drawingml/2006/main">
               <a:ext uri="{FF2B5EF4-FFF2-40B4-BE49-F238E27FC236}">
-                <a16:creationId xmlns:a16="http://schemas.microsoft.com/office/drawing/2014/main" id="{592D78CE-0D75-4DA1-8561-F82BE489C4B7}"/>
+                <a16:creationId xmlns:a16="http://schemas.microsoft.com/office/drawing/2014/main" id="{EFA6CB74-2F77-48A5-906E-0D41D2B0A12B}"/>
               </a:ext>
             </a:extLst>
           </p:cNvPr>
@@ -9671,7 +10903,7 @@
                 <a:ea typeface="Helvetica Neue"/>
                 <a:cs typeface="Helvetica Neue"/>
               </a:rPr>
-              <a:t>All conditions contain 719 units. Uncertainty may help a user.</a:t>
+              <a:t>100% stacked bars: percentage of 719 units per condition</a:t>
             </a:r>
           </a:p>
         </p:txBody>
@@ -9681,7 +10913,7 @@
           <p:cNvPr id="4" name="">
             <a:extLst xmlns:a="http://schemas.openxmlformats.org/drawingml/2006/main">
               <a:ext uri="{FF2B5EF4-FFF2-40B4-BE49-F238E27FC236}">
-                <a16:creationId xmlns:a16="http://schemas.microsoft.com/office/drawing/2014/main" id="{BB83C00C-6CE2-4CE1-8F33-C98B487E7249}"/>
+                <a16:creationId xmlns:a16="http://schemas.microsoft.com/office/drawing/2014/main" id="{690E1C1F-D2D8-48B7-A046-68A5620D6F7A}"/>
               </a:ext>
             </a:extLst>
           </p:cNvPr>
@@ -9728,7 +10960,7 @@
                 <a:ea typeface="Helvetica Neue"/>
                 <a:cs typeface="Helvetica Neue"/>
               </a:rPr>
-              <a:t>A correct answer or a claim of verification does not prove evidence was checked.</a:t>
+              <a:t>Correct, wrong and abstaining outputs remain separate outcomes.</a:t>
             </a:r>
           </a:p>
         </p:txBody>
@@ -9738,7 +10970,7 @@
           <p:cNvPr id="5" name="">
             <a:extLst xmlns:a="http://schemas.openxmlformats.org/drawingml/2006/main">
               <a:ext uri="{FF2B5EF4-FFF2-40B4-BE49-F238E27FC236}">
-                <a16:creationId xmlns:a16="http://schemas.microsoft.com/office/drawing/2014/main" id="{227EE52E-939A-447B-93F9-0F77054949A8}"/>
+                <a16:creationId xmlns:a16="http://schemas.microsoft.com/office/drawing/2014/main" id="{7E3AC62B-F822-4B56-AD9A-CC2A890362D8}"/>
               </a:ext>
             </a:extLst>
           </p:cNvPr>
@@ -9793,7 +11025,7 @@
     </p:spTree>
     <p:extLst>
       <p:ext uri="{BB962C8B-B14F-4D97-AF65-F5344CB8AC3E}">
-        <p14:creationId xmlns:p14="http://schemas.microsoft.com/office/powerpoint/2010/main" val="1596679076"/>
+        <p14:creationId xmlns:p14="http://schemas.microsoft.com/office/powerpoint/2010/main" val="1170983894"/>
       </p:ext>
     </p:extLst>
   </p:cSld>

</xml_diff>

<commit_message>
Simplify core results to error-rate bar comparisons
</commit_message>
<xml_diff>
--- a/Submission_Pack/COMP2501_presentation.pptx
+++ b/Submission_Pack/COMP2501_presentation.pptx
@@ -2,28 +2,28 @@
 <file path=ppt/presentation.xml><?xml version="1.0" encoding="utf-8"?>
 <p:presentation xmlns:p="http://schemas.openxmlformats.org/presentationml/2006/main">
   <p:sldMasterIdLst>
-    <p:sldMasterId xmlns:r="http://schemas.openxmlformats.org/officeDocument/2006/relationships" id="2147483648" r:id="R1cebeb1b34524514"/>
+    <p:sldMasterId xmlns:r="http://schemas.openxmlformats.org/officeDocument/2006/relationships" id="2147483648" r:id="R183356e85d3b403a"/>
   </p:sldMasterIdLst>
   <p:notesMasterIdLst>
-    <p:notesMasterId xmlns:r="http://schemas.openxmlformats.org/officeDocument/2006/relationships" r:id="R875776c6fe3a4b28"/>
+    <p:notesMasterId xmlns:r="http://schemas.openxmlformats.org/officeDocument/2006/relationships" r:id="R3a446955fb7342b7"/>
   </p:notesMasterIdLst>
   <p:sldIdLst>
-    <p:sldId xmlns:r="http://schemas.openxmlformats.org/officeDocument/2006/relationships" id="256" r:id="R8dc19e59becf4692"/>
-    <p:sldId xmlns:r="http://schemas.openxmlformats.org/officeDocument/2006/relationships" id="257" r:id="R2df6b90cf886430e"/>
-    <p:sldId xmlns:r="http://schemas.openxmlformats.org/officeDocument/2006/relationships" id="258" r:id="R49f9837c795e4656"/>
-    <p:sldId xmlns:r="http://schemas.openxmlformats.org/officeDocument/2006/relationships" id="259" r:id="Ra37b237bdf354f85"/>
-    <p:sldId xmlns:r="http://schemas.openxmlformats.org/officeDocument/2006/relationships" id="260" r:id="R39c84e5acc8a46d9"/>
-    <p:sldId xmlns:r="http://schemas.openxmlformats.org/officeDocument/2006/relationships" id="261" r:id="Rc50ad27dee0e467a"/>
-    <p:sldId xmlns:r="http://schemas.openxmlformats.org/officeDocument/2006/relationships" id="262" r:id="Ref46506e5bc34b36"/>
-    <p:sldId xmlns:r="http://schemas.openxmlformats.org/officeDocument/2006/relationships" id="263" r:id="R2c4399f4f7484fd0"/>
-    <p:sldId xmlns:r="http://schemas.openxmlformats.org/officeDocument/2006/relationships" id="264" r:id="R78c9938c0bfa4239"/>
-    <p:sldId xmlns:r="http://schemas.openxmlformats.org/officeDocument/2006/relationships" id="265" r:id="R0d65cc650d2d4aa6"/>
-    <p:sldId xmlns:r="http://schemas.openxmlformats.org/officeDocument/2006/relationships" id="266" r:id="R8515a7c6164048a9"/>
-    <p:sldId xmlns:r="http://schemas.openxmlformats.org/officeDocument/2006/relationships" id="267" r:id="Re5babb91c73c4f11"/>
-    <p:sldId xmlns:r="http://schemas.openxmlformats.org/officeDocument/2006/relationships" id="268" r:id="Rf0be3d44bb7645a2"/>
-    <p:sldId xmlns:r="http://schemas.openxmlformats.org/officeDocument/2006/relationships" id="269" r:id="R1b42dcbd0adc44ca"/>
-    <p:sldId xmlns:r="http://schemas.openxmlformats.org/officeDocument/2006/relationships" id="270" r:id="R99577ee61c6f4721"/>
-    <p:sldId xmlns:r="http://schemas.openxmlformats.org/officeDocument/2006/relationships" id="271" r:id="Ra26f0da3544a440f"/>
+    <p:sldId xmlns:r="http://schemas.openxmlformats.org/officeDocument/2006/relationships" id="256" r:id="Re212f1b388254228"/>
+    <p:sldId xmlns:r="http://schemas.openxmlformats.org/officeDocument/2006/relationships" id="257" r:id="R1f9ad35683f94eb2"/>
+    <p:sldId xmlns:r="http://schemas.openxmlformats.org/officeDocument/2006/relationships" id="258" r:id="Rfdc6a94c14b44bdd"/>
+    <p:sldId xmlns:r="http://schemas.openxmlformats.org/officeDocument/2006/relationships" id="259" r:id="R8ef73499545249d8"/>
+    <p:sldId xmlns:r="http://schemas.openxmlformats.org/officeDocument/2006/relationships" id="260" r:id="Rb34b7d5e21e84f02"/>
+    <p:sldId xmlns:r="http://schemas.openxmlformats.org/officeDocument/2006/relationships" id="261" r:id="R906925638c8240c5"/>
+    <p:sldId xmlns:r="http://schemas.openxmlformats.org/officeDocument/2006/relationships" id="262" r:id="Ra3bbcdca71dd469b"/>
+    <p:sldId xmlns:r="http://schemas.openxmlformats.org/officeDocument/2006/relationships" id="263" r:id="R87572bc0929f492e"/>
+    <p:sldId xmlns:r="http://schemas.openxmlformats.org/officeDocument/2006/relationships" id="264" r:id="Rde233ccab5a74211"/>
+    <p:sldId xmlns:r="http://schemas.openxmlformats.org/officeDocument/2006/relationships" id="265" r:id="R11609b539953493d"/>
+    <p:sldId xmlns:r="http://schemas.openxmlformats.org/officeDocument/2006/relationships" id="266" r:id="R7d9bef7be68e4e78"/>
+    <p:sldId xmlns:r="http://schemas.openxmlformats.org/officeDocument/2006/relationships" id="267" r:id="R0a892994cc82414b"/>
+    <p:sldId xmlns:r="http://schemas.openxmlformats.org/officeDocument/2006/relationships" id="268" r:id="R7e4089d7ba0f4774"/>
+    <p:sldId xmlns:r="http://schemas.openxmlformats.org/officeDocument/2006/relationships" id="269" r:id="R249fb404d6344185"/>
+    <p:sldId xmlns:r="http://schemas.openxmlformats.org/officeDocument/2006/relationships" id="270" r:id="R9b65493b395a4b3b"/>
+    <p:sldId xmlns:r="http://schemas.openxmlformats.org/officeDocument/2006/relationships" id="271" r:id="Rff8d2f042a7b4183"/>
   </p:sldIdLst>
   <p:sldSz cx="12192000" cy="6858000"/>
   <p:notesSz cx="6858000" cy="9144000"/>
@@ -1397,7 +1397,7 @@
           <a:lstStyle xmlns:a="http://schemas.openxmlformats.org/drawingml/2006/main"/>
           <a:p xmlns:a="http://schemas.openxmlformats.org/drawingml/2006/main">
             <a:r>
-              <a:t>90 seconds. Read the forest plot: points show error-rate differences, horizontal segments show 95% question-cluster intervals, and zero means no difference. Negative values mean less error, not necessarily more correct answers. The exact values are printed on the right. Post-hoc analysis of all 719 paired units. Error rates are 46.04% for C0, 64.81% C1, 52.43% C2 and 35.88% C3. C1-C0 is +18.78 points [14.35,23.09], C2-C0 +6.40 [1.94,10.99], and C3-C2 -16.55 [-20.70,-12.38]. Pointwise exploratory intervals use 5000 question-cluster draws, seed 25011003. C0 minus initial error is +1.25 [-3.06,5.56]. The wrong-target counts are 11,251,147,58. C0 matching is spontaneous. These results do not support explanations being more harmful than wrong answers alone. </a:t>
+              <a:t>90 seconds. Read the two bar charts using their shared 0-100% vertical scale. The left compares C0/C1/C2: wrong input raises error. The right compares identical wrong material in C2/C3: structured checking lowers error. Error rate is wrong divided by correct plus wrong plus abstain; explicit abstentions count as non-errors for this metric but remain a separate outcome. Each denominator is 719. Values follow the existing final-answer score, not a guarantee that every explanation is factually correct. Statistical intervals are retained in the report supplement. Post-hoc analysis of all 719 paired units. Error rates are 46.04% for C0, 64.81% C1, 52.43% C2 and 35.88% C3. C1-C0 is +18.78 points [14.35,23.09], C2-C0 +6.40 [1.94,10.99], and C3-C2 -16.55 [-20.70,-12.38]. Pointwise exploratory intervals use 5000 question-cluster draws, seed 25011003. C0 minus initial error is +1.25 [-3.06,5.56]. The wrong-target counts are 11,251,147,58. C0 matching is spontaneous. These results do not support explanations being more harmful than wrong answers alone. </a:t>
             </a:r>
           </a:p>
           <a:p xmlns:a="http://schemas.openxmlformats.org/drawingml/2006/main">
@@ -1695,7 +1695,7 @@
   </p:cSld>
   <p:clrMap bg1="lt1" tx1="dk1" bg2="lt2" tx2="dk2" accent1="accent1" accent2="accent2" accent3="accent3" accent4="accent4" accent5="accent5" accent6="accent6" hlink="hlink" folHlink="folHlink"/>
   <p:sldLayoutIdLst>
-    <p:sldLayoutId xmlns:r="http://schemas.openxmlformats.org/officeDocument/2006/relationships" id="2147483649" r:id="R017ef42e8f994f52"/>
+    <p:sldLayoutId xmlns:r="http://schemas.openxmlformats.org/officeDocument/2006/relationships" id="2147483649" r:id="Rd959e20116a84a75"/>
   </p:sldLayoutIdLst>
   <p:txStyles>
     <p:titleStyle>
@@ -2391,519 +2391,86 @@
   <c:lang val="en-US"/>
   <c:chart>
     <c:plotArea>
-      <c:scatterChart>
-        <c:scatterStyle val="lineMarker"/>
+      <c:barChart>
+        <c:barDir val="col"/>
+        <c:grouping val="clustered"/>
+        <c:varyColors val="0"/>
         <c:ser>
           <c:idx val="0"/>
           <c:order val="0"/>
           <c:tx>
-            <c:v>No difference</c:v>
+            <c:v>Error rate</c:v>
           </c:tx>
           <c:spPr>
-            <a:ln xmlns:a="http://schemas.openxmlformats.org/drawingml/2006/main" w="9525">
-              <a:solidFill>
+            <a:solidFill xmlns:a="http://schemas.openxmlformats.org/drawingml/2006/main">
+              <a:srgbClr val="C45F48"/>
+            </a:solidFill>
+          </c:spPr>
+          <c:dPt>
+            <c:idx val="0"/>
+            <c:invertIfNegative val="0"/>
+            <c:spPr>
+              <a:solidFill xmlns:a="http://schemas.openxmlformats.org/drawingml/2006/main">
                 <a:srgbClr val="657586"/>
               </a:solidFill>
-            </a:ln>
-          </c:spPr>
-          <c:marker>
-            <c:symbol val="none"/>
-          </c:marker>
-          <c:xVal>
-            <c:numRef>
-              <c:f>'Chart Data'!$A$2:$A$3</c:f>
-              <c:numCache>
-                <c:formatCode>General</c:formatCode>
-                <c:ptCount val="2"/>
+            </c:spPr>
+          </c:dPt>
+          <c:dPt>
+            <c:idx val="1"/>
+            <c:invertIfNegative val="0"/>
+            <c:spPr>
+              <a:solidFill xmlns:a="http://schemas.openxmlformats.org/drawingml/2006/main">
+                <a:srgbClr val="C45F48"/>
+              </a:solidFill>
+            </c:spPr>
+          </c:dPt>
+          <c:dPt>
+            <c:idx val="2"/>
+            <c:invertIfNegative val="0"/>
+            <c:spPr>
+              <a:solidFill xmlns:a="http://schemas.openxmlformats.org/drawingml/2006/main">
+                <a:srgbClr val="C45F48"/>
+              </a:solidFill>
+            </c:spPr>
+          </c:dPt>
+          <c:cat>
+            <c:strRef>
+              <c:f>'Chart Data'!$A$2:$A$4</c:f>
+              <c:strCache>
+                <c:ptCount val="3"/>
                 <c:pt idx="0">
-                  <c:v>0</c:v>
+                  <c:v>C0 Neutral
+recheck</c:v>
                 </c:pt>
                 <c:pt idx="1">
-                  <c:v>0</c:v>
+                  <c:v>C1 Wrong
+answer</c:v>
+                </c:pt>
+                <c:pt idx="2">
+                  <c:v>C2 Wrong +
+reason</c:v>
+                </c:pt>
+              </c:strCache>
+            </c:strRef>
+          </c:cat>
+          <c:val>
+            <c:numRef>
+              <c:f>'Chart Data'!$B$2:$B$4</c:f>
+              <c:numCache>
+                <c:formatCode>0.00%</c:formatCode>
+                <c:ptCount val="3"/>
+                <c:pt idx="0">
+                  <c:v>0.460361613351878</c:v>
+                </c:pt>
+                <c:pt idx="1">
+                  <c:v>0.648122392211405</c:v>
+                </c:pt>
+                <c:pt idx="2">
+                  <c:v>0.524339360222531</c:v>
                 </c:pt>
               </c:numCache>
             </c:numRef>
-          </c:xVal>
-          <c:yVal>
-            <c:numRef>
-              <c:f>'Chart Data'!$B$2:$B$3</c:f>
-              <c:numCache>
-                <c:formatCode>General</c:formatCode>
-                <c:ptCount val="2"/>
-                <c:pt idx="0">
-                  <c:v>0</c:v>
-                </c:pt>
-                <c:pt idx="1">
-                  <c:v>6</c:v>
-                </c:pt>
-              </c:numCache>
-            </c:numRef>
-          </c:yVal>
-        </c:ser>
-        <c:ser>
-          <c:idx val="1"/>
-          <c:order val="1"/>
-          <c:tx>
-            <c:v>C0_vs_baseline interval</c:v>
-          </c:tx>
-          <c:spPr>
-            <a:ln xmlns:a="http://schemas.openxmlformats.org/drawingml/2006/main" w="28575">
-              <a:solidFill>
-                <a:srgbClr val="142C40"/>
-              </a:solidFill>
-            </a:ln>
-          </c:spPr>
-          <c:marker>
-            <c:symbol val="none"/>
-          </c:marker>
-          <c:xVal>
-            <c:numRef>
-              <c:f>'Chart Data'!$C$2:$C$3</c:f>
-              <c:numCache>
-                <c:formatCode>General</c:formatCode>
-                <c:ptCount val="2"/>
-                <c:pt idx="0">
-                  <c:v>-3.06406685236769</c:v>
-                </c:pt>
-                <c:pt idx="1">
-                  <c:v>5.56328233657858</c:v>
-                </c:pt>
-              </c:numCache>
-            </c:numRef>
-          </c:xVal>
-          <c:yVal>
-            <c:numRef>
-              <c:f>'Chart Data'!$D$2:$D$3</c:f>
-              <c:numCache>
-                <c:formatCode>General</c:formatCode>
-                <c:ptCount val="2"/>
-                <c:pt idx="0">
-                  <c:v>5</c:v>
-                </c:pt>
-                <c:pt idx="1">
-                  <c:v>5</c:v>
-                </c:pt>
-              </c:numCache>
-            </c:numRef>
-          </c:yVal>
-        </c:ser>
-        <c:ser>
-          <c:idx val="2"/>
-          <c:order val="2"/>
-          <c:tx>
-            <c:v>C0_vs_baseline</c:v>
-          </c:tx>
-          <c:spPr>
-            <a:solidFill xmlns:a="http://schemas.openxmlformats.org/drawingml/2006/main">
-              <a:srgbClr val="147E77"/>
-            </a:solidFill>
-            <a:ln xmlns:a="http://schemas.openxmlformats.org/drawingml/2006/main">
-              <a:noFill/>
-            </a:ln>
-          </c:spPr>
-          <c:marker>
-            <c:symbol val="circle"/>
-            <c:size val="9"/>
-            <c:spPr>
-              <a:noFill xmlns:a="http://schemas.openxmlformats.org/drawingml/2006/main"/>
-            </c:spPr>
-          </c:marker>
-          <c:xVal>
-            <c:numRef>
-              <c:f>'Chart Data'!$E$2:$E$2</c:f>
-              <c:numCache>
-                <c:formatCode>General</c:formatCode>
-                <c:ptCount val="1"/>
-                <c:pt idx="0">
-                  <c:v>1.25173852573018</c:v>
-                </c:pt>
-              </c:numCache>
-            </c:numRef>
-          </c:xVal>
-          <c:yVal>
-            <c:numRef>
-              <c:f>'Chart Data'!$F$2:$F$2</c:f>
-              <c:numCache>
-                <c:formatCode>General</c:formatCode>
-                <c:ptCount val="1"/>
-                <c:pt idx="0">
-                  <c:v>5</c:v>
-                </c:pt>
-              </c:numCache>
-            </c:numRef>
-          </c:yVal>
-        </c:ser>
-        <c:ser>
-          <c:idx val="3"/>
-          <c:order val="3"/>
-          <c:tx>
-            <c:v>C1_vs_C0 interval</c:v>
-          </c:tx>
-          <c:spPr>
-            <a:ln xmlns:a="http://schemas.openxmlformats.org/drawingml/2006/main" w="28575">
-              <a:solidFill>
-                <a:srgbClr val="142C40"/>
-              </a:solidFill>
-            </a:ln>
-          </c:spPr>
-          <c:marker>
-            <c:symbol val="none"/>
-          </c:marker>
-          <c:xVal>
-            <c:numRef>
-              <c:f>'Chart Data'!$G$2:$G$3</c:f>
-              <c:numCache>
-                <c:formatCode>General</c:formatCode>
-                <c:ptCount val="2"/>
-                <c:pt idx="0">
-                  <c:v>14.3454038997214</c:v>
-                </c:pt>
-                <c:pt idx="1">
-                  <c:v>23.0876216968011</c:v>
-                </c:pt>
-              </c:numCache>
-            </c:numRef>
-          </c:xVal>
-          <c:yVal>
-            <c:numRef>
-              <c:f>'Chart Data'!$H$2:$H$3</c:f>
-              <c:numCache>
-                <c:formatCode>General</c:formatCode>
-                <c:ptCount val="2"/>
-                <c:pt idx="0">
-                  <c:v>4</c:v>
-                </c:pt>
-                <c:pt idx="1">
-                  <c:v>4</c:v>
-                </c:pt>
-              </c:numCache>
-            </c:numRef>
-          </c:yVal>
-        </c:ser>
-        <c:ser>
-          <c:idx val="4"/>
-          <c:order val="4"/>
-          <c:tx>
-            <c:v>C1_vs_C0</c:v>
-          </c:tx>
-          <c:spPr>
-            <a:solidFill xmlns:a="http://schemas.openxmlformats.org/drawingml/2006/main">
-              <a:srgbClr val="147E77"/>
-            </a:solidFill>
-            <a:ln xmlns:a="http://schemas.openxmlformats.org/drawingml/2006/main">
-              <a:noFill/>
-            </a:ln>
-          </c:spPr>
-          <c:marker>
-            <c:symbol val="circle"/>
-            <c:size val="9"/>
-            <c:spPr>
-              <a:noFill xmlns:a="http://schemas.openxmlformats.org/drawingml/2006/main"/>
-            </c:spPr>
-          </c:marker>
-          <c:xVal>
-            <c:numRef>
-              <c:f>'Chart Data'!$I$2:$I$2</c:f>
-              <c:numCache>
-                <c:formatCode>General</c:formatCode>
-                <c:ptCount val="1"/>
-                <c:pt idx="0">
-                  <c:v>18.7760778859527</c:v>
-                </c:pt>
-              </c:numCache>
-            </c:numRef>
-          </c:xVal>
-          <c:yVal>
-            <c:numRef>
-              <c:f>'Chart Data'!$J$2:$J$2</c:f>
-              <c:numCache>
-                <c:formatCode>General</c:formatCode>
-                <c:ptCount val="1"/>
-                <c:pt idx="0">
-                  <c:v>4</c:v>
-                </c:pt>
-              </c:numCache>
-            </c:numRef>
-          </c:yVal>
-        </c:ser>
-        <c:ser>
-          <c:idx val="5"/>
-          <c:order val="5"/>
-          <c:tx>
-            <c:v>C2_vs_C0 interval</c:v>
-          </c:tx>
-          <c:spPr>
-            <a:ln xmlns:a="http://schemas.openxmlformats.org/drawingml/2006/main" w="28575">
-              <a:solidFill>
-                <a:srgbClr val="142C40"/>
-              </a:solidFill>
-            </a:ln>
-          </c:spPr>
-          <c:marker>
-            <c:symbol val="none"/>
-          </c:marker>
-          <c:xVal>
-            <c:numRef>
-              <c:f>'Chart Data'!$K$2:$K$3</c:f>
-              <c:numCache>
-                <c:formatCode>General</c:formatCode>
-                <c:ptCount val="2"/>
-                <c:pt idx="0">
-                  <c:v>1.94444444444445</c:v>
-                </c:pt>
-                <c:pt idx="1">
-                  <c:v>10.9874826147427</c:v>
-                </c:pt>
-              </c:numCache>
-            </c:numRef>
-          </c:xVal>
-          <c:yVal>
-            <c:numRef>
-              <c:f>'Chart Data'!$L$2:$L$3</c:f>
-              <c:numCache>
-                <c:formatCode>General</c:formatCode>
-                <c:ptCount val="2"/>
-                <c:pt idx="0">
-                  <c:v>3</c:v>
-                </c:pt>
-                <c:pt idx="1">
-                  <c:v>3</c:v>
-                </c:pt>
-              </c:numCache>
-            </c:numRef>
-          </c:yVal>
-        </c:ser>
-        <c:ser>
-          <c:idx val="6"/>
-          <c:order val="6"/>
-          <c:tx>
-            <c:v>C2_vs_C0</c:v>
-          </c:tx>
-          <c:spPr>
-            <a:solidFill xmlns:a="http://schemas.openxmlformats.org/drawingml/2006/main">
-              <a:srgbClr val="147E77"/>
-            </a:solidFill>
-            <a:ln xmlns:a="http://schemas.openxmlformats.org/drawingml/2006/main">
-              <a:noFill/>
-            </a:ln>
-          </c:spPr>
-          <c:marker>
-            <c:symbol val="circle"/>
-            <c:size val="9"/>
-            <c:spPr>
-              <a:noFill xmlns:a="http://schemas.openxmlformats.org/drawingml/2006/main"/>
-            </c:spPr>
-          </c:marker>
-          <c:xVal>
-            <c:numRef>
-              <c:f>'Chart Data'!$M$2:$M$2</c:f>
-              <c:numCache>
-                <c:formatCode>General</c:formatCode>
-                <c:ptCount val="1"/>
-                <c:pt idx="0">
-                  <c:v>6.39777468706536</c:v>
-                </c:pt>
-              </c:numCache>
-            </c:numRef>
-          </c:xVal>
-          <c:yVal>
-            <c:numRef>
-              <c:f>'Chart Data'!$N$2:$N$2</c:f>
-              <c:numCache>
-                <c:formatCode>General</c:formatCode>
-                <c:ptCount val="1"/>
-                <c:pt idx="0">
-                  <c:v>3</c:v>
-                </c:pt>
-              </c:numCache>
-            </c:numRef>
-          </c:yVal>
-        </c:ser>
-        <c:ser>
-          <c:idx val="7"/>
-          <c:order val="7"/>
-          <c:tx>
-            <c:v>C3_vs_C2 interval</c:v>
-          </c:tx>
-          <c:spPr>
-            <a:ln xmlns:a="http://schemas.openxmlformats.org/drawingml/2006/main" w="28575">
-              <a:solidFill>
-                <a:srgbClr val="142C40"/>
-              </a:solidFill>
-            </a:ln>
-          </c:spPr>
-          <c:marker>
-            <c:symbol val="none"/>
-          </c:marker>
-          <c:xVal>
-            <c:numRef>
-              <c:f>'Chart Data'!$O$2:$O$3</c:f>
-              <c:numCache>
-                <c:formatCode>General</c:formatCode>
-                <c:ptCount val="2"/>
-                <c:pt idx="0">
-                  <c:v>-20.6951640009272</c:v>
-                </c:pt>
-                <c:pt idx="1">
-                  <c:v>-12.3783031988873</c:v>
-                </c:pt>
-              </c:numCache>
-            </c:numRef>
-          </c:xVal>
-          <c:yVal>
-            <c:numRef>
-              <c:f>'Chart Data'!$P$2:$P$3</c:f>
-              <c:numCache>
-                <c:formatCode>General</c:formatCode>
-                <c:ptCount val="2"/>
-                <c:pt idx="0">
-                  <c:v>2</c:v>
-                </c:pt>
-                <c:pt idx="1">
-                  <c:v>2</c:v>
-                </c:pt>
-              </c:numCache>
-            </c:numRef>
-          </c:yVal>
-        </c:ser>
-        <c:ser>
-          <c:idx val="8"/>
-          <c:order val="8"/>
-          <c:tx>
-            <c:v>C3_vs_C2</c:v>
-          </c:tx>
-          <c:spPr>
-            <a:solidFill xmlns:a="http://schemas.openxmlformats.org/drawingml/2006/main">
-              <a:srgbClr val="147E77"/>
-            </a:solidFill>
-            <a:ln xmlns:a="http://schemas.openxmlformats.org/drawingml/2006/main">
-              <a:noFill/>
-            </a:ln>
-          </c:spPr>
-          <c:marker>
-            <c:symbol val="circle"/>
-            <c:size val="9"/>
-            <c:spPr>
-              <a:noFill xmlns:a="http://schemas.openxmlformats.org/drawingml/2006/main"/>
-            </c:spPr>
-          </c:marker>
-          <c:xVal>
-            <c:numRef>
-              <c:f>'Chart Data'!$Q$2:$Q$2</c:f>
-              <c:numCache>
-                <c:formatCode>General</c:formatCode>
-                <c:ptCount val="1"/>
-                <c:pt idx="0">
-                  <c:v>-16.5507649513213</c:v>
-                </c:pt>
-              </c:numCache>
-            </c:numRef>
-          </c:xVal>
-          <c:yVal>
-            <c:numRef>
-              <c:f>'Chart Data'!$R$2:$R$2</c:f>
-              <c:numCache>
-                <c:formatCode>General</c:formatCode>
-                <c:ptCount val="1"/>
-                <c:pt idx="0">
-                  <c:v>2</c:v>
-                </c:pt>
-              </c:numCache>
-            </c:numRef>
-          </c:yVal>
-        </c:ser>
-        <c:ser>
-          <c:idx val="9"/>
-          <c:order val="9"/>
-          <c:tx>
-            <c:v>C5_vs_C4 interval</c:v>
-          </c:tx>
-          <c:spPr>
-            <a:ln xmlns:a="http://schemas.openxmlformats.org/drawingml/2006/main" w="28575">
-              <a:solidFill>
-                <a:srgbClr val="142C40"/>
-              </a:solidFill>
-            </a:ln>
-          </c:spPr>
-          <c:marker>
-            <c:symbol val="none"/>
-          </c:marker>
-          <c:xVal>
-            <c:numRef>
-              <c:f>'Chart Data'!$S$2:$S$3</c:f>
-              <c:numCache>
-                <c:formatCode>General</c:formatCode>
-                <c:ptCount val="2"/>
-                <c:pt idx="0">
-                  <c:v>-7.37134909596662</c:v>
-                </c:pt>
-                <c:pt idx="1">
-                  <c:v>-2.22222222222222</c:v>
-                </c:pt>
-              </c:numCache>
-            </c:numRef>
-          </c:xVal>
-          <c:yVal>
-            <c:numRef>
-              <c:f>'Chart Data'!$T$2:$T$3</c:f>
-              <c:numCache>
-                <c:formatCode>General</c:formatCode>
-                <c:ptCount val="2"/>
-                <c:pt idx="0">
-                  <c:v>1</c:v>
-                </c:pt>
-                <c:pt idx="1">
-                  <c:v>1</c:v>
-                </c:pt>
-              </c:numCache>
-            </c:numRef>
-          </c:yVal>
-        </c:ser>
-        <c:ser>
-          <c:idx val="10"/>
-          <c:order val="10"/>
-          <c:tx>
-            <c:v>C5_vs_C4</c:v>
-          </c:tx>
-          <c:spPr>
-            <a:solidFill xmlns:a="http://schemas.openxmlformats.org/drawingml/2006/main">
-              <a:srgbClr val="147E77"/>
-            </a:solidFill>
-            <a:ln xmlns:a="http://schemas.openxmlformats.org/drawingml/2006/main">
-              <a:noFill/>
-            </a:ln>
-          </c:spPr>
-          <c:marker>
-            <c:symbol val="circle"/>
-            <c:size val="9"/>
-            <c:spPr>
-              <a:noFill xmlns:a="http://schemas.openxmlformats.org/drawingml/2006/main"/>
-            </c:spPr>
-          </c:marker>
-          <c:xVal>
-            <c:numRef>
-              <c:f>'Chart Data'!$U$2:$U$2</c:f>
-              <c:numCache>
-                <c:formatCode>General</c:formatCode>
-                <c:ptCount val="1"/>
-                <c:pt idx="0">
-                  <c:v>-4.72878998609179</c:v>
-                </c:pt>
-              </c:numCache>
-            </c:numRef>
-          </c:xVal>
-          <c:yVal>
-            <c:numRef>
-              <c:f>'Chart Data'!$V$2:$V$2</c:f>
-              <c:numCache>
-                <c:formatCode>General</c:formatCode>
-                <c:ptCount val="1"/>
-                <c:pt idx="0">
-                  <c:v>1</c:v>
-                </c:pt>
-              </c:numCache>
-            </c:numRef>
-          </c:yVal>
+          </c:val>
         </c:ser>
         <c:dLbls>
           <c:txPr>
@@ -2911,7 +2478,7 @@
             <a:lstStyle xmlns:a="http://schemas.openxmlformats.org/drawingml/2006/main"/>
             <a:p xmlns:a="http://schemas.openxmlformats.org/drawingml/2006/main">
               <a:pPr>
-                <a:defRPr>
+                <a:defRPr sz="1875" b="1">
                   <a:latin typeface="Helvetica Neue"/>
                   <a:ea typeface="Helvetica Neue"/>
                   <a:cs typeface="Helvetica Neue"/>
@@ -2919,8 +2486,9 @@
               </a:pPr>
             </a:p>
           </c:txPr>
+          <c:dLblPos val="outEnd"/>
           <c:showLegendKey val="0"/>
-          <c:showVal val="0"/>
+          <c:showVal val="1"/>
           <c:showCatName val="0"/>
           <c:showSerName val="0"/>
           <c:showPercent val="0"/>
@@ -2929,53 +2497,15 @@
         </c:dLbls>
         <c:axId val="48650112"/>
         <c:axId val="48672768"/>
-      </c:scatterChart>
-      <c:valAx>
-        <c:axId val="48672768"/>
-        <c:scaling>
-          <c:orientation val="minMax"/>
-          <c:max val="6"/>
-          <c:min val="0"/>
-        </c:scaling>
-        <c:delete val="0"/>
-        <c:axPos val="l"/>
-        <c:numFmt formatCode="General"/>
-        <c:majorTickMark val="none"/>
-        <c:minorTickMark val="none"/>
-        <c:tickLblPos val="none"/>
-        <c:spPr>
-          <a:ln xmlns:a="http://schemas.openxmlformats.org/drawingml/2006/main">
-            <a:noFill/>
-          </a:ln>
-        </c:spPr>
-        <c:txPr>
-          <a:bodyPr xmlns:a="http://schemas.openxmlformats.org/drawingml/2006/main" anchorCtr="1"/>
-          <a:lstStyle xmlns:a="http://schemas.openxmlformats.org/drawingml/2006/main"/>
-          <a:p xmlns:a="http://schemas.openxmlformats.org/drawingml/2006/main">
-            <a:pPr>
-              <a:defRPr>
-                <a:solidFill>
-                  <a:srgbClr val="666666"/>
-                </a:solidFill>
-                <a:latin typeface="Helvetica Neue"/>
-                <a:ea typeface="Helvetica Neue"/>
-                <a:cs typeface="Helvetica Neue"/>
-              </a:defRPr>
-            </a:pPr>
-          </a:p>
-        </c:txPr>
-        <c:crossAx val="48650112"/>
-      </c:valAx>
-      <c:valAx>
+      </c:barChart>
+      <c:catAx>
         <c:axId val="48650112"/>
         <c:scaling>
           <c:orientation val="minMax"/>
-          <c:max val="25"/>
-          <c:min val="-25"/>
         </c:scaling>
         <c:delete val="0"/>
         <c:axPos val="b"/>
-        <c:numFmt formatCode="0"/>
+        <c:numFmt formatCode="General"/>
         <c:majorTickMark val="none"/>
         <c:minorTickMark val="none"/>
         <c:spPr>
@@ -2991,7 +2521,7 @@
           <a:lstStyle xmlns:a="http://schemas.openxmlformats.org/drawingml/2006/main"/>
           <a:p xmlns:a="http://schemas.openxmlformats.org/drawingml/2006/main">
             <a:pPr>
-              <a:defRPr sz="1425">
+              <a:defRPr sz="1575">
                 <a:solidFill>
                   <a:srgbClr val="666666"/>
                 </a:solidFill>
@@ -3003,7 +2533,46 @@
           </a:p>
         </c:txPr>
         <c:crossAx val="48672768"/>
-        <c:majorUnit val="5"/>
+      </c:catAx>
+      <c:valAx>
+        <c:axId val="48672768"/>
+        <c:scaling>
+          <c:orientation val="minMax"/>
+          <c:max val="1"/>
+          <c:min val="0"/>
+        </c:scaling>
+        <c:delete val="0"/>
+        <c:axPos val="l"/>
+        <c:numFmt formatCode="0%"/>
+        <c:majorTickMark val="none"/>
+        <c:minorTickMark val="none"/>
+        <c:spPr>
+          <a:ln xmlns:a="http://schemas.openxmlformats.org/drawingml/2006/main" w="9525">
+            <a:solidFill>
+              <a:srgbClr val="D4D4D4"/>
+            </a:solidFill>
+            <a:prstDash val="solid"/>
+          </a:ln>
+        </c:spPr>
+        <c:txPr>
+          <a:bodyPr xmlns:a="http://schemas.openxmlformats.org/drawingml/2006/main" anchorCtr="1"/>
+          <a:lstStyle xmlns:a="http://schemas.openxmlformats.org/drawingml/2006/main"/>
+          <a:p xmlns:a="http://schemas.openxmlformats.org/drawingml/2006/main">
+            <a:pPr>
+              <a:defRPr sz="1575">
+                <a:solidFill>
+                  <a:srgbClr val="666666"/>
+                </a:solidFill>
+                <a:latin typeface="Helvetica Neue"/>
+                <a:ea typeface="Helvetica Neue"/>
+                <a:cs typeface="Helvetica Neue"/>
+              </a:defRPr>
+            </a:pPr>
+          </a:p>
+        </c:txPr>
+        <c:crossAx val="48650112"/>
+        <c:crossBetween val="between"/>
+        <c:majorUnit val="0.25"/>
       </c:valAx>
     </c:plotArea>
     <c:plotVisOnly val="1"/>
@@ -3015,6 +2584,187 @@
 </file>
 
 <file path=ppt/slides/charts/chart3.xml><?xml version="1.0" encoding="utf-8"?>
+<c:chartSpace xmlns:c="http://schemas.openxmlformats.org/drawingml/2006/chart" xmlns:r="http://schemas.openxmlformats.org/officeDocument/2006/relationships">
+  <c:lang val="en-US"/>
+  <c:chart>
+    <c:plotArea>
+      <c:barChart>
+        <c:barDir val="col"/>
+        <c:grouping val="clustered"/>
+        <c:varyColors val="0"/>
+        <c:ser>
+          <c:idx val="0"/>
+          <c:order val="0"/>
+          <c:tx>
+            <c:v>Error rate</c:v>
+          </c:tx>
+          <c:spPr>
+            <a:solidFill xmlns:a="http://schemas.openxmlformats.org/drawingml/2006/main">
+              <a:srgbClr val="C45F48"/>
+            </a:solidFill>
+          </c:spPr>
+          <c:dPt>
+            <c:idx val="0"/>
+            <c:invertIfNegative val="0"/>
+            <c:spPr>
+              <a:solidFill xmlns:a="http://schemas.openxmlformats.org/drawingml/2006/main">
+                <a:srgbClr val="C45F48"/>
+              </a:solidFill>
+            </c:spPr>
+          </c:dPt>
+          <c:dPt>
+            <c:idx val="1"/>
+            <c:invertIfNegative val="0"/>
+            <c:spPr>
+              <a:solidFill xmlns:a="http://schemas.openxmlformats.org/drawingml/2006/main">
+                <a:srgbClr val="147E77"/>
+              </a:solidFill>
+            </c:spPr>
+          </c:dPt>
+          <c:cat>
+            <c:strRef>
+              <c:f>'Chart Data'!$A$2:$A$3</c:f>
+              <c:strCache>
+                <c:ptCount val="2"/>
+                <c:pt idx="0">
+                  <c:v>C2 Ordinary
+recheck</c:v>
+                </c:pt>
+                <c:pt idx="1">
+                  <c:v>C3 Structured
+check</c:v>
+                </c:pt>
+              </c:strCache>
+            </c:strRef>
+          </c:cat>
+          <c:val>
+            <c:numRef>
+              <c:f>'Chart Data'!$B$2:$B$3</c:f>
+              <c:numCache>
+                <c:formatCode>0.00%</c:formatCode>
+                <c:ptCount val="2"/>
+                <c:pt idx="0">
+                  <c:v>0.524339360222531</c:v>
+                </c:pt>
+                <c:pt idx="1">
+                  <c:v>0.358831710709319</c:v>
+                </c:pt>
+              </c:numCache>
+            </c:numRef>
+          </c:val>
+        </c:ser>
+        <c:dLbls>
+          <c:txPr>
+            <a:bodyPr xmlns:a="http://schemas.openxmlformats.org/drawingml/2006/main" anchorCtr="1"/>
+            <a:lstStyle xmlns:a="http://schemas.openxmlformats.org/drawingml/2006/main"/>
+            <a:p xmlns:a="http://schemas.openxmlformats.org/drawingml/2006/main">
+              <a:pPr>
+                <a:defRPr sz="1875" b="1">
+                  <a:latin typeface="Helvetica Neue"/>
+                  <a:ea typeface="Helvetica Neue"/>
+                  <a:cs typeface="Helvetica Neue"/>
+                </a:defRPr>
+              </a:pPr>
+            </a:p>
+          </c:txPr>
+          <c:dLblPos val="outEnd"/>
+          <c:showLegendKey val="0"/>
+          <c:showVal val="1"/>
+          <c:showCatName val="0"/>
+          <c:showSerName val="0"/>
+          <c:showPercent val="0"/>
+          <c:showBubbleSize val="0"/>
+          <c:showLeaderLines val="0"/>
+        </c:dLbls>
+        <c:axId val="48650112"/>
+        <c:axId val="48672768"/>
+      </c:barChart>
+      <c:catAx>
+        <c:axId val="48650112"/>
+        <c:scaling>
+          <c:orientation val="minMax"/>
+        </c:scaling>
+        <c:delete val="0"/>
+        <c:axPos val="b"/>
+        <c:numFmt formatCode="General"/>
+        <c:majorTickMark val="none"/>
+        <c:minorTickMark val="none"/>
+        <c:spPr>
+          <a:ln xmlns:a="http://schemas.openxmlformats.org/drawingml/2006/main" w="9525">
+            <a:solidFill>
+              <a:srgbClr val="D4D4D4"/>
+            </a:solidFill>
+            <a:prstDash val="solid"/>
+          </a:ln>
+        </c:spPr>
+        <c:txPr>
+          <a:bodyPr xmlns:a="http://schemas.openxmlformats.org/drawingml/2006/main" anchorCtr="1"/>
+          <a:lstStyle xmlns:a="http://schemas.openxmlformats.org/drawingml/2006/main"/>
+          <a:p xmlns:a="http://schemas.openxmlformats.org/drawingml/2006/main">
+            <a:pPr>
+              <a:defRPr sz="1575">
+                <a:solidFill>
+                  <a:srgbClr val="666666"/>
+                </a:solidFill>
+                <a:latin typeface="Helvetica Neue"/>
+                <a:ea typeface="Helvetica Neue"/>
+                <a:cs typeface="Helvetica Neue"/>
+              </a:defRPr>
+            </a:pPr>
+          </a:p>
+        </c:txPr>
+        <c:crossAx val="48672768"/>
+      </c:catAx>
+      <c:valAx>
+        <c:axId val="48672768"/>
+        <c:scaling>
+          <c:orientation val="minMax"/>
+          <c:max val="1"/>
+          <c:min val="0"/>
+        </c:scaling>
+        <c:delete val="0"/>
+        <c:axPos val="l"/>
+        <c:numFmt formatCode="0%"/>
+        <c:majorTickMark val="none"/>
+        <c:minorTickMark val="none"/>
+        <c:spPr>
+          <a:ln xmlns:a="http://schemas.openxmlformats.org/drawingml/2006/main" w="9525">
+            <a:solidFill>
+              <a:srgbClr val="D4D4D4"/>
+            </a:solidFill>
+            <a:prstDash val="solid"/>
+          </a:ln>
+        </c:spPr>
+        <c:txPr>
+          <a:bodyPr xmlns:a="http://schemas.openxmlformats.org/drawingml/2006/main" anchorCtr="1"/>
+          <a:lstStyle xmlns:a="http://schemas.openxmlformats.org/drawingml/2006/main"/>
+          <a:p xmlns:a="http://schemas.openxmlformats.org/drawingml/2006/main">
+            <a:pPr>
+              <a:defRPr sz="1575">
+                <a:solidFill>
+                  <a:srgbClr val="666666"/>
+                </a:solidFill>
+                <a:latin typeface="Helvetica Neue"/>
+                <a:ea typeface="Helvetica Neue"/>
+                <a:cs typeface="Helvetica Neue"/>
+              </a:defRPr>
+            </a:pPr>
+          </a:p>
+        </c:txPr>
+        <c:crossAx val="48650112"/>
+        <c:crossBetween val="between"/>
+        <c:majorUnit val="0.25"/>
+      </c:valAx>
+    </c:plotArea>
+    <c:plotVisOnly val="1"/>
+  </c:chart>
+  <c:externalData r:id="rIdChartSnapshot1">
+    <c:autoUpdate val="0"/>
+  </c:externalData>
+</c:chartSpace>
+</file>
+
+<file path=ppt/slides/charts/chart4.xml><?xml version="1.0" encoding="utf-8"?>
 <c:chartSpace xmlns:c="http://schemas.openxmlformats.org/drawingml/2006/chart" xmlns:r="http://schemas.openxmlformats.org/officeDocument/2006/relationships">
   <c:lang val="en-US"/>
   <c:chart>
@@ -3172,7 +2922,7 @@
 </c:chartSpace>
 </file>
 
-<file path=ppt/slides/charts/chart4.xml><?xml version="1.0" encoding="utf-8"?>
+<file path=ppt/slides/charts/chart5.xml><?xml version="1.0" encoding="utf-8"?>
 <c:chartSpace xmlns:c="http://schemas.openxmlformats.org/drawingml/2006/chart" xmlns:r="http://schemas.openxmlformats.org/officeDocument/2006/relationships">
   <c:lang val="en-US"/>
   <c:chart>
@@ -3472,7 +3222,7 @@
 </c:chartSpace>
 </file>
 
-<file path=ppt/slides/charts/chart5.xml><?xml version="1.0" encoding="utf-8"?>
+<file path=ppt/slides/charts/chart6.xml><?xml version="1.0" encoding="utf-8"?>
 <c:chartSpace xmlns:c="http://schemas.openxmlformats.org/drawingml/2006/chart" xmlns:r="http://schemas.openxmlformats.org/officeDocument/2006/relationships">
   <c:lang val="en-US"/>
   <c:chart>
@@ -3644,7 +3394,7 @@
 </c:chartSpace>
 </file>
 
-<file path=ppt/slides/charts/chart6.xml><?xml version="1.0" encoding="utf-8"?>
+<file path=ppt/slides/charts/chart7.xml><?xml version="1.0" encoding="utf-8"?>
 <c:chartSpace xmlns:c="http://schemas.openxmlformats.org/drawingml/2006/chart" xmlns:r="http://schemas.openxmlformats.org/officeDocument/2006/relationships">
   <c:lang val="en-US"/>
   <c:chart>
@@ -3856,7 +3606,7 @@
           <p:cNvPr id="7" name="">
             <a:extLst xmlns:a="http://schemas.openxmlformats.org/drawingml/2006/main">
               <a:ext uri="{FF2B5EF4-FFF2-40B4-BE49-F238E27FC236}">
-                <a16:creationId xmlns:a16="http://schemas.microsoft.com/office/drawing/2014/main" id="{45668D9D-8665-4E6E-8A98-7ED9C3689C75}"/>
+                <a16:creationId xmlns:a16="http://schemas.microsoft.com/office/drawing/2014/main" id="{B0CFC13B-0592-4506-8681-2F31ED29513A}"/>
               </a:ext>
             </a:extLst>
           </p:cNvPr>
@@ -3936,7 +3686,7 @@
           <p:cNvPr id="2" name="">
             <a:extLst xmlns:a="http://schemas.openxmlformats.org/drawingml/2006/main">
               <a:ext uri="{FF2B5EF4-FFF2-40B4-BE49-F238E27FC236}">
-                <a16:creationId xmlns:a16="http://schemas.microsoft.com/office/drawing/2014/main" id="{F5F5FA30-7127-441F-8B40-8D532F8893FB}"/>
+                <a16:creationId xmlns:a16="http://schemas.microsoft.com/office/drawing/2014/main" id="{DE028A09-4744-406D-AC53-EA971F0B4B16}"/>
               </a:ext>
             </a:extLst>
           </p:cNvPr>
@@ -3993,7 +3743,7 @@
           <p:cNvPr id="3" name="">
             <a:extLst xmlns:a="http://schemas.openxmlformats.org/drawingml/2006/main">
               <a:ext uri="{FF2B5EF4-FFF2-40B4-BE49-F238E27FC236}">
-                <a16:creationId xmlns:a16="http://schemas.microsoft.com/office/drawing/2014/main" id="{2A7D91DC-3CF6-491D-9D2E-564041E2C4A3}"/>
+                <a16:creationId xmlns:a16="http://schemas.microsoft.com/office/drawing/2014/main" id="{CA1C2347-8F7C-452D-B3AF-480F436D947A}"/>
               </a:ext>
             </a:extLst>
           </p:cNvPr>
@@ -4050,7 +3800,7 @@
           <p:cNvPr id="4" name="">
             <a:extLst xmlns:a="http://schemas.openxmlformats.org/drawingml/2006/main">
               <a:ext uri="{FF2B5EF4-FFF2-40B4-BE49-F238E27FC236}">
-                <a16:creationId xmlns:a16="http://schemas.microsoft.com/office/drawing/2014/main" id="{AEA2E4EB-B600-43AD-906C-113E84EA3C02}"/>
+                <a16:creationId xmlns:a16="http://schemas.microsoft.com/office/drawing/2014/main" id="{470D10B7-A520-475B-BC7E-57CAFE11EE81}"/>
               </a:ext>
             </a:extLst>
           </p:cNvPr>
@@ -4107,7 +3857,7 @@
           <p:cNvPr id="5" name="">
             <a:extLst xmlns:a="http://schemas.openxmlformats.org/drawingml/2006/main">
               <a:ext uri="{FF2B5EF4-FFF2-40B4-BE49-F238E27FC236}">
-                <a16:creationId xmlns:a16="http://schemas.microsoft.com/office/drawing/2014/main" id="{5D3A9123-2AEB-4E7E-AE4A-F8018CD199E0}"/>
+                <a16:creationId xmlns:a16="http://schemas.microsoft.com/office/drawing/2014/main" id="{9F9F4872-A717-406D-A89F-D15EB21A2731}"/>
               </a:ext>
             </a:extLst>
           </p:cNvPr>
@@ -4164,7 +3914,7 @@
           <p:cNvPr id="6" name="">
             <a:extLst xmlns:a="http://schemas.openxmlformats.org/drawingml/2006/main">
               <a:ext uri="{FF2B5EF4-FFF2-40B4-BE49-F238E27FC236}">
-                <a16:creationId xmlns:a16="http://schemas.microsoft.com/office/drawing/2014/main" id="{6DF54561-BF9D-4D00-81F4-3B0266A67A84}"/>
+                <a16:creationId xmlns:a16="http://schemas.microsoft.com/office/drawing/2014/main" id="{C71250C7-5FC4-447E-BF52-C67B0FD2A155}"/>
               </a:ext>
             </a:extLst>
           </p:cNvPr>
@@ -4219,7 +3969,7 @@
     </p:spTree>
     <p:extLst>
       <p:ext uri="{BB962C8B-B14F-4D97-AF65-F5344CB8AC3E}">
-        <p14:creationId xmlns:p14="http://schemas.microsoft.com/office/powerpoint/2010/main" val="511649868"/>
+        <p14:creationId xmlns:p14="http://schemas.microsoft.com/office/powerpoint/2010/main" val="1075213864"/>
       </p:ext>
     </p:extLst>
   </p:cSld>
@@ -4250,7 +4000,7 @@
           <p:cNvPr id="7" name="">
             <a:extLst xmlns:a="http://schemas.openxmlformats.org/drawingml/2006/main">
               <a:ext uri="{FF2B5EF4-FFF2-40B4-BE49-F238E27FC236}">
-                <a16:creationId xmlns:a16="http://schemas.microsoft.com/office/drawing/2014/main" id="{C694E23E-0511-4676-A87F-EADB8671DD41}"/>
+                <a16:creationId xmlns:a16="http://schemas.microsoft.com/office/drawing/2014/main" id="{69A83A01-87E5-4218-953B-1160C047D657}"/>
               </a:ext>
             </a:extLst>
           </p:cNvPr>
@@ -4307,7 +4057,7 @@
           <p:cNvPr id="2" name="">
             <a:extLst xmlns:a="http://schemas.openxmlformats.org/drawingml/2006/main">
               <a:ext uri="{FF2B5EF4-FFF2-40B4-BE49-F238E27FC236}">
-                <a16:creationId xmlns:a16="http://schemas.microsoft.com/office/drawing/2014/main" id="{25FC1BCB-8522-4F50-A78A-0AC5CE42841A}"/>
+                <a16:creationId xmlns:a16="http://schemas.microsoft.com/office/drawing/2014/main" id="{01107CBF-EE9B-469E-A014-C250AE7FAF7D}"/>
               </a:ext>
             </a:extLst>
           </p:cNvPr>
@@ -4586,7 +4336,7 @@
           <p:cNvPr id="4" name="">
             <a:extLst xmlns:a="http://schemas.openxmlformats.org/drawingml/2006/main">
               <a:ext uri="{FF2B5EF4-FFF2-40B4-BE49-F238E27FC236}">
-                <a16:creationId xmlns:a16="http://schemas.microsoft.com/office/drawing/2014/main" id="{84237B6D-CC1B-405D-AD42-52B23FE32663}"/>
+                <a16:creationId xmlns:a16="http://schemas.microsoft.com/office/drawing/2014/main" id="{8FF01CD0-6FA0-4950-A160-60C6FD589137}"/>
               </a:ext>
             </a:extLst>
           </p:cNvPr>
@@ -4643,7 +4393,7 @@
           <p:cNvPr id="5" name="">
             <a:extLst xmlns:a="http://schemas.openxmlformats.org/drawingml/2006/main">
               <a:ext uri="{FF2B5EF4-FFF2-40B4-BE49-F238E27FC236}">
-                <a16:creationId xmlns:a16="http://schemas.microsoft.com/office/drawing/2014/main" id="{BFC0568E-06D8-4714-AD10-78681BB7B867}"/>
+                <a16:creationId xmlns:a16="http://schemas.microsoft.com/office/drawing/2014/main" id="{38AAB2D8-D5FC-4EF4-8CC9-5C8E1ACEFA4B}"/>
               </a:ext>
             </a:extLst>
           </p:cNvPr>
@@ -4700,7 +4450,7 @@
           <p:cNvPr id="6" name="">
             <a:extLst xmlns:a="http://schemas.openxmlformats.org/drawingml/2006/main">
               <a:ext uri="{FF2B5EF4-FFF2-40B4-BE49-F238E27FC236}">
-                <a16:creationId xmlns:a16="http://schemas.microsoft.com/office/drawing/2014/main" id="{DCFF83F8-E7E5-4CDE-8CBF-76FF16D600B5}"/>
+                <a16:creationId xmlns:a16="http://schemas.microsoft.com/office/drawing/2014/main" id="{89B7869D-8D3D-45D3-BDA7-969A091CF916}"/>
               </a:ext>
             </a:extLst>
           </p:cNvPr>
@@ -4755,7 +4505,7 @@
     </p:spTree>
     <p:extLst>
       <p:ext uri="{BB962C8B-B14F-4D97-AF65-F5344CB8AC3E}">
-        <p14:creationId xmlns:p14="http://schemas.microsoft.com/office/powerpoint/2010/main" val="348781889"/>
+        <p14:creationId xmlns:p14="http://schemas.microsoft.com/office/powerpoint/2010/main" val="914328668"/>
       </p:ext>
     </p:extLst>
   </p:cSld>
@@ -4786,7 +4536,7 @@
           <p:cNvPr id="7" name="">
             <a:extLst xmlns:a="http://schemas.openxmlformats.org/drawingml/2006/main">
               <a:ext uri="{FF2B5EF4-FFF2-40B4-BE49-F238E27FC236}">
-                <a16:creationId xmlns:a16="http://schemas.microsoft.com/office/drawing/2014/main" id="{54A083DF-847A-4C1E-9BDE-53E8F204C3AC}"/>
+                <a16:creationId xmlns:a16="http://schemas.microsoft.com/office/drawing/2014/main" id="{0CA3D88A-895B-4154-8CD8-66DA5F5CFC7B}"/>
               </a:ext>
             </a:extLst>
           </p:cNvPr>
@@ -4843,7 +4593,7 @@
           <p:cNvPr id="2" name="">
             <a:extLst xmlns:a="http://schemas.openxmlformats.org/drawingml/2006/main">
               <a:ext uri="{FF2B5EF4-FFF2-40B4-BE49-F238E27FC236}">
-                <a16:creationId xmlns:a16="http://schemas.microsoft.com/office/drawing/2014/main" id="{793F6AB6-24F5-4DBA-B7B6-6D464A8083A6}"/>
+                <a16:creationId xmlns:a16="http://schemas.microsoft.com/office/drawing/2014/main" id="{C8228879-C0AF-47A6-9433-FCEB2EF26DEF}"/>
               </a:ext>
             </a:extLst>
           </p:cNvPr>
@@ -4907,7 +4657,7 @@
         </p:xfrm>
         <a:graphic xmlns:a="http://schemas.openxmlformats.org/drawingml/2006/main">
           <a:graphicData uri="http://schemas.openxmlformats.org/drawingml/2006/chart">
-            <c:chart xmlns:r="http://schemas.openxmlformats.org/officeDocument/2006/relationships" xmlns:c="http://schemas.openxmlformats.org/drawingml/2006/chart" r:id="R79f9165169384598"/>
+            <c:chart xmlns:r="http://schemas.openxmlformats.org/officeDocument/2006/relationships" xmlns:c="http://schemas.openxmlformats.org/drawingml/2006/chart" r:id="R2c66876ba7d44b63"/>
           </a:graphicData>
         </a:graphic>
       </p:graphicFrame>
@@ -4916,7 +4666,7 @@
           <p:cNvPr id="4" name="">
             <a:extLst xmlns:a="http://schemas.openxmlformats.org/drawingml/2006/main">
               <a:ext uri="{FF2B5EF4-FFF2-40B4-BE49-F238E27FC236}">
-                <a16:creationId xmlns:a16="http://schemas.microsoft.com/office/drawing/2014/main" id="{55633E05-97EC-4764-87D4-EA7DD7BD2104}"/>
+                <a16:creationId xmlns:a16="http://schemas.microsoft.com/office/drawing/2014/main" id="{86887113-148D-4D65-9588-81B5187AFC5A}"/>
               </a:ext>
             </a:extLst>
           </p:cNvPr>
@@ -4973,7 +4723,7 @@
           <p:cNvPr id="5" name="">
             <a:extLst xmlns:a="http://schemas.openxmlformats.org/drawingml/2006/main">
               <a:ext uri="{FF2B5EF4-FFF2-40B4-BE49-F238E27FC236}">
-                <a16:creationId xmlns:a16="http://schemas.microsoft.com/office/drawing/2014/main" id="{1B6A32CC-2900-424B-9134-AE1D246239BC}"/>
+                <a16:creationId xmlns:a16="http://schemas.microsoft.com/office/drawing/2014/main" id="{4C9F6BAB-4F13-4B52-8414-71498AB29EA3}"/>
               </a:ext>
             </a:extLst>
           </p:cNvPr>
@@ -5030,7 +4780,7 @@
           <p:cNvPr id="6" name="">
             <a:extLst xmlns:a="http://schemas.openxmlformats.org/drawingml/2006/main">
               <a:ext uri="{FF2B5EF4-FFF2-40B4-BE49-F238E27FC236}">
-                <a16:creationId xmlns:a16="http://schemas.microsoft.com/office/drawing/2014/main" id="{2A6293E9-AE41-4B5B-BBAF-B45A86B37670}"/>
+                <a16:creationId xmlns:a16="http://schemas.microsoft.com/office/drawing/2014/main" id="{6D0AD6C6-B75F-4A38-93F0-BAF04FCB46E1}"/>
               </a:ext>
             </a:extLst>
           </p:cNvPr>
@@ -5085,7 +4835,7 @@
     </p:spTree>
     <p:extLst>
       <p:ext uri="{BB962C8B-B14F-4D97-AF65-F5344CB8AC3E}">
-        <p14:creationId xmlns:p14="http://schemas.microsoft.com/office/powerpoint/2010/main" val="1266880308"/>
+        <p14:creationId xmlns:p14="http://schemas.microsoft.com/office/powerpoint/2010/main" val="1713454883"/>
       </p:ext>
     </p:extLst>
   </p:cSld>
@@ -5116,7 +4866,7 @@
           <p:cNvPr id="7" name="">
             <a:extLst xmlns:a="http://schemas.openxmlformats.org/drawingml/2006/main">
               <a:ext uri="{FF2B5EF4-FFF2-40B4-BE49-F238E27FC236}">
-                <a16:creationId xmlns:a16="http://schemas.microsoft.com/office/drawing/2014/main" id="{D1E4F57A-7168-4252-B1EF-61DA84207666}"/>
+                <a16:creationId xmlns:a16="http://schemas.microsoft.com/office/drawing/2014/main" id="{E28493F6-77BC-401E-8038-B6D1C789BE35}"/>
               </a:ext>
             </a:extLst>
           </p:cNvPr>
@@ -5173,7 +4923,7 @@
           <p:cNvPr id="2" name="">
             <a:extLst xmlns:a="http://schemas.openxmlformats.org/drawingml/2006/main">
               <a:ext uri="{FF2B5EF4-FFF2-40B4-BE49-F238E27FC236}">
-                <a16:creationId xmlns:a16="http://schemas.microsoft.com/office/drawing/2014/main" id="{BDDBB526-487B-4F3B-A84D-37DF689F48D8}"/>
+                <a16:creationId xmlns:a16="http://schemas.microsoft.com/office/drawing/2014/main" id="{C0BEBF85-3463-4046-BA20-7913AAE64050}"/>
               </a:ext>
             </a:extLst>
           </p:cNvPr>
@@ -5230,7 +4980,7 @@
           <p:cNvPr id="3" name="">
             <a:extLst xmlns:a="http://schemas.openxmlformats.org/drawingml/2006/main">
               <a:ext uri="{FF2B5EF4-FFF2-40B4-BE49-F238E27FC236}">
-                <a16:creationId xmlns:a16="http://schemas.microsoft.com/office/drawing/2014/main" id="{CE96665A-39B1-4566-A3CF-E7733B5FDB8D}"/>
+                <a16:creationId xmlns:a16="http://schemas.microsoft.com/office/drawing/2014/main" id="{3530B815-1ECB-405E-9680-7C718DC8BE3F}"/>
               </a:ext>
             </a:extLst>
           </p:cNvPr>
@@ -5287,7 +5037,7 @@
           <p:cNvPr id="4" name="">
             <a:extLst xmlns:a="http://schemas.openxmlformats.org/drawingml/2006/main">
               <a:ext uri="{FF2B5EF4-FFF2-40B4-BE49-F238E27FC236}">
-                <a16:creationId xmlns:a16="http://schemas.microsoft.com/office/drawing/2014/main" id="{D839B95A-D342-405B-AE99-A862D0C5D657}"/>
+                <a16:creationId xmlns:a16="http://schemas.microsoft.com/office/drawing/2014/main" id="{C7E52E14-9735-4051-B3E3-0DFA8DDB911A}"/>
               </a:ext>
             </a:extLst>
           </p:cNvPr>
@@ -5344,7 +5094,7 @@
           <p:cNvPr id="5" name="">
             <a:extLst xmlns:a="http://schemas.openxmlformats.org/drawingml/2006/main">
               <a:ext uri="{FF2B5EF4-FFF2-40B4-BE49-F238E27FC236}">
-                <a16:creationId xmlns:a16="http://schemas.microsoft.com/office/drawing/2014/main" id="{ED3DC8E6-91DE-44A7-B68D-860A360C1229}"/>
+                <a16:creationId xmlns:a16="http://schemas.microsoft.com/office/drawing/2014/main" id="{7DB262B4-91E5-4C2E-9B08-90B43B946023}"/>
               </a:ext>
             </a:extLst>
           </p:cNvPr>
@@ -5401,7 +5151,7 @@
           <p:cNvPr id="6" name="">
             <a:extLst xmlns:a="http://schemas.openxmlformats.org/drawingml/2006/main">
               <a:ext uri="{FF2B5EF4-FFF2-40B4-BE49-F238E27FC236}">
-                <a16:creationId xmlns:a16="http://schemas.microsoft.com/office/drawing/2014/main" id="{A4478B9E-2469-44E1-AB1D-58FC4A0DA7A6}"/>
+                <a16:creationId xmlns:a16="http://schemas.microsoft.com/office/drawing/2014/main" id="{FE662A9B-87BC-4CB5-BDF7-C1F767F55BE7}"/>
               </a:ext>
             </a:extLst>
           </p:cNvPr>
@@ -5456,7 +5206,7 @@
     </p:spTree>
     <p:extLst>
       <p:ext uri="{BB962C8B-B14F-4D97-AF65-F5344CB8AC3E}">
-        <p14:creationId xmlns:p14="http://schemas.microsoft.com/office/powerpoint/2010/main" val="1086725950"/>
+        <p14:creationId xmlns:p14="http://schemas.microsoft.com/office/powerpoint/2010/main" val="17000610"/>
       </p:ext>
     </p:extLst>
   </p:cSld>
@@ -5487,7 +5237,7 @@
           <p:cNvPr id="6" name="">
             <a:extLst xmlns:a="http://schemas.openxmlformats.org/drawingml/2006/main">
               <a:ext uri="{FF2B5EF4-FFF2-40B4-BE49-F238E27FC236}">
-                <a16:creationId xmlns:a16="http://schemas.microsoft.com/office/drawing/2014/main" id="{83414D74-DD99-4F24-9014-7638EEC99990}"/>
+                <a16:creationId xmlns:a16="http://schemas.microsoft.com/office/drawing/2014/main" id="{5EFAE299-6A55-4FEE-AE36-7E245F85BE07}"/>
               </a:ext>
             </a:extLst>
           </p:cNvPr>
@@ -5551,7 +5301,7 @@
         </p:xfrm>
         <a:graphic xmlns:a="http://schemas.openxmlformats.org/drawingml/2006/main">
           <a:graphicData uri="http://schemas.openxmlformats.org/drawingml/2006/chart">
-            <c:chart xmlns:r="http://schemas.openxmlformats.org/officeDocument/2006/relationships" xmlns:c="http://schemas.openxmlformats.org/drawingml/2006/chart" r:id="R420c8460588c46b4"/>
+            <c:chart xmlns:r="http://schemas.openxmlformats.org/officeDocument/2006/relationships" xmlns:c="http://schemas.openxmlformats.org/drawingml/2006/chart" r:id="R685263203d3c4d49"/>
           </a:graphicData>
         </a:graphic>
       </p:graphicFrame>
@@ -5560,7 +5310,7 @@
           <p:cNvPr id="3" name="">
             <a:extLst xmlns:a="http://schemas.openxmlformats.org/drawingml/2006/main">
               <a:ext uri="{FF2B5EF4-FFF2-40B4-BE49-F238E27FC236}">
-                <a16:creationId xmlns:a16="http://schemas.microsoft.com/office/drawing/2014/main" id="{D2EF7B9A-E456-4E1F-A300-3EF041349E88}"/>
+                <a16:creationId xmlns:a16="http://schemas.microsoft.com/office/drawing/2014/main" id="{FB23E596-818E-4566-B99F-2D7735C35B6A}"/>
               </a:ext>
             </a:extLst>
           </p:cNvPr>
@@ -5617,7 +5367,7 @@
           <p:cNvPr id="4" name="">
             <a:extLst xmlns:a="http://schemas.openxmlformats.org/drawingml/2006/main">
               <a:ext uri="{FF2B5EF4-FFF2-40B4-BE49-F238E27FC236}">
-                <a16:creationId xmlns:a16="http://schemas.microsoft.com/office/drawing/2014/main" id="{D764B480-1CD7-4350-9094-E5EC84AEC167}"/>
+                <a16:creationId xmlns:a16="http://schemas.microsoft.com/office/drawing/2014/main" id="{D916D1A8-EB06-4F52-8579-3552B0999F7D}"/>
               </a:ext>
             </a:extLst>
           </p:cNvPr>
@@ -5674,7 +5424,7 @@
           <p:cNvPr id="5" name="">
             <a:extLst xmlns:a="http://schemas.openxmlformats.org/drawingml/2006/main">
               <a:ext uri="{FF2B5EF4-FFF2-40B4-BE49-F238E27FC236}">
-                <a16:creationId xmlns:a16="http://schemas.microsoft.com/office/drawing/2014/main" id="{9C8F9D57-A099-46D3-84D1-B135EA7DBF73}"/>
+                <a16:creationId xmlns:a16="http://schemas.microsoft.com/office/drawing/2014/main" id="{AA3BB1EC-DC41-490A-AB25-E26D664F0A46}"/>
               </a:ext>
             </a:extLst>
           </p:cNvPr>
@@ -5729,7 +5479,7 @@
     </p:spTree>
     <p:extLst>
       <p:ext uri="{BB962C8B-B14F-4D97-AF65-F5344CB8AC3E}">
-        <p14:creationId xmlns:p14="http://schemas.microsoft.com/office/powerpoint/2010/main" val="1562102700"/>
+        <p14:creationId xmlns:p14="http://schemas.microsoft.com/office/powerpoint/2010/main" val="242199506"/>
       </p:ext>
     </p:extLst>
   </p:cSld>
@@ -5760,7 +5510,7 @@
           <p:cNvPr id="7" name="">
             <a:extLst xmlns:a="http://schemas.openxmlformats.org/drawingml/2006/main">
               <a:ext uri="{FF2B5EF4-FFF2-40B4-BE49-F238E27FC236}">
-                <a16:creationId xmlns:a16="http://schemas.microsoft.com/office/drawing/2014/main" id="{F3BB5F8C-80D0-473C-BF31-BB51924874B5}"/>
+                <a16:creationId xmlns:a16="http://schemas.microsoft.com/office/drawing/2014/main" id="{FE61BA68-50F2-4C8E-8AFB-0C17DC84EDE2}"/>
               </a:ext>
             </a:extLst>
           </p:cNvPr>
@@ -5817,7 +5567,7 @@
           <p:cNvPr id="2" name="">
             <a:extLst xmlns:a="http://schemas.openxmlformats.org/drawingml/2006/main">
               <a:ext uri="{FF2B5EF4-FFF2-40B4-BE49-F238E27FC236}">
-                <a16:creationId xmlns:a16="http://schemas.microsoft.com/office/drawing/2014/main" id="{A0F80704-CC01-4579-BD40-477D4612E3E0}"/>
+                <a16:creationId xmlns:a16="http://schemas.microsoft.com/office/drawing/2014/main" id="{4C6091A1-E06D-4D0B-B90A-8A7292ED5EA8}"/>
               </a:ext>
             </a:extLst>
           </p:cNvPr>
@@ -5874,7 +5624,7 @@
           <p:cNvPr id="3" name="">
             <a:extLst xmlns:a="http://schemas.openxmlformats.org/drawingml/2006/main">
               <a:ext uri="{FF2B5EF4-FFF2-40B4-BE49-F238E27FC236}">
-                <a16:creationId xmlns:a16="http://schemas.microsoft.com/office/drawing/2014/main" id="{25B750A0-BD4A-450D-8FE8-FEC72E4B670B}"/>
+                <a16:creationId xmlns:a16="http://schemas.microsoft.com/office/drawing/2014/main" id="{45C036C9-A0D1-4E58-8114-B31461592CB1}"/>
               </a:ext>
             </a:extLst>
           </p:cNvPr>
@@ -5931,7 +5681,7 @@
           <p:cNvPr id="4" name="">
             <a:extLst xmlns:a="http://schemas.openxmlformats.org/drawingml/2006/main">
               <a:ext uri="{FF2B5EF4-FFF2-40B4-BE49-F238E27FC236}">
-                <a16:creationId xmlns:a16="http://schemas.microsoft.com/office/drawing/2014/main" id="{E418EDEE-753A-4F88-A489-CEA685D55DE1}"/>
+                <a16:creationId xmlns:a16="http://schemas.microsoft.com/office/drawing/2014/main" id="{C31D3AC2-DB9A-4CF9-93A1-66820B07DA7C}"/>
               </a:ext>
             </a:extLst>
           </p:cNvPr>
@@ -5988,7 +5738,7 @@
           <p:cNvPr id="5" name="">
             <a:extLst xmlns:a="http://schemas.openxmlformats.org/drawingml/2006/main">
               <a:ext uri="{FF2B5EF4-FFF2-40B4-BE49-F238E27FC236}">
-                <a16:creationId xmlns:a16="http://schemas.microsoft.com/office/drawing/2014/main" id="{DD566318-E4E0-403F-835C-D78DDE1C9EA7}"/>
+                <a16:creationId xmlns:a16="http://schemas.microsoft.com/office/drawing/2014/main" id="{09E1A8D4-D7A3-4473-8F71-7D1ED8C8613C}"/>
               </a:ext>
             </a:extLst>
           </p:cNvPr>
@@ -6045,7 +5795,7 @@
           <p:cNvPr id="6" name="">
             <a:extLst xmlns:a="http://schemas.openxmlformats.org/drawingml/2006/main">
               <a:ext uri="{FF2B5EF4-FFF2-40B4-BE49-F238E27FC236}">
-                <a16:creationId xmlns:a16="http://schemas.microsoft.com/office/drawing/2014/main" id="{78B960F3-5A7F-4040-A6A4-F1B5D9AFDA58}"/>
+                <a16:creationId xmlns:a16="http://schemas.microsoft.com/office/drawing/2014/main" id="{B35407B0-2D43-4C13-B93B-6E1B6BD4C1FC}"/>
               </a:ext>
             </a:extLst>
           </p:cNvPr>
@@ -6100,7 +5850,7 @@
     </p:spTree>
     <p:extLst>
       <p:ext uri="{BB962C8B-B14F-4D97-AF65-F5344CB8AC3E}">
-        <p14:creationId xmlns:p14="http://schemas.microsoft.com/office/powerpoint/2010/main" val="664290676"/>
+        <p14:creationId xmlns:p14="http://schemas.microsoft.com/office/powerpoint/2010/main" val="2139913440"/>
       </p:ext>
     </p:extLst>
   </p:cSld>
@@ -6131,7 +5881,7 @@
           <p:cNvPr id="7" name="">
             <a:extLst xmlns:a="http://schemas.openxmlformats.org/drawingml/2006/main">
               <a:ext uri="{FF2B5EF4-FFF2-40B4-BE49-F238E27FC236}">
-                <a16:creationId xmlns:a16="http://schemas.microsoft.com/office/drawing/2014/main" id="{E515C2BE-D77A-4046-AE09-A84CBE42D897}"/>
+                <a16:creationId xmlns:a16="http://schemas.microsoft.com/office/drawing/2014/main" id="{98F2C3A8-00EA-47F5-9E8B-097B924518EE}"/>
               </a:ext>
             </a:extLst>
           </p:cNvPr>
@@ -6188,7 +5938,7 @@
           <p:cNvPr id="2" name="">
             <a:extLst xmlns:a="http://schemas.openxmlformats.org/drawingml/2006/main">
               <a:ext uri="{FF2B5EF4-FFF2-40B4-BE49-F238E27FC236}">
-                <a16:creationId xmlns:a16="http://schemas.microsoft.com/office/drawing/2014/main" id="{7478C829-A697-4FD6-8AA4-C602963784F5}"/>
+                <a16:creationId xmlns:a16="http://schemas.microsoft.com/office/drawing/2014/main" id="{C771D17F-8E08-4313-B627-6EA61B4539B8}"/>
               </a:ext>
             </a:extLst>
           </p:cNvPr>
@@ -6245,7 +5995,7 @@
           <p:cNvPr id="3" name="">
             <a:extLst xmlns:a="http://schemas.openxmlformats.org/drawingml/2006/main">
               <a:ext uri="{FF2B5EF4-FFF2-40B4-BE49-F238E27FC236}">
-                <a16:creationId xmlns:a16="http://schemas.microsoft.com/office/drawing/2014/main" id="{0F3ED641-2CB6-4725-B4E9-64942D5ADF11}"/>
+                <a16:creationId xmlns:a16="http://schemas.microsoft.com/office/drawing/2014/main" id="{E13437DA-3D8D-41F6-9F83-FBEE76E328A5}"/>
               </a:ext>
             </a:extLst>
           </p:cNvPr>
@@ -6302,7 +6052,7 @@
           <p:cNvPr id="4" name="">
             <a:extLst xmlns:a="http://schemas.openxmlformats.org/drawingml/2006/main">
               <a:ext uri="{FF2B5EF4-FFF2-40B4-BE49-F238E27FC236}">
-                <a16:creationId xmlns:a16="http://schemas.microsoft.com/office/drawing/2014/main" id="{0122C58E-B503-466F-95B5-415071A0BFEB}"/>
+                <a16:creationId xmlns:a16="http://schemas.microsoft.com/office/drawing/2014/main" id="{D31C0187-6ECA-4DB9-937E-1674A44E92D5}"/>
               </a:ext>
             </a:extLst>
           </p:cNvPr>
@@ -6359,7 +6109,7 @@
           <p:cNvPr id="5" name="">
             <a:extLst xmlns:a="http://schemas.openxmlformats.org/drawingml/2006/main">
               <a:ext uri="{FF2B5EF4-FFF2-40B4-BE49-F238E27FC236}">
-                <a16:creationId xmlns:a16="http://schemas.microsoft.com/office/drawing/2014/main" id="{8C8CA8A7-B7BE-4BA7-B2DC-5ABC6008C9BD}"/>
+                <a16:creationId xmlns:a16="http://schemas.microsoft.com/office/drawing/2014/main" id="{753996A7-C001-451B-A347-DBC800E2FC9B}"/>
               </a:ext>
             </a:extLst>
           </p:cNvPr>
@@ -6416,7 +6166,7 @@
           <p:cNvPr id="6" name="">
             <a:extLst xmlns:a="http://schemas.openxmlformats.org/drawingml/2006/main">
               <a:ext uri="{FF2B5EF4-FFF2-40B4-BE49-F238E27FC236}">
-                <a16:creationId xmlns:a16="http://schemas.microsoft.com/office/drawing/2014/main" id="{406470D5-9BF9-413B-B96C-42CF965A4DB9}"/>
+                <a16:creationId xmlns:a16="http://schemas.microsoft.com/office/drawing/2014/main" id="{991B1D16-9B31-4EA1-8607-15345D33C3CF}"/>
               </a:ext>
             </a:extLst>
           </p:cNvPr>
@@ -6471,7 +6221,7 @@
     </p:spTree>
     <p:extLst>
       <p:ext uri="{BB962C8B-B14F-4D97-AF65-F5344CB8AC3E}">
-        <p14:creationId xmlns:p14="http://schemas.microsoft.com/office/powerpoint/2010/main" val="1638407733"/>
+        <p14:creationId xmlns:p14="http://schemas.microsoft.com/office/powerpoint/2010/main" val="136249587"/>
       </p:ext>
     </p:extLst>
   </p:cSld>
@@ -6502,7 +6252,7 @@
           <p:cNvPr id="9" name="">
             <a:extLst xmlns:a="http://schemas.openxmlformats.org/drawingml/2006/main">
               <a:ext uri="{FF2B5EF4-FFF2-40B4-BE49-F238E27FC236}">
-                <a16:creationId xmlns:a16="http://schemas.microsoft.com/office/drawing/2014/main" id="{66E34EA1-8280-47F5-8EAB-8D4A8C290010}"/>
+                <a16:creationId xmlns:a16="http://schemas.microsoft.com/office/drawing/2014/main" id="{D61B14CB-47C1-4F75-8AEF-7D3C1F3E6E84}"/>
               </a:ext>
             </a:extLst>
           </p:cNvPr>
@@ -6559,7 +6309,7 @@
           <p:cNvPr id="2" name="">
             <a:extLst xmlns:a="http://schemas.openxmlformats.org/drawingml/2006/main">
               <a:ext uri="{FF2B5EF4-FFF2-40B4-BE49-F238E27FC236}">
-                <a16:creationId xmlns:a16="http://schemas.microsoft.com/office/drawing/2014/main" id="{4FD23858-C5A0-449B-B66F-507E25EB59D9}"/>
+                <a16:creationId xmlns:a16="http://schemas.microsoft.com/office/drawing/2014/main" id="{9C30373F-852F-4C57-876B-EF546F4A8088}"/>
               </a:ext>
             </a:extLst>
           </p:cNvPr>
@@ -6616,7 +6366,7 @@
           <p:cNvPr id="3" name="">
             <a:extLst xmlns:a="http://schemas.openxmlformats.org/drawingml/2006/main">
               <a:ext uri="{FF2B5EF4-FFF2-40B4-BE49-F238E27FC236}">
-                <a16:creationId xmlns:a16="http://schemas.microsoft.com/office/drawing/2014/main" id="{C9CEF16C-8AB2-461B-A4EC-CED100D789BB}"/>
+                <a16:creationId xmlns:a16="http://schemas.microsoft.com/office/drawing/2014/main" id="{148D0F49-C275-4F8D-B659-F40A52398C7D}"/>
               </a:ext>
             </a:extLst>
           </p:cNvPr>
@@ -6673,7 +6423,7 @@
           <p:cNvPr id="4" name="">
             <a:extLst xmlns:a="http://schemas.openxmlformats.org/drawingml/2006/main">
               <a:ext uri="{FF2B5EF4-FFF2-40B4-BE49-F238E27FC236}">
-                <a16:creationId xmlns:a16="http://schemas.microsoft.com/office/drawing/2014/main" id="{C7601778-876A-4380-AA2E-46E218E827E7}"/>
+                <a16:creationId xmlns:a16="http://schemas.microsoft.com/office/drawing/2014/main" id="{6F02543F-374F-4C38-A63E-43E47857BDE8}"/>
               </a:ext>
             </a:extLst>
           </p:cNvPr>
@@ -6730,7 +6480,7 @@
           <p:cNvPr id="5" name="">
             <a:extLst xmlns:a="http://schemas.openxmlformats.org/drawingml/2006/main">
               <a:ext uri="{FF2B5EF4-FFF2-40B4-BE49-F238E27FC236}">
-                <a16:creationId xmlns:a16="http://schemas.microsoft.com/office/drawing/2014/main" id="{7FADEBB7-7FDE-4F73-A592-D3B01C2E0CB9}"/>
+                <a16:creationId xmlns:a16="http://schemas.microsoft.com/office/drawing/2014/main" id="{EE5FA604-7960-457D-86EC-DE5A9ADAD717}"/>
               </a:ext>
             </a:extLst>
           </p:cNvPr>
@@ -6787,7 +6537,7 @@
           <p:cNvPr id="6" name="">
             <a:extLst xmlns:a="http://schemas.openxmlformats.org/drawingml/2006/main">
               <a:ext uri="{FF2B5EF4-FFF2-40B4-BE49-F238E27FC236}">
-                <a16:creationId xmlns:a16="http://schemas.microsoft.com/office/drawing/2014/main" id="{4ACD083A-D0FD-4F47-978B-8D84E41A0BA1}"/>
+                <a16:creationId xmlns:a16="http://schemas.microsoft.com/office/drawing/2014/main" id="{2552CA78-D0BC-4B1C-9B7D-AC932D118B86}"/>
               </a:ext>
             </a:extLst>
           </p:cNvPr>
@@ -6844,7 +6594,7 @@
           <p:cNvPr id="7" name="">
             <a:extLst xmlns:a="http://schemas.openxmlformats.org/drawingml/2006/main">
               <a:ext uri="{FF2B5EF4-FFF2-40B4-BE49-F238E27FC236}">
-                <a16:creationId xmlns:a16="http://schemas.microsoft.com/office/drawing/2014/main" id="{103618C5-2527-4AC7-8C34-2A7C1814FB5C}"/>
+                <a16:creationId xmlns:a16="http://schemas.microsoft.com/office/drawing/2014/main" id="{5E1E3C8E-05D7-47BF-8A29-6CC0935E6E7E}"/>
               </a:ext>
             </a:extLst>
           </p:cNvPr>
@@ -6924,7 +6674,7 @@
           <p:cNvPr id="8" name="">
             <a:extLst xmlns:a="http://schemas.openxmlformats.org/drawingml/2006/main">
               <a:ext uri="{FF2B5EF4-FFF2-40B4-BE49-F238E27FC236}">
-                <a16:creationId xmlns:a16="http://schemas.microsoft.com/office/drawing/2014/main" id="{5A4CA1C4-7DDB-4471-8A50-67200BE17CEF}"/>
+                <a16:creationId xmlns:a16="http://schemas.microsoft.com/office/drawing/2014/main" id="{E57ED659-468C-465F-BE12-4C69C190FAE1}"/>
               </a:ext>
             </a:extLst>
           </p:cNvPr>
@@ -6979,7 +6729,7 @@
     </p:spTree>
     <p:extLst>
       <p:ext uri="{BB962C8B-B14F-4D97-AF65-F5344CB8AC3E}">
-        <p14:creationId xmlns:p14="http://schemas.microsoft.com/office/powerpoint/2010/main" val="710976380"/>
+        <p14:creationId xmlns:p14="http://schemas.microsoft.com/office/powerpoint/2010/main" val="1883925320"/>
       </p:ext>
     </p:extLst>
   </p:cSld>
@@ -7010,7 +6760,7 @@
           <p:cNvPr id="7" name="">
             <a:extLst xmlns:a="http://schemas.openxmlformats.org/drawingml/2006/main">
               <a:ext uri="{FF2B5EF4-FFF2-40B4-BE49-F238E27FC236}">
-                <a16:creationId xmlns:a16="http://schemas.microsoft.com/office/drawing/2014/main" id="{4F44123B-E559-4CB9-AEE5-4568F3A090CD}"/>
+                <a16:creationId xmlns:a16="http://schemas.microsoft.com/office/drawing/2014/main" id="{3D611B06-FCFB-436B-B938-DB319DB0805C}"/>
               </a:ext>
             </a:extLst>
           </p:cNvPr>
@@ -7067,7 +6817,7 @@
           <p:cNvPr id="2" name="">
             <a:extLst xmlns:a="http://schemas.openxmlformats.org/drawingml/2006/main">
               <a:ext uri="{FF2B5EF4-FFF2-40B4-BE49-F238E27FC236}">
-                <a16:creationId xmlns:a16="http://schemas.microsoft.com/office/drawing/2014/main" id="{8C68AE0B-F2F9-4C3B-BEAA-13B32FE4FAD4}"/>
+                <a16:creationId xmlns:a16="http://schemas.microsoft.com/office/drawing/2014/main" id="{758F7462-4A0D-4A1B-B250-4999FD6140BC}"/>
               </a:ext>
             </a:extLst>
           </p:cNvPr>
@@ -7124,7 +6874,7 @@
           <p:cNvPr id="3" name="">
             <a:extLst xmlns:a="http://schemas.openxmlformats.org/drawingml/2006/main">
               <a:ext uri="{FF2B5EF4-FFF2-40B4-BE49-F238E27FC236}">
-                <a16:creationId xmlns:a16="http://schemas.microsoft.com/office/drawing/2014/main" id="{0AEA7B88-B52D-41D7-906D-E0D1E28C0F8A}"/>
+                <a16:creationId xmlns:a16="http://schemas.microsoft.com/office/drawing/2014/main" id="{58D2F73C-BE5A-47EA-AE6A-2FD245C9867A}"/>
               </a:ext>
             </a:extLst>
           </p:cNvPr>
@@ -7181,7 +6931,7 @@
           <p:cNvPr id="4" name="">
             <a:extLst xmlns:a="http://schemas.openxmlformats.org/drawingml/2006/main">
               <a:ext uri="{FF2B5EF4-FFF2-40B4-BE49-F238E27FC236}">
-                <a16:creationId xmlns:a16="http://schemas.microsoft.com/office/drawing/2014/main" id="{660C0B69-EDD8-42FD-BB9E-D3516212D46B}"/>
+                <a16:creationId xmlns:a16="http://schemas.microsoft.com/office/drawing/2014/main" id="{DDDCCE79-BEF2-4F4D-B77F-4362C5AC30FD}"/>
               </a:ext>
             </a:extLst>
           </p:cNvPr>
@@ -7238,7 +6988,7 @@
           <p:cNvPr id="5" name="">
             <a:extLst xmlns:a="http://schemas.openxmlformats.org/drawingml/2006/main">
               <a:ext uri="{FF2B5EF4-FFF2-40B4-BE49-F238E27FC236}">
-                <a16:creationId xmlns:a16="http://schemas.microsoft.com/office/drawing/2014/main" id="{35FA0E34-12B7-42CE-88D9-7C9509B06B40}"/>
+                <a16:creationId xmlns:a16="http://schemas.microsoft.com/office/drawing/2014/main" id="{EB5AFA96-5F80-4424-A26C-5DDB09C8834E}"/>
               </a:ext>
             </a:extLst>
           </p:cNvPr>
@@ -7295,7 +7045,7 @@
           <p:cNvPr id="6" name="">
             <a:extLst xmlns:a="http://schemas.openxmlformats.org/drawingml/2006/main">
               <a:ext uri="{FF2B5EF4-FFF2-40B4-BE49-F238E27FC236}">
-                <a16:creationId xmlns:a16="http://schemas.microsoft.com/office/drawing/2014/main" id="{C21F07A2-72E3-429C-9B46-B582C3C4673B}"/>
+                <a16:creationId xmlns:a16="http://schemas.microsoft.com/office/drawing/2014/main" id="{F11B5919-0907-4C73-9552-22C4CF09A631}"/>
               </a:ext>
             </a:extLst>
           </p:cNvPr>
@@ -7350,7 +7100,7 @@
     </p:spTree>
     <p:extLst>
       <p:ext uri="{BB962C8B-B14F-4D97-AF65-F5344CB8AC3E}">
-        <p14:creationId xmlns:p14="http://schemas.microsoft.com/office/powerpoint/2010/main" val="1675870309"/>
+        <p14:creationId xmlns:p14="http://schemas.microsoft.com/office/powerpoint/2010/main" val="951466129"/>
       </p:ext>
     </p:extLst>
   </p:cSld>
@@ -7381,7 +7131,7 @@
           <p:cNvPr id="5" name="">
             <a:extLst xmlns:a="http://schemas.openxmlformats.org/drawingml/2006/main">
               <a:ext uri="{FF2B5EF4-FFF2-40B4-BE49-F238E27FC236}">
-                <a16:creationId xmlns:a16="http://schemas.microsoft.com/office/drawing/2014/main" id="{860E85B5-CD51-4983-96C4-4530E3D53855}"/>
+                <a16:creationId xmlns:a16="http://schemas.microsoft.com/office/drawing/2014/main" id="{80036298-15AA-45FA-812D-18CBE3ED0936}"/>
               </a:ext>
             </a:extLst>
           </p:cNvPr>
@@ -7979,7 +7729,7 @@
           <p:cNvPr id="3" name="">
             <a:extLst xmlns:a="http://schemas.openxmlformats.org/drawingml/2006/main">
               <a:ext uri="{FF2B5EF4-FFF2-40B4-BE49-F238E27FC236}">
-                <a16:creationId xmlns:a16="http://schemas.microsoft.com/office/drawing/2014/main" id="{D2674BC2-1CF7-4304-BDEE-5D4D3DC3EBC7}"/>
+                <a16:creationId xmlns:a16="http://schemas.microsoft.com/office/drawing/2014/main" id="{350C2500-90B9-47A2-A1A6-907FF4F61DA2}"/>
               </a:ext>
             </a:extLst>
           </p:cNvPr>
@@ -8036,7 +7786,7 @@
           <p:cNvPr id="4" name="">
             <a:extLst xmlns:a="http://schemas.openxmlformats.org/drawingml/2006/main">
               <a:ext uri="{FF2B5EF4-FFF2-40B4-BE49-F238E27FC236}">
-                <a16:creationId xmlns:a16="http://schemas.microsoft.com/office/drawing/2014/main" id="{BB147B02-D54C-4774-B94E-6FCBC97AEDC6}"/>
+                <a16:creationId xmlns:a16="http://schemas.microsoft.com/office/drawing/2014/main" id="{5DC2AF05-943E-4DE5-AE26-F6DA31F3653D}"/>
               </a:ext>
             </a:extLst>
           </p:cNvPr>
@@ -8091,7 +7841,7 @@
     </p:spTree>
     <p:extLst>
       <p:ext uri="{BB962C8B-B14F-4D97-AF65-F5344CB8AC3E}">
-        <p14:creationId xmlns:p14="http://schemas.microsoft.com/office/powerpoint/2010/main" val="1878844451"/>
+        <p14:creationId xmlns:p14="http://schemas.microsoft.com/office/powerpoint/2010/main" val="1435889497"/>
       </p:ext>
     </p:extLst>
   </p:cSld>
@@ -8122,7 +7872,7 @@
           <p:cNvPr id="7" name="">
             <a:extLst xmlns:a="http://schemas.openxmlformats.org/drawingml/2006/main">
               <a:ext uri="{FF2B5EF4-FFF2-40B4-BE49-F238E27FC236}">
-                <a16:creationId xmlns:a16="http://schemas.microsoft.com/office/drawing/2014/main" id="{95CE5142-87C1-4C87-B19F-CED6B6EE792A}"/>
+                <a16:creationId xmlns:a16="http://schemas.microsoft.com/office/drawing/2014/main" id="{A10E2641-CF38-43E1-89F0-943BDD088A4F}"/>
               </a:ext>
             </a:extLst>
           </p:cNvPr>
@@ -8179,7 +7929,7 @@
           <p:cNvPr id="2" name="">
             <a:extLst xmlns:a="http://schemas.openxmlformats.org/drawingml/2006/main">
               <a:ext uri="{FF2B5EF4-FFF2-40B4-BE49-F238E27FC236}">
-                <a16:creationId xmlns:a16="http://schemas.microsoft.com/office/drawing/2014/main" id="{25E265E8-07CD-4B26-A4A5-8DC10F0C8A7F}"/>
+                <a16:creationId xmlns:a16="http://schemas.microsoft.com/office/drawing/2014/main" id="{15802FCC-8E47-47A2-9D42-9812EC4A0A86}"/>
               </a:ext>
             </a:extLst>
           </p:cNvPr>
@@ -8236,7 +7986,7 @@
           <p:cNvPr id="3" name="">
             <a:extLst xmlns:a="http://schemas.openxmlformats.org/drawingml/2006/main">
               <a:ext uri="{FF2B5EF4-FFF2-40B4-BE49-F238E27FC236}">
-                <a16:creationId xmlns:a16="http://schemas.microsoft.com/office/drawing/2014/main" id="{8A9E4012-949B-41C7-AEBE-30B606FCE842}"/>
+                <a16:creationId xmlns:a16="http://schemas.microsoft.com/office/drawing/2014/main" id="{2B45CD6F-B571-4674-B8FB-A22DCA747084}"/>
               </a:ext>
             </a:extLst>
           </p:cNvPr>
@@ -8293,7 +8043,7 @@
           <p:cNvPr id="4" name="">
             <a:extLst xmlns:a="http://schemas.openxmlformats.org/drawingml/2006/main">
               <a:ext uri="{FF2B5EF4-FFF2-40B4-BE49-F238E27FC236}">
-                <a16:creationId xmlns:a16="http://schemas.microsoft.com/office/drawing/2014/main" id="{B64E774A-8259-4C6D-9B56-5A1022ACD719}"/>
+                <a16:creationId xmlns:a16="http://schemas.microsoft.com/office/drawing/2014/main" id="{32400B76-DBC9-475C-914C-BBE0B229EC26}"/>
               </a:ext>
             </a:extLst>
           </p:cNvPr>
@@ -8350,7 +8100,7 @@
           <p:cNvPr id="5" name="">
             <a:extLst xmlns:a="http://schemas.openxmlformats.org/drawingml/2006/main">
               <a:ext uri="{FF2B5EF4-FFF2-40B4-BE49-F238E27FC236}">
-                <a16:creationId xmlns:a16="http://schemas.microsoft.com/office/drawing/2014/main" id="{9BA387FB-6929-4449-9949-FC6F3C6FE7BD}"/>
+                <a16:creationId xmlns:a16="http://schemas.microsoft.com/office/drawing/2014/main" id="{664E21DD-0C39-404E-A90E-3CB9015DF037}"/>
               </a:ext>
             </a:extLst>
           </p:cNvPr>
@@ -8407,7 +8157,7 @@
           <p:cNvPr id="6" name="">
             <a:extLst xmlns:a="http://schemas.openxmlformats.org/drawingml/2006/main">
               <a:ext uri="{FF2B5EF4-FFF2-40B4-BE49-F238E27FC236}">
-                <a16:creationId xmlns:a16="http://schemas.microsoft.com/office/drawing/2014/main" id="{1BDD3394-911B-46FD-9726-460E25C95D8F}"/>
+                <a16:creationId xmlns:a16="http://schemas.microsoft.com/office/drawing/2014/main" id="{BE61BBD4-442A-4BD0-9AB1-FB78B1704645}"/>
               </a:ext>
             </a:extLst>
           </p:cNvPr>
@@ -8462,7 +8212,7 @@
     </p:spTree>
     <p:extLst>
       <p:ext uri="{BB962C8B-B14F-4D97-AF65-F5344CB8AC3E}">
-        <p14:creationId xmlns:p14="http://schemas.microsoft.com/office/powerpoint/2010/main" val="1186850196"/>
+        <p14:creationId xmlns:p14="http://schemas.microsoft.com/office/powerpoint/2010/main" val="1618778649"/>
       </p:ext>
     </p:extLst>
   </p:cSld>
@@ -8493,7 +8243,7 @@
           <p:cNvPr id="6" name="">
             <a:extLst xmlns:a="http://schemas.openxmlformats.org/drawingml/2006/main">
               <a:ext uri="{FF2B5EF4-FFF2-40B4-BE49-F238E27FC236}">
-                <a16:creationId xmlns:a16="http://schemas.microsoft.com/office/drawing/2014/main" id="{A649FFED-F24B-4867-A98D-54DE81470774}"/>
+                <a16:creationId xmlns:a16="http://schemas.microsoft.com/office/drawing/2014/main" id="{670104FC-9427-46B7-8C91-74A310DDF63B}"/>
               </a:ext>
             </a:extLst>
           </p:cNvPr>
@@ -8557,7 +8307,7 @@
         </p:xfrm>
         <a:graphic xmlns:a="http://schemas.openxmlformats.org/drawingml/2006/main">
           <a:graphicData uri="http://schemas.openxmlformats.org/drawingml/2006/chart">
-            <c:chart xmlns:r="http://schemas.openxmlformats.org/officeDocument/2006/relationships" xmlns:c="http://schemas.openxmlformats.org/drawingml/2006/chart" r:id="R4a32360394994e8f"/>
+            <c:chart xmlns:r="http://schemas.openxmlformats.org/officeDocument/2006/relationships" xmlns:c="http://schemas.openxmlformats.org/drawingml/2006/chart" r:id="R792f07fc9e0040a8"/>
           </a:graphicData>
         </a:graphic>
       </p:graphicFrame>
@@ -8566,7 +8316,7 @@
           <p:cNvPr id="3" name="">
             <a:extLst xmlns:a="http://schemas.openxmlformats.org/drawingml/2006/main">
               <a:ext uri="{FF2B5EF4-FFF2-40B4-BE49-F238E27FC236}">
-                <a16:creationId xmlns:a16="http://schemas.microsoft.com/office/drawing/2014/main" id="{F59B928D-63C4-4760-901C-BC5B702A4A2C}"/>
+                <a16:creationId xmlns:a16="http://schemas.microsoft.com/office/drawing/2014/main" id="{B62B15E0-6664-4041-A0C0-09C11C7856A7}"/>
               </a:ext>
             </a:extLst>
           </p:cNvPr>
@@ -8623,7 +8373,7 @@
           <p:cNvPr id="4" name="">
             <a:extLst xmlns:a="http://schemas.openxmlformats.org/drawingml/2006/main">
               <a:ext uri="{FF2B5EF4-FFF2-40B4-BE49-F238E27FC236}">
-                <a16:creationId xmlns:a16="http://schemas.microsoft.com/office/drawing/2014/main" id="{CD0EC500-6A42-4FC4-861C-DD2570544F1B}"/>
+                <a16:creationId xmlns:a16="http://schemas.microsoft.com/office/drawing/2014/main" id="{C3F6E899-16B7-453D-B004-6F2AF06C90FE}"/>
               </a:ext>
             </a:extLst>
           </p:cNvPr>
@@ -8680,7 +8430,7 @@
           <p:cNvPr id="5" name="">
             <a:extLst xmlns:a="http://schemas.openxmlformats.org/drawingml/2006/main">
               <a:ext uri="{FF2B5EF4-FFF2-40B4-BE49-F238E27FC236}">
-                <a16:creationId xmlns:a16="http://schemas.microsoft.com/office/drawing/2014/main" id="{6A6B3AA5-4838-4A18-A6C2-53CE7A15F256}"/>
+                <a16:creationId xmlns:a16="http://schemas.microsoft.com/office/drawing/2014/main" id="{68AED611-53C2-4C46-9731-42C1B5CEE4D7}"/>
               </a:ext>
             </a:extLst>
           </p:cNvPr>
@@ -8735,7 +8485,7 @@
     </p:spTree>
     <p:extLst>
       <p:ext uri="{BB962C8B-B14F-4D97-AF65-F5344CB8AC3E}">
-        <p14:creationId xmlns:p14="http://schemas.microsoft.com/office/powerpoint/2010/main" val="1775336576"/>
+        <p14:creationId xmlns:p14="http://schemas.microsoft.com/office/powerpoint/2010/main" val="968667416"/>
       </p:ext>
     </p:extLst>
   </p:cSld>
@@ -8763,10 +8513,10 @@
       </p:grpSpPr>
       <p:sp>
         <p:nvSpPr>
-          <p:cNvPr id="18" name="">
+          <p:cNvPr id="11" name="">
             <a:extLst xmlns:a="http://schemas.openxmlformats.org/drawingml/2006/main">
               <a:ext uri="{FF2B5EF4-FFF2-40B4-BE49-F238E27FC236}">
-                <a16:creationId xmlns:a16="http://schemas.microsoft.com/office/drawing/2014/main" id="{5859D280-D84D-4E0C-8CCD-817918902B3A}"/>
+                <a16:creationId xmlns:a16="http://schemas.microsoft.com/office/drawing/2014/main" id="{C21EDD63-8B95-4818-9F25-B50E8E58EB59}"/>
               </a:ext>
             </a:extLst>
           </p:cNvPr>
@@ -8813,33 +8563,17 @@
                 <a:ea typeface="Helvetica Neue"/>
                 <a:cs typeface="Helvetica Neue"/>
               </a:rPr>
-              <a:t>How much does the error rate change?</a:t>
-            </a:r>
-          </a:p>
-        </p:txBody>
-      </p:sp>
-      <p:graphicFrame>
-        <p:nvGraphicFramePr>
-          <p:cNvPr id="19" name="Chart"/>
-          <p:cNvGraphicFramePr/>
-          <p:nvPr/>
-        </p:nvGraphicFramePr>
-        <p:xfrm>
-          <a:off xmlns:a="http://schemas.openxmlformats.org/drawingml/2006/main" x="3067050" y="1524000"/>
-          <a:ext xmlns:a="http://schemas.openxmlformats.org/drawingml/2006/main" cx="5905500" cy="3667125"/>
-        </p:xfrm>
-        <a:graphic xmlns:a="http://schemas.openxmlformats.org/drawingml/2006/main">
-          <a:graphicData uri="http://schemas.openxmlformats.org/drawingml/2006/chart">
-            <c:chart xmlns:r="http://schemas.openxmlformats.org/officeDocument/2006/relationships" xmlns:c="http://schemas.openxmlformats.org/drawingml/2006/chart" r:id="R7b2139576f284651"/>
-          </a:graphicData>
-        </a:graphic>
-      </p:graphicFrame>
-      <p:sp>
-        <p:nvSpPr>
-          <p:cNvPr id="3" name="">
+              <a:t>Wrong input and structured double-checking</a:t>
+            </a:r>
+          </a:p>
+        </p:txBody>
+      </p:sp>
+      <p:sp>
+        <p:nvSpPr>
+          <p:cNvPr id="2" name="">
             <a:extLst xmlns:a="http://schemas.openxmlformats.org/drawingml/2006/main">
               <a:ext uri="{FF2B5EF4-FFF2-40B4-BE49-F238E27FC236}">
-                <a16:creationId xmlns:a16="http://schemas.microsoft.com/office/drawing/2014/main" id="{AACEE707-12CD-47E4-BF6D-5B9D8B3AAF6F}"/>
+                <a16:creationId xmlns:a16="http://schemas.microsoft.com/office/drawing/2014/main" id="{CD79178C-53FE-4F27-8BCB-79F71A0C5AD9}"/>
               </a:ext>
             </a:extLst>
           </p:cNvPr>
@@ -8850,8 +8584,8 @@
         </p:nvSpPr>
         <p:spPr>
           <a:xfrm xmlns:a="http://schemas.openxmlformats.org/drawingml/2006/main">
-            <a:off x="714375" y="1914525"/>
-            <a:ext cx="2286000" cy="400050"/>
+            <a:off x="685800" y="1333500"/>
+            <a:ext cx="5143500" cy="476250"/>
           </a:xfrm>
           <a:prstGeom xmlns:a="http://schemas.openxmlformats.org/drawingml/2006/main" prst="rect">
             <a:avLst/>
@@ -8868,7 +8602,7 @@
           <a:lstStyle xmlns:a="http://schemas.openxmlformats.org/drawingml/2006/main"/>
           <a:p xmlns:a="http://schemas.openxmlformats.org/drawingml/2006/main">
             <a:pPr>
-              <a:defRPr sz="1950" b="1">
+              <a:defRPr sz="2250" b="1">
                 <a:solidFill>
                   <a:srgbClr val="142C40"/>
                 </a:solidFill>
@@ -8878,7 +8612,7 @@
               </a:defRPr>
             </a:pPr>
             <a:r>
-              <a:rPr sz="1950" b="1">
+              <a:rPr sz="2250" b="1">
                 <a:solidFill>
                   <a:srgbClr val="142C40"/>
                 </a:solidFill>
@@ -8886,17 +8620,17 @@
                 <a:ea typeface="Helvetica Neue"/>
                 <a:cs typeface="Helvetica Neue"/>
               </a:rPr>
-              <a:t>C0 - Initial</a:t>
-            </a:r>
-          </a:p>
-        </p:txBody>
-      </p:sp>
-      <p:sp>
-        <p:nvSpPr>
-          <p:cNvPr id="4" name="">
+              <a:t>1  Misleading input</a:t>
+            </a:r>
+          </a:p>
+        </p:txBody>
+      </p:sp>
+      <p:sp>
+        <p:nvSpPr>
+          <p:cNvPr id="3" name="">
             <a:extLst xmlns:a="http://schemas.openxmlformats.org/drawingml/2006/main">
               <a:ext uri="{FF2B5EF4-FFF2-40B4-BE49-F238E27FC236}">
-                <a16:creationId xmlns:a16="http://schemas.microsoft.com/office/drawing/2014/main" id="{D0F681F3-AF05-41C3-A567-ED35E6172562}"/>
+                <a16:creationId xmlns:a16="http://schemas.microsoft.com/office/drawing/2014/main" id="{305B6567-61D2-4279-90B8-8601F325BD69}"/>
               </a:ext>
             </a:extLst>
           </p:cNvPr>
@@ -8907,8 +8641,8 @@
         </p:nvSpPr>
         <p:spPr>
           <a:xfrm xmlns:a="http://schemas.openxmlformats.org/drawingml/2006/main">
-            <a:off x="8972550" y="1971675"/>
-            <a:ext cx="2667000" cy="428625"/>
+            <a:off x="6362700" y="1333500"/>
+            <a:ext cx="5191125" cy="476250"/>
           </a:xfrm>
           <a:prstGeom xmlns:a="http://schemas.openxmlformats.org/drawingml/2006/main" prst="rect">
             <a:avLst/>
@@ -8925,7 +8659,7 @@
           <a:lstStyle xmlns:a="http://schemas.openxmlformats.org/drawingml/2006/main"/>
           <a:p xmlns:a="http://schemas.openxmlformats.org/drawingml/2006/main">
             <a:pPr>
-              <a:defRPr sz="1500" b="0">
+              <a:defRPr sz="2250" b="1">
                 <a:solidFill>
                   <a:srgbClr val="142C40"/>
                 </a:solidFill>
@@ -8935,7 +8669,7 @@
               </a:defRPr>
             </a:pPr>
             <a:r>
-              <a:rPr sz="1500" b="0">
+              <a:rPr sz="2250" b="1">
                 <a:solidFill>
                   <a:srgbClr val="142C40"/>
                 </a:solidFill>
@@ -8943,17 +8677,49 @@
                 <a:ea typeface="Helvetica Neue"/>
                 <a:cs typeface="Helvetica Neue"/>
               </a:rPr>
-              <a:t>+1.25 [-3.06, +5.56]</a:t>
-            </a:r>
-          </a:p>
-        </p:txBody>
-      </p:sp>
-      <p:sp>
-        <p:nvSpPr>
-          <p:cNvPr id="5" name="">
+              <a:t>2  Structured double-check</a:t>
+            </a:r>
+          </a:p>
+        </p:txBody>
+      </p:sp>
+      <p:graphicFrame>
+        <p:nvGraphicFramePr>
+          <p:cNvPr id="14" name="Chart"/>
+          <p:cNvGraphicFramePr/>
+          <p:nvPr/>
+        </p:nvGraphicFramePr>
+        <p:xfrm>
+          <a:off xmlns:a="http://schemas.openxmlformats.org/drawingml/2006/main" x="552450" y="2047875"/>
+          <a:ext xmlns:a="http://schemas.openxmlformats.org/drawingml/2006/main" cx="5353050" cy="3143250"/>
+        </p:xfrm>
+        <a:graphic xmlns:a="http://schemas.openxmlformats.org/drawingml/2006/main">
+          <a:graphicData uri="http://schemas.openxmlformats.org/drawingml/2006/chart">
+            <c:chart xmlns:r="http://schemas.openxmlformats.org/officeDocument/2006/relationships" xmlns:c="http://schemas.openxmlformats.org/drawingml/2006/chart" r:id="Rb5a51e0e90c44474"/>
+          </a:graphicData>
+        </a:graphic>
+      </p:graphicFrame>
+      <p:graphicFrame>
+        <p:nvGraphicFramePr>
+          <p:cNvPr id="15" name="Chart"/>
+          <p:cNvGraphicFramePr/>
+          <p:nvPr/>
+        </p:nvGraphicFramePr>
+        <p:xfrm>
+          <a:off xmlns:a="http://schemas.openxmlformats.org/drawingml/2006/main" x="6248400" y="2047875"/>
+          <a:ext xmlns:a="http://schemas.openxmlformats.org/drawingml/2006/main" cx="5257800" cy="3143250"/>
+        </p:xfrm>
+        <a:graphic xmlns:a="http://schemas.openxmlformats.org/drawingml/2006/main">
+          <a:graphicData uri="http://schemas.openxmlformats.org/drawingml/2006/chart">
+            <c:chart xmlns:r="http://schemas.openxmlformats.org/officeDocument/2006/relationships" xmlns:c="http://schemas.openxmlformats.org/drawingml/2006/chart" r:id="R9f05ee5630404fa8"/>
+          </a:graphicData>
+        </a:graphic>
+      </p:graphicFrame>
+      <p:sp>
+        <p:nvSpPr>
+          <p:cNvPr id="6" name="">
             <a:extLst xmlns:a="http://schemas.openxmlformats.org/drawingml/2006/main">
               <a:ext uri="{FF2B5EF4-FFF2-40B4-BE49-F238E27FC236}">
-                <a16:creationId xmlns:a16="http://schemas.microsoft.com/office/drawing/2014/main" id="{99F1100F-0FD7-42D0-BCB4-9DE8CE29B3F2}"/>
+                <a16:creationId xmlns:a16="http://schemas.microsoft.com/office/drawing/2014/main" id="{52D5E513-5D98-4437-A25A-57F197C44057}"/>
               </a:ext>
             </a:extLst>
           </p:cNvPr>
@@ -8964,8 +8730,8 @@
         </p:nvSpPr>
         <p:spPr>
           <a:xfrm xmlns:a="http://schemas.openxmlformats.org/drawingml/2006/main">
-            <a:off x="714375" y="2457450"/>
-            <a:ext cx="2286000" cy="400050"/>
+            <a:off x="685800" y="5257800"/>
+            <a:ext cx="5334000" cy="476250"/>
           </a:xfrm>
           <a:prstGeom xmlns:a="http://schemas.openxmlformats.org/drawingml/2006/main" prst="rect">
             <a:avLst/>
@@ -8982,9 +8748,9 @@
           <a:lstStyle xmlns:a="http://schemas.openxmlformats.org/drawingml/2006/main"/>
           <a:p xmlns:a="http://schemas.openxmlformats.org/drawingml/2006/main">
             <a:pPr>
-              <a:defRPr sz="1950" b="1">
-                <a:solidFill>
-                  <a:srgbClr val="142C40"/>
+              <a:defRPr sz="1725" b="1">
+                <a:solidFill>
+                  <a:srgbClr val="C45F48"/>
                 </a:solidFill>
                 <a:latin typeface="Helvetica Neue"/>
                 <a:ea typeface="Helvetica Neue"/>
@@ -8992,25 +8758,25 @@
               </a:defRPr>
             </a:pPr>
             <a:r>
-              <a:rPr sz="1950" b="1">
-                <a:solidFill>
-                  <a:srgbClr val="142C40"/>
+              <a:rPr sz="1725" b="1">
+                <a:solidFill>
+                  <a:srgbClr val="C45F48"/>
                 </a:solidFill>
                 <a:latin typeface="Helvetica Neue"/>
                 <a:ea typeface="Helvetica Neue"/>
                 <a:cs typeface="Helvetica Neue"/>
               </a:rPr>
-              <a:t>C1 - C0</a:t>
-            </a:r>
-          </a:p>
-        </p:txBody>
-      </p:sp>
-      <p:sp>
-        <p:nvSpPr>
-          <p:cNvPr id="6" name="">
+              <a:t>+18.78 / +6.40 percentage points vs C0</a:t>
+            </a:r>
+          </a:p>
+        </p:txBody>
+      </p:sp>
+      <p:sp>
+        <p:nvSpPr>
+          <p:cNvPr id="7" name="">
             <a:extLst xmlns:a="http://schemas.openxmlformats.org/drawingml/2006/main">
               <a:ext uri="{FF2B5EF4-FFF2-40B4-BE49-F238E27FC236}">
-                <a16:creationId xmlns:a16="http://schemas.microsoft.com/office/drawing/2014/main" id="{964EF77A-E3C3-4C77-A6E4-5195EF42F5C5}"/>
+                <a16:creationId xmlns:a16="http://schemas.microsoft.com/office/drawing/2014/main" id="{48F8DB8D-8DFF-431B-9FC4-A96CE3428A6A}"/>
               </a:ext>
             </a:extLst>
           </p:cNvPr>
@@ -9021,8 +8787,8 @@
         </p:nvSpPr>
         <p:spPr>
           <a:xfrm xmlns:a="http://schemas.openxmlformats.org/drawingml/2006/main">
-            <a:off x="8972550" y="2514600"/>
-            <a:ext cx="2667000" cy="428625"/>
+            <a:off x="6438900" y="5257800"/>
+            <a:ext cx="5048250" cy="476250"/>
           </a:xfrm>
           <a:prstGeom xmlns:a="http://schemas.openxmlformats.org/drawingml/2006/main" prst="rect">
             <a:avLst/>
@@ -9039,9 +8805,9 @@
           <a:lstStyle xmlns:a="http://schemas.openxmlformats.org/drawingml/2006/main"/>
           <a:p xmlns:a="http://schemas.openxmlformats.org/drawingml/2006/main">
             <a:pPr>
-              <a:defRPr sz="1500" b="0">
-                <a:solidFill>
-                  <a:srgbClr val="142C40"/>
+              <a:defRPr sz="1725" b="1">
+                <a:solidFill>
+                  <a:srgbClr val="147E77"/>
                 </a:solidFill>
                 <a:latin typeface="Helvetica Neue"/>
                 <a:ea typeface="Helvetica Neue"/>
@@ -9049,25 +8815,25 @@
               </a:defRPr>
             </a:pPr>
             <a:r>
-              <a:rPr sz="1500" b="0">
-                <a:solidFill>
-                  <a:srgbClr val="142C40"/>
+              <a:rPr sz="1725" b="1">
+                <a:solidFill>
+                  <a:srgbClr val="147E77"/>
                 </a:solidFill>
                 <a:latin typeface="Helvetica Neue"/>
                 <a:ea typeface="Helvetica Neue"/>
                 <a:cs typeface="Helvetica Neue"/>
               </a:rPr>
-              <a:t>+18.78 [+14.35, +23.09]</a:t>
-            </a:r>
-          </a:p>
-        </p:txBody>
-      </p:sp>
-      <p:sp>
-        <p:nvSpPr>
-          <p:cNvPr id="7" name="">
+              <a:t>16.55 percentage points less error</a:t>
+            </a:r>
+          </a:p>
+        </p:txBody>
+      </p:sp>
+      <p:sp>
+        <p:nvSpPr>
+          <p:cNvPr id="8" name="">
             <a:extLst xmlns:a="http://schemas.openxmlformats.org/drawingml/2006/main">
               <a:ext uri="{FF2B5EF4-FFF2-40B4-BE49-F238E27FC236}">
-                <a16:creationId xmlns:a16="http://schemas.microsoft.com/office/drawing/2014/main" id="{D1EB48F4-D360-464A-BA05-288E2A7069CA}"/>
+                <a16:creationId xmlns:a16="http://schemas.microsoft.com/office/drawing/2014/main" id="{4E374C79-DA60-4B24-9899-C44A1275028E}"/>
               </a:ext>
             </a:extLst>
           </p:cNvPr>
@@ -9078,8 +8844,8 @@
         </p:nvSpPr>
         <p:spPr>
           <a:xfrm xmlns:a="http://schemas.openxmlformats.org/drawingml/2006/main">
-            <a:off x="714375" y="3000375"/>
-            <a:ext cx="2286000" cy="400050"/>
+            <a:off x="685800" y="5791200"/>
+            <a:ext cx="10858500" cy="361950"/>
           </a:xfrm>
           <a:prstGeom xmlns:a="http://schemas.openxmlformats.org/drawingml/2006/main" prst="rect">
             <a:avLst/>
@@ -9096,7 +8862,7 @@
           <a:lstStyle xmlns:a="http://schemas.openxmlformats.org/drawingml/2006/main"/>
           <a:p xmlns:a="http://schemas.openxmlformats.org/drawingml/2006/main">
             <a:pPr>
-              <a:defRPr sz="1950" b="1">
+              <a:defRPr sz="1800" b="1">
                 <a:solidFill>
                   <a:srgbClr val="142C40"/>
                 </a:solidFill>
@@ -9106,7 +8872,7 @@
               </a:defRPr>
             </a:pPr>
             <a:r>
-              <a:rPr sz="1950" b="1">
+              <a:rPr sz="1800" b="1">
                 <a:solidFill>
                   <a:srgbClr val="142C40"/>
                 </a:solidFill>
@@ -9114,17 +8880,17 @@
                 <a:ea typeface="Helvetica Neue"/>
                 <a:cs typeface="Helvetica Neue"/>
               </a:rPr>
-              <a:t>C2 - C0</a:t>
-            </a:r>
-          </a:p>
-        </p:txBody>
-      </p:sp>
-      <p:sp>
-        <p:nvSpPr>
-          <p:cNvPr id="8" name="">
+              <a:t>Error rate = wrong / (correct + wrong + abstain). Each group: 719.</a:t>
+            </a:r>
+          </a:p>
+        </p:txBody>
+      </p:sp>
+      <p:sp>
+        <p:nvSpPr>
+          <p:cNvPr id="9" name="">
             <a:extLst xmlns:a="http://schemas.openxmlformats.org/drawingml/2006/main">
               <a:ext uri="{FF2B5EF4-FFF2-40B4-BE49-F238E27FC236}">
-                <a16:creationId xmlns:a16="http://schemas.microsoft.com/office/drawing/2014/main" id="{C003B562-FF31-4E04-9713-C6689881ADF3}"/>
+                <a16:creationId xmlns:a16="http://schemas.microsoft.com/office/drawing/2014/main" id="{62470016-E329-483D-B57A-5569D8F18CB0}"/>
               </a:ext>
             </a:extLst>
           </p:cNvPr>
@@ -9135,8 +8901,8 @@
         </p:nvSpPr>
         <p:spPr>
           <a:xfrm xmlns:a="http://schemas.openxmlformats.org/drawingml/2006/main">
-            <a:off x="8972550" y="3057525"/>
-            <a:ext cx="2667000" cy="428625"/>
+            <a:off x="685800" y="6229350"/>
+            <a:ext cx="10477500" cy="304800"/>
           </a:xfrm>
           <a:prstGeom xmlns:a="http://schemas.openxmlformats.org/drawingml/2006/main" prst="rect">
             <a:avLst/>
@@ -9153,9 +8919,9 @@
           <a:lstStyle xmlns:a="http://schemas.openxmlformats.org/drawingml/2006/main"/>
           <a:p xmlns:a="http://schemas.openxmlformats.org/drawingml/2006/main">
             <a:pPr>
-              <a:defRPr sz="1500" b="0">
-                <a:solidFill>
-                  <a:srgbClr val="142C40"/>
+              <a:defRPr sz="1575" b="0">
+                <a:solidFill>
+                  <a:srgbClr val="657586"/>
                 </a:solidFill>
                 <a:latin typeface="Helvetica Neue"/>
                 <a:ea typeface="Helvetica Neue"/>
@@ -9163,72 +8929,15 @@
               </a:defRPr>
             </a:pPr>
             <a:r>
-              <a:rPr sz="1500" b="0">
-                <a:solidFill>
-                  <a:srgbClr val="142C40"/>
+              <a:rPr sz="1575" b="0">
+                <a:solidFill>
+                  <a:srgbClr val="657586"/>
                 </a:solidFill>
                 <a:latin typeface="Helvetica Neue"/>
                 <a:ea typeface="Helvetica Neue"/>
                 <a:cs typeface="Helvetica Neue"/>
               </a:rPr>
-              <a:t>+6.40 [+1.94, +10.99]</a:t>
-            </a:r>
-          </a:p>
-        </p:txBody>
-      </p:sp>
-      <p:sp>
-        <p:nvSpPr>
-          <p:cNvPr id="9" name="">
-            <a:extLst xmlns:a="http://schemas.openxmlformats.org/drawingml/2006/main">
-              <a:ext uri="{FF2B5EF4-FFF2-40B4-BE49-F238E27FC236}">
-                <a16:creationId xmlns:a16="http://schemas.microsoft.com/office/drawing/2014/main" id="{D2DC9DE5-AF6F-48DB-9546-821E8BA48192}"/>
-              </a:ext>
-            </a:extLst>
-          </p:cNvPr>
-          <p:cNvSpPr>
-            <a:spLocks xmlns:a="http://schemas.openxmlformats.org/drawingml/2006/main" noGrp="1"/>
-          </p:cNvSpPr>
-          <p:nvPr/>
-        </p:nvSpPr>
-        <p:spPr>
-          <a:xfrm xmlns:a="http://schemas.openxmlformats.org/drawingml/2006/main">
-            <a:off x="714375" y="3543300"/>
-            <a:ext cx="2286000" cy="400050"/>
-          </a:xfrm>
-          <a:prstGeom xmlns:a="http://schemas.openxmlformats.org/drawingml/2006/main" prst="rect">
-            <a:avLst/>
-          </a:prstGeom>
-          <a:noFill xmlns:a="http://schemas.openxmlformats.org/drawingml/2006/main"/>
-          <a:ln xmlns:a="http://schemas.openxmlformats.org/drawingml/2006/main" w="0">
-            <a:noFill/>
-          </a:ln>
-        </p:spPr>
-        <p:txBody>
-          <a:bodyPr xmlns:a="http://schemas.openxmlformats.org/drawingml/2006/main">
-            <a:noAutofit/>
-          </a:bodyPr>
-          <a:lstStyle xmlns:a="http://schemas.openxmlformats.org/drawingml/2006/main"/>
-          <a:p xmlns:a="http://schemas.openxmlformats.org/drawingml/2006/main">
-            <a:pPr>
-              <a:defRPr sz="1950" b="1">
-                <a:solidFill>
-                  <a:srgbClr val="142C40"/>
-                </a:solidFill>
-                <a:latin typeface="Helvetica Neue"/>
-                <a:ea typeface="Helvetica Neue"/>
-                <a:cs typeface="Helvetica Neue"/>
-              </a:defRPr>
-            </a:pPr>
-            <a:r>
-              <a:rPr sz="1950" b="1">
-                <a:solidFill>
-                  <a:srgbClr val="142C40"/>
-                </a:solidFill>
-                <a:latin typeface="Helvetica Neue"/>
-                <a:ea typeface="Helvetica Neue"/>
-                <a:cs typeface="Helvetica Neue"/>
-              </a:rPr>
-              <a:t>C3 - C2</a:t>
+              <a:t>Abstentions are not errors and stay in the denominator. Post-hoc comparisons.</a:t>
             </a:r>
           </a:p>
         </p:txBody>
@@ -9238,406 +8947,7 @@
           <p:cNvPr id="10" name="">
             <a:extLst xmlns:a="http://schemas.openxmlformats.org/drawingml/2006/main">
               <a:ext uri="{FF2B5EF4-FFF2-40B4-BE49-F238E27FC236}">
-                <a16:creationId xmlns:a16="http://schemas.microsoft.com/office/drawing/2014/main" id="{FABC6299-DD18-47CF-9468-0ED67B11AA23}"/>
-              </a:ext>
-            </a:extLst>
-          </p:cNvPr>
-          <p:cNvSpPr>
-            <a:spLocks xmlns:a="http://schemas.openxmlformats.org/drawingml/2006/main" noGrp="1"/>
-          </p:cNvSpPr>
-          <p:nvPr/>
-        </p:nvSpPr>
-        <p:spPr>
-          <a:xfrm xmlns:a="http://schemas.openxmlformats.org/drawingml/2006/main">
-            <a:off x="8972550" y="3600450"/>
-            <a:ext cx="2667000" cy="428625"/>
-          </a:xfrm>
-          <a:prstGeom xmlns:a="http://schemas.openxmlformats.org/drawingml/2006/main" prst="rect">
-            <a:avLst/>
-          </a:prstGeom>
-          <a:noFill xmlns:a="http://schemas.openxmlformats.org/drawingml/2006/main"/>
-          <a:ln xmlns:a="http://schemas.openxmlformats.org/drawingml/2006/main" w="0">
-            <a:noFill/>
-          </a:ln>
-        </p:spPr>
-        <p:txBody>
-          <a:bodyPr xmlns:a="http://schemas.openxmlformats.org/drawingml/2006/main">
-            <a:noAutofit/>
-          </a:bodyPr>
-          <a:lstStyle xmlns:a="http://schemas.openxmlformats.org/drawingml/2006/main"/>
-          <a:p xmlns:a="http://schemas.openxmlformats.org/drawingml/2006/main">
-            <a:pPr>
-              <a:defRPr sz="1500" b="0">
-                <a:solidFill>
-                  <a:srgbClr val="142C40"/>
-                </a:solidFill>
-                <a:latin typeface="Helvetica Neue"/>
-                <a:ea typeface="Helvetica Neue"/>
-                <a:cs typeface="Helvetica Neue"/>
-              </a:defRPr>
-            </a:pPr>
-            <a:r>
-              <a:rPr sz="1500" b="0">
-                <a:solidFill>
-                  <a:srgbClr val="142C40"/>
-                </a:solidFill>
-                <a:latin typeface="Helvetica Neue"/>
-                <a:ea typeface="Helvetica Neue"/>
-                <a:cs typeface="Helvetica Neue"/>
-              </a:rPr>
-              <a:t>-16.55 [-20.70, -12.38]</a:t>
-            </a:r>
-          </a:p>
-        </p:txBody>
-      </p:sp>
-      <p:sp>
-        <p:nvSpPr>
-          <p:cNvPr id="11" name="">
-            <a:extLst xmlns:a="http://schemas.openxmlformats.org/drawingml/2006/main">
-              <a:ext uri="{FF2B5EF4-FFF2-40B4-BE49-F238E27FC236}">
-                <a16:creationId xmlns:a16="http://schemas.microsoft.com/office/drawing/2014/main" id="{A2C3789F-1A66-4A45-A418-D17FB747662F}"/>
-              </a:ext>
-            </a:extLst>
-          </p:cNvPr>
-          <p:cNvSpPr>
-            <a:spLocks xmlns:a="http://schemas.openxmlformats.org/drawingml/2006/main" noGrp="1"/>
-          </p:cNvSpPr>
-          <p:nvPr/>
-        </p:nvSpPr>
-        <p:spPr>
-          <a:xfrm xmlns:a="http://schemas.openxmlformats.org/drawingml/2006/main">
-            <a:off x="714375" y="4086225"/>
-            <a:ext cx="2286000" cy="400050"/>
-          </a:xfrm>
-          <a:prstGeom xmlns:a="http://schemas.openxmlformats.org/drawingml/2006/main" prst="rect">
-            <a:avLst/>
-          </a:prstGeom>
-          <a:noFill xmlns:a="http://schemas.openxmlformats.org/drawingml/2006/main"/>
-          <a:ln xmlns:a="http://schemas.openxmlformats.org/drawingml/2006/main" w="0">
-            <a:noFill/>
-          </a:ln>
-        </p:spPr>
-        <p:txBody>
-          <a:bodyPr xmlns:a="http://schemas.openxmlformats.org/drawingml/2006/main">
-            <a:noAutofit/>
-          </a:bodyPr>
-          <a:lstStyle xmlns:a="http://schemas.openxmlformats.org/drawingml/2006/main"/>
-          <a:p xmlns:a="http://schemas.openxmlformats.org/drawingml/2006/main">
-            <a:pPr>
-              <a:defRPr sz="1950" b="1">
-                <a:solidFill>
-                  <a:srgbClr val="142C40"/>
-                </a:solidFill>
-                <a:latin typeface="Helvetica Neue"/>
-                <a:ea typeface="Helvetica Neue"/>
-                <a:cs typeface="Helvetica Neue"/>
-              </a:defRPr>
-            </a:pPr>
-            <a:r>
-              <a:rPr sz="1950" b="1">
-                <a:solidFill>
-                  <a:srgbClr val="142C40"/>
-                </a:solidFill>
-                <a:latin typeface="Helvetica Neue"/>
-                <a:ea typeface="Helvetica Neue"/>
-                <a:cs typeface="Helvetica Neue"/>
-              </a:rPr>
-              <a:t>C5 - C4</a:t>
-            </a:r>
-          </a:p>
-        </p:txBody>
-      </p:sp>
-      <p:sp>
-        <p:nvSpPr>
-          <p:cNvPr id="12" name="">
-            <a:extLst xmlns:a="http://schemas.openxmlformats.org/drawingml/2006/main">
-              <a:ext uri="{FF2B5EF4-FFF2-40B4-BE49-F238E27FC236}">
-                <a16:creationId xmlns:a16="http://schemas.microsoft.com/office/drawing/2014/main" id="{203A9852-BBD0-4DFA-8D9B-7F4A3EBF49AD}"/>
-              </a:ext>
-            </a:extLst>
-          </p:cNvPr>
-          <p:cNvSpPr>
-            <a:spLocks xmlns:a="http://schemas.openxmlformats.org/drawingml/2006/main" noGrp="1"/>
-          </p:cNvSpPr>
-          <p:nvPr/>
-        </p:nvSpPr>
-        <p:spPr>
-          <a:xfrm xmlns:a="http://schemas.openxmlformats.org/drawingml/2006/main">
-            <a:off x="8972550" y="4143375"/>
-            <a:ext cx="2667000" cy="428625"/>
-          </a:xfrm>
-          <a:prstGeom xmlns:a="http://schemas.openxmlformats.org/drawingml/2006/main" prst="rect">
-            <a:avLst/>
-          </a:prstGeom>
-          <a:noFill xmlns:a="http://schemas.openxmlformats.org/drawingml/2006/main"/>
-          <a:ln xmlns:a="http://schemas.openxmlformats.org/drawingml/2006/main" w="0">
-            <a:noFill/>
-          </a:ln>
-        </p:spPr>
-        <p:txBody>
-          <a:bodyPr xmlns:a="http://schemas.openxmlformats.org/drawingml/2006/main">
-            <a:noAutofit/>
-          </a:bodyPr>
-          <a:lstStyle xmlns:a="http://schemas.openxmlformats.org/drawingml/2006/main"/>
-          <a:p xmlns:a="http://schemas.openxmlformats.org/drawingml/2006/main">
-            <a:pPr>
-              <a:defRPr sz="1500" b="0">
-                <a:solidFill>
-                  <a:srgbClr val="142C40"/>
-                </a:solidFill>
-                <a:latin typeface="Helvetica Neue"/>
-                <a:ea typeface="Helvetica Neue"/>
-                <a:cs typeface="Helvetica Neue"/>
-              </a:defRPr>
-            </a:pPr>
-            <a:r>
-              <a:rPr sz="1500" b="0">
-                <a:solidFill>
-                  <a:srgbClr val="142C40"/>
-                </a:solidFill>
-                <a:latin typeface="Helvetica Neue"/>
-                <a:ea typeface="Helvetica Neue"/>
-                <a:cs typeface="Helvetica Neue"/>
-              </a:rPr>
-              <a:t>-4.73 [-7.37, -2.22]</a:t>
-            </a:r>
-          </a:p>
-        </p:txBody>
-      </p:sp>
-      <p:sp>
-        <p:nvSpPr>
-          <p:cNvPr id="13" name="">
-            <a:extLst xmlns:a="http://schemas.openxmlformats.org/drawingml/2006/main">
-              <a:ext uri="{FF2B5EF4-FFF2-40B4-BE49-F238E27FC236}">
-                <a16:creationId xmlns:a16="http://schemas.microsoft.com/office/drawing/2014/main" id="{2C459DAF-9B93-40A5-8E09-5D665346CCE0}"/>
-              </a:ext>
-            </a:extLst>
-          </p:cNvPr>
-          <p:cNvSpPr>
-            <a:spLocks xmlns:a="http://schemas.openxmlformats.org/drawingml/2006/main" noGrp="1"/>
-          </p:cNvSpPr>
-          <p:nvPr/>
-        </p:nvSpPr>
-        <p:spPr>
-          <a:xfrm xmlns:a="http://schemas.openxmlformats.org/drawingml/2006/main">
-            <a:off x="8934450" y="1495425"/>
-            <a:ext cx="2809875" cy="381000"/>
-          </a:xfrm>
-          <a:prstGeom xmlns:a="http://schemas.openxmlformats.org/drawingml/2006/main" prst="rect">
-            <a:avLst/>
-          </a:prstGeom>
-          <a:noFill xmlns:a="http://schemas.openxmlformats.org/drawingml/2006/main"/>
-          <a:ln xmlns:a="http://schemas.openxmlformats.org/drawingml/2006/main" w="0">
-            <a:noFill/>
-          </a:ln>
-        </p:spPr>
-        <p:txBody>
-          <a:bodyPr xmlns:a="http://schemas.openxmlformats.org/drawingml/2006/main">
-            <a:noAutofit/>
-          </a:bodyPr>
-          <a:lstStyle xmlns:a="http://schemas.openxmlformats.org/drawingml/2006/main"/>
-          <a:p xmlns:a="http://schemas.openxmlformats.org/drawingml/2006/main">
-            <a:pPr>
-              <a:defRPr sz="1500" b="0">
-                <a:solidFill>
-                  <a:srgbClr val="657586"/>
-                </a:solidFill>
-                <a:latin typeface="Helvetica Neue"/>
-                <a:ea typeface="Helvetica Neue"/>
-                <a:cs typeface="Helvetica Neue"/>
-              </a:defRPr>
-            </a:pPr>
-            <a:r>
-              <a:rPr sz="1500" b="0">
-                <a:solidFill>
-                  <a:srgbClr val="657586"/>
-                </a:solidFill>
-                <a:latin typeface="Helvetica Neue"/>
-                <a:ea typeface="Helvetica Neue"/>
-                <a:cs typeface="Helvetica Neue"/>
-              </a:rPr>
-              <a:t>Difference [95% interval]</a:t>
-            </a:r>
-          </a:p>
-        </p:txBody>
-      </p:sp>
-      <p:sp>
-        <p:nvSpPr>
-          <p:cNvPr id="14" name="">
-            <a:extLst xmlns:a="http://schemas.openxmlformats.org/drawingml/2006/main">
-              <a:ext uri="{FF2B5EF4-FFF2-40B4-BE49-F238E27FC236}">
-                <a16:creationId xmlns:a16="http://schemas.microsoft.com/office/drawing/2014/main" id="{F39F55C9-C65A-47CE-BACB-8EE7BA40F9D2}"/>
-              </a:ext>
-            </a:extLst>
-          </p:cNvPr>
-          <p:cNvSpPr>
-            <a:spLocks xmlns:a="http://schemas.openxmlformats.org/drawingml/2006/main" noGrp="1"/>
-          </p:cNvSpPr>
-          <p:nvPr/>
-        </p:nvSpPr>
-        <p:spPr>
-          <a:xfrm xmlns:a="http://schemas.openxmlformats.org/drawingml/2006/main">
-            <a:off x="3067050" y="5124450"/>
-            <a:ext cx="6286500" cy="381000"/>
-          </a:xfrm>
-          <a:prstGeom xmlns:a="http://schemas.openxmlformats.org/drawingml/2006/main" prst="rect">
-            <a:avLst/>
-          </a:prstGeom>
-          <a:noFill xmlns:a="http://schemas.openxmlformats.org/drawingml/2006/main"/>
-          <a:ln xmlns:a="http://schemas.openxmlformats.org/drawingml/2006/main" w="0">
-            <a:noFill/>
-          </a:ln>
-        </p:spPr>
-        <p:txBody>
-          <a:bodyPr xmlns:a="http://schemas.openxmlformats.org/drawingml/2006/main">
-            <a:noAutofit/>
-          </a:bodyPr>
-          <a:lstStyle xmlns:a="http://schemas.openxmlformats.org/drawingml/2006/main"/>
-          <a:p xmlns:a="http://schemas.openxmlformats.org/drawingml/2006/main">
-            <a:pPr>
-              <a:defRPr sz="1875" b="1">
-                <a:solidFill>
-                  <a:srgbClr val="147E77"/>
-                </a:solidFill>
-                <a:latin typeface="Helvetica Neue"/>
-                <a:ea typeface="Helvetica Neue"/>
-                <a:cs typeface="Helvetica Neue"/>
-              </a:defRPr>
-            </a:pPr>
-            <a:r>
-              <a:rPr sz="1875" b="1">
-                <a:solidFill>
-                  <a:srgbClr val="147E77"/>
-                </a:solidFill>
-                <a:latin typeface="Helvetica Neue"/>
-                <a:ea typeface="Helvetica Neue"/>
-                <a:cs typeface="Helvetica Neue"/>
-              </a:rPr>
-              <a:t>Change in error rate (percentage points)</a:t>
-            </a:r>
-          </a:p>
-        </p:txBody>
-      </p:sp>
-      <p:sp>
-        <p:nvSpPr>
-          <p:cNvPr id="15" name="">
-            <a:extLst xmlns:a="http://schemas.openxmlformats.org/drawingml/2006/main">
-              <a:ext uri="{FF2B5EF4-FFF2-40B4-BE49-F238E27FC236}">
-                <a16:creationId xmlns:a16="http://schemas.microsoft.com/office/drawing/2014/main" id="{879E0052-5ED8-4C5B-884E-FF835CE1A234}"/>
-              </a:ext>
-            </a:extLst>
-          </p:cNvPr>
-          <p:cNvSpPr>
-            <a:spLocks xmlns:a="http://schemas.openxmlformats.org/drawingml/2006/main" noGrp="1"/>
-          </p:cNvSpPr>
-          <p:nvPr/>
-        </p:nvSpPr>
-        <p:spPr>
-          <a:xfrm xmlns:a="http://schemas.openxmlformats.org/drawingml/2006/main">
-            <a:off x="685800" y="5581650"/>
-            <a:ext cx="10668000" cy="381000"/>
-          </a:xfrm>
-          <a:prstGeom xmlns:a="http://schemas.openxmlformats.org/drawingml/2006/main" prst="rect">
-            <a:avLst/>
-          </a:prstGeom>
-          <a:noFill xmlns:a="http://schemas.openxmlformats.org/drawingml/2006/main"/>
-          <a:ln xmlns:a="http://schemas.openxmlformats.org/drawingml/2006/main" w="0">
-            <a:noFill/>
-          </a:ln>
-        </p:spPr>
-        <p:txBody>
-          <a:bodyPr xmlns:a="http://schemas.openxmlformats.org/drawingml/2006/main">
-            <a:noAutofit/>
-          </a:bodyPr>
-          <a:lstStyle xmlns:a="http://schemas.openxmlformats.org/drawingml/2006/main"/>
-          <a:p xmlns:a="http://schemas.openxmlformats.org/drawingml/2006/main">
-            <a:pPr>
-              <a:defRPr sz="1950" b="0">
-                <a:solidFill>
-                  <a:srgbClr val="142C40"/>
-                </a:solidFill>
-                <a:latin typeface="Helvetica Neue"/>
-                <a:ea typeface="Helvetica Neue"/>
-                <a:cs typeface="Helvetica Neue"/>
-              </a:defRPr>
-            </a:pPr>
-            <a:r>
-              <a:rPr sz="1950" b="0">
-                <a:solidFill>
-                  <a:srgbClr val="142C40"/>
-                </a:solidFill>
-                <a:latin typeface="Helvetica Neue"/>
-                <a:ea typeface="Helvetica Neue"/>
-                <a:cs typeface="Helvetica Neue"/>
-              </a:rPr>
-              <a:t>Left: fewer wrong answers. Right: more wrong answers.</a:t>
-            </a:r>
-          </a:p>
-        </p:txBody>
-      </p:sp>
-      <p:sp>
-        <p:nvSpPr>
-          <p:cNvPr id="16" name="">
-            <a:extLst xmlns:a="http://schemas.openxmlformats.org/drawingml/2006/main">
-              <a:ext uri="{FF2B5EF4-FFF2-40B4-BE49-F238E27FC236}">
-                <a16:creationId xmlns:a16="http://schemas.microsoft.com/office/drawing/2014/main" id="{77ECDDA7-6909-40DC-93A7-7AF5FBFF80D4}"/>
-              </a:ext>
-            </a:extLst>
-          </p:cNvPr>
-          <p:cNvSpPr>
-            <a:spLocks xmlns:a="http://schemas.openxmlformats.org/drawingml/2006/main" noGrp="1"/>
-          </p:cNvSpPr>
-          <p:nvPr/>
-        </p:nvSpPr>
-        <p:spPr>
-          <a:xfrm xmlns:a="http://schemas.openxmlformats.org/drawingml/2006/main">
-            <a:off x="685800" y="6057900"/>
-            <a:ext cx="10477500" cy="381000"/>
-          </a:xfrm>
-          <a:prstGeom xmlns:a="http://schemas.openxmlformats.org/drawingml/2006/main" prst="rect">
-            <a:avLst/>
-          </a:prstGeom>
-          <a:noFill xmlns:a="http://schemas.openxmlformats.org/drawingml/2006/main"/>
-          <a:ln xmlns:a="http://schemas.openxmlformats.org/drawingml/2006/main" w="0">
-            <a:noFill/>
-          </a:ln>
-        </p:spPr>
-        <p:txBody>
-          <a:bodyPr xmlns:a="http://schemas.openxmlformats.org/drawingml/2006/main">
-            <a:noAutofit/>
-          </a:bodyPr>
-          <a:lstStyle xmlns:a="http://schemas.openxmlformats.org/drawingml/2006/main"/>
-          <a:p xmlns:a="http://schemas.openxmlformats.org/drawingml/2006/main">
-            <a:pPr>
-              <a:defRPr sz="1575" b="0">
-                <a:solidFill>
-                  <a:srgbClr val="657586"/>
-                </a:solidFill>
-                <a:latin typeface="Helvetica Neue"/>
-                <a:ea typeface="Helvetica Neue"/>
-                <a:cs typeface="Helvetica Neue"/>
-              </a:defRPr>
-            </a:pPr>
-            <a:r>
-              <a:rPr sz="1575" b="0">
-                <a:solidFill>
-                  <a:srgbClr val="657586"/>
-                </a:solidFill>
-                <a:latin typeface="Helvetica Neue"/>
-                <a:ea typeface="Helvetica Neue"/>
-                <a:cs typeface="Helvetica Neue"/>
-              </a:rPr>
-              <a:t>Post hoc; 719 paired units; 120 question clusters. Pointwise bootstrap intervals.</a:t>
-            </a:r>
-          </a:p>
-        </p:txBody>
-      </p:sp>
-      <p:sp>
-        <p:nvSpPr>
-          <p:cNvPr id="17" name="">
-            <a:extLst xmlns:a="http://schemas.openxmlformats.org/drawingml/2006/main">
-              <a:ext uri="{FF2B5EF4-FFF2-40B4-BE49-F238E27FC236}">
-                <a16:creationId xmlns:a16="http://schemas.microsoft.com/office/drawing/2014/main" id="{D0127590-F340-4C04-8467-A82DA626E4D3}"/>
+                <a16:creationId xmlns:a16="http://schemas.microsoft.com/office/drawing/2014/main" id="{8F0730FB-5C3D-40BD-908E-DCD2DF891E6D}"/>
               </a:ext>
             </a:extLst>
           </p:cNvPr>
@@ -9692,7 +9002,7 @@
     </p:spTree>
     <p:extLst>
       <p:ext uri="{BB962C8B-B14F-4D97-AF65-F5344CB8AC3E}">
-        <p14:creationId xmlns:p14="http://schemas.microsoft.com/office/powerpoint/2010/main" val="277823871"/>
+        <p14:creationId xmlns:p14="http://schemas.microsoft.com/office/powerpoint/2010/main" val="1076023091"/>
       </p:ext>
     </p:extLst>
   </p:cSld>
@@ -9723,7 +9033,7 @@
           <p:cNvPr id="8" name="">
             <a:extLst xmlns:a="http://schemas.openxmlformats.org/drawingml/2006/main">
               <a:ext uri="{FF2B5EF4-FFF2-40B4-BE49-F238E27FC236}">
-                <a16:creationId xmlns:a16="http://schemas.microsoft.com/office/drawing/2014/main" id="{B634A877-A8C4-4930-9197-34259DD8DA68}"/>
+                <a16:creationId xmlns:a16="http://schemas.microsoft.com/office/drawing/2014/main" id="{3EAFADFB-F359-4FE6-A92F-31C6275AE942}"/>
               </a:ext>
             </a:extLst>
           </p:cNvPr>
@@ -10196,7 +9506,7 @@
           <p:cNvPr id="3" name="">
             <a:extLst xmlns:a="http://schemas.openxmlformats.org/drawingml/2006/main">
               <a:ext uri="{FF2B5EF4-FFF2-40B4-BE49-F238E27FC236}">
-                <a16:creationId xmlns:a16="http://schemas.microsoft.com/office/drawing/2014/main" id="{F9B768A9-03CB-415F-8FC3-F1316CB1FAB6}"/>
+                <a16:creationId xmlns:a16="http://schemas.microsoft.com/office/drawing/2014/main" id="{8A6F8EA8-95D5-4E31-8F81-164FAC880E49}"/>
               </a:ext>
             </a:extLst>
           </p:cNvPr>
@@ -10253,7 +9563,7 @@
           <p:cNvPr id="4" name="">
             <a:extLst xmlns:a="http://schemas.openxmlformats.org/drawingml/2006/main">
               <a:ext uri="{FF2B5EF4-FFF2-40B4-BE49-F238E27FC236}">
-                <a16:creationId xmlns:a16="http://schemas.microsoft.com/office/drawing/2014/main" id="{7EE4FB6B-C34F-41AE-8B20-C0A4FFDFC341}"/>
+                <a16:creationId xmlns:a16="http://schemas.microsoft.com/office/drawing/2014/main" id="{22DA4FA5-54C3-448F-AF3C-83A2CC5D6D7A}"/>
               </a:ext>
             </a:extLst>
           </p:cNvPr>
@@ -10310,7 +9620,7 @@
           <p:cNvPr id="5" name="">
             <a:extLst xmlns:a="http://schemas.openxmlformats.org/drawingml/2006/main">
               <a:ext uri="{FF2B5EF4-FFF2-40B4-BE49-F238E27FC236}">
-                <a16:creationId xmlns:a16="http://schemas.microsoft.com/office/drawing/2014/main" id="{8434E4F7-C0F2-4C5C-87EA-65172D1689BB}"/>
+                <a16:creationId xmlns:a16="http://schemas.microsoft.com/office/drawing/2014/main" id="{761F7B4F-7419-4A2C-905D-95F22B662CE8}"/>
               </a:ext>
             </a:extLst>
           </p:cNvPr>
@@ -10367,7 +9677,7 @@
           <p:cNvPr id="6" name="">
             <a:extLst xmlns:a="http://schemas.openxmlformats.org/drawingml/2006/main">
               <a:ext uri="{FF2B5EF4-FFF2-40B4-BE49-F238E27FC236}">
-                <a16:creationId xmlns:a16="http://schemas.microsoft.com/office/drawing/2014/main" id="{CBD83F11-761F-4ACB-A0F5-3DB50E59B847}"/>
+                <a16:creationId xmlns:a16="http://schemas.microsoft.com/office/drawing/2014/main" id="{080B8D47-B204-40F2-BACD-996DB6306266}"/>
               </a:ext>
             </a:extLst>
           </p:cNvPr>
@@ -10424,7 +9734,7 @@
           <p:cNvPr id="7" name="">
             <a:extLst xmlns:a="http://schemas.openxmlformats.org/drawingml/2006/main">
               <a:ext uri="{FF2B5EF4-FFF2-40B4-BE49-F238E27FC236}">
-                <a16:creationId xmlns:a16="http://schemas.microsoft.com/office/drawing/2014/main" id="{C5DE491E-9B33-4B34-B29A-7231F80FA93D}"/>
+                <a16:creationId xmlns:a16="http://schemas.microsoft.com/office/drawing/2014/main" id="{AA8CE940-7B2D-4821-BC49-D84693A0C22B}"/>
               </a:ext>
             </a:extLst>
           </p:cNvPr>
@@ -10479,7 +9789,7 @@
     </p:spTree>
     <p:extLst>
       <p:ext uri="{BB962C8B-B14F-4D97-AF65-F5344CB8AC3E}">
-        <p14:creationId xmlns:p14="http://schemas.microsoft.com/office/powerpoint/2010/main" val="1607350860"/>
+        <p14:creationId xmlns:p14="http://schemas.microsoft.com/office/powerpoint/2010/main" val="1304957032"/>
       </p:ext>
     </p:extLst>
   </p:cSld>
@@ -10510,7 +9820,7 @@
           <p:cNvPr id="6" name="">
             <a:extLst xmlns:a="http://schemas.openxmlformats.org/drawingml/2006/main">
               <a:ext uri="{FF2B5EF4-FFF2-40B4-BE49-F238E27FC236}">
-                <a16:creationId xmlns:a16="http://schemas.microsoft.com/office/drawing/2014/main" id="{1D5FB349-0F41-4EC6-89AB-0DDB0F45D196}"/>
+                <a16:creationId xmlns:a16="http://schemas.microsoft.com/office/drawing/2014/main" id="{0855A30E-B4EC-40FF-BBE5-7CB46D925363}"/>
               </a:ext>
             </a:extLst>
           </p:cNvPr>
@@ -10574,7 +9884,7 @@
         </p:xfrm>
         <a:graphic xmlns:a="http://schemas.openxmlformats.org/drawingml/2006/main">
           <a:graphicData uri="http://schemas.openxmlformats.org/drawingml/2006/chart">
-            <c:chart xmlns:r="http://schemas.openxmlformats.org/officeDocument/2006/relationships" xmlns:c="http://schemas.openxmlformats.org/drawingml/2006/chart" r:id="Ra01c87e7dc3a4f14"/>
+            <c:chart xmlns:r="http://schemas.openxmlformats.org/officeDocument/2006/relationships" xmlns:c="http://schemas.openxmlformats.org/drawingml/2006/chart" r:id="Rb212d89931a24e86"/>
           </a:graphicData>
         </a:graphic>
       </p:graphicFrame>
@@ -10583,7 +9893,7 @@
           <p:cNvPr id="3" name="">
             <a:extLst xmlns:a="http://schemas.openxmlformats.org/drawingml/2006/main">
               <a:ext uri="{FF2B5EF4-FFF2-40B4-BE49-F238E27FC236}">
-                <a16:creationId xmlns:a16="http://schemas.microsoft.com/office/drawing/2014/main" id="{98BC372B-71AC-4433-A523-D4A923A2B94C}"/>
+                <a16:creationId xmlns:a16="http://schemas.microsoft.com/office/drawing/2014/main" id="{76CC0D07-A965-4C14-A62A-30400B873DBE}"/>
               </a:ext>
             </a:extLst>
           </p:cNvPr>
@@ -10640,7 +9950,7 @@
           <p:cNvPr id="4" name="">
             <a:extLst xmlns:a="http://schemas.openxmlformats.org/drawingml/2006/main">
               <a:ext uri="{FF2B5EF4-FFF2-40B4-BE49-F238E27FC236}">
-                <a16:creationId xmlns:a16="http://schemas.microsoft.com/office/drawing/2014/main" id="{40989377-1949-4B82-83DB-38C79EE13960}"/>
+                <a16:creationId xmlns:a16="http://schemas.microsoft.com/office/drawing/2014/main" id="{CC95E088-E912-4D44-96B4-6D69B6BDECC6}"/>
               </a:ext>
             </a:extLst>
           </p:cNvPr>
@@ -10697,7 +10007,7 @@
           <p:cNvPr id="5" name="">
             <a:extLst xmlns:a="http://schemas.openxmlformats.org/drawingml/2006/main">
               <a:ext uri="{FF2B5EF4-FFF2-40B4-BE49-F238E27FC236}">
-                <a16:creationId xmlns:a16="http://schemas.microsoft.com/office/drawing/2014/main" id="{0EA44874-A855-49B7-9870-7A9BB0F1717A}"/>
+                <a16:creationId xmlns:a16="http://schemas.microsoft.com/office/drawing/2014/main" id="{C9B2D3BD-C2E5-44B1-8EC8-9F3555155BAA}"/>
               </a:ext>
             </a:extLst>
           </p:cNvPr>
@@ -10752,7 +10062,7 @@
     </p:spTree>
     <p:extLst>
       <p:ext uri="{BB962C8B-B14F-4D97-AF65-F5344CB8AC3E}">
-        <p14:creationId xmlns:p14="http://schemas.microsoft.com/office/powerpoint/2010/main" val="1907371644"/>
+        <p14:creationId xmlns:p14="http://schemas.microsoft.com/office/powerpoint/2010/main" val="1519226542"/>
       </p:ext>
     </p:extLst>
   </p:cSld>
@@ -10783,7 +10093,7 @@
           <p:cNvPr id="6" name="">
             <a:extLst xmlns:a="http://schemas.openxmlformats.org/drawingml/2006/main">
               <a:ext uri="{FF2B5EF4-FFF2-40B4-BE49-F238E27FC236}">
-                <a16:creationId xmlns:a16="http://schemas.microsoft.com/office/drawing/2014/main" id="{6738305E-7F4F-469E-B019-E01F0F6F9187}"/>
+                <a16:creationId xmlns:a16="http://schemas.microsoft.com/office/drawing/2014/main" id="{A2103A79-3F5F-430C-A523-D4A33E1A60E5}"/>
               </a:ext>
             </a:extLst>
           </p:cNvPr>
@@ -10847,7 +10157,7 @@
         </p:xfrm>
         <a:graphic xmlns:a="http://schemas.openxmlformats.org/drawingml/2006/main">
           <a:graphicData uri="http://schemas.openxmlformats.org/drawingml/2006/chart">
-            <c:chart xmlns:r="http://schemas.openxmlformats.org/officeDocument/2006/relationships" xmlns:c="http://schemas.openxmlformats.org/drawingml/2006/chart" r:id="R4bbc1c64c8264d10"/>
+            <c:chart xmlns:r="http://schemas.openxmlformats.org/officeDocument/2006/relationships" xmlns:c="http://schemas.openxmlformats.org/drawingml/2006/chart" r:id="R8ad6e578a072433f"/>
           </a:graphicData>
         </a:graphic>
       </p:graphicFrame>
@@ -10856,7 +10166,7 @@
           <p:cNvPr id="3" name="">
             <a:extLst xmlns:a="http://schemas.openxmlformats.org/drawingml/2006/main">
               <a:ext uri="{FF2B5EF4-FFF2-40B4-BE49-F238E27FC236}">
-                <a16:creationId xmlns:a16="http://schemas.microsoft.com/office/drawing/2014/main" id="{EFA6CB74-2F77-48A5-906E-0D41D2B0A12B}"/>
+                <a16:creationId xmlns:a16="http://schemas.microsoft.com/office/drawing/2014/main" id="{2E52812C-CBAE-40E2-9861-77AEF31E1640}"/>
               </a:ext>
             </a:extLst>
           </p:cNvPr>
@@ -10913,7 +10223,7 @@
           <p:cNvPr id="4" name="">
             <a:extLst xmlns:a="http://schemas.openxmlformats.org/drawingml/2006/main">
               <a:ext uri="{FF2B5EF4-FFF2-40B4-BE49-F238E27FC236}">
-                <a16:creationId xmlns:a16="http://schemas.microsoft.com/office/drawing/2014/main" id="{690E1C1F-D2D8-48B7-A046-68A5620D6F7A}"/>
+                <a16:creationId xmlns:a16="http://schemas.microsoft.com/office/drawing/2014/main" id="{BA7BDE08-4222-4BBB-9BEE-9F736A5E01DB}"/>
               </a:ext>
             </a:extLst>
           </p:cNvPr>
@@ -10970,7 +10280,7 @@
           <p:cNvPr id="5" name="">
             <a:extLst xmlns:a="http://schemas.openxmlformats.org/drawingml/2006/main">
               <a:ext uri="{FF2B5EF4-FFF2-40B4-BE49-F238E27FC236}">
-                <a16:creationId xmlns:a16="http://schemas.microsoft.com/office/drawing/2014/main" id="{7E3AC62B-F822-4B56-AD9A-CC2A890362D8}"/>
+                <a16:creationId xmlns:a16="http://schemas.microsoft.com/office/drawing/2014/main" id="{381E832F-1E56-4E12-ABA0-34A2A496E26E}"/>
               </a:ext>
             </a:extLst>
           </p:cNvPr>
@@ -11025,7 +10335,7 @@
     </p:spTree>
     <p:extLst>
       <p:ext uri="{BB962C8B-B14F-4D97-AF65-F5344CB8AC3E}">
-        <p14:creationId xmlns:p14="http://schemas.microsoft.com/office/powerpoint/2010/main" val="1170983894"/>
+        <p14:creationId xmlns:p14="http://schemas.microsoft.com/office/powerpoint/2010/main" val="1115667881"/>
       </p:ext>
     </p:extLst>
   </p:cSld>

</xml_diff>